<commit_message>
Apply poster template typography rules
</commit_message>
<xml_diff>
--- a/docs/PAU_Market_Tez_Posteri.pptx
+++ b/docs/PAU_Market_Tez_Posteri.pptx
@@ -7,7 +7,7 @@
   <p:sldIdLst>
     <p:sldId id="256" r:id="rId7"/>
   </p:sldIdLst>
-  <p:sldSz cx="21387816" cy="30275784" type="screen4x3"/>
+  <p:sldSz cx="21384000" cy="30275999" type="screen4x3"/>
   <p:notesSz cx="6858000" cy="9144000"/>
   <p:defaultTextStyle>
     <a:defPPr>
@@ -3097,7 +3097,7 @@
         <p:spPr>
           <a:xfrm>
             <a:off x="0" y="0"/>
-            <a:ext cx="21387816" cy="30275784"/>
+            <a:ext cx="21384000" cy="30275999"/>
           </a:xfrm>
           <a:prstGeom prst="rect">
             <a:avLst/>
@@ -3141,8 +3141,8 @@
         </p:nvSpPr>
         <p:spPr>
           <a:xfrm>
-            <a:off x="914400" y="777240"/>
-            <a:ext cx="19568160" cy="28483560"/>
+            <a:off x="774000" y="558000"/>
+            <a:ext cx="19836000" cy="29142000"/>
           </a:xfrm>
           <a:prstGeom prst="rect">
             <a:avLst/>
@@ -3186,8 +3186,8 @@
         </p:nvSpPr>
         <p:spPr>
           <a:xfrm>
-            <a:off x="960120" y="914400"/>
-            <a:ext cx="19476719" cy="3520440"/>
+            <a:off x="827999" y="684000"/>
+            <a:ext cx="19728000" cy="3671999"/>
           </a:xfrm>
           <a:prstGeom prst="rect">
             <a:avLst/>
@@ -3231,8 +3231,8 @@
         </p:nvSpPr>
         <p:spPr>
           <a:xfrm>
-            <a:off x="1207008" y="1115568"/>
-            <a:ext cx="1325880" cy="1325880"/>
+            <a:off x="1025999" y="882000"/>
+            <a:ext cx="1800000" cy="1800000"/>
           </a:xfrm>
           <a:prstGeom prst="ellipse">
             <a:avLst/>
@@ -3276,14 +3276,14 @@
         </p:nvSpPr>
         <p:spPr>
           <a:xfrm>
-            <a:off x="1362456" y="1271016"/>
-            <a:ext cx="1014983" cy="1014983"/>
+            <a:off x="1198799" y="1054800"/>
+            <a:ext cx="1454400" cy="1454400"/>
           </a:xfrm>
           <a:prstGeom prst="ellipse">
             <a:avLst/>
           </a:prstGeom>
           <a:solidFill>
-            <a:srgbClr val="D9E6F2"/>
+            <a:srgbClr val="DFEBF7"/>
           </a:solidFill>
           <a:ln w="10160">
             <a:solidFill>
@@ -3321,8 +3321,8 @@
         </p:nvSpPr>
         <p:spPr>
           <a:xfrm>
-            <a:off x="1408176" y="1444752"/>
-            <a:ext cx="923544" cy="320040"/>
+            <a:off x="1259999" y="1404000"/>
+            <a:ext cx="1332000" cy="324000"/>
           </a:xfrm>
           <a:prstGeom prst="rect">
             <a:avLst/>
@@ -3337,7 +3337,7 @@
           <a:p>
             <a:pPr algn="ctr"/>
             <a:r>
-              <a:rPr sz="1200" b="1">
+              <a:rPr sz="2500" b="1">
                 <a:solidFill>
                   <a:srgbClr val="1F4E79"/>
                 </a:solidFill>
@@ -3356,8 +3356,8 @@
         </p:nvSpPr>
         <p:spPr>
           <a:xfrm>
-            <a:off x="1371600" y="1773936"/>
-            <a:ext cx="996695" cy="228600"/>
+            <a:off x="1259999" y="1818000"/>
+            <a:ext cx="1332000" cy="198000"/>
           </a:xfrm>
           <a:prstGeom prst="rect">
             <a:avLst/>
@@ -3372,7 +3372,7 @@
           <a:p>
             <a:pPr algn="ctr"/>
             <a:r>
-              <a:rPr sz="670" b="1">
+              <a:rPr sz="1300" b="1">
                 <a:solidFill>
                   <a:srgbClr val="1F4E79"/>
                 </a:solidFill>
@@ -3391,8 +3391,8 @@
         </p:nvSpPr>
         <p:spPr>
           <a:xfrm>
-            <a:off x="16276319" y="914400"/>
-            <a:ext cx="4160520" cy="749808"/>
+            <a:off x="15336000" y="684000"/>
+            <a:ext cx="5220000" cy="936000"/>
           </a:xfrm>
           <a:prstGeom prst="rect">
             <a:avLst/>
@@ -3426,7 +3426,7 @@
           <a:p>
             <a:pPr algn="ctr"/>
             <a:r>
-              <a:rPr sz="1400" b="1">
+              <a:rPr sz="5000" b="1">
                 <a:solidFill>
                   <a:srgbClr val="000000"/>
                 </a:solidFill>
@@ -3445,8 +3445,8 @@
         </p:nvSpPr>
         <p:spPr>
           <a:xfrm>
-            <a:off x="16962119" y="1325880"/>
-            <a:ext cx="2834640" cy="228600"/>
+            <a:off x="3078000" y="954000"/>
+            <a:ext cx="12096000" cy="396000"/>
           </a:xfrm>
           <a:prstGeom prst="rect">
             <a:avLst/>
@@ -3461,13 +3461,13 @@
           <a:p>
             <a:pPr algn="ctr"/>
             <a:r>
-              <a:rPr sz="819" b="1">
-                <a:solidFill>
-                  <a:srgbClr val="000000"/>
+              <a:rPr sz="3100" b="1">
+                <a:solidFill>
+                  <a:srgbClr val="FFFFFF"/>
                 </a:solidFill>
                 <a:latin typeface="Arial"/>
               </a:rPr>
-              <a:t>[Proje No]</a:t>
+              <a:t>Pamukkale Üniversitesi</a:t>
             </a:r>
           </a:p>
         </p:txBody>
@@ -3480,8 +3480,8 @@
         </p:nvSpPr>
         <p:spPr>
           <a:xfrm>
-            <a:off x="3931920" y="1170432"/>
-            <a:ext cx="13075920" cy="438912"/>
+            <a:off x="3078000" y="1494000"/>
+            <a:ext cx="12096000" cy="450000"/>
           </a:xfrm>
           <a:prstGeom prst="rect">
             <a:avLst/>
@@ -3496,13 +3496,13 @@
           <a:p>
             <a:pPr algn="ctr"/>
             <a:r>
-              <a:rPr sz="1700" b="1">
+              <a:rPr sz="3200" b="1">
                 <a:solidFill>
                   <a:srgbClr val="FFFFFF"/>
                 </a:solidFill>
                 <a:latin typeface="Arial"/>
               </a:rPr>
-              <a:t>Pamukkale Üniversitesi</a:t>
+              <a:t>PAÜ Market: Kampüs İçi Akıllı</a:t>
             </a:r>
           </a:p>
         </p:txBody>
@@ -3515,8 +3515,8 @@
         </p:nvSpPr>
         <p:spPr>
           <a:xfrm>
-            <a:off x="2971800" y="1874519"/>
-            <a:ext cx="15453359" cy="896112"/>
+            <a:off x="3078000" y="1890000"/>
+            <a:ext cx="12096000" cy="450000"/>
           </a:xfrm>
           <a:prstGeom prst="rect">
             <a:avLst/>
@@ -3531,13 +3531,13 @@
           <a:p>
             <a:pPr algn="ctr"/>
             <a:r>
-              <a:rPr sz="2200" b="1">
+              <a:rPr sz="3200" b="1">
                 <a:solidFill>
                   <a:srgbClr val="FFFFFF"/>
                 </a:solidFill>
                 <a:latin typeface="Arial"/>
               </a:rPr>
-              <a:t>PAÜ Market: Kampüs İçi Akıllı İkinci El Pazar Yeri</a:t>
+              <a:t>İkinci El Pazar Yeri</a:t>
             </a:r>
           </a:p>
         </p:txBody>
@@ -3550,8 +3550,8 @@
         </p:nvSpPr>
         <p:spPr>
           <a:xfrm>
-            <a:off x="2926080" y="3127248"/>
-            <a:ext cx="15544800" cy="384048"/>
+            <a:off x="3078000" y="2970000"/>
+            <a:ext cx="12096000" cy="288000"/>
           </a:xfrm>
           <a:prstGeom prst="rect">
             <a:avLst/>
@@ -3566,7 +3566,7 @@
           <a:p>
             <a:pPr algn="ctr"/>
             <a:r>
-              <a:rPr sz="1060" b="1">
+              <a:rPr sz="1600" b="1">
                 <a:solidFill>
                   <a:srgbClr val="FFFFFF"/>
                 </a:solidFill>
@@ -3585,8 +3585,8 @@
         </p:nvSpPr>
         <p:spPr>
           <a:xfrm>
-            <a:off x="2926080" y="3611880"/>
-            <a:ext cx="15544800" cy="310896"/>
+            <a:off x="3078000" y="3330000"/>
+            <a:ext cx="12096000" cy="270000"/>
           </a:xfrm>
           <a:prstGeom prst="rect">
             <a:avLst/>
@@ -3601,9 +3601,9 @@
           <a:p>
             <a:pPr algn="ctr"/>
             <a:r>
-              <a:rPr sz="930" b="1">
-                <a:solidFill>
-                  <a:srgbClr val="E6EEF7"/>
+              <a:rPr sz="1500" b="1">
+                <a:solidFill>
+                  <a:srgbClr val="EBF2FA"/>
                 </a:solidFill>
                 <a:latin typeface="Arial"/>
               </a:rPr>
@@ -3620,8 +3620,8 @@
         </p:nvSpPr>
         <p:spPr>
           <a:xfrm>
-            <a:off x="1234440" y="4663440"/>
-            <a:ext cx="18928080" cy="22448520"/>
+            <a:off x="1115999" y="4608000"/>
+            <a:ext cx="19152000" cy="22752000"/>
           </a:xfrm>
           <a:prstGeom prst="rect">
             <a:avLst/>
@@ -3665,8 +3665,8 @@
         </p:nvSpPr>
         <p:spPr>
           <a:xfrm>
-            <a:off x="10588752" y="4800600"/>
-            <a:ext cx="164592" cy="22174200"/>
+            <a:off x="10547999" y="4752000"/>
+            <a:ext cx="125999" cy="22464000"/>
           </a:xfrm>
           <a:prstGeom prst="rect">
             <a:avLst/>
@@ -3710,14 +3710,14 @@
         </p:nvSpPr>
         <p:spPr>
           <a:xfrm>
-            <a:off x="1481328" y="4892040"/>
-            <a:ext cx="8778240" cy="3611880"/>
+            <a:off x="1332000" y="4842000"/>
+            <a:ext cx="9072000" cy="3600000"/>
           </a:xfrm>
           <a:prstGeom prst="rect">
             <a:avLst/>
           </a:prstGeom>
           <a:solidFill>
-            <a:srgbClr val="EFEFEF"/>
+            <a:srgbClr val="F1F1F1"/>
           </a:solidFill>
           <a:ln w="7620">
             <a:solidFill>
@@ -3755,18 +3755,18 @@
         </p:nvSpPr>
         <p:spPr>
           <a:xfrm>
-            <a:off x="1481328" y="4892040"/>
-            <a:ext cx="8778240" cy="411480"/>
+            <a:off x="1332000" y="4842000"/>
+            <a:ext cx="9072000" cy="424800"/>
           </a:xfrm>
           <a:prstGeom prst="rect">
             <a:avLst/>
           </a:prstGeom>
           <a:solidFill>
-            <a:srgbClr val="1F4E79"/>
+            <a:srgbClr val="205280"/>
           </a:solidFill>
           <a:ln w="5080">
             <a:solidFill>
-              <a:srgbClr val="1F4E79"/>
+              <a:srgbClr val="205280"/>
             </a:solidFill>
           </a:ln>
         </p:spPr>
@@ -3800,8 +3800,8 @@
         </p:nvSpPr>
         <p:spPr>
           <a:xfrm>
-            <a:off x="1527048" y="4960620"/>
-            <a:ext cx="8686800" cy="256032"/>
+            <a:off x="1386000" y="4906800"/>
+            <a:ext cx="8964000" cy="251999"/>
           </a:xfrm>
           <a:prstGeom prst="rect">
             <a:avLst/>
@@ -3816,7 +3816,7 @@
           <a:p>
             <a:pPr algn="ctr"/>
             <a:r>
-              <a:rPr sz="1300" b="1">
+              <a:rPr sz="2200" b="1">
                 <a:solidFill>
                   <a:srgbClr val="FFFFFF"/>
                 </a:solidFill>
@@ -3835,8 +3835,8 @@
         </p:nvSpPr>
         <p:spPr>
           <a:xfrm>
-            <a:off x="1618488" y="5458968"/>
-            <a:ext cx="8503919" cy="2926080"/>
+            <a:off x="1450800" y="5363999"/>
+            <a:ext cx="8834400" cy="3006000"/>
           </a:xfrm>
           <a:prstGeom prst="rect">
             <a:avLst/>
@@ -3844,20 +3844,23 @@
           <a:noFill/>
         </p:spPr>
         <p:txBody>
-          <a:bodyPr wrap="square" lIns="36576" rIns="36576" tIns="18288">
+          <a:bodyPr wrap="square" lIns="50400" rIns="43200" tIns="18000">
             <a:spAutoFit/>
           </a:bodyPr>
           <a:lstStyle/>
           <a:p>
             <a:pPr>
+              <a:lnSpc>
+                <a:spcPct val="102000"/>
+              </a:lnSpc>
               <a:spcAft>
-                <a:spcPts val="420"/>
+                <a:spcPts val="500"/>
               </a:spcAft>
             </a:pPr>
             <a:r>
-              <a:rPr sz="860" b="0">
-                <a:solidFill>
-                  <a:srgbClr val="141414"/>
+              <a:rPr sz="1620" b="0">
+                <a:solidFill>
+                  <a:srgbClr val="0A0A0A"/>
                 </a:solidFill>
                 <a:latin typeface="Arial"/>
               </a:rPr>
@@ -3866,34 +3869,40 @@
           </a:p>
           <a:p>
             <a:pPr>
+              <a:lnSpc>
+                <a:spcPct val="102000"/>
+              </a:lnSpc>
               <a:spcAft>
-                <a:spcPts val="420"/>
+                <a:spcPts val="500"/>
               </a:spcAft>
             </a:pPr>
             <a:r>
-              <a:rPr sz="860" b="0">
-                <a:solidFill>
-                  <a:srgbClr val="141414"/>
+              <a:rPr sz="1620" b="0">
+                <a:solidFill>
+                  <a:srgbClr val="0A0A0A"/>
                 </a:solidFill>
                 <a:latin typeface="Arial"/>
               </a:rPr>
-              <a:t>Sistem; okul e-postasıyla doğrulanan kullanıcıların ilan eklemesini, ilanları keşfetmesini, favorilemesini, satıcıyla mesajlaşmasını ve anlaşma isteği göndermesini sağlar.</a:t>
+              <a:t>Okul e-postasıyla doğrulanan öğrenciler ilan ekler, ilanları keşfeder, favoriler, satıcıya mesaj atar ve anlaşma isteği gönderir.</a:t>
             </a:r>
           </a:p>
           <a:p>
             <a:pPr>
+              <a:lnSpc>
+                <a:spcPct val="102000"/>
+              </a:lnSpc>
               <a:spcAft>
-                <a:spcPts val="420"/>
+                <a:spcPts val="500"/>
               </a:spcAft>
             </a:pPr>
             <a:r>
-              <a:rPr sz="860" b="0">
-                <a:solidFill>
-                  <a:srgbClr val="141414"/>
+              <a:rPr sz="1620" b="0">
+                <a:solidFill>
+                  <a:srgbClr val="0A0A0A"/>
                 </a:solidFill>
                 <a:latin typeface="Arial"/>
               </a:rPr>
-              <a:t>Tezin teknik odağı, bu etkileşimlerden öğrenerek kişiselleştirilmiş ilan önerileri üreten hibrit öneri sistemidir.</a:t>
+              <a:t>Tezin teknik odağı, kullanıcı etkileşimlerinden öğrenen kişiselleştirilmiş öneri sistemidir.</a:t>
             </a:r>
           </a:p>
         </p:txBody>
@@ -3906,14 +3915,14 @@
         </p:nvSpPr>
         <p:spPr>
           <a:xfrm>
-            <a:off x="1481328" y="8823959"/>
-            <a:ext cx="8778240" cy="3886200"/>
+            <a:off x="1332000" y="8766000"/>
+            <a:ext cx="9072000" cy="3960000"/>
           </a:xfrm>
           <a:prstGeom prst="rect">
             <a:avLst/>
           </a:prstGeom>
           <a:solidFill>
-            <a:srgbClr val="EFEFEF"/>
+            <a:srgbClr val="F1F1F1"/>
           </a:solidFill>
           <a:ln w="7620">
             <a:solidFill>
@@ -3951,18 +3960,18 @@
         </p:nvSpPr>
         <p:spPr>
           <a:xfrm>
-            <a:off x="1481328" y="8823959"/>
-            <a:ext cx="8778240" cy="411480"/>
+            <a:off x="1332000" y="8766000"/>
+            <a:ext cx="9072000" cy="424800"/>
           </a:xfrm>
           <a:prstGeom prst="rect">
             <a:avLst/>
           </a:prstGeom>
           <a:solidFill>
-            <a:srgbClr val="1F4E79"/>
+            <a:srgbClr val="205280"/>
           </a:solidFill>
           <a:ln w="5080">
             <a:solidFill>
-              <a:srgbClr val="1F4E79"/>
+              <a:srgbClr val="205280"/>
             </a:solidFill>
           </a:ln>
         </p:spPr>
@@ -3996,8 +4005,8 @@
         </p:nvSpPr>
         <p:spPr>
           <a:xfrm>
-            <a:off x="1527048" y="8892539"/>
-            <a:ext cx="8686800" cy="256032"/>
+            <a:off x="1386000" y="8830800"/>
+            <a:ext cx="8964000" cy="251999"/>
           </a:xfrm>
           <a:prstGeom prst="rect">
             <a:avLst/>
@@ -4012,7 +4021,7 @@
           <a:p>
             <a:pPr algn="ctr"/>
             <a:r>
-              <a:rPr sz="1300" b="1">
+              <a:rPr sz="2200" b="1">
                 <a:solidFill>
                   <a:srgbClr val="FFFFFF"/>
                 </a:solidFill>
@@ -4031,8 +4040,8 @@
         </p:nvSpPr>
         <p:spPr>
           <a:xfrm>
-            <a:off x="1618488" y="9390887"/>
-            <a:ext cx="8503919" cy="3200400"/>
+            <a:off x="1450800" y="9288000"/>
+            <a:ext cx="8834400" cy="3366000"/>
           </a:xfrm>
           <a:prstGeom prst="rect">
             <a:avLst/>
@@ -4040,56 +4049,65 @@
           <a:noFill/>
         </p:spPr>
         <p:txBody>
-          <a:bodyPr wrap="square" lIns="36576" rIns="36576" tIns="18288">
+          <a:bodyPr wrap="square" lIns="50400" rIns="43200" tIns="18000">
             <a:spAutoFit/>
           </a:bodyPr>
           <a:lstStyle/>
           <a:p>
             <a:pPr>
+              <a:lnSpc>
+                <a:spcPct val="102000"/>
+              </a:lnSpc>
               <a:spcAft>
-                <a:spcPts val="420"/>
+                <a:spcPts val="500"/>
               </a:spcAft>
             </a:pPr>
             <a:r>
-              <a:rPr sz="850" b="0">
-                <a:solidFill>
-                  <a:srgbClr val="141414"/>
+              <a:rPr sz="1600" b="0">
+                <a:solidFill>
+                  <a:srgbClr val="0A0A0A"/>
                 </a:solidFill>
                 <a:latin typeface="Arial"/>
               </a:rPr>
-              <a:t>Genel e-ticaret platformları öğrenciler için güven ve kampüs içi erişim problemini tam çözmemektedir.</a:t>
+              <a:t>Genel e-ticaret platformları öğrenciler için güven, yerellik ve erişim problemini tam çözmemektedir.</a:t>
             </a:r>
           </a:p>
           <a:p>
             <a:pPr>
+              <a:lnSpc>
+                <a:spcPct val="102000"/>
+              </a:lnSpc>
               <a:spcAft>
-                <a:spcPts val="420"/>
+                <a:spcPts val="500"/>
               </a:spcAft>
             </a:pPr>
             <a:r>
-              <a:rPr sz="850" b="0">
-                <a:solidFill>
-                  <a:srgbClr val="141414"/>
+              <a:rPr sz="1600" b="0">
+                <a:solidFill>
+                  <a:srgbClr val="0A0A0A"/>
                 </a:solidFill>
                 <a:latin typeface="Arial"/>
               </a:rPr>
-              <a:t>Bu projede amaç; sadece PAÜ öğrencilerine açık, doğrulanmış, moderasyon destekli ve kullanıcı davranışlarından öğrenebilen bir pazar yeri geliştirmektir.</a:t>
+              <a:t>Bu projede amaç; sadece PAÜ öğrencilerine açık, doğrulanmış, moderasyon destekli ve öneri sistemiyle kişiselleşen bir kampüs pazarı geliştirmektir.</a:t>
             </a:r>
           </a:p>
           <a:p>
             <a:pPr>
+              <a:lnSpc>
+                <a:spcPct val="102000"/>
+              </a:lnSpc>
               <a:spcAft>
-                <a:spcPts val="420"/>
+                <a:spcPts val="500"/>
               </a:spcAft>
             </a:pPr>
             <a:r>
-              <a:rPr sz="850" b="0">
-                <a:solidFill>
-                  <a:srgbClr val="141414"/>
+              <a:rPr sz="1600" b="0">
+                <a:solidFill>
+                  <a:srgbClr val="0A0A0A"/>
                 </a:solidFill>
                 <a:latin typeface="Arial"/>
               </a:rPr>
-              <a:t>Platformun ana hedefleri: güvenli kullanıcı doğrulama, ilan yönetimi, mesajlaşma, anlaşma/satış kaydı ve kişiselleştirilmiş önerilerdir.</a:t>
+              <a:t>Platform güvenli kullanıcı doğrulama, ilan yönetimi, mesajlaşma, anlaşma/satış kaydı ve satıcı değerlendirme süreçlerini tek sistemde toplar.</a:t>
             </a:r>
           </a:p>
         </p:txBody>
@@ -4102,14 +4120,14 @@
         </p:nvSpPr>
         <p:spPr>
           <a:xfrm>
-            <a:off x="1481328" y="13030200"/>
-            <a:ext cx="8778240" cy="4160520"/>
+            <a:off x="1332000" y="13050000"/>
+            <a:ext cx="9072000" cy="4464000"/>
           </a:xfrm>
           <a:prstGeom prst="rect">
             <a:avLst/>
           </a:prstGeom>
           <a:solidFill>
-            <a:srgbClr val="EFEFEF"/>
+            <a:srgbClr val="F1F1F1"/>
           </a:solidFill>
           <a:ln w="7620">
             <a:solidFill>
@@ -4147,18 +4165,18 @@
         </p:nvSpPr>
         <p:spPr>
           <a:xfrm>
-            <a:off x="1481328" y="13030200"/>
-            <a:ext cx="8778240" cy="411480"/>
+            <a:off x="1332000" y="13050000"/>
+            <a:ext cx="9072000" cy="424800"/>
           </a:xfrm>
           <a:prstGeom prst="rect">
             <a:avLst/>
           </a:prstGeom>
           <a:solidFill>
-            <a:srgbClr val="1F4E79"/>
+            <a:srgbClr val="205280"/>
           </a:solidFill>
           <a:ln w="5080">
             <a:solidFill>
-              <a:srgbClr val="1F4E79"/>
+              <a:srgbClr val="205280"/>
             </a:solidFill>
           </a:ln>
         </p:spPr>
@@ -4192,8 +4210,8 @@
         </p:nvSpPr>
         <p:spPr>
           <a:xfrm>
-            <a:off x="1527048" y="13098780"/>
-            <a:ext cx="8686800" cy="256032"/>
+            <a:off x="1386000" y="13114800"/>
+            <a:ext cx="8964000" cy="251999"/>
           </a:xfrm>
           <a:prstGeom prst="rect">
             <a:avLst/>
@@ -4208,13 +4226,13 @@
           <a:p>
             <a:pPr algn="ctr"/>
             <a:r>
-              <a:rPr sz="1300" b="1">
+              <a:rPr sz="2200" b="1">
                 <a:solidFill>
                   <a:srgbClr val="FFFFFF"/>
                 </a:solidFill>
                 <a:latin typeface="Arial"/>
               </a:rPr>
-              <a:t>Kullanılan Teknolojiler</a:t>
+              <a:t>Sistem Mimarisi ve Teknolojiler</a:t>
             </a:r>
           </a:p>
         </p:txBody>
@@ -4227,8 +4245,8 @@
         </p:nvSpPr>
         <p:spPr>
           <a:xfrm>
-            <a:off x="1618488" y="13597128"/>
-            <a:ext cx="8503919" cy="3474720"/>
+            <a:off x="1450800" y="13572000"/>
+            <a:ext cx="8834400" cy="3870000"/>
           </a:xfrm>
           <a:prstGeom prst="rect">
             <a:avLst/>
@@ -4236,88 +4254,103 @@
           <a:noFill/>
         </p:spPr>
         <p:txBody>
-          <a:bodyPr wrap="square" lIns="36576" rIns="36576" tIns="18288">
+          <a:bodyPr wrap="square" lIns="50400" rIns="43200" tIns="18000">
             <a:spAutoFit/>
           </a:bodyPr>
           <a:lstStyle/>
           <a:p>
             <a:pPr>
+              <a:lnSpc>
+                <a:spcPct val="102000"/>
+              </a:lnSpc>
               <a:spcAft>
-                <a:spcPts val="420"/>
+                <a:spcPts val="500"/>
               </a:spcAft>
             </a:pPr>
             <a:r>
-              <a:rPr sz="825" b="0">
-                <a:solidFill>
-                  <a:srgbClr val="141414"/>
+              <a:rPr sz="1580" b="0">
+                <a:solidFill>
+                  <a:srgbClr val="0A0A0A"/>
                 </a:solidFill>
                 <a:latin typeface="Arial"/>
               </a:rPr>
-              <a:t>Frontend: React + Vite ile responsive kullanıcı arayüzü.</a:t>
+              <a:t>• Frontend: React + Vite ile responsive kullanıcı arayüzü.</a:t>
             </a:r>
           </a:p>
           <a:p>
             <a:pPr>
+              <a:lnSpc>
+                <a:spcPct val="102000"/>
+              </a:lnSpc>
               <a:spcAft>
-                <a:spcPts val="420"/>
+                <a:spcPts val="500"/>
               </a:spcAft>
             </a:pPr>
             <a:r>
-              <a:rPr sz="825" b="0">
-                <a:solidFill>
-                  <a:srgbClr val="141414"/>
+              <a:rPr sz="1580" b="0">
+                <a:solidFill>
+                  <a:srgbClr val="0A0A0A"/>
                 </a:solidFill>
                 <a:latin typeface="Arial"/>
               </a:rPr>
-              <a:t>Backend: ASP.NET Core Web API, JWT tabanlı kimlik doğrulama ve servis katmanı.</a:t>
+              <a:t>• Backend: ASP.NET Core Web API, JWT kimlik doğrulama, servis katmanı ve DTO yapısı.</a:t>
             </a:r>
           </a:p>
           <a:p>
             <a:pPr>
+              <a:lnSpc>
+                <a:spcPct val="102000"/>
+              </a:lnSpc>
               <a:spcAft>
-                <a:spcPts val="420"/>
+                <a:spcPts val="500"/>
               </a:spcAft>
             </a:pPr>
             <a:r>
-              <a:rPr sz="825" b="0">
-                <a:solidFill>
-                  <a:srgbClr val="141414"/>
+              <a:rPr sz="1580" b="0">
+                <a:solidFill>
+                  <a:srgbClr val="0A0A0A"/>
                 </a:solidFill>
                 <a:latin typeface="Arial"/>
               </a:rPr>
-              <a:t>Veritabanı: MSSQL + Entity Framework Core.</a:t>
+              <a:t>• Veritabanı: MSSQL + Entity Framework Core.</a:t>
             </a:r>
           </a:p>
           <a:p>
             <a:pPr>
+              <a:lnSpc>
+                <a:spcPct val="102000"/>
+              </a:lnSpc>
               <a:spcAft>
-                <a:spcPts val="420"/>
+                <a:spcPts val="500"/>
               </a:spcAft>
             </a:pPr>
             <a:r>
-              <a:rPr sz="825" b="0">
-                <a:solidFill>
-                  <a:srgbClr val="141414"/>
+              <a:rPr sz="1580" b="0">
+                <a:solidFill>
+                  <a:srgbClr val="0A0A0A"/>
                 </a:solidFill>
                 <a:latin typeface="Arial"/>
               </a:rPr>
-              <a:t>Öneri Servisi: Python + FastAPI mikroservisi.</a:t>
+              <a:t>• Öneri Servisi: Python + FastAPI mikroservisi.</a:t>
             </a:r>
           </a:p>
           <a:p>
             <a:pPr>
+              <a:lnSpc>
+                <a:spcPct val="102000"/>
+              </a:lnSpc>
               <a:spcAft>
-                <a:spcPts val="420"/>
+                <a:spcPts val="500"/>
               </a:spcAft>
             </a:pPr>
             <a:r>
-              <a:rPr sz="825" b="0">
-                <a:solidFill>
-                  <a:srgbClr val="141414"/>
+              <a:rPr sz="1580" b="0">
+                <a:solidFill>
+                  <a:srgbClr val="0A0A0A"/>
                 </a:solidFill>
                 <a:latin typeface="Arial"/>
               </a:rPr>
-              <a:t>DevOps: Docker Compose ile frontend, backend, SQL ve recommender servisleri birlikte çalıştırılır.</a:t>
+              <a:t>• DevOps: Docker Compose ile frontend, backend, SQL ve recommender birlikte çalıştırılır.</a:t>
             </a:r>
           </a:p>
         </p:txBody>
@@ -4330,14 +4363,14 @@
         </p:nvSpPr>
         <p:spPr>
           <a:xfrm>
-            <a:off x="1481328" y="17510760"/>
-            <a:ext cx="8778240" cy="4617720"/>
+            <a:off x="1332000" y="17838000"/>
+            <a:ext cx="9072000" cy="4500000"/>
           </a:xfrm>
           <a:prstGeom prst="rect">
             <a:avLst/>
           </a:prstGeom>
           <a:solidFill>
-            <a:srgbClr val="EFEFEF"/>
+            <a:srgbClr val="F1F1F1"/>
           </a:solidFill>
           <a:ln w="7620">
             <a:solidFill>
@@ -4375,18 +4408,18 @@
         </p:nvSpPr>
         <p:spPr>
           <a:xfrm>
-            <a:off x="1481328" y="17510760"/>
-            <a:ext cx="8778240" cy="411480"/>
+            <a:off x="1332000" y="17838000"/>
+            <a:ext cx="9072000" cy="424800"/>
           </a:xfrm>
           <a:prstGeom prst="rect">
             <a:avLst/>
           </a:prstGeom>
           <a:solidFill>
-            <a:srgbClr val="1F4E79"/>
+            <a:srgbClr val="205280"/>
           </a:solidFill>
           <a:ln w="5080">
             <a:solidFill>
-              <a:srgbClr val="1F4E79"/>
+              <a:srgbClr val="205280"/>
             </a:solidFill>
           </a:ln>
         </p:spPr>
@@ -4420,8 +4453,8 @@
         </p:nvSpPr>
         <p:spPr>
           <a:xfrm>
-            <a:off x="1527048" y="17579339"/>
-            <a:ext cx="8686800" cy="256032"/>
+            <a:off x="1386000" y="17902800"/>
+            <a:ext cx="8964000" cy="251999"/>
           </a:xfrm>
           <a:prstGeom prst="rect">
             <a:avLst/>
@@ -4436,13 +4469,13 @@
           <a:p>
             <a:pPr algn="ctr"/>
             <a:r>
-              <a:rPr sz="1300" b="1">
+              <a:rPr sz="2200" b="1">
                 <a:solidFill>
                   <a:srgbClr val="FFFFFF"/>
                 </a:solidFill>
                 <a:latin typeface="Arial"/>
               </a:rPr>
-              <a:t>Sistem Mimarisi</a:t>
+              <a:t>Platform Özellikleri</a:t>
             </a:r>
           </a:p>
         </p:txBody>
@@ -4455,8 +4488,8 @@
         </p:nvSpPr>
         <p:spPr>
           <a:xfrm>
-            <a:off x="1618488" y="18077688"/>
-            <a:ext cx="8503919" cy="3931920"/>
+            <a:off x="1450800" y="18360000"/>
+            <a:ext cx="8834400" cy="3906000"/>
           </a:xfrm>
           <a:prstGeom prst="rect">
             <a:avLst/>
@@ -4464,72 +4497,103 @@
           <a:noFill/>
         </p:spPr>
         <p:txBody>
-          <a:bodyPr wrap="square" lIns="36576" rIns="36576" tIns="18288">
+          <a:bodyPr wrap="square" lIns="50400" rIns="43200" tIns="18000">
             <a:spAutoFit/>
           </a:bodyPr>
           <a:lstStyle/>
           <a:p>
             <a:pPr>
+              <a:lnSpc>
+                <a:spcPct val="102000"/>
+              </a:lnSpc>
               <a:spcAft>
-                <a:spcPts val="420"/>
+                <a:spcPts val="500"/>
               </a:spcAft>
             </a:pPr>
             <a:r>
-              <a:rPr sz="825" b="0">
-                <a:solidFill>
-                  <a:srgbClr val="141414"/>
+              <a:rPr sz="1600" b="0">
+                <a:solidFill>
+                  <a:srgbClr val="0A0A0A"/>
                 </a:solidFill>
                 <a:latin typeface="Arial"/>
               </a:rPr>
-              <a:t>Kullanıcı davranışları frontend üzerinden backend'e iletilir ve Interaction tablosuna kaydedilir.</a:t>
+              <a:t>• PAÜ e-posta doğrulamalı kayıt, giriş ve şifre sıfırlama</a:t>
             </a:r>
           </a:p>
           <a:p>
             <a:pPr>
+              <a:lnSpc>
+                <a:spcPct val="102000"/>
+              </a:lnSpc>
               <a:spcAft>
-                <a:spcPts val="420"/>
+                <a:spcPts val="500"/>
               </a:spcAft>
             </a:pPr>
             <a:r>
-              <a:rPr sz="825" b="0">
-                <a:solidFill>
-                  <a:srgbClr val="141414"/>
+              <a:rPr sz="1600" b="0">
+                <a:solidFill>
+                  <a:srgbClr val="0A0A0A"/>
                 </a:solidFill>
                 <a:latin typeface="Arial"/>
               </a:rPr>
-              <a:t>Backend; ilan, kullanıcı, mesaj, favori, anlaşma ve satış süreçlerini yönetir.</a:t>
+              <a:t>• Çoklu fotoğraflı ilan oluşturma ve kapak görseli sıralama</a:t>
             </a:r>
           </a:p>
           <a:p>
             <a:pPr>
+              <a:lnSpc>
+                <a:spcPct val="102000"/>
+              </a:lnSpc>
               <a:spcAft>
-                <a:spcPts val="420"/>
+                <a:spcPts val="500"/>
               </a:spcAft>
             </a:pPr>
             <a:r>
-              <a:rPr sz="825" b="0">
-                <a:solidFill>
-                  <a:srgbClr val="141414"/>
+              <a:rPr sz="1600" b="0">
+                <a:solidFill>
+                  <a:srgbClr val="0A0A0A"/>
                 </a:solidFill>
                 <a:latin typeface="Arial"/>
               </a:rPr>
-              <a:t>Recommender servisi eğitim sırasında PAÜ Market etkileşim export'unu kullanır; öneri sırasında backend'e gerçek Listing.Id değerleri döner.</a:t>
+              <a:t>• Favori, güvenli mesajlaşma ve anlaşma isteği</a:t>
             </a:r>
           </a:p>
           <a:p>
             <a:pPr>
+              <a:lnSpc>
+                <a:spcPct val="102000"/>
+              </a:lnSpc>
               <a:spcAft>
-                <a:spcPts val="420"/>
+                <a:spcPts val="500"/>
               </a:spcAft>
             </a:pPr>
             <a:r>
-              <a:rPr sz="825" b="0">
-                <a:solidFill>
-                  <a:srgbClr val="141414"/>
+              <a:rPr sz="1600" b="0">
+                <a:solidFill>
+                  <a:srgbClr val="0A0A0A"/>
                 </a:solidFill>
                 <a:latin typeface="Arial"/>
               </a:rPr>
-              <a:t>Backend önerileri tekrar doğrular: onaylı, aktif, satılmamış ve gösterilebilir ilanlar kullanıcıya sunulur.</a:t>
+              <a:t>• Satıldı akışı, alıcı kaydı ve satıcı değerlendirme</a:t>
+            </a:r>
+          </a:p>
+          <a:p>
+            <a:pPr>
+              <a:lnSpc>
+                <a:spcPct val="102000"/>
+              </a:lnSpc>
+              <a:spcAft>
+                <a:spcPts val="500"/>
+              </a:spcAft>
+            </a:pPr>
+            <a:r>
+              <a:rPr sz="1600" b="0">
+                <a:solidFill>
+                  <a:srgbClr val="0A0A0A"/>
+                </a:solidFill>
+                <a:latin typeface="Arial"/>
+              </a:rPr>
+              <a:t>• Admin paneli ve ilan moderasyonu</a:t>
             </a:r>
           </a:p>
         </p:txBody>
@@ -4542,14 +4606,14 @@
         </p:nvSpPr>
         <p:spPr>
           <a:xfrm>
-            <a:off x="1481328" y="22448519"/>
-            <a:ext cx="8778240" cy="4434840"/>
+            <a:off x="11016000" y="4842000"/>
+            <a:ext cx="9072000" cy="4752000"/>
           </a:xfrm>
           <a:prstGeom prst="rect">
             <a:avLst/>
           </a:prstGeom>
           <a:solidFill>
-            <a:srgbClr val="EFEFEF"/>
+            <a:srgbClr val="F1F1F1"/>
           </a:solidFill>
           <a:ln w="7620">
             <a:solidFill>
@@ -4587,18 +4651,18 @@
         </p:nvSpPr>
         <p:spPr>
           <a:xfrm>
-            <a:off x="1481328" y="22448519"/>
-            <a:ext cx="8778240" cy="411480"/>
+            <a:off x="11016000" y="4842000"/>
+            <a:ext cx="9072000" cy="424800"/>
           </a:xfrm>
           <a:prstGeom prst="rect">
             <a:avLst/>
           </a:prstGeom>
           <a:solidFill>
-            <a:srgbClr val="1F4E79"/>
+            <a:srgbClr val="205280"/>
           </a:solidFill>
           <a:ln w="5080">
             <a:solidFill>
-              <a:srgbClr val="1F4E79"/>
+              <a:srgbClr val="205280"/>
             </a:solidFill>
           </a:ln>
         </p:spPr>
@@ -4632,8 +4696,8 @@
         </p:nvSpPr>
         <p:spPr>
           <a:xfrm>
-            <a:off x="1527048" y="22517099"/>
-            <a:ext cx="8686800" cy="256032"/>
+            <a:off x="11069999" y="4906800"/>
+            <a:ext cx="8964000" cy="251999"/>
           </a:xfrm>
           <a:prstGeom prst="rect">
             <a:avLst/>
@@ -4648,13 +4712,13 @@
           <a:p>
             <a:pPr algn="ctr"/>
             <a:r>
-              <a:rPr sz="1300" b="1">
+              <a:rPr sz="2200" b="1">
                 <a:solidFill>
                   <a:srgbClr val="FFFFFF"/>
                 </a:solidFill>
                 <a:latin typeface="Arial"/>
               </a:rPr>
-              <a:t>Platform Özellikleri</a:t>
+              <a:t>Öneri Sistemi</a:t>
             </a:r>
           </a:p>
         </p:txBody>
@@ -4667,8 +4731,8 @@
         </p:nvSpPr>
         <p:spPr>
           <a:xfrm>
-            <a:off x="1618488" y="23015448"/>
-            <a:ext cx="8503919" cy="3749039"/>
+            <a:off x="11134799" y="5363999"/>
+            <a:ext cx="8834400" cy="4157999"/>
           </a:xfrm>
           <a:prstGeom prst="rect">
             <a:avLst/>
@@ -4676,104 +4740,84 @@
           <a:noFill/>
         </p:spPr>
         <p:txBody>
-          <a:bodyPr wrap="square" lIns="36576" rIns="36576" tIns="18288">
+          <a:bodyPr wrap="square" lIns="50400" rIns="43200" tIns="18000">
             <a:spAutoFit/>
           </a:bodyPr>
           <a:lstStyle/>
           <a:p>
             <a:pPr>
+              <a:lnSpc>
+                <a:spcPct val="102000"/>
+              </a:lnSpc>
               <a:spcAft>
-                <a:spcPts val="420"/>
+                <a:spcPts val="500"/>
               </a:spcAft>
             </a:pPr>
             <a:r>
-              <a:rPr sz="840" b="0">
-                <a:solidFill>
-                  <a:srgbClr val="141414"/>
+              <a:rPr sz="1590" b="0">
+                <a:solidFill>
+                  <a:srgbClr val="0A0A0A"/>
                 </a:solidFill>
                 <a:latin typeface="Arial"/>
               </a:rPr>
-              <a:t>• PAÜ e-posta doğrulamalı kayıt ve giriş</a:t>
+              <a:t>Öneri sistemi, kullanıcı-ilan etkileşimlerini implicit feedback olarak yorumlar.</a:t>
             </a:r>
           </a:p>
           <a:p>
             <a:pPr>
+              <a:lnSpc>
+                <a:spcPct val="102000"/>
+              </a:lnSpc>
               <a:spcAft>
-                <a:spcPts val="420"/>
+                <a:spcPts val="500"/>
               </a:spcAft>
             </a:pPr>
             <a:r>
-              <a:rPr sz="840" b="0">
-                <a:solidFill>
-                  <a:srgbClr val="141414"/>
+              <a:rPr sz="1590" b="0">
+                <a:solidFill>
+                  <a:srgbClr val="0A0A0A"/>
                 </a:solidFill>
                 <a:latin typeface="Arial"/>
               </a:rPr>
-              <a:t>• Şifre sıfırlama ve profil yönetimi</a:t>
+              <a:t>Etkileşim ağırlıkları: görüntüleme=1.0, mesaj=2.0, favori=3.0, anlaşma isteği=4.0, kabul=4.5, satın alma/satıldı=5.0.</a:t>
             </a:r>
           </a:p>
           <a:p>
             <a:pPr>
+              <a:lnSpc>
+                <a:spcPct val="102000"/>
+              </a:lnSpc>
               <a:spcAft>
-                <a:spcPts val="420"/>
+                <a:spcPts val="500"/>
               </a:spcAft>
             </a:pPr>
             <a:r>
-              <a:rPr sz="840" b="0">
-                <a:solidFill>
-                  <a:srgbClr val="141414"/>
+              <a:rPr sz="1590" b="0">
+                <a:solidFill>
+                  <a:srgbClr val="0A0A0A"/>
                 </a:solidFill>
                 <a:latin typeface="Arial"/>
               </a:rPr>
-              <a:t>• Çoklu fotoğraflı ilan oluşturma</a:t>
+              <a:t>Matris yapısı R[u, i] biçimindedir; satırlar kullanıcıları, sütunlar ilanları, hücreler ilgi gücünü temsil eder.</a:t>
             </a:r>
           </a:p>
           <a:p>
             <a:pPr>
+              <a:lnSpc>
+                <a:spcPct val="102000"/>
+              </a:lnSpc>
               <a:spcAft>
-                <a:spcPts val="420"/>
+                <a:spcPts val="500"/>
               </a:spcAft>
             </a:pPr>
             <a:r>
-              <a:rPr sz="840" b="0">
-                <a:solidFill>
-                  <a:srgbClr val="141414"/>
+              <a:rPr sz="1590" b="0">
+                <a:solidFill>
+                  <a:srgbClr val="0A0A0A"/>
                 </a:solidFill>
                 <a:latin typeface="Arial"/>
               </a:rPr>
-              <a:t>• Favori, mesajlaşma ve anlaşma isteği</a:t>
-            </a:r>
-          </a:p>
-          <a:p>
-            <a:pPr>
-              <a:spcAft>
-                <a:spcPts val="420"/>
-              </a:spcAft>
-            </a:pPr>
-            <a:r>
-              <a:rPr sz="840" b="0">
-                <a:solidFill>
-                  <a:srgbClr val="141414"/>
-                </a:solidFill>
-                <a:latin typeface="Arial"/>
-              </a:rPr>
-              <a:t>• Satıldı akışı, alıcı kaydı ve satıcı değerlendirme</a:t>
-            </a:r>
-          </a:p>
-          <a:p>
-            <a:pPr>
-              <a:spcAft>
-                <a:spcPts val="420"/>
-              </a:spcAft>
-            </a:pPr>
-            <a:r>
-              <a:rPr sz="840" b="0">
-                <a:solidFill>
-                  <a:srgbClr val="141414"/>
-                </a:solidFill>
-                <a:latin typeface="Arial"/>
-              </a:rPr>
-              <a:t>• Admin paneli ve ilan moderasyonu</a:t>
+              <a:t>LightFM tabanlı hibrit yaklaşım collaborative sinyalleri kategori/içerik özellikleriyle birleştirir.</a:t>
             </a:r>
           </a:p>
         </p:txBody>
@@ -4786,14 +4830,14 @@
         </p:nvSpPr>
         <p:spPr>
           <a:xfrm>
-            <a:off x="10954512" y="4892040"/>
-            <a:ext cx="8778240" cy="5532120"/>
+            <a:off x="11016000" y="9917999"/>
+            <a:ext cx="9072000" cy="4176000"/>
           </a:xfrm>
           <a:prstGeom prst="rect">
             <a:avLst/>
           </a:prstGeom>
           <a:solidFill>
-            <a:srgbClr val="EFEFEF"/>
+            <a:srgbClr val="F1F1F1"/>
           </a:solidFill>
           <a:ln w="7620">
             <a:solidFill>
@@ -4831,18 +4875,18 @@
         </p:nvSpPr>
         <p:spPr>
           <a:xfrm>
-            <a:off x="10954512" y="4892040"/>
-            <a:ext cx="8778240" cy="411480"/>
+            <a:off x="11016000" y="9917999"/>
+            <a:ext cx="9072000" cy="424800"/>
           </a:xfrm>
           <a:prstGeom prst="rect">
             <a:avLst/>
           </a:prstGeom>
           <a:solidFill>
-            <a:srgbClr val="1F4E79"/>
+            <a:srgbClr val="205280"/>
           </a:solidFill>
           <a:ln w="5080">
             <a:solidFill>
-              <a:srgbClr val="1F4E79"/>
+              <a:srgbClr val="205280"/>
             </a:solidFill>
           </a:ln>
         </p:spPr>
@@ -4876,8 +4920,8 @@
         </p:nvSpPr>
         <p:spPr>
           <a:xfrm>
-            <a:off x="11000232" y="4960620"/>
-            <a:ext cx="8686800" cy="256032"/>
+            <a:off x="11069999" y="9982799"/>
+            <a:ext cx="8964000" cy="251999"/>
           </a:xfrm>
           <a:prstGeom prst="rect">
             <a:avLst/>
@@ -4892,13 +4936,13 @@
           <a:p>
             <a:pPr algn="ctr"/>
             <a:r>
-              <a:rPr sz="1300" b="1">
+              <a:rPr sz="2200" b="1">
                 <a:solidFill>
                   <a:srgbClr val="FFFFFF"/>
                 </a:solidFill>
                 <a:latin typeface="Arial"/>
               </a:rPr>
-              <a:t>Öneri Sistemi</a:t>
+              <a:t>Pilot Veri Planı</a:t>
             </a:r>
           </a:p>
         </p:txBody>
@@ -4911,8 +4955,8 @@
         </p:nvSpPr>
         <p:spPr>
           <a:xfrm>
-            <a:off x="11091672" y="5458968"/>
-            <a:ext cx="8503919" cy="4846320"/>
+            <a:off x="11134799" y="10439999"/>
+            <a:ext cx="8834400" cy="3581999"/>
           </a:xfrm>
           <a:prstGeom prst="rect">
             <a:avLst/>
@@ -4920,72 +4964,84 @@
           <a:noFill/>
         </p:spPr>
         <p:txBody>
-          <a:bodyPr wrap="square" lIns="36576" rIns="36576" tIns="18288">
+          <a:bodyPr wrap="square" lIns="50400" rIns="43200" tIns="18000">
             <a:spAutoFit/>
           </a:bodyPr>
           <a:lstStyle/>
           <a:p>
             <a:pPr>
+              <a:lnSpc>
+                <a:spcPct val="102000"/>
+              </a:lnSpc>
               <a:spcAft>
-                <a:spcPts val="420"/>
+                <a:spcPts val="500"/>
               </a:spcAft>
             </a:pPr>
             <a:r>
-              <a:rPr sz="830" b="0">
-                <a:solidFill>
-                  <a:srgbClr val="141414"/>
+              <a:rPr sz="1590" b="0">
+                <a:solidFill>
+                  <a:srgbClr val="0A0A0A"/>
                 </a:solidFill>
                 <a:latin typeface="Arial"/>
               </a:rPr>
-              <a:t>Öneri sistemi, kullanıcı-ilan etkileşimlerini implicit feedback olarak yorumlar. Her davranış kullanıcı ilgisinin farklı seviyesini temsil eder.</a:t>
+              <a:t>Tez sunumu öncesinde küçük ölçekli gerçek kampüs pilotu yapılacaktır.</a:t>
             </a:r>
           </a:p>
           <a:p>
             <a:pPr>
+              <a:lnSpc>
+                <a:spcPct val="102000"/>
+              </a:lnSpc>
               <a:spcAft>
-                <a:spcPts val="420"/>
+                <a:spcPts val="500"/>
               </a:spcAft>
             </a:pPr>
             <a:r>
-              <a:rPr sz="830" b="0">
-                <a:solidFill>
-                  <a:srgbClr val="141414"/>
+              <a:rPr sz="1590" b="0">
+                <a:solidFill>
+                  <a:srgbClr val="0A0A0A"/>
                 </a:solidFill>
                 <a:latin typeface="Arial"/>
               </a:rPr>
-              <a:t>Etkileşim ağırlıkları: görüntüleme=1.0, mesaj=2.0, favori=3.0, anlaşma isteği=4.0, kabul=4.5, satın alma/satıldı=5.0.</a:t>
+              <a:t>Planlanan veri: 30-50 ilan, 10-20 PAÜ öğrencisi, kişi başı 10-20 etkileşim.</a:t>
             </a:r>
           </a:p>
           <a:p>
             <a:pPr>
+              <a:lnSpc>
+                <a:spcPct val="102000"/>
+              </a:lnSpc>
               <a:spcAft>
-                <a:spcPts val="420"/>
+                <a:spcPts val="500"/>
               </a:spcAft>
             </a:pPr>
             <a:r>
-              <a:rPr sz="830" b="0">
-                <a:solidFill>
-                  <a:srgbClr val="141414"/>
+              <a:rPr sz="1590" b="0">
+                <a:solidFill>
+                  <a:srgbClr val="0A0A0A"/>
                 </a:solidFill>
                 <a:latin typeface="Arial"/>
               </a:rPr>
-              <a:t>Matris yapısı R[u, i] şeklindedir: satırlar kullanıcıları, sütunlar ilanları, hücreler ise ilgi gücünü temsil eder.</a:t>
+              <a:t>Her kullanıcı kendi okul e-postasıyla giriş yapacak; görüntüleme, favori, mesaj ve anlaşma isteği davranışları toplanacaktır.</a:t>
             </a:r>
           </a:p>
           <a:p>
             <a:pPr>
+              <a:lnSpc>
+                <a:spcPct val="102000"/>
+              </a:lnSpc>
               <a:spcAft>
-                <a:spcPts val="420"/>
+                <a:spcPts val="500"/>
               </a:spcAft>
             </a:pPr>
             <a:r>
-              <a:rPr sz="830" b="0">
-                <a:solidFill>
-                  <a:srgbClr val="141414"/>
+              <a:rPr sz="1590" b="0">
+                <a:solidFill>
+                  <a:srgbClr val="0A0A0A"/>
                 </a:solidFill>
                 <a:latin typeface="Arial"/>
               </a:rPr>
-              <a:t>LightFM tabanlı hibrit yaklaşım collaborative sinyalleri kategori/içerik özellikleriyle birleştirir. Cold-start durumunda kategori, onboarding ve popüler/yeni ilan fallback'i kullanılır.</a:t>
+              <a:t>Amaç sentetik veri yerine gerçek öğrencilerden kontrollü ve açıklanabilir pilot veri elde etmektir.</a:t>
             </a:r>
           </a:p>
         </p:txBody>
@@ -4998,14 +5054,14 @@
         </p:nvSpPr>
         <p:spPr>
           <a:xfrm>
-            <a:off x="10954512" y="10744200"/>
-            <a:ext cx="8778240" cy="4160520"/>
+            <a:off x="11016000" y="14417999"/>
+            <a:ext cx="9072000" cy="3600000"/>
           </a:xfrm>
           <a:prstGeom prst="rect">
             <a:avLst/>
           </a:prstGeom>
           <a:solidFill>
-            <a:srgbClr val="EFEFEF"/>
+            <a:srgbClr val="F1F1F1"/>
           </a:solidFill>
           <a:ln w="7620">
             <a:solidFill>
@@ -5043,18 +5099,18 @@
         </p:nvSpPr>
         <p:spPr>
           <a:xfrm>
-            <a:off x="10954512" y="10744200"/>
-            <a:ext cx="8778240" cy="411480"/>
+            <a:off x="11016000" y="14417999"/>
+            <a:ext cx="9072000" cy="424800"/>
           </a:xfrm>
           <a:prstGeom prst="rect">
             <a:avLst/>
           </a:prstGeom>
           <a:solidFill>
-            <a:srgbClr val="1F4E79"/>
+            <a:srgbClr val="205280"/>
           </a:solidFill>
           <a:ln w="5080">
             <a:solidFill>
-              <a:srgbClr val="1F4E79"/>
+              <a:srgbClr val="205280"/>
             </a:solidFill>
           </a:ln>
         </p:spPr>
@@ -5088,8 +5144,8 @@
         </p:nvSpPr>
         <p:spPr>
           <a:xfrm>
-            <a:off x="11000232" y="10812780"/>
-            <a:ext cx="8686800" cy="256032"/>
+            <a:off x="11069999" y="14482799"/>
+            <a:ext cx="8964000" cy="251999"/>
           </a:xfrm>
           <a:prstGeom prst="rect">
             <a:avLst/>
@@ -5104,13 +5160,13 @@
           <a:p>
             <a:pPr algn="ctr"/>
             <a:r>
-              <a:rPr sz="1300" b="1">
+              <a:rPr sz="2200" b="1">
                 <a:solidFill>
                   <a:srgbClr val="FFFFFF"/>
                 </a:solidFill>
                 <a:latin typeface="Arial"/>
               </a:rPr>
-              <a:t>Pilot Veri Planı</a:t>
+              <a:t>Değerlendirme Yaklaşımı</a:t>
             </a:r>
           </a:p>
         </p:txBody>
@@ -5123,8 +5179,8 @@
         </p:nvSpPr>
         <p:spPr>
           <a:xfrm>
-            <a:off x="11091672" y="11311128"/>
-            <a:ext cx="8503919" cy="3474720"/>
+            <a:off x="11134799" y="14940000"/>
+            <a:ext cx="8834400" cy="3006000"/>
           </a:xfrm>
           <a:prstGeom prst="rect">
             <a:avLst/>
@@ -5132,232 +5188,23 @@
           <a:noFill/>
         </p:spPr>
         <p:txBody>
-          <a:bodyPr wrap="square" lIns="36576" rIns="36576" tIns="18288">
+          <a:bodyPr wrap="square" lIns="50400" rIns="43200" tIns="18000">
             <a:spAutoFit/>
           </a:bodyPr>
           <a:lstStyle/>
           <a:p>
             <a:pPr>
+              <a:lnSpc>
+                <a:spcPct val="102000"/>
+              </a:lnSpc>
               <a:spcAft>
-                <a:spcPts val="420"/>
+                <a:spcPts val="500"/>
               </a:spcAft>
             </a:pPr>
             <a:r>
-              <a:rPr sz="819" b="0">
-                <a:solidFill>
-                  <a:srgbClr val="141414"/>
-                </a:solidFill>
-                <a:latin typeface="Arial"/>
-              </a:rPr>
-              <a:t>Tez sunumu öncesinde küçük ölçekli gerçek kampüs pilotu yapılacaktır.</a:t>
-            </a:r>
-          </a:p>
-          <a:p>
-            <a:pPr>
-              <a:spcAft>
-                <a:spcPts val="420"/>
-              </a:spcAft>
-            </a:pPr>
-            <a:r>
-              <a:rPr sz="819" b="0">
-                <a:solidFill>
-                  <a:srgbClr val="141414"/>
-                </a:solidFill>
-                <a:latin typeface="Arial"/>
-              </a:rPr>
-              <a:t>Planlanan veri: 30-50 ilan, 10-20 PAÜ öğrencisi, kişi başı 10-20 etkileşim.</a:t>
-            </a:r>
-          </a:p>
-          <a:p>
-            <a:pPr>
-              <a:spcAft>
-                <a:spcPts val="420"/>
-              </a:spcAft>
-            </a:pPr>
-            <a:r>
-              <a:rPr sz="819" b="0">
-                <a:solidFill>
-                  <a:srgbClr val="141414"/>
-                </a:solidFill>
-                <a:latin typeface="Arial"/>
-              </a:rPr>
-              <a:t>Her kullanıcı kendi okul e-postasıyla giriş yapacak; ilan görüntüleme, favori, mesaj ve anlaşma isteği gibi gerçek davranışlar bırakacaktır.</a:t>
-            </a:r>
-          </a:p>
-          <a:p>
-            <a:pPr>
-              <a:spcAft>
-                <a:spcPts val="420"/>
-              </a:spcAft>
-            </a:pPr>
-            <a:r>
-              <a:rPr sz="819" b="0">
-                <a:solidFill>
-                  <a:srgbClr val="141414"/>
-                </a:solidFill>
-                <a:latin typeface="Arial"/>
-              </a:rPr>
-              <a:t>Amaç sentetik veri üretmek değil, gerçek öğrencilerden kontrollü ve açıklanabilir pilot veri toplamaktır.</a:t>
-            </a:r>
-          </a:p>
-        </p:txBody>
-      </p:sp>
-      <p:sp>
-        <p:nvSpPr>
-          <p:cNvPr id="45" name="Rectangle 44"/>
-          <p:cNvSpPr/>
-          <p:nvPr/>
-        </p:nvSpPr>
-        <p:spPr>
-          <a:xfrm>
-            <a:off x="10954512" y="15224759"/>
-            <a:ext cx="8778240" cy="3429000"/>
-          </a:xfrm>
-          <a:prstGeom prst="rect">
-            <a:avLst/>
-          </a:prstGeom>
-          <a:solidFill>
-            <a:srgbClr val="EFEFEF"/>
-          </a:solidFill>
-          <a:ln w="7620">
-            <a:solidFill>
-              <a:srgbClr val="8EA9DB"/>
-            </a:solidFill>
-          </a:ln>
-        </p:spPr>
-        <p:style>
-          <a:lnRef idx="1">
-            <a:schemeClr val="accent1"/>
-          </a:lnRef>
-          <a:fillRef idx="3">
-            <a:schemeClr val="accent1"/>
-          </a:fillRef>
-          <a:effectRef idx="2">
-            <a:schemeClr val="accent1"/>
-          </a:effectRef>
-          <a:fontRef idx="minor">
-            <a:schemeClr val="lt1"/>
-          </a:fontRef>
-        </p:style>
-        <p:txBody>
-          <a:bodyPr rtlCol="0" anchor="ctr"/>
-          <a:lstStyle/>
-          <a:p>
-            <a:pPr algn="ctr"/>
-          </a:p>
-        </p:txBody>
-      </p:sp>
-      <p:sp>
-        <p:nvSpPr>
-          <p:cNvPr id="46" name="Rectangle 45"/>
-          <p:cNvSpPr/>
-          <p:nvPr/>
-        </p:nvSpPr>
-        <p:spPr>
-          <a:xfrm>
-            <a:off x="10954512" y="15224759"/>
-            <a:ext cx="8778240" cy="411480"/>
-          </a:xfrm>
-          <a:prstGeom prst="rect">
-            <a:avLst/>
-          </a:prstGeom>
-          <a:solidFill>
-            <a:srgbClr val="1F4E79"/>
-          </a:solidFill>
-          <a:ln w="5080">
-            <a:solidFill>
-              <a:srgbClr val="1F4E79"/>
-            </a:solidFill>
-          </a:ln>
-        </p:spPr>
-        <p:style>
-          <a:lnRef idx="1">
-            <a:schemeClr val="accent1"/>
-          </a:lnRef>
-          <a:fillRef idx="3">
-            <a:schemeClr val="accent1"/>
-          </a:fillRef>
-          <a:effectRef idx="2">
-            <a:schemeClr val="accent1"/>
-          </a:effectRef>
-          <a:fontRef idx="minor">
-            <a:schemeClr val="lt1"/>
-          </a:fontRef>
-        </p:style>
-        <p:txBody>
-          <a:bodyPr rtlCol="0" anchor="ctr"/>
-          <a:lstStyle/>
-          <a:p>
-            <a:pPr algn="ctr"/>
-          </a:p>
-        </p:txBody>
-      </p:sp>
-      <p:sp>
-        <p:nvSpPr>
-          <p:cNvPr id="47" name="TextBox 46"/>
-          <p:cNvSpPr txBox="1"/>
-          <p:nvPr/>
-        </p:nvSpPr>
-        <p:spPr>
-          <a:xfrm>
-            <a:off x="11000232" y="15293339"/>
-            <a:ext cx="8686800" cy="256032"/>
-          </a:xfrm>
-          <a:prstGeom prst="rect">
-            <a:avLst/>
-          </a:prstGeom>
-          <a:noFill/>
-        </p:spPr>
-        <p:txBody>
-          <a:bodyPr wrap="square" anchor="t">
-            <a:spAutoFit/>
-          </a:bodyPr>
-          <a:lstStyle/>
-          <a:p>
-            <a:pPr algn="ctr"/>
-            <a:r>
-              <a:rPr sz="1300" b="1">
-                <a:solidFill>
-                  <a:srgbClr val="FFFFFF"/>
-                </a:solidFill>
-                <a:latin typeface="Arial"/>
-              </a:rPr>
-              <a:t>Değerlendirme Yaklaşımı</a:t>
-            </a:r>
-          </a:p>
-        </p:txBody>
-      </p:sp>
-      <p:sp>
-        <p:nvSpPr>
-          <p:cNvPr id="48" name="TextBox 47"/>
-          <p:cNvSpPr txBox="1"/>
-          <p:nvPr/>
-        </p:nvSpPr>
-        <p:spPr>
-          <a:xfrm>
-            <a:off x="11091672" y="15791688"/>
-            <a:ext cx="8503919" cy="2743200"/>
-          </a:xfrm>
-          <a:prstGeom prst="rect">
-            <a:avLst/>
-          </a:prstGeom>
-          <a:noFill/>
-        </p:spPr>
-        <p:txBody>
-          <a:bodyPr wrap="square" lIns="36576" rIns="36576" tIns="18288">
-            <a:spAutoFit/>
-          </a:bodyPr>
-          <a:lstStyle/>
-          <a:p>
-            <a:pPr>
-              <a:spcAft>
-                <a:spcPts val="420"/>
-              </a:spcAft>
-            </a:pPr>
-            <a:r>
-              <a:rPr sz="825" b="0">
-                <a:solidFill>
-                  <a:srgbClr val="141414"/>
+              <a:rPr sz="1540" b="0">
+                <a:solidFill>
+                  <a:srgbClr val="0A0A0A"/>
                 </a:solidFill>
                 <a:latin typeface="Arial"/>
               </a:rPr>
@@ -5366,14 +5213,17 @@
           </a:p>
           <a:p>
             <a:pPr>
+              <a:lnSpc>
+                <a:spcPct val="102000"/>
+              </a:lnSpc>
               <a:spcAft>
-                <a:spcPts val="420"/>
+                <a:spcPts val="500"/>
               </a:spcAft>
             </a:pPr>
             <a:r>
-              <a:rPr sz="825" b="0">
-                <a:solidFill>
-                  <a:srgbClr val="141414"/>
+              <a:rPr sz="1540" b="0">
+                <a:solidFill>
+                  <a:srgbClr val="0A0A0A"/>
                 </a:solidFill>
                 <a:latin typeface="Arial"/>
               </a:rPr>
@@ -5382,33 +5232,36 @@
           </a:p>
           <a:p>
             <a:pPr>
+              <a:lnSpc>
+                <a:spcPct val="102000"/>
+              </a:lnSpc>
               <a:spcAft>
-                <a:spcPts val="420"/>
+                <a:spcPts val="500"/>
               </a:spcAft>
             </a:pPr>
             <a:r>
-              <a:rPr sz="825" b="0">
-                <a:solidFill>
-                  <a:srgbClr val="141414"/>
+              <a:rPr sz="1540" b="0">
+                <a:solidFill>
+                  <a:srgbClr val="0A0A0A"/>
                 </a:solidFill>
                 <a:latin typeface="Arial"/>
               </a:rPr>
-              <a:t>Pilot veri toplandıktan sonra model PAÜ Market verisiyle yeniden eğitilecek ve metrikler bu alana işlenecektir.</a:t>
+              <a:t>Pilot veri toplandıktan sonra model PAÜ Market verisiyle yeniden eğitilecek ve sonuçlar bu tabloya işlenecektir.</a:t>
             </a:r>
           </a:p>
         </p:txBody>
       </p:sp>
       <p:graphicFrame>
         <p:nvGraphicFramePr>
-          <p:cNvPr id="49" name="Table 48"/>
+          <p:cNvPr id="45" name="Table 44"/>
           <p:cNvGraphicFramePr>
             <a:graphicFrameLocks noGrp="1"/>
           </p:cNvGraphicFramePr>
           <p:nvPr/>
         </p:nvGraphicFramePr>
         <p:xfrm>
-          <a:off x="11137392" y="18882360"/>
-          <a:ext cx="8412478" cy="2743200"/>
+          <a:off x="11196000" y="18198000"/>
+          <a:ext cx="8712000" cy="2700000"/>
         </p:xfrm>
         <a:graphic>
           <a:graphicData uri="http://schemas.openxmlformats.org/drawingml/2006/table">
@@ -5417,18 +5270,18 @@
                 <a:tableStyleId>{5C22544A-7EE6-4342-B048-85BDC9FD1C3A}</a:tableStyleId>
               </a:tblPr>
               <a:tblGrid>
-                <a:gridCol w="3112617"/>
-                <a:gridCol w="1934870"/>
-                <a:gridCol w="3364991"/>
+                <a:gridCol w="3136320"/>
+                <a:gridCol w="2178000"/>
+                <a:gridCol w="3397680"/>
               </a:tblGrid>
-              <a:tr h="457200">
+              <a:tr h="450000">
                 <a:tc>
                   <a:txBody>
                     <a:bodyPr/>
                     <a:lstStyle/>
                     <a:p>
                       <a:r>
-                        <a:rPr sz="780" b="1">
+                        <a:rPr sz="1250" b="1">
                           <a:solidFill>
                             <a:srgbClr val="FFFFFF"/>
                           </a:solidFill>
@@ -5440,7 +5293,7 @@
                   </a:txBody>
                   <a:tcPr>
                     <a:solidFill>
-                      <a:srgbClr val="1F4E79"/>
+                      <a:srgbClr val="205280"/>
                     </a:solidFill>
                   </a:tcPr>
                 </a:tc>
@@ -5450,7 +5303,7 @@
                     <a:lstStyle/>
                     <a:p>
                       <a:r>
-                        <a:rPr sz="780" b="1">
+                        <a:rPr sz="1250" b="1">
                           <a:solidFill>
                             <a:srgbClr val="FFFFFF"/>
                           </a:solidFill>
@@ -5462,7 +5315,7 @@
                   </a:txBody>
                   <a:tcPr>
                     <a:solidFill>
-                      <a:srgbClr val="1F4E79"/>
+                      <a:srgbClr val="205280"/>
                     </a:solidFill>
                   </a:tcPr>
                 </a:tc>
@@ -5472,33 +5325,33 @@
                     <a:lstStyle/>
                     <a:p>
                       <a:r>
-                        <a:rPr sz="780" b="1">
+                        <a:rPr sz="1250" b="1">
                           <a:solidFill>
                             <a:srgbClr val="FFFFFF"/>
                           </a:solidFill>
                           <a:latin typeface="Arial"/>
                         </a:rPr>
-                        <a:t>Açıklama</a:t>
+                        <a:t>Anlamı</a:t>
                       </a:r>
                     </a:p>
                   </a:txBody>
                   <a:tcPr>
                     <a:solidFill>
-                      <a:srgbClr val="1F4E79"/>
+                      <a:srgbClr val="205280"/>
                     </a:solidFill>
                   </a:tcPr>
                 </a:tc>
               </a:tr>
-              <a:tr h="457200">
+              <a:tr h="450000">
                 <a:tc>
                   <a:txBody>
                     <a:bodyPr/>
                     <a:lstStyle/>
                     <a:p>
                       <a:r>
-                        <a:rPr sz="780" b="1">
+                        <a:rPr sz="1250" b="1">
                           <a:solidFill>
-                            <a:srgbClr val="141414"/>
+                            <a:srgbClr val="0A0A0A"/>
                           </a:solidFill>
                           <a:latin typeface="Arial"/>
                         </a:rPr>
@@ -5518,9 +5371,9 @@
                     <a:lstStyle/>
                     <a:p>
                       <a:r>
-                        <a:rPr sz="780" b="0">
+                        <a:rPr sz="1250" b="0">
                           <a:solidFill>
-                            <a:srgbClr val="141414"/>
+                            <a:srgbClr val="0A0A0A"/>
                           </a:solidFill>
                           <a:latin typeface="Arial"/>
                         </a:rPr>
@@ -5540,9 +5393,9 @@
                     <a:lstStyle/>
                     <a:p>
                       <a:r>
-                        <a:rPr sz="780" b="0">
+                        <a:rPr sz="1250" b="0">
                           <a:solidFill>
-                            <a:srgbClr val="141414"/>
+                            <a:srgbClr val="0A0A0A"/>
                           </a:solidFill>
                           <a:latin typeface="Arial"/>
                         </a:rPr>
@@ -5557,16 +5410,16 @@
                   </a:tcPr>
                 </a:tc>
               </a:tr>
-              <a:tr h="457200">
+              <a:tr h="450000">
                 <a:tc>
                   <a:txBody>
                     <a:bodyPr/>
                     <a:lstStyle/>
                     <a:p>
                       <a:r>
-                        <a:rPr sz="780" b="1">
+                        <a:rPr sz="1250" b="1">
                           <a:solidFill>
-                            <a:srgbClr val="141414"/>
+                            <a:srgbClr val="0A0A0A"/>
                           </a:solidFill>
                           <a:latin typeface="Arial"/>
                         </a:rPr>
@@ -5586,9 +5439,9 @@
                     <a:lstStyle/>
                     <a:p>
                       <a:r>
-                        <a:rPr sz="780" b="0">
+                        <a:rPr sz="1250" b="0">
                           <a:solidFill>
-                            <a:srgbClr val="141414"/>
+                            <a:srgbClr val="0A0A0A"/>
                           </a:solidFill>
                           <a:latin typeface="Arial"/>
                         </a:rPr>
@@ -5608,13 +5461,13 @@
                     <a:lstStyle/>
                     <a:p>
                       <a:r>
-                        <a:rPr sz="780" b="0">
+                        <a:rPr sz="1250" b="0">
                           <a:solidFill>
-                            <a:srgbClr val="141414"/>
+                            <a:srgbClr val="0A0A0A"/>
                           </a:solidFill>
                           <a:latin typeface="Arial"/>
                         </a:rPr>
-                        <a:t>İlk 5'te en az 1 doğru öneri</a:t>
+                        <a:t>İlk 5'te doğru öneri var mı?</a:t>
                       </a:r>
                     </a:p>
                   </a:txBody>
@@ -5625,16 +5478,16 @@
                   </a:tcPr>
                 </a:tc>
               </a:tr>
-              <a:tr h="457200">
+              <a:tr h="450000">
                 <a:tc>
                   <a:txBody>
                     <a:bodyPr/>
                     <a:lstStyle/>
                     <a:p>
                       <a:r>
-                        <a:rPr sz="780" b="1">
+                        <a:rPr sz="1250" b="1">
                           <a:solidFill>
-                            <a:srgbClr val="141414"/>
+                            <a:srgbClr val="0A0A0A"/>
                           </a:solidFill>
                           <a:latin typeface="Arial"/>
                         </a:rPr>
@@ -5654,9 +5507,9 @@
                     <a:lstStyle/>
                     <a:p>
                       <a:r>
-                        <a:rPr sz="780" b="0">
+                        <a:rPr sz="1250" b="0">
                           <a:solidFill>
-                            <a:srgbClr val="141414"/>
+                            <a:srgbClr val="0A0A0A"/>
                           </a:solidFill>
                           <a:latin typeface="Arial"/>
                         </a:rPr>
@@ -5676,9 +5529,9 @@
                     <a:lstStyle/>
                     <a:p>
                       <a:r>
-                        <a:rPr sz="780" b="0">
+                        <a:rPr sz="1250" b="0">
                           <a:solidFill>
-                            <a:srgbClr val="141414"/>
+                            <a:srgbClr val="0A0A0A"/>
                           </a:solidFill>
                           <a:latin typeface="Arial"/>
                         </a:rPr>
@@ -5693,16 +5546,16 @@
                   </a:tcPr>
                 </a:tc>
               </a:tr>
-              <a:tr h="457200">
+              <a:tr h="450000">
                 <a:tc>
                   <a:txBody>
                     <a:bodyPr/>
                     <a:lstStyle/>
                     <a:p>
                       <a:r>
-                        <a:rPr sz="780" b="1">
+                        <a:rPr sz="1250" b="1">
                           <a:solidFill>
-                            <a:srgbClr val="141414"/>
+                            <a:srgbClr val="0A0A0A"/>
                           </a:solidFill>
                           <a:latin typeface="Arial"/>
                         </a:rPr>
@@ -5722,9 +5575,9 @@
                     <a:lstStyle/>
                     <a:p>
                       <a:r>
-                        <a:rPr sz="780" b="0">
+                        <a:rPr sz="1250" b="0">
                           <a:solidFill>
-                            <a:srgbClr val="141414"/>
+                            <a:srgbClr val="0A0A0A"/>
                           </a:solidFill>
                           <a:latin typeface="Arial"/>
                         </a:rPr>
@@ -5744,9 +5597,9 @@
                     <a:lstStyle/>
                     <a:p>
                       <a:r>
-                        <a:rPr sz="780" b="0">
+                        <a:rPr sz="1250" b="0">
                           <a:solidFill>
-                            <a:srgbClr val="141414"/>
+                            <a:srgbClr val="0A0A0A"/>
                           </a:solidFill>
                           <a:latin typeface="Arial"/>
                         </a:rPr>
@@ -5761,16 +5614,16 @@
                   </a:tcPr>
                 </a:tc>
               </a:tr>
-              <a:tr h="457200">
+              <a:tr h="450000">
                 <a:tc>
                   <a:txBody>
                     <a:bodyPr/>
                     <a:lstStyle/>
                     <a:p>
                       <a:r>
-                        <a:rPr sz="780" b="1">
+                        <a:rPr sz="1250" b="1">
                           <a:solidFill>
-                            <a:srgbClr val="141414"/>
+                            <a:srgbClr val="0A0A0A"/>
                           </a:solidFill>
                           <a:latin typeface="Arial"/>
                         </a:rPr>
@@ -5790,9 +5643,9 @@
                     <a:lstStyle/>
                     <a:p>
                       <a:r>
-                        <a:rPr sz="780" b="0">
+                        <a:rPr sz="1250" b="0">
                           <a:solidFill>
-                            <a:srgbClr val="141414"/>
+                            <a:srgbClr val="0A0A0A"/>
                           </a:solidFill>
                           <a:latin typeface="Arial"/>
                         </a:rPr>
@@ -5812,13 +5665,13 @@
                     <a:lstStyle/>
                     <a:p>
                       <a:r>
-                        <a:rPr sz="780" b="0">
+                        <a:rPr sz="1250" b="0">
                           <a:solidFill>
-                            <a:srgbClr val="141414"/>
+                            <a:srgbClr val="0A0A0A"/>
                           </a:solidFill>
                           <a:latin typeface="Arial"/>
                         </a:rPr>
-                        <a:t>Etkileşim ağırlığı tahmin hatası</a:t>
+                        <a:t>Etkileşim tahmin hatası</a:t>
                       </a:r>
                     </a:p>
                   </a:txBody>
@@ -5835,20 +5688,20 @@
       </p:graphicFrame>
       <p:sp>
         <p:nvSpPr>
-          <p:cNvPr id="50" name="Rectangle 49"/>
+          <p:cNvPr id="46" name="Rectangle 45"/>
           <p:cNvSpPr/>
           <p:nvPr/>
         </p:nvSpPr>
         <p:spPr>
           <a:xfrm>
-            <a:off x="10954512" y="21991319"/>
-            <a:ext cx="8778240" cy="4892040"/>
+            <a:off x="11016000" y="21222000"/>
+            <a:ext cx="9072000" cy="4716000"/>
           </a:xfrm>
           <a:prstGeom prst="rect">
             <a:avLst/>
           </a:prstGeom>
           <a:solidFill>
-            <a:srgbClr val="EFEFEF"/>
+            <a:srgbClr val="F1F1F1"/>
           </a:solidFill>
           <a:ln w="7620">
             <a:solidFill>
@@ -5880,24 +5733,24 @@
       </p:sp>
       <p:sp>
         <p:nvSpPr>
-          <p:cNvPr id="51" name="Rectangle 50"/>
+          <p:cNvPr id="47" name="Rectangle 46"/>
           <p:cNvSpPr/>
           <p:nvPr/>
         </p:nvSpPr>
         <p:spPr>
           <a:xfrm>
-            <a:off x="10954512" y="21991319"/>
-            <a:ext cx="8778240" cy="411480"/>
+            <a:off x="11016000" y="21222000"/>
+            <a:ext cx="9072000" cy="424800"/>
           </a:xfrm>
           <a:prstGeom prst="rect">
             <a:avLst/>
           </a:prstGeom>
           <a:solidFill>
-            <a:srgbClr val="1F4E79"/>
+            <a:srgbClr val="205280"/>
           </a:solidFill>
           <a:ln w="5080">
             <a:solidFill>
-              <a:srgbClr val="1F4E79"/>
+              <a:srgbClr val="205280"/>
             </a:solidFill>
           </a:ln>
         </p:spPr>
@@ -5925,14 +5778,14 @@
       </p:sp>
       <p:sp>
         <p:nvSpPr>
-          <p:cNvPr id="52" name="TextBox 51"/>
+          <p:cNvPr id="48" name="TextBox 47"/>
           <p:cNvSpPr txBox="1"/>
           <p:nvPr/>
         </p:nvSpPr>
         <p:spPr>
           <a:xfrm>
-            <a:off x="11000232" y="22059899"/>
-            <a:ext cx="8686800" cy="256032"/>
+            <a:off x="11069999" y="21286800"/>
+            <a:ext cx="8964000" cy="251999"/>
           </a:xfrm>
           <a:prstGeom prst="rect">
             <a:avLst/>
@@ -5947,7 +5800,7 @@
           <a:p>
             <a:pPr algn="ctr"/>
             <a:r>
-              <a:rPr sz="1300" b="1">
+              <a:rPr sz="2200" b="1">
                 <a:solidFill>
                   <a:srgbClr val="FFFFFF"/>
                 </a:solidFill>
@@ -5960,14 +5813,14 @@
       </p:sp>
       <p:sp>
         <p:nvSpPr>
-          <p:cNvPr id="53" name="TextBox 52"/>
+          <p:cNvPr id="49" name="TextBox 48"/>
           <p:cNvSpPr txBox="1"/>
           <p:nvPr/>
         </p:nvSpPr>
         <p:spPr>
           <a:xfrm>
-            <a:off x="11091672" y="22558248"/>
-            <a:ext cx="8503919" cy="4206240"/>
+            <a:off x="11134799" y="21744000"/>
+            <a:ext cx="8834400" cy="4121999"/>
           </a:xfrm>
           <a:prstGeom prst="rect">
             <a:avLst/>
@@ -5975,86 +5828,98 @@
           <a:noFill/>
         </p:spPr>
         <p:txBody>
-          <a:bodyPr wrap="square" lIns="36576" rIns="36576" tIns="18288">
+          <a:bodyPr wrap="square" lIns="50400" rIns="43200" tIns="18000">
             <a:spAutoFit/>
           </a:bodyPr>
           <a:lstStyle/>
           <a:p>
             <a:pPr>
+              <a:lnSpc>
+                <a:spcPct val="102000"/>
+              </a:lnSpc>
               <a:spcAft>
-                <a:spcPts val="420"/>
+                <a:spcPts val="500"/>
               </a:spcAft>
             </a:pPr>
             <a:r>
-              <a:rPr sz="825" b="0">
-                <a:solidFill>
-                  <a:srgbClr val="141414"/>
+              <a:rPr sz="1560" b="0">
+                <a:solidFill>
+                  <a:srgbClr val="0A0A0A"/>
                 </a:solidFill>
                 <a:latin typeface="Arial"/>
               </a:rPr>
-              <a:t>PAÜ Market, kampüs içinde güvenli ve doğrulanmış ikinci el alışveriş ortamı sunar.</a:t>
+              <a:t>• PAÜ Market, kampüs içinde doğrulanmış ve güvenli ikinci el alışveriş ortamı sunar.</a:t>
             </a:r>
           </a:p>
           <a:p>
             <a:pPr>
+              <a:lnSpc>
+                <a:spcPct val="102000"/>
+              </a:lnSpc>
               <a:spcAft>
-                <a:spcPts val="420"/>
+                <a:spcPts val="500"/>
               </a:spcAft>
             </a:pPr>
             <a:r>
-              <a:rPr sz="825" b="0">
-                <a:solidFill>
-                  <a:srgbClr val="141414"/>
+              <a:rPr sz="1560" b="0">
+                <a:solidFill>
+                  <a:srgbClr val="0A0A0A"/>
                 </a:solidFill>
                 <a:latin typeface="Arial"/>
               </a:rPr>
-              <a:t>Mesajlaşma ve anlaşma akışı sayesinde sadece tıklama değil, gerçek satın alma niyeti de veri olarak toplanır.</a:t>
+              <a:t>• Mesajlaşma ve anlaşma akışı sayesinde gerçek satın alma niyeti veri olarak toplanır.</a:t>
             </a:r>
           </a:p>
           <a:p>
             <a:pPr>
+              <a:lnSpc>
+                <a:spcPct val="102000"/>
+              </a:lnSpc>
               <a:spcAft>
-                <a:spcPts val="420"/>
+                <a:spcPts val="500"/>
               </a:spcAft>
             </a:pPr>
             <a:r>
-              <a:rPr sz="825" b="0">
-                <a:solidFill>
-                  <a:srgbClr val="141414"/>
+              <a:rPr sz="1560" b="0">
+                <a:solidFill>
+                  <a:srgbClr val="0A0A0A"/>
                 </a:solidFill>
                 <a:latin typeface="Arial"/>
               </a:rPr>
-              <a:t>Öneri sistemi kullanıcıların ilgi alanlarına göre ilanları sıralayarak keşif sürecini kolaylaştırır.</a:t>
+              <a:t>• Öneri sistemi kullanıcıların ilgi alanlarına göre ilanları sıralayarak keşif sürecini kolaylaştırır.</a:t>
             </a:r>
           </a:p>
           <a:p>
             <a:pPr>
+              <a:lnSpc>
+                <a:spcPct val="102000"/>
+              </a:lnSpc>
               <a:spcAft>
-                <a:spcPts val="420"/>
+                <a:spcPts val="500"/>
               </a:spcAft>
             </a:pPr>
             <a:r>
-              <a:rPr sz="825" b="0">
-                <a:solidFill>
-                  <a:srgbClr val="141414"/>
+              <a:rPr sz="1560" b="0">
+                <a:solidFill>
+                  <a:srgbClr val="0A0A0A"/>
                 </a:solidFill>
                 <a:latin typeface="Arial"/>
               </a:rPr>
-              <a:t>Mikroservis mimarisi, öneri modelini ana backend'den ayırarak ölçeklenebilir ve sürdürülebilir bir yapı sağlar.</a:t>
-            </a:r>
-          </a:p>
-        </p:txBody>
-      </p:sp>
-      <p:sp>
-        <p:nvSpPr>
-          <p:cNvPr id="54" name="Oval 53"/>
+              <a:t>• Mikroservis mimarisi, öneri modelini ana backend'den ayırarak sürdürülebilir bir yapı sağlar.</a:t>
+            </a:r>
+          </a:p>
+        </p:txBody>
+      </p:sp>
+      <p:sp>
+        <p:nvSpPr>
+          <p:cNvPr id="50" name="Oval 49"/>
           <p:cNvSpPr/>
           <p:nvPr/>
         </p:nvSpPr>
         <p:spPr>
           <a:xfrm>
-            <a:off x="4800600" y="28072080"/>
-            <a:ext cx="731520" cy="731520"/>
+            <a:off x="4734000" y="28656000"/>
+            <a:ext cx="864000" cy="864000"/>
           </a:xfrm>
           <a:prstGeom prst="ellipse">
             <a:avLst/>
@@ -6092,14 +5957,14 @@
       </p:sp>
       <p:sp>
         <p:nvSpPr>
-          <p:cNvPr id="55" name="TextBox 54"/>
+          <p:cNvPr id="51" name="TextBox 50"/>
           <p:cNvSpPr txBox="1"/>
           <p:nvPr/>
         </p:nvSpPr>
         <p:spPr>
           <a:xfrm>
-            <a:off x="4873752" y="28318968"/>
-            <a:ext cx="585216" cy="201168"/>
+            <a:off x="4824000" y="28936800"/>
+            <a:ext cx="684000" cy="198000"/>
           </a:xfrm>
           <a:prstGeom prst="rect">
             <a:avLst/>
@@ -6114,7 +5979,7 @@
           <a:p>
             <a:pPr algn="ctr"/>
             <a:r>
-              <a:rPr sz="660" b="1">
+              <a:rPr sz="1500" b="1">
                 <a:solidFill>
                   <a:srgbClr val="FFFFFF"/>
                 </a:solidFill>
@@ -6127,14 +5992,14 @@
       </p:sp>
       <p:sp>
         <p:nvSpPr>
-          <p:cNvPr id="56" name="TextBox 55"/>
+          <p:cNvPr id="52" name="TextBox 51"/>
           <p:cNvSpPr txBox="1"/>
           <p:nvPr/>
         </p:nvSpPr>
         <p:spPr>
           <a:xfrm>
-            <a:off x="5715000" y="27953208"/>
-            <a:ext cx="10241280" cy="347472"/>
+            <a:off x="5813999" y="28620000"/>
+            <a:ext cx="8640000" cy="324000"/>
           </a:xfrm>
           <a:prstGeom prst="rect">
             <a:avLst/>
@@ -6149,7 +6014,7 @@
           <a:p>
             <a:pPr algn="ctr"/>
             <a:r>
-              <a:rPr sz="1200" b="1">
+              <a:rPr sz="2000" b="1">
                 <a:solidFill>
                   <a:srgbClr val="000000"/>
                 </a:solidFill>
@@ -6162,14 +6027,14 @@
       </p:sp>
       <p:sp>
         <p:nvSpPr>
-          <p:cNvPr id="57" name="TextBox 56"/>
+          <p:cNvPr id="53" name="TextBox 52"/>
           <p:cNvSpPr txBox="1"/>
           <p:nvPr/>
         </p:nvSpPr>
         <p:spPr>
           <a:xfrm>
-            <a:off x="5715000" y="28410408"/>
-            <a:ext cx="10241280" cy="292608"/>
+            <a:off x="5813999" y="28980000"/>
+            <a:ext cx="8640000" cy="270000"/>
           </a:xfrm>
           <a:prstGeom prst="rect">
             <a:avLst/>
@@ -6184,7 +6049,7 @@
           <a:p>
             <a:pPr algn="ctr"/>
             <a:r>
-              <a:rPr sz="919" b="0">
+              <a:rPr sz="1600" b="0">
                 <a:solidFill>
                   <a:srgbClr val="000000"/>
                 </a:solidFill>

</xml_diff>

<commit_message>
Use PAU Market colors in thesis poster
</commit_message>
<xml_diff>
--- a/docs/PAU_Market_Tez_Posteri.pptx
+++ b/docs/PAU_Market_Tez_Posteri.pptx
@@ -3193,11 +3193,11 @@
             <a:avLst/>
           </a:prstGeom>
           <a:solidFill>
-            <a:srgbClr val="205280"/>
+            <a:srgbClr val="2563EB"/>
           </a:solidFill>
           <a:ln w="7620">
             <a:solidFill>
-              <a:srgbClr val="205280"/>
+              <a:srgbClr val="2563EB"/>
             </a:solidFill>
           </a:ln>
         </p:spPr>
@@ -3242,7 +3242,7 @@
           </a:solidFill>
           <a:ln w="19050">
             <a:solidFill>
-              <a:srgbClr val="1F4E79"/>
+              <a:srgbClr val="0F172A"/>
             </a:solidFill>
           </a:ln>
         </p:spPr>
@@ -3283,11 +3283,11 @@
             <a:avLst/>
           </a:prstGeom>
           <a:solidFill>
-            <a:srgbClr val="DFEBF7"/>
+            <a:srgbClr val="E5F1FF"/>
           </a:solidFill>
           <a:ln w="10160">
             <a:solidFill>
-              <a:srgbClr val="1F4E79"/>
+              <a:srgbClr val="0F172A"/>
             </a:solidFill>
           </a:ln>
         </p:spPr>
@@ -3339,7 +3339,7 @@
             <a:r>
               <a:rPr sz="2500" b="1">
                 <a:solidFill>
-                  <a:srgbClr val="1F4E79"/>
+                  <a:srgbClr val="0F172A"/>
                 </a:solidFill>
                 <a:latin typeface="Arial"/>
               </a:rPr>
@@ -3374,7 +3374,7 @@
             <a:r>
               <a:rPr sz="1300" b="1">
                 <a:solidFill>
-                  <a:srgbClr val="1F4E79"/>
+                  <a:srgbClr val="0F172A"/>
                 </a:solidFill>
                 <a:latin typeface="Arial"/>
               </a:rPr>
@@ -3627,7 +3627,7 @@
             <a:avLst/>
           </a:prstGeom>
           <a:solidFill>
-            <a:srgbClr val="D9D9D9"/>
+            <a:srgbClr val="E5F1FF"/>
           </a:solidFill>
           <a:ln w="11430">
             <a:solidFill>
@@ -3717,11 +3717,11 @@
             <a:avLst/>
           </a:prstGeom>
           <a:solidFill>
-            <a:srgbClr val="F1F1F1"/>
+            <a:srgbClr val="F6F9FF"/>
           </a:solidFill>
           <a:ln w="7620">
             <a:solidFill>
-              <a:srgbClr val="8EA9DB"/>
+              <a:srgbClr val="BFDBFE"/>
             </a:solidFill>
           </a:ln>
         </p:spPr>
@@ -3756,17 +3756,17 @@
         <p:spPr>
           <a:xfrm>
             <a:off x="1332000" y="4842000"/>
-            <a:ext cx="9072000" cy="424800"/>
+            <a:ext cx="79200" cy="3600000"/>
           </a:xfrm>
           <a:prstGeom prst="rect">
             <a:avLst/>
           </a:prstGeom>
           <a:solidFill>
-            <a:srgbClr val="205280"/>
+            <a:srgbClr val="10B981"/>
           </a:solidFill>
-          <a:ln w="5080">
+          <a:ln>
             <a:solidFill>
-              <a:srgbClr val="205280"/>
+              <a:srgbClr val="10B981"/>
             </a:solidFill>
           </a:ln>
         </p:spPr>
@@ -3794,7 +3794,52 @@
       </p:sp>
       <p:sp>
         <p:nvSpPr>
-          <p:cNvPr id="19" name="TextBox 18"/>
+          <p:cNvPr id="19" name="Rectangle 18"/>
+          <p:cNvSpPr/>
+          <p:nvPr/>
+        </p:nvSpPr>
+        <p:spPr>
+          <a:xfrm>
+            <a:off x="1332000" y="4842000"/>
+            <a:ext cx="9072000" cy="424800"/>
+          </a:xfrm>
+          <a:prstGeom prst="rect">
+            <a:avLst/>
+          </a:prstGeom>
+          <a:solidFill>
+            <a:srgbClr val="1E40AF"/>
+          </a:solidFill>
+          <a:ln w="5080">
+            <a:solidFill>
+              <a:srgbClr val="1E40AF"/>
+            </a:solidFill>
+          </a:ln>
+        </p:spPr>
+        <p:style>
+          <a:lnRef idx="1">
+            <a:schemeClr val="accent1"/>
+          </a:lnRef>
+          <a:fillRef idx="3">
+            <a:schemeClr val="accent1"/>
+          </a:fillRef>
+          <a:effectRef idx="2">
+            <a:schemeClr val="accent1"/>
+          </a:effectRef>
+          <a:fontRef idx="minor">
+            <a:schemeClr val="lt1"/>
+          </a:fontRef>
+        </p:style>
+        <p:txBody>
+          <a:bodyPr rtlCol="0" anchor="ctr"/>
+          <a:lstStyle/>
+          <a:p>
+            <a:pPr algn="ctr"/>
+          </a:p>
+        </p:txBody>
+      </p:sp>
+      <p:sp>
+        <p:nvSpPr>
+          <p:cNvPr id="20" name="TextBox 19"/>
           <p:cNvSpPr txBox="1"/>
           <p:nvPr/>
         </p:nvSpPr>
@@ -3829,7 +3874,7 @@
       </p:sp>
       <p:sp>
         <p:nvSpPr>
-          <p:cNvPr id="20" name="TextBox 19"/>
+          <p:cNvPr id="21" name="TextBox 20"/>
           <p:cNvSpPr txBox="1"/>
           <p:nvPr/>
         </p:nvSpPr>
@@ -3860,7 +3905,7 @@
             <a:r>
               <a:rPr sz="1620" b="0">
                 <a:solidFill>
-                  <a:srgbClr val="0A0A0A"/>
+                  <a:srgbClr val="0F172A"/>
                 </a:solidFill>
                 <a:latin typeface="Arial"/>
               </a:rPr>
@@ -3879,7 +3924,7 @@
             <a:r>
               <a:rPr sz="1620" b="0">
                 <a:solidFill>
-                  <a:srgbClr val="0A0A0A"/>
+                  <a:srgbClr val="0F172A"/>
                 </a:solidFill>
                 <a:latin typeface="Arial"/>
               </a:rPr>
@@ -3898,7 +3943,7 @@
             <a:r>
               <a:rPr sz="1620" b="0">
                 <a:solidFill>
-                  <a:srgbClr val="0A0A0A"/>
+                  <a:srgbClr val="0F172A"/>
                 </a:solidFill>
                 <a:latin typeface="Arial"/>
               </a:rPr>
@@ -3909,7 +3954,7 @@
       </p:sp>
       <p:sp>
         <p:nvSpPr>
-          <p:cNvPr id="21" name="Rectangle 20"/>
+          <p:cNvPr id="22" name="Rectangle 21"/>
           <p:cNvSpPr/>
           <p:nvPr/>
         </p:nvSpPr>
@@ -3922,11 +3967,11 @@
             <a:avLst/>
           </a:prstGeom>
           <a:solidFill>
-            <a:srgbClr val="F1F1F1"/>
+            <a:srgbClr val="F6F9FF"/>
           </a:solidFill>
           <a:ln w="7620">
             <a:solidFill>
-              <a:srgbClr val="8EA9DB"/>
+              <a:srgbClr val="BFDBFE"/>
             </a:solidFill>
           </a:ln>
         </p:spPr>
@@ -3954,24 +3999,24 @@
       </p:sp>
       <p:sp>
         <p:nvSpPr>
-          <p:cNvPr id="22" name="Rectangle 21"/>
+          <p:cNvPr id="23" name="Rectangle 22"/>
           <p:cNvSpPr/>
           <p:nvPr/>
         </p:nvSpPr>
         <p:spPr>
           <a:xfrm>
             <a:off x="1332000" y="8766000"/>
-            <a:ext cx="9072000" cy="424800"/>
+            <a:ext cx="79200" cy="3960000"/>
           </a:xfrm>
           <a:prstGeom prst="rect">
             <a:avLst/>
           </a:prstGeom>
           <a:solidFill>
-            <a:srgbClr val="205280"/>
+            <a:srgbClr val="10B981"/>
           </a:solidFill>
-          <a:ln w="5080">
+          <a:ln>
             <a:solidFill>
-              <a:srgbClr val="205280"/>
+              <a:srgbClr val="10B981"/>
             </a:solidFill>
           </a:ln>
         </p:spPr>
@@ -3999,7 +4044,52 @@
       </p:sp>
       <p:sp>
         <p:nvSpPr>
-          <p:cNvPr id="23" name="TextBox 22"/>
+          <p:cNvPr id="24" name="Rectangle 23"/>
+          <p:cNvSpPr/>
+          <p:nvPr/>
+        </p:nvSpPr>
+        <p:spPr>
+          <a:xfrm>
+            <a:off x="1332000" y="8766000"/>
+            <a:ext cx="9072000" cy="424800"/>
+          </a:xfrm>
+          <a:prstGeom prst="rect">
+            <a:avLst/>
+          </a:prstGeom>
+          <a:solidFill>
+            <a:srgbClr val="1E40AF"/>
+          </a:solidFill>
+          <a:ln w="5080">
+            <a:solidFill>
+              <a:srgbClr val="1E40AF"/>
+            </a:solidFill>
+          </a:ln>
+        </p:spPr>
+        <p:style>
+          <a:lnRef idx="1">
+            <a:schemeClr val="accent1"/>
+          </a:lnRef>
+          <a:fillRef idx="3">
+            <a:schemeClr val="accent1"/>
+          </a:fillRef>
+          <a:effectRef idx="2">
+            <a:schemeClr val="accent1"/>
+          </a:effectRef>
+          <a:fontRef idx="minor">
+            <a:schemeClr val="lt1"/>
+          </a:fontRef>
+        </p:style>
+        <p:txBody>
+          <a:bodyPr rtlCol="0" anchor="ctr"/>
+          <a:lstStyle/>
+          <a:p>
+            <a:pPr algn="ctr"/>
+          </a:p>
+        </p:txBody>
+      </p:sp>
+      <p:sp>
+        <p:nvSpPr>
+          <p:cNvPr id="25" name="TextBox 24"/>
           <p:cNvSpPr txBox="1"/>
           <p:nvPr/>
         </p:nvSpPr>
@@ -4034,7 +4124,7 @@
       </p:sp>
       <p:sp>
         <p:nvSpPr>
-          <p:cNvPr id="24" name="TextBox 23"/>
+          <p:cNvPr id="26" name="TextBox 25"/>
           <p:cNvSpPr txBox="1"/>
           <p:nvPr/>
         </p:nvSpPr>
@@ -4065,7 +4155,7 @@
             <a:r>
               <a:rPr sz="1600" b="0">
                 <a:solidFill>
-                  <a:srgbClr val="0A0A0A"/>
+                  <a:srgbClr val="0F172A"/>
                 </a:solidFill>
                 <a:latin typeface="Arial"/>
               </a:rPr>
@@ -4084,7 +4174,7 @@
             <a:r>
               <a:rPr sz="1600" b="0">
                 <a:solidFill>
-                  <a:srgbClr val="0A0A0A"/>
+                  <a:srgbClr val="0F172A"/>
                 </a:solidFill>
                 <a:latin typeface="Arial"/>
               </a:rPr>
@@ -4103,7 +4193,7 @@
             <a:r>
               <a:rPr sz="1600" b="0">
                 <a:solidFill>
-                  <a:srgbClr val="0A0A0A"/>
+                  <a:srgbClr val="0F172A"/>
                 </a:solidFill>
                 <a:latin typeface="Arial"/>
               </a:rPr>
@@ -4114,7 +4204,7 @@
       </p:sp>
       <p:sp>
         <p:nvSpPr>
-          <p:cNvPr id="25" name="Rectangle 24"/>
+          <p:cNvPr id="27" name="Rectangle 26"/>
           <p:cNvSpPr/>
           <p:nvPr/>
         </p:nvSpPr>
@@ -4127,11 +4217,11 @@
             <a:avLst/>
           </a:prstGeom>
           <a:solidFill>
-            <a:srgbClr val="F1F1F1"/>
+            <a:srgbClr val="F6F9FF"/>
           </a:solidFill>
           <a:ln w="7620">
             <a:solidFill>
-              <a:srgbClr val="8EA9DB"/>
+              <a:srgbClr val="BFDBFE"/>
             </a:solidFill>
           </a:ln>
         </p:spPr>
@@ -4159,24 +4249,24 @@
       </p:sp>
       <p:sp>
         <p:nvSpPr>
-          <p:cNvPr id="26" name="Rectangle 25"/>
+          <p:cNvPr id="28" name="Rectangle 27"/>
           <p:cNvSpPr/>
           <p:nvPr/>
         </p:nvSpPr>
         <p:spPr>
           <a:xfrm>
             <a:off x="1332000" y="13050000"/>
-            <a:ext cx="9072000" cy="424800"/>
+            <a:ext cx="79200" cy="4464000"/>
           </a:xfrm>
           <a:prstGeom prst="rect">
             <a:avLst/>
           </a:prstGeom>
           <a:solidFill>
-            <a:srgbClr val="205280"/>
+            <a:srgbClr val="10B981"/>
           </a:solidFill>
-          <a:ln w="5080">
+          <a:ln>
             <a:solidFill>
-              <a:srgbClr val="205280"/>
+              <a:srgbClr val="10B981"/>
             </a:solidFill>
           </a:ln>
         </p:spPr>
@@ -4204,7 +4294,52 @@
       </p:sp>
       <p:sp>
         <p:nvSpPr>
-          <p:cNvPr id="27" name="TextBox 26"/>
+          <p:cNvPr id="29" name="Rectangle 28"/>
+          <p:cNvSpPr/>
+          <p:nvPr/>
+        </p:nvSpPr>
+        <p:spPr>
+          <a:xfrm>
+            <a:off x="1332000" y="13050000"/>
+            <a:ext cx="9072000" cy="424800"/>
+          </a:xfrm>
+          <a:prstGeom prst="rect">
+            <a:avLst/>
+          </a:prstGeom>
+          <a:solidFill>
+            <a:srgbClr val="1E40AF"/>
+          </a:solidFill>
+          <a:ln w="5080">
+            <a:solidFill>
+              <a:srgbClr val="1E40AF"/>
+            </a:solidFill>
+          </a:ln>
+        </p:spPr>
+        <p:style>
+          <a:lnRef idx="1">
+            <a:schemeClr val="accent1"/>
+          </a:lnRef>
+          <a:fillRef idx="3">
+            <a:schemeClr val="accent1"/>
+          </a:fillRef>
+          <a:effectRef idx="2">
+            <a:schemeClr val="accent1"/>
+          </a:effectRef>
+          <a:fontRef idx="minor">
+            <a:schemeClr val="lt1"/>
+          </a:fontRef>
+        </p:style>
+        <p:txBody>
+          <a:bodyPr rtlCol="0" anchor="ctr"/>
+          <a:lstStyle/>
+          <a:p>
+            <a:pPr algn="ctr"/>
+          </a:p>
+        </p:txBody>
+      </p:sp>
+      <p:sp>
+        <p:nvSpPr>
+          <p:cNvPr id="30" name="TextBox 29"/>
           <p:cNvSpPr txBox="1"/>
           <p:nvPr/>
         </p:nvSpPr>
@@ -4239,7 +4374,7 @@
       </p:sp>
       <p:sp>
         <p:nvSpPr>
-          <p:cNvPr id="28" name="TextBox 27"/>
+          <p:cNvPr id="31" name="TextBox 30"/>
           <p:cNvSpPr txBox="1"/>
           <p:nvPr/>
         </p:nvSpPr>
@@ -4270,7 +4405,7 @@
             <a:r>
               <a:rPr sz="1580" b="0">
                 <a:solidFill>
-                  <a:srgbClr val="0A0A0A"/>
+                  <a:srgbClr val="0F172A"/>
                 </a:solidFill>
                 <a:latin typeface="Arial"/>
               </a:rPr>
@@ -4289,7 +4424,7 @@
             <a:r>
               <a:rPr sz="1580" b="0">
                 <a:solidFill>
-                  <a:srgbClr val="0A0A0A"/>
+                  <a:srgbClr val="0F172A"/>
                 </a:solidFill>
                 <a:latin typeface="Arial"/>
               </a:rPr>
@@ -4308,7 +4443,7 @@
             <a:r>
               <a:rPr sz="1580" b="0">
                 <a:solidFill>
-                  <a:srgbClr val="0A0A0A"/>
+                  <a:srgbClr val="0F172A"/>
                 </a:solidFill>
                 <a:latin typeface="Arial"/>
               </a:rPr>
@@ -4327,7 +4462,7 @@
             <a:r>
               <a:rPr sz="1580" b="0">
                 <a:solidFill>
-                  <a:srgbClr val="0A0A0A"/>
+                  <a:srgbClr val="0F172A"/>
                 </a:solidFill>
                 <a:latin typeface="Arial"/>
               </a:rPr>
@@ -4346,7 +4481,7 @@
             <a:r>
               <a:rPr sz="1580" b="0">
                 <a:solidFill>
-                  <a:srgbClr val="0A0A0A"/>
+                  <a:srgbClr val="0F172A"/>
                 </a:solidFill>
                 <a:latin typeface="Arial"/>
               </a:rPr>
@@ -4357,7 +4492,7 @@
       </p:sp>
       <p:sp>
         <p:nvSpPr>
-          <p:cNvPr id="29" name="Rectangle 28"/>
+          <p:cNvPr id="32" name="Rectangle 31"/>
           <p:cNvSpPr/>
           <p:nvPr/>
         </p:nvSpPr>
@@ -4370,11 +4505,11 @@
             <a:avLst/>
           </a:prstGeom>
           <a:solidFill>
-            <a:srgbClr val="F1F1F1"/>
+            <a:srgbClr val="F6F9FF"/>
           </a:solidFill>
           <a:ln w="7620">
             <a:solidFill>
-              <a:srgbClr val="8EA9DB"/>
+              <a:srgbClr val="BFDBFE"/>
             </a:solidFill>
           </a:ln>
         </p:spPr>
@@ -4402,24 +4537,24 @@
       </p:sp>
       <p:sp>
         <p:nvSpPr>
-          <p:cNvPr id="30" name="Rectangle 29"/>
+          <p:cNvPr id="33" name="Rectangle 32"/>
           <p:cNvSpPr/>
           <p:nvPr/>
         </p:nvSpPr>
         <p:spPr>
           <a:xfrm>
             <a:off x="1332000" y="17838000"/>
-            <a:ext cx="9072000" cy="424800"/>
+            <a:ext cx="79200" cy="4500000"/>
           </a:xfrm>
           <a:prstGeom prst="rect">
             <a:avLst/>
           </a:prstGeom>
           <a:solidFill>
-            <a:srgbClr val="205280"/>
+            <a:srgbClr val="10B981"/>
           </a:solidFill>
-          <a:ln w="5080">
+          <a:ln>
             <a:solidFill>
-              <a:srgbClr val="205280"/>
+              <a:srgbClr val="10B981"/>
             </a:solidFill>
           </a:ln>
         </p:spPr>
@@ -4447,7 +4582,52 @@
       </p:sp>
       <p:sp>
         <p:nvSpPr>
-          <p:cNvPr id="31" name="TextBox 30"/>
+          <p:cNvPr id="34" name="Rectangle 33"/>
+          <p:cNvSpPr/>
+          <p:nvPr/>
+        </p:nvSpPr>
+        <p:spPr>
+          <a:xfrm>
+            <a:off x="1332000" y="17838000"/>
+            <a:ext cx="9072000" cy="424800"/>
+          </a:xfrm>
+          <a:prstGeom prst="rect">
+            <a:avLst/>
+          </a:prstGeom>
+          <a:solidFill>
+            <a:srgbClr val="1E40AF"/>
+          </a:solidFill>
+          <a:ln w="5080">
+            <a:solidFill>
+              <a:srgbClr val="1E40AF"/>
+            </a:solidFill>
+          </a:ln>
+        </p:spPr>
+        <p:style>
+          <a:lnRef idx="1">
+            <a:schemeClr val="accent1"/>
+          </a:lnRef>
+          <a:fillRef idx="3">
+            <a:schemeClr val="accent1"/>
+          </a:fillRef>
+          <a:effectRef idx="2">
+            <a:schemeClr val="accent1"/>
+          </a:effectRef>
+          <a:fontRef idx="minor">
+            <a:schemeClr val="lt1"/>
+          </a:fontRef>
+        </p:style>
+        <p:txBody>
+          <a:bodyPr rtlCol="0" anchor="ctr"/>
+          <a:lstStyle/>
+          <a:p>
+            <a:pPr algn="ctr"/>
+          </a:p>
+        </p:txBody>
+      </p:sp>
+      <p:sp>
+        <p:nvSpPr>
+          <p:cNvPr id="35" name="TextBox 34"/>
           <p:cNvSpPr txBox="1"/>
           <p:nvPr/>
         </p:nvSpPr>
@@ -4482,7 +4662,7 @@
       </p:sp>
       <p:sp>
         <p:nvSpPr>
-          <p:cNvPr id="32" name="TextBox 31"/>
+          <p:cNvPr id="36" name="TextBox 35"/>
           <p:cNvSpPr txBox="1"/>
           <p:nvPr/>
         </p:nvSpPr>
@@ -4513,7 +4693,7 @@
             <a:r>
               <a:rPr sz="1600" b="0">
                 <a:solidFill>
-                  <a:srgbClr val="0A0A0A"/>
+                  <a:srgbClr val="0F172A"/>
                 </a:solidFill>
                 <a:latin typeface="Arial"/>
               </a:rPr>
@@ -4532,7 +4712,7 @@
             <a:r>
               <a:rPr sz="1600" b="0">
                 <a:solidFill>
-                  <a:srgbClr val="0A0A0A"/>
+                  <a:srgbClr val="0F172A"/>
                 </a:solidFill>
                 <a:latin typeface="Arial"/>
               </a:rPr>
@@ -4551,7 +4731,7 @@
             <a:r>
               <a:rPr sz="1600" b="0">
                 <a:solidFill>
-                  <a:srgbClr val="0A0A0A"/>
+                  <a:srgbClr val="0F172A"/>
                 </a:solidFill>
                 <a:latin typeface="Arial"/>
               </a:rPr>
@@ -4570,7 +4750,7 @@
             <a:r>
               <a:rPr sz="1600" b="0">
                 <a:solidFill>
-                  <a:srgbClr val="0A0A0A"/>
+                  <a:srgbClr val="0F172A"/>
                 </a:solidFill>
                 <a:latin typeface="Arial"/>
               </a:rPr>
@@ -4589,7 +4769,7 @@
             <a:r>
               <a:rPr sz="1600" b="0">
                 <a:solidFill>
-                  <a:srgbClr val="0A0A0A"/>
+                  <a:srgbClr val="0F172A"/>
                 </a:solidFill>
                 <a:latin typeface="Arial"/>
               </a:rPr>
@@ -4600,7 +4780,7 @@
       </p:sp>
       <p:sp>
         <p:nvSpPr>
-          <p:cNvPr id="33" name="Rectangle 32"/>
+          <p:cNvPr id="37" name="Rectangle 36"/>
           <p:cNvSpPr/>
           <p:nvPr/>
         </p:nvSpPr>
@@ -4613,11 +4793,11 @@
             <a:avLst/>
           </a:prstGeom>
           <a:solidFill>
-            <a:srgbClr val="F1F1F1"/>
+            <a:srgbClr val="F6F9FF"/>
           </a:solidFill>
           <a:ln w="7620">
             <a:solidFill>
-              <a:srgbClr val="8EA9DB"/>
+              <a:srgbClr val="BFDBFE"/>
             </a:solidFill>
           </a:ln>
         </p:spPr>
@@ -4645,24 +4825,24 @@
       </p:sp>
       <p:sp>
         <p:nvSpPr>
-          <p:cNvPr id="34" name="Rectangle 33"/>
+          <p:cNvPr id="38" name="Rectangle 37"/>
           <p:cNvSpPr/>
           <p:nvPr/>
         </p:nvSpPr>
         <p:spPr>
           <a:xfrm>
             <a:off x="11016000" y="4842000"/>
-            <a:ext cx="9072000" cy="424800"/>
+            <a:ext cx="79200" cy="4752000"/>
           </a:xfrm>
           <a:prstGeom prst="rect">
             <a:avLst/>
           </a:prstGeom>
           <a:solidFill>
-            <a:srgbClr val="205280"/>
+            <a:srgbClr val="10B981"/>
           </a:solidFill>
-          <a:ln w="5080">
+          <a:ln>
             <a:solidFill>
-              <a:srgbClr val="205280"/>
+              <a:srgbClr val="10B981"/>
             </a:solidFill>
           </a:ln>
         </p:spPr>
@@ -4690,7 +4870,52 @@
       </p:sp>
       <p:sp>
         <p:nvSpPr>
-          <p:cNvPr id="35" name="TextBox 34"/>
+          <p:cNvPr id="39" name="Rectangle 38"/>
+          <p:cNvSpPr/>
+          <p:nvPr/>
+        </p:nvSpPr>
+        <p:spPr>
+          <a:xfrm>
+            <a:off x="11016000" y="4842000"/>
+            <a:ext cx="9072000" cy="424800"/>
+          </a:xfrm>
+          <a:prstGeom prst="rect">
+            <a:avLst/>
+          </a:prstGeom>
+          <a:solidFill>
+            <a:srgbClr val="1E40AF"/>
+          </a:solidFill>
+          <a:ln w="5080">
+            <a:solidFill>
+              <a:srgbClr val="1E40AF"/>
+            </a:solidFill>
+          </a:ln>
+        </p:spPr>
+        <p:style>
+          <a:lnRef idx="1">
+            <a:schemeClr val="accent1"/>
+          </a:lnRef>
+          <a:fillRef idx="3">
+            <a:schemeClr val="accent1"/>
+          </a:fillRef>
+          <a:effectRef idx="2">
+            <a:schemeClr val="accent1"/>
+          </a:effectRef>
+          <a:fontRef idx="minor">
+            <a:schemeClr val="lt1"/>
+          </a:fontRef>
+        </p:style>
+        <p:txBody>
+          <a:bodyPr rtlCol="0" anchor="ctr"/>
+          <a:lstStyle/>
+          <a:p>
+            <a:pPr algn="ctr"/>
+          </a:p>
+        </p:txBody>
+      </p:sp>
+      <p:sp>
+        <p:nvSpPr>
+          <p:cNvPr id="40" name="TextBox 39"/>
           <p:cNvSpPr txBox="1"/>
           <p:nvPr/>
         </p:nvSpPr>
@@ -4725,7 +4950,7 @@
       </p:sp>
       <p:sp>
         <p:nvSpPr>
-          <p:cNvPr id="36" name="TextBox 35"/>
+          <p:cNvPr id="41" name="TextBox 40"/>
           <p:cNvSpPr txBox="1"/>
           <p:nvPr/>
         </p:nvSpPr>
@@ -4756,7 +4981,7 @@
             <a:r>
               <a:rPr sz="1590" b="0">
                 <a:solidFill>
-                  <a:srgbClr val="0A0A0A"/>
+                  <a:srgbClr val="0F172A"/>
                 </a:solidFill>
                 <a:latin typeface="Arial"/>
               </a:rPr>
@@ -4775,7 +5000,7 @@
             <a:r>
               <a:rPr sz="1590" b="0">
                 <a:solidFill>
-                  <a:srgbClr val="0A0A0A"/>
+                  <a:srgbClr val="0F172A"/>
                 </a:solidFill>
                 <a:latin typeface="Arial"/>
               </a:rPr>
@@ -4794,7 +5019,7 @@
             <a:r>
               <a:rPr sz="1590" b="0">
                 <a:solidFill>
-                  <a:srgbClr val="0A0A0A"/>
+                  <a:srgbClr val="0F172A"/>
                 </a:solidFill>
                 <a:latin typeface="Arial"/>
               </a:rPr>
@@ -4813,7 +5038,7 @@
             <a:r>
               <a:rPr sz="1590" b="0">
                 <a:solidFill>
-                  <a:srgbClr val="0A0A0A"/>
+                  <a:srgbClr val="0F172A"/>
                 </a:solidFill>
                 <a:latin typeface="Arial"/>
               </a:rPr>
@@ -4824,7 +5049,7 @@
       </p:sp>
       <p:sp>
         <p:nvSpPr>
-          <p:cNvPr id="37" name="Rectangle 36"/>
+          <p:cNvPr id="42" name="Rectangle 41"/>
           <p:cNvSpPr/>
           <p:nvPr/>
         </p:nvSpPr>
@@ -4837,11 +5062,11 @@
             <a:avLst/>
           </a:prstGeom>
           <a:solidFill>
-            <a:srgbClr val="F1F1F1"/>
+            <a:srgbClr val="F6F9FF"/>
           </a:solidFill>
           <a:ln w="7620">
             <a:solidFill>
-              <a:srgbClr val="8EA9DB"/>
+              <a:srgbClr val="BFDBFE"/>
             </a:solidFill>
           </a:ln>
         </p:spPr>
@@ -4869,24 +5094,24 @@
       </p:sp>
       <p:sp>
         <p:nvSpPr>
-          <p:cNvPr id="38" name="Rectangle 37"/>
+          <p:cNvPr id="43" name="Rectangle 42"/>
           <p:cNvSpPr/>
           <p:nvPr/>
         </p:nvSpPr>
         <p:spPr>
           <a:xfrm>
             <a:off x="11016000" y="9917999"/>
-            <a:ext cx="9072000" cy="424800"/>
+            <a:ext cx="79200" cy="4176000"/>
           </a:xfrm>
           <a:prstGeom prst="rect">
             <a:avLst/>
           </a:prstGeom>
           <a:solidFill>
-            <a:srgbClr val="205280"/>
+            <a:srgbClr val="10B981"/>
           </a:solidFill>
-          <a:ln w="5080">
+          <a:ln>
             <a:solidFill>
-              <a:srgbClr val="205280"/>
+              <a:srgbClr val="10B981"/>
             </a:solidFill>
           </a:ln>
         </p:spPr>
@@ -4914,7 +5139,52 @@
       </p:sp>
       <p:sp>
         <p:nvSpPr>
-          <p:cNvPr id="39" name="TextBox 38"/>
+          <p:cNvPr id="44" name="Rectangle 43"/>
+          <p:cNvSpPr/>
+          <p:nvPr/>
+        </p:nvSpPr>
+        <p:spPr>
+          <a:xfrm>
+            <a:off x="11016000" y="9917999"/>
+            <a:ext cx="9072000" cy="424800"/>
+          </a:xfrm>
+          <a:prstGeom prst="rect">
+            <a:avLst/>
+          </a:prstGeom>
+          <a:solidFill>
+            <a:srgbClr val="1E40AF"/>
+          </a:solidFill>
+          <a:ln w="5080">
+            <a:solidFill>
+              <a:srgbClr val="1E40AF"/>
+            </a:solidFill>
+          </a:ln>
+        </p:spPr>
+        <p:style>
+          <a:lnRef idx="1">
+            <a:schemeClr val="accent1"/>
+          </a:lnRef>
+          <a:fillRef idx="3">
+            <a:schemeClr val="accent1"/>
+          </a:fillRef>
+          <a:effectRef idx="2">
+            <a:schemeClr val="accent1"/>
+          </a:effectRef>
+          <a:fontRef idx="minor">
+            <a:schemeClr val="lt1"/>
+          </a:fontRef>
+        </p:style>
+        <p:txBody>
+          <a:bodyPr rtlCol="0" anchor="ctr"/>
+          <a:lstStyle/>
+          <a:p>
+            <a:pPr algn="ctr"/>
+          </a:p>
+        </p:txBody>
+      </p:sp>
+      <p:sp>
+        <p:nvSpPr>
+          <p:cNvPr id="45" name="TextBox 44"/>
           <p:cNvSpPr txBox="1"/>
           <p:nvPr/>
         </p:nvSpPr>
@@ -4949,7 +5219,7 @@
       </p:sp>
       <p:sp>
         <p:nvSpPr>
-          <p:cNvPr id="40" name="TextBox 39"/>
+          <p:cNvPr id="46" name="TextBox 45"/>
           <p:cNvSpPr txBox="1"/>
           <p:nvPr/>
         </p:nvSpPr>
@@ -4980,7 +5250,7 @@
             <a:r>
               <a:rPr sz="1590" b="0">
                 <a:solidFill>
-                  <a:srgbClr val="0A0A0A"/>
+                  <a:srgbClr val="0F172A"/>
                 </a:solidFill>
                 <a:latin typeface="Arial"/>
               </a:rPr>
@@ -4999,7 +5269,7 @@
             <a:r>
               <a:rPr sz="1590" b="0">
                 <a:solidFill>
-                  <a:srgbClr val="0A0A0A"/>
+                  <a:srgbClr val="0F172A"/>
                 </a:solidFill>
                 <a:latin typeface="Arial"/>
               </a:rPr>
@@ -5018,7 +5288,7 @@
             <a:r>
               <a:rPr sz="1590" b="0">
                 <a:solidFill>
-                  <a:srgbClr val="0A0A0A"/>
+                  <a:srgbClr val="0F172A"/>
                 </a:solidFill>
                 <a:latin typeface="Arial"/>
               </a:rPr>
@@ -5037,7 +5307,7 @@
             <a:r>
               <a:rPr sz="1590" b="0">
                 <a:solidFill>
-                  <a:srgbClr val="0A0A0A"/>
+                  <a:srgbClr val="0F172A"/>
                 </a:solidFill>
                 <a:latin typeface="Arial"/>
               </a:rPr>
@@ -5048,7 +5318,7 @@
       </p:sp>
       <p:sp>
         <p:nvSpPr>
-          <p:cNvPr id="41" name="Rectangle 40"/>
+          <p:cNvPr id="47" name="Rectangle 46"/>
           <p:cNvSpPr/>
           <p:nvPr/>
         </p:nvSpPr>
@@ -5061,11 +5331,11 @@
             <a:avLst/>
           </a:prstGeom>
           <a:solidFill>
-            <a:srgbClr val="F1F1F1"/>
+            <a:srgbClr val="F6F9FF"/>
           </a:solidFill>
           <a:ln w="7620">
             <a:solidFill>
-              <a:srgbClr val="8EA9DB"/>
+              <a:srgbClr val="BFDBFE"/>
             </a:solidFill>
           </a:ln>
         </p:spPr>
@@ -5093,24 +5363,24 @@
       </p:sp>
       <p:sp>
         <p:nvSpPr>
-          <p:cNvPr id="42" name="Rectangle 41"/>
+          <p:cNvPr id="48" name="Rectangle 47"/>
           <p:cNvSpPr/>
           <p:nvPr/>
         </p:nvSpPr>
         <p:spPr>
           <a:xfrm>
             <a:off x="11016000" y="14417999"/>
-            <a:ext cx="9072000" cy="424800"/>
+            <a:ext cx="79200" cy="3600000"/>
           </a:xfrm>
           <a:prstGeom prst="rect">
             <a:avLst/>
           </a:prstGeom>
           <a:solidFill>
-            <a:srgbClr val="205280"/>
+            <a:srgbClr val="10B981"/>
           </a:solidFill>
-          <a:ln w="5080">
+          <a:ln>
             <a:solidFill>
-              <a:srgbClr val="205280"/>
+              <a:srgbClr val="10B981"/>
             </a:solidFill>
           </a:ln>
         </p:spPr>
@@ -5138,7 +5408,52 @@
       </p:sp>
       <p:sp>
         <p:nvSpPr>
-          <p:cNvPr id="43" name="TextBox 42"/>
+          <p:cNvPr id="49" name="Rectangle 48"/>
+          <p:cNvSpPr/>
+          <p:nvPr/>
+        </p:nvSpPr>
+        <p:spPr>
+          <a:xfrm>
+            <a:off x="11016000" y="14417999"/>
+            <a:ext cx="9072000" cy="424800"/>
+          </a:xfrm>
+          <a:prstGeom prst="rect">
+            <a:avLst/>
+          </a:prstGeom>
+          <a:solidFill>
+            <a:srgbClr val="1E40AF"/>
+          </a:solidFill>
+          <a:ln w="5080">
+            <a:solidFill>
+              <a:srgbClr val="1E40AF"/>
+            </a:solidFill>
+          </a:ln>
+        </p:spPr>
+        <p:style>
+          <a:lnRef idx="1">
+            <a:schemeClr val="accent1"/>
+          </a:lnRef>
+          <a:fillRef idx="3">
+            <a:schemeClr val="accent1"/>
+          </a:fillRef>
+          <a:effectRef idx="2">
+            <a:schemeClr val="accent1"/>
+          </a:effectRef>
+          <a:fontRef idx="minor">
+            <a:schemeClr val="lt1"/>
+          </a:fontRef>
+        </p:style>
+        <p:txBody>
+          <a:bodyPr rtlCol="0" anchor="ctr"/>
+          <a:lstStyle/>
+          <a:p>
+            <a:pPr algn="ctr"/>
+          </a:p>
+        </p:txBody>
+      </p:sp>
+      <p:sp>
+        <p:nvSpPr>
+          <p:cNvPr id="50" name="TextBox 49"/>
           <p:cNvSpPr txBox="1"/>
           <p:nvPr/>
         </p:nvSpPr>
@@ -5173,7 +5488,7 @@
       </p:sp>
       <p:sp>
         <p:nvSpPr>
-          <p:cNvPr id="44" name="TextBox 43"/>
+          <p:cNvPr id="51" name="TextBox 50"/>
           <p:cNvSpPr txBox="1"/>
           <p:nvPr/>
         </p:nvSpPr>
@@ -5204,7 +5519,7 @@
             <a:r>
               <a:rPr sz="1540" b="0">
                 <a:solidFill>
-                  <a:srgbClr val="0A0A0A"/>
+                  <a:srgbClr val="0F172A"/>
                 </a:solidFill>
                 <a:latin typeface="Arial"/>
               </a:rPr>
@@ -5223,7 +5538,7 @@
             <a:r>
               <a:rPr sz="1540" b="0">
                 <a:solidFill>
-                  <a:srgbClr val="0A0A0A"/>
+                  <a:srgbClr val="0F172A"/>
                 </a:solidFill>
                 <a:latin typeface="Arial"/>
               </a:rPr>
@@ -5242,7 +5557,7 @@
             <a:r>
               <a:rPr sz="1540" b="0">
                 <a:solidFill>
-                  <a:srgbClr val="0A0A0A"/>
+                  <a:srgbClr val="0F172A"/>
                 </a:solidFill>
                 <a:latin typeface="Arial"/>
               </a:rPr>
@@ -5253,7 +5568,7 @@
       </p:sp>
       <p:graphicFrame>
         <p:nvGraphicFramePr>
-          <p:cNvPr id="45" name="Table 44"/>
+          <p:cNvPr id="52" name="Table 51"/>
           <p:cNvGraphicFramePr>
             <a:graphicFrameLocks noGrp="1"/>
           </p:cNvGraphicFramePr>
@@ -5293,7 +5608,7 @@
                   </a:txBody>
                   <a:tcPr>
                     <a:solidFill>
-                      <a:srgbClr val="205280"/>
+                      <a:srgbClr val="1E40AF"/>
                     </a:solidFill>
                   </a:tcPr>
                 </a:tc>
@@ -5315,7 +5630,7 @@
                   </a:txBody>
                   <a:tcPr>
                     <a:solidFill>
-                      <a:srgbClr val="205280"/>
+                      <a:srgbClr val="1E40AF"/>
                     </a:solidFill>
                   </a:tcPr>
                 </a:tc>
@@ -5337,7 +5652,7 @@
                   </a:txBody>
                   <a:tcPr>
                     <a:solidFill>
-                      <a:srgbClr val="205280"/>
+                      <a:srgbClr val="1E40AF"/>
                     </a:solidFill>
                   </a:tcPr>
                 </a:tc>
@@ -5351,7 +5666,7 @@
                       <a:r>
                         <a:rPr sz="1250" b="1">
                           <a:solidFill>
-                            <a:srgbClr val="0A0A0A"/>
+                            <a:srgbClr val="0F172A"/>
                           </a:solidFill>
                           <a:latin typeface="Arial"/>
                         </a:rPr>
@@ -5361,7 +5676,7 @@
                   </a:txBody>
                   <a:tcPr>
                     <a:solidFill>
-                      <a:srgbClr val="F8F8F8"/>
+                      <a:srgbClr val="E5F1FF"/>
                     </a:solidFill>
                   </a:tcPr>
                 </a:tc>
@@ -5373,7 +5688,7 @@
                       <a:r>
                         <a:rPr sz="1250" b="0">
                           <a:solidFill>
-                            <a:srgbClr val="0A0A0A"/>
+                            <a:srgbClr val="0F172A"/>
                           </a:solidFill>
                           <a:latin typeface="Arial"/>
                         </a:rPr>
@@ -5383,7 +5698,7 @@
                   </a:txBody>
                   <a:tcPr>
                     <a:solidFill>
-                      <a:srgbClr val="F8F8F8"/>
+                      <a:srgbClr val="E5F1FF"/>
                     </a:solidFill>
                   </a:tcPr>
                 </a:tc>
@@ -5395,7 +5710,7 @@
                       <a:r>
                         <a:rPr sz="1250" b="0">
                           <a:solidFill>
-                            <a:srgbClr val="0A0A0A"/>
+                            <a:srgbClr val="0F172A"/>
                           </a:solidFill>
                           <a:latin typeface="Arial"/>
                         </a:rPr>
@@ -5405,7 +5720,7 @@
                   </a:txBody>
                   <a:tcPr>
                     <a:solidFill>
-                      <a:srgbClr val="F8F8F8"/>
+                      <a:srgbClr val="E5F1FF"/>
                     </a:solidFill>
                   </a:tcPr>
                 </a:tc>
@@ -5419,7 +5734,7 @@
                       <a:r>
                         <a:rPr sz="1250" b="1">
                           <a:solidFill>
-                            <a:srgbClr val="0A0A0A"/>
+                            <a:srgbClr val="0F172A"/>
                           </a:solidFill>
                           <a:latin typeface="Arial"/>
                         </a:rPr>
@@ -5441,7 +5756,7 @@
                       <a:r>
                         <a:rPr sz="1250" b="0">
                           <a:solidFill>
-                            <a:srgbClr val="0A0A0A"/>
+                            <a:srgbClr val="0F172A"/>
                           </a:solidFill>
                           <a:latin typeface="Arial"/>
                         </a:rPr>
@@ -5463,7 +5778,7 @@
                       <a:r>
                         <a:rPr sz="1250" b="0">
                           <a:solidFill>
-                            <a:srgbClr val="0A0A0A"/>
+                            <a:srgbClr val="0F172A"/>
                           </a:solidFill>
                           <a:latin typeface="Arial"/>
                         </a:rPr>
@@ -5487,7 +5802,7 @@
                       <a:r>
                         <a:rPr sz="1250" b="1">
                           <a:solidFill>
-                            <a:srgbClr val="0A0A0A"/>
+                            <a:srgbClr val="0F172A"/>
                           </a:solidFill>
                           <a:latin typeface="Arial"/>
                         </a:rPr>
@@ -5497,7 +5812,7 @@
                   </a:txBody>
                   <a:tcPr>
                     <a:solidFill>
-                      <a:srgbClr val="F8F8F8"/>
+                      <a:srgbClr val="E5F1FF"/>
                     </a:solidFill>
                   </a:tcPr>
                 </a:tc>
@@ -5509,7 +5824,7 @@
                       <a:r>
                         <a:rPr sz="1250" b="0">
                           <a:solidFill>
-                            <a:srgbClr val="0A0A0A"/>
+                            <a:srgbClr val="0F172A"/>
                           </a:solidFill>
                           <a:latin typeface="Arial"/>
                         </a:rPr>
@@ -5519,7 +5834,7 @@
                   </a:txBody>
                   <a:tcPr>
                     <a:solidFill>
-                      <a:srgbClr val="F8F8F8"/>
+                      <a:srgbClr val="E5F1FF"/>
                     </a:solidFill>
                   </a:tcPr>
                 </a:tc>
@@ -5531,7 +5846,7 @@
                       <a:r>
                         <a:rPr sz="1250" b="0">
                           <a:solidFill>
-                            <a:srgbClr val="0A0A0A"/>
+                            <a:srgbClr val="0F172A"/>
                           </a:solidFill>
                           <a:latin typeface="Arial"/>
                         </a:rPr>
@@ -5541,7 +5856,7 @@
                   </a:txBody>
                   <a:tcPr>
                     <a:solidFill>
-                      <a:srgbClr val="F8F8F8"/>
+                      <a:srgbClr val="E5F1FF"/>
                     </a:solidFill>
                   </a:tcPr>
                 </a:tc>
@@ -5555,7 +5870,7 @@
                       <a:r>
                         <a:rPr sz="1250" b="1">
                           <a:solidFill>
-                            <a:srgbClr val="0A0A0A"/>
+                            <a:srgbClr val="0F172A"/>
                           </a:solidFill>
                           <a:latin typeface="Arial"/>
                         </a:rPr>
@@ -5577,7 +5892,7 @@
                       <a:r>
                         <a:rPr sz="1250" b="0">
                           <a:solidFill>
-                            <a:srgbClr val="0A0A0A"/>
+                            <a:srgbClr val="0F172A"/>
                           </a:solidFill>
                           <a:latin typeface="Arial"/>
                         </a:rPr>
@@ -5599,7 +5914,7 @@
                       <a:r>
                         <a:rPr sz="1250" b="0">
                           <a:solidFill>
-                            <a:srgbClr val="0A0A0A"/>
+                            <a:srgbClr val="0F172A"/>
                           </a:solidFill>
                           <a:latin typeface="Arial"/>
                         </a:rPr>
@@ -5623,7 +5938,7 @@
                       <a:r>
                         <a:rPr sz="1250" b="1">
                           <a:solidFill>
-                            <a:srgbClr val="0A0A0A"/>
+                            <a:srgbClr val="0F172A"/>
                           </a:solidFill>
                           <a:latin typeface="Arial"/>
                         </a:rPr>
@@ -5633,7 +5948,7 @@
                   </a:txBody>
                   <a:tcPr>
                     <a:solidFill>
-                      <a:srgbClr val="F8F8F8"/>
+                      <a:srgbClr val="E5F1FF"/>
                     </a:solidFill>
                   </a:tcPr>
                 </a:tc>
@@ -5645,7 +5960,7 @@
                       <a:r>
                         <a:rPr sz="1250" b="0">
                           <a:solidFill>
-                            <a:srgbClr val="0A0A0A"/>
+                            <a:srgbClr val="0F172A"/>
                           </a:solidFill>
                           <a:latin typeface="Arial"/>
                         </a:rPr>
@@ -5655,7 +5970,7 @@
                   </a:txBody>
                   <a:tcPr>
                     <a:solidFill>
-                      <a:srgbClr val="F8F8F8"/>
+                      <a:srgbClr val="E5F1FF"/>
                     </a:solidFill>
                   </a:tcPr>
                 </a:tc>
@@ -5667,7 +5982,7 @@
                       <a:r>
                         <a:rPr sz="1250" b="0">
                           <a:solidFill>
-                            <a:srgbClr val="0A0A0A"/>
+                            <a:srgbClr val="0F172A"/>
                           </a:solidFill>
                           <a:latin typeface="Arial"/>
                         </a:rPr>
@@ -5677,7 +5992,7 @@
                   </a:txBody>
                   <a:tcPr>
                     <a:solidFill>
-                      <a:srgbClr val="F8F8F8"/>
+                      <a:srgbClr val="E5F1FF"/>
                     </a:solidFill>
                   </a:tcPr>
                 </a:tc>
@@ -5688,7 +6003,7 @@
       </p:graphicFrame>
       <p:sp>
         <p:nvSpPr>
-          <p:cNvPr id="46" name="Rectangle 45"/>
+          <p:cNvPr id="53" name="Rectangle 52"/>
           <p:cNvSpPr/>
           <p:nvPr/>
         </p:nvSpPr>
@@ -5701,11 +6016,11 @@
             <a:avLst/>
           </a:prstGeom>
           <a:solidFill>
-            <a:srgbClr val="F1F1F1"/>
+            <a:srgbClr val="F6F9FF"/>
           </a:solidFill>
           <a:ln w="7620">
             <a:solidFill>
-              <a:srgbClr val="8EA9DB"/>
+              <a:srgbClr val="BFDBFE"/>
             </a:solidFill>
           </a:ln>
         </p:spPr>
@@ -5733,24 +6048,24 @@
       </p:sp>
       <p:sp>
         <p:nvSpPr>
-          <p:cNvPr id="47" name="Rectangle 46"/>
+          <p:cNvPr id="54" name="Rectangle 53"/>
           <p:cNvSpPr/>
           <p:nvPr/>
         </p:nvSpPr>
         <p:spPr>
           <a:xfrm>
             <a:off x="11016000" y="21222000"/>
-            <a:ext cx="9072000" cy="424800"/>
+            <a:ext cx="79200" cy="4716000"/>
           </a:xfrm>
           <a:prstGeom prst="rect">
             <a:avLst/>
           </a:prstGeom>
           <a:solidFill>
-            <a:srgbClr val="205280"/>
+            <a:srgbClr val="10B981"/>
           </a:solidFill>
-          <a:ln w="5080">
+          <a:ln>
             <a:solidFill>
-              <a:srgbClr val="205280"/>
+              <a:srgbClr val="10B981"/>
             </a:solidFill>
           </a:ln>
         </p:spPr>
@@ -5778,7 +6093,52 @@
       </p:sp>
       <p:sp>
         <p:nvSpPr>
-          <p:cNvPr id="48" name="TextBox 47"/>
+          <p:cNvPr id="55" name="Rectangle 54"/>
+          <p:cNvSpPr/>
+          <p:nvPr/>
+        </p:nvSpPr>
+        <p:spPr>
+          <a:xfrm>
+            <a:off x="11016000" y="21222000"/>
+            <a:ext cx="9072000" cy="424800"/>
+          </a:xfrm>
+          <a:prstGeom prst="rect">
+            <a:avLst/>
+          </a:prstGeom>
+          <a:solidFill>
+            <a:srgbClr val="1E40AF"/>
+          </a:solidFill>
+          <a:ln w="5080">
+            <a:solidFill>
+              <a:srgbClr val="1E40AF"/>
+            </a:solidFill>
+          </a:ln>
+        </p:spPr>
+        <p:style>
+          <a:lnRef idx="1">
+            <a:schemeClr val="accent1"/>
+          </a:lnRef>
+          <a:fillRef idx="3">
+            <a:schemeClr val="accent1"/>
+          </a:fillRef>
+          <a:effectRef idx="2">
+            <a:schemeClr val="accent1"/>
+          </a:effectRef>
+          <a:fontRef idx="minor">
+            <a:schemeClr val="lt1"/>
+          </a:fontRef>
+        </p:style>
+        <p:txBody>
+          <a:bodyPr rtlCol="0" anchor="ctr"/>
+          <a:lstStyle/>
+          <a:p>
+            <a:pPr algn="ctr"/>
+          </a:p>
+        </p:txBody>
+      </p:sp>
+      <p:sp>
+        <p:nvSpPr>
+          <p:cNvPr id="56" name="TextBox 55"/>
           <p:cNvSpPr txBox="1"/>
           <p:nvPr/>
         </p:nvSpPr>
@@ -5813,7 +6173,7 @@
       </p:sp>
       <p:sp>
         <p:nvSpPr>
-          <p:cNvPr id="49" name="TextBox 48"/>
+          <p:cNvPr id="57" name="TextBox 56"/>
           <p:cNvSpPr txBox="1"/>
           <p:nvPr/>
         </p:nvSpPr>
@@ -5844,7 +6204,7 @@
             <a:r>
               <a:rPr sz="1560" b="0">
                 <a:solidFill>
-                  <a:srgbClr val="0A0A0A"/>
+                  <a:srgbClr val="0F172A"/>
                 </a:solidFill>
                 <a:latin typeface="Arial"/>
               </a:rPr>
@@ -5863,7 +6223,7 @@
             <a:r>
               <a:rPr sz="1560" b="0">
                 <a:solidFill>
-                  <a:srgbClr val="0A0A0A"/>
+                  <a:srgbClr val="0F172A"/>
                 </a:solidFill>
                 <a:latin typeface="Arial"/>
               </a:rPr>
@@ -5882,7 +6242,7 @@
             <a:r>
               <a:rPr sz="1560" b="0">
                 <a:solidFill>
-                  <a:srgbClr val="0A0A0A"/>
+                  <a:srgbClr val="0F172A"/>
                 </a:solidFill>
                 <a:latin typeface="Arial"/>
               </a:rPr>
@@ -5901,7 +6261,7 @@
             <a:r>
               <a:rPr sz="1560" b="0">
                 <a:solidFill>
-                  <a:srgbClr val="0A0A0A"/>
+                  <a:srgbClr val="0F172A"/>
                 </a:solidFill>
                 <a:latin typeface="Arial"/>
               </a:rPr>
@@ -5912,7 +6272,7 @@
       </p:sp>
       <p:sp>
         <p:nvSpPr>
-          <p:cNvPr id="50" name="Oval 49"/>
+          <p:cNvPr id="58" name="Oval 57"/>
           <p:cNvSpPr/>
           <p:nvPr/>
         </p:nvSpPr>
@@ -5925,7 +6285,7 @@
             <a:avLst/>
           </a:prstGeom>
           <a:solidFill>
-            <a:srgbClr val="B42828"/>
+            <a:srgbClr val="2563EB"/>
           </a:solidFill>
           <a:ln w="19050">
             <a:solidFill>
@@ -5957,7 +6317,7 @@
       </p:sp>
       <p:sp>
         <p:nvSpPr>
-          <p:cNvPr id="51" name="TextBox 50"/>
+          <p:cNvPr id="59" name="TextBox 58"/>
           <p:cNvSpPr txBox="1"/>
           <p:nvPr/>
         </p:nvSpPr>
@@ -5992,7 +6352,7 @@
       </p:sp>
       <p:sp>
         <p:nvSpPr>
-          <p:cNvPr id="52" name="TextBox 51"/>
+          <p:cNvPr id="60" name="TextBox 59"/>
           <p:cNvSpPr txBox="1"/>
           <p:nvPr/>
         </p:nvSpPr>
@@ -6027,7 +6387,7 @@
       </p:sp>
       <p:sp>
         <p:nvSpPr>
-          <p:cNvPr id="53" name="TextBox 52"/>
+          <p:cNvPr id="61" name="TextBox 60"/>
           <p:cNvSpPr txBox="1"/>
           <p:nvPr/>
         </p:nvSpPr>

</xml_diff>

<commit_message>
Add visual system diagrams to thesis poster
</commit_message>
<xml_diff>
--- a/docs/PAU_Market_Tez_Posteri.pptx
+++ b/docs/PAU_Market_Tez_Posteri.pptx
@@ -3954,7 +3954,169 @@
       </p:sp>
       <p:sp>
         <p:nvSpPr>
-          <p:cNvPr id="22" name="Rectangle 21"/>
+          <p:cNvPr id="22" name="Rounded Rectangle 21"/>
+          <p:cNvSpPr/>
+          <p:nvPr/>
+        </p:nvSpPr>
+        <p:spPr>
+          <a:xfrm>
+            <a:off x="1638000" y="7793999"/>
+            <a:ext cx="2520000" cy="360000"/>
+          </a:xfrm>
+          <a:prstGeom prst="roundRect">
+            <a:avLst/>
+          </a:prstGeom>
+          <a:solidFill>
+            <a:srgbClr val="FFFFFF"/>
+          </a:solidFill>
+          <a:ln w="10160">
+            <a:solidFill>
+              <a:srgbClr val="10B981"/>
+            </a:solidFill>
+          </a:ln>
+        </p:spPr>
+        <p:style>
+          <a:lnRef idx="1">
+            <a:schemeClr val="accent1"/>
+          </a:lnRef>
+          <a:fillRef idx="3">
+            <a:schemeClr val="accent1"/>
+          </a:fillRef>
+          <a:effectRef idx="2">
+            <a:schemeClr val="accent1"/>
+          </a:effectRef>
+          <a:fontRef idx="minor">
+            <a:schemeClr val="lt1"/>
+          </a:fontRef>
+        </p:style>
+        <p:txBody>
+          <a:bodyPr rtlCol="0" anchor="ctr"/>
+          <a:lstStyle/>
+          <a:p>
+            <a:pPr algn="ctr"/>
+            <a:r>
+              <a:rPr sz="1080" b="1">
+                <a:solidFill>
+                  <a:srgbClr val="0F172A"/>
+                </a:solidFill>
+                <a:latin typeface="Arial"/>
+              </a:rPr>
+              <a:t>Sadece PAÜ öğrencileri</a:t>
+            </a:r>
+          </a:p>
+        </p:txBody>
+      </p:sp>
+      <p:sp>
+        <p:nvSpPr>
+          <p:cNvPr id="23" name="Rounded Rectangle 22"/>
+          <p:cNvSpPr/>
+          <p:nvPr/>
+        </p:nvSpPr>
+        <p:spPr>
+          <a:xfrm>
+            <a:off x="4356000" y="7793999"/>
+            <a:ext cx="2412000" cy="360000"/>
+          </a:xfrm>
+          <a:prstGeom prst="roundRect">
+            <a:avLst/>
+          </a:prstGeom>
+          <a:solidFill>
+            <a:srgbClr val="FFFFFF"/>
+          </a:solidFill>
+          <a:ln w="10160">
+            <a:solidFill>
+              <a:srgbClr val="2563EB"/>
+            </a:solidFill>
+          </a:ln>
+        </p:spPr>
+        <p:style>
+          <a:lnRef idx="1">
+            <a:schemeClr val="accent1"/>
+          </a:lnRef>
+          <a:fillRef idx="3">
+            <a:schemeClr val="accent1"/>
+          </a:fillRef>
+          <a:effectRef idx="2">
+            <a:schemeClr val="accent1"/>
+          </a:effectRef>
+          <a:fontRef idx="minor">
+            <a:schemeClr val="lt1"/>
+          </a:fontRef>
+        </p:style>
+        <p:txBody>
+          <a:bodyPr rtlCol="0" anchor="ctr"/>
+          <a:lstStyle/>
+          <a:p>
+            <a:pPr algn="ctr"/>
+            <a:r>
+              <a:rPr sz="1080" b="1">
+                <a:solidFill>
+                  <a:srgbClr val="0F172A"/>
+                </a:solidFill>
+                <a:latin typeface="Arial"/>
+              </a:rPr>
+              <a:t>Kampüs içi alışveriş</a:t>
+            </a:r>
+          </a:p>
+        </p:txBody>
+      </p:sp>
+      <p:sp>
+        <p:nvSpPr>
+          <p:cNvPr id="24" name="Rounded Rectangle 23"/>
+          <p:cNvSpPr/>
+          <p:nvPr/>
+        </p:nvSpPr>
+        <p:spPr>
+          <a:xfrm>
+            <a:off x="6966000" y="7793999"/>
+            <a:ext cx="2088000" cy="360000"/>
+          </a:xfrm>
+          <a:prstGeom prst="roundRect">
+            <a:avLst/>
+          </a:prstGeom>
+          <a:solidFill>
+            <a:srgbClr val="FFFFFF"/>
+          </a:solidFill>
+          <a:ln w="10160">
+            <a:solidFill>
+              <a:srgbClr val="2563EB"/>
+            </a:solidFill>
+          </a:ln>
+        </p:spPr>
+        <p:style>
+          <a:lnRef idx="1">
+            <a:schemeClr val="accent1"/>
+          </a:lnRef>
+          <a:fillRef idx="3">
+            <a:schemeClr val="accent1"/>
+          </a:fillRef>
+          <a:effectRef idx="2">
+            <a:schemeClr val="accent1"/>
+          </a:effectRef>
+          <a:fontRef idx="minor">
+            <a:schemeClr val="lt1"/>
+          </a:fontRef>
+        </p:style>
+        <p:txBody>
+          <a:bodyPr rtlCol="0" anchor="ctr"/>
+          <a:lstStyle/>
+          <a:p>
+            <a:pPr algn="ctr"/>
+            <a:r>
+              <a:rPr sz="1080" b="1">
+                <a:solidFill>
+                  <a:srgbClr val="0F172A"/>
+                </a:solidFill>
+                <a:latin typeface="Arial"/>
+              </a:rPr>
+              <a:t>Akıllı öneriler</a:t>
+            </a:r>
+          </a:p>
+        </p:txBody>
+      </p:sp>
+      <p:sp>
+        <p:nvSpPr>
+          <p:cNvPr id="25" name="Rectangle 24"/>
           <p:cNvSpPr/>
           <p:nvPr/>
         </p:nvSpPr>
@@ -3999,7 +4161,7 @@
       </p:sp>
       <p:sp>
         <p:nvSpPr>
-          <p:cNvPr id="23" name="Rectangle 22"/>
+          <p:cNvPr id="26" name="Rectangle 25"/>
           <p:cNvSpPr/>
           <p:nvPr/>
         </p:nvSpPr>
@@ -4044,7 +4206,7 @@
       </p:sp>
       <p:sp>
         <p:nvSpPr>
-          <p:cNvPr id="24" name="Rectangle 23"/>
+          <p:cNvPr id="27" name="Rectangle 26"/>
           <p:cNvSpPr/>
           <p:nvPr/>
         </p:nvSpPr>
@@ -4089,7 +4251,7 @@
       </p:sp>
       <p:sp>
         <p:nvSpPr>
-          <p:cNvPr id="25" name="TextBox 24"/>
+          <p:cNvPr id="28" name="TextBox 27"/>
           <p:cNvSpPr txBox="1"/>
           <p:nvPr/>
         </p:nvSpPr>
@@ -4124,7 +4286,7 @@
       </p:sp>
       <p:sp>
         <p:nvSpPr>
-          <p:cNvPr id="26" name="TextBox 25"/>
+          <p:cNvPr id="29" name="TextBox 28"/>
           <p:cNvSpPr txBox="1"/>
           <p:nvPr/>
         </p:nvSpPr>
@@ -4204,7 +4366,7 @@
       </p:sp>
       <p:sp>
         <p:nvSpPr>
-          <p:cNvPr id="27" name="Rectangle 26"/>
+          <p:cNvPr id="30" name="Rectangle 29"/>
           <p:cNvSpPr/>
           <p:nvPr/>
         </p:nvSpPr>
@@ -4249,7 +4411,7 @@
       </p:sp>
       <p:sp>
         <p:nvSpPr>
-          <p:cNvPr id="28" name="Rectangle 27"/>
+          <p:cNvPr id="31" name="Rectangle 30"/>
           <p:cNvSpPr/>
           <p:nvPr/>
         </p:nvSpPr>
@@ -4294,7 +4456,7 @@
       </p:sp>
       <p:sp>
         <p:nvSpPr>
-          <p:cNvPr id="29" name="Rectangle 28"/>
+          <p:cNvPr id="32" name="Rectangle 31"/>
           <p:cNvSpPr/>
           <p:nvPr/>
         </p:nvSpPr>
@@ -4339,7 +4501,7 @@
       </p:sp>
       <p:sp>
         <p:nvSpPr>
-          <p:cNvPr id="30" name="TextBox 29"/>
+          <p:cNvPr id="33" name="TextBox 32"/>
           <p:cNvSpPr txBox="1"/>
           <p:nvPr/>
         </p:nvSpPr>
@@ -4374,7 +4536,7 @@
       </p:sp>
       <p:sp>
         <p:nvSpPr>
-          <p:cNvPr id="31" name="TextBox 30"/>
+          <p:cNvPr id="34" name="TextBox 33"/>
           <p:cNvSpPr txBox="1"/>
           <p:nvPr/>
         </p:nvSpPr>
@@ -4492,7 +4654,379 @@
       </p:sp>
       <p:sp>
         <p:nvSpPr>
-          <p:cNvPr id="32" name="Rectangle 31"/>
+          <p:cNvPr id="35" name="Rounded Rectangle 34"/>
+          <p:cNvSpPr/>
+          <p:nvPr/>
+        </p:nvSpPr>
+        <p:spPr>
+          <a:xfrm>
+            <a:off x="1818000" y="16020000"/>
+            <a:ext cx="1728000" cy="827999"/>
+          </a:xfrm>
+          <a:prstGeom prst="roundRect">
+            <a:avLst/>
+          </a:prstGeom>
+          <a:solidFill>
+            <a:srgbClr val="2563EB"/>
+          </a:solidFill>
+          <a:ln w="10160">
+            <a:solidFill>
+              <a:srgbClr val="2563EB"/>
+            </a:solidFill>
+          </a:ln>
+        </p:spPr>
+        <p:style>
+          <a:lnRef idx="1">
+            <a:schemeClr val="accent1"/>
+          </a:lnRef>
+          <a:fillRef idx="3">
+            <a:schemeClr val="accent1"/>
+          </a:fillRef>
+          <a:effectRef idx="2">
+            <a:schemeClr val="accent1"/>
+          </a:effectRef>
+          <a:fontRef idx="minor">
+            <a:schemeClr val="lt1"/>
+          </a:fontRef>
+        </p:style>
+        <p:txBody>
+          <a:bodyPr rtlCol="0" anchor="ctr"/>
+          <a:lstStyle/>
+          <a:p>
+            <a:pPr algn="ctr"/>
+            <a:r>
+              <a:rPr sz="1150" b="1">
+                <a:solidFill>
+                  <a:srgbClr val="FFFFFF"/>
+                </a:solidFill>
+                <a:latin typeface="Arial"/>
+              </a:rPr>
+              <a:t>React</a:t>
+            </a:r>
+            <a:br/>
+            <a:r>
+              <a:t>Arayüz</a:t>
+            </a:r>
+          </a:p>
+        </p:txBody>
+      </p:sp>
+      <p:sp>
+        <p:nvSpPr>
+          <p:cNvPr id="36" name="Rounded Rectangle 35"/>
+          <p:cNvSpPr/>
+          <p:nvPr/>
+        </p:nvSpPr>
+        <p:spPr>
+          <a:xfrm>
+            <a:off x="3852000" y="16020000"/>
+            <a:ext cx="1728000" cy="827999"/>
+          </a:xfrm>
+          <a:prstGeom prst="roundRect">
+            <a:avLst/>
+          </a:prstGeom>
+          <a:solidFill>
+            <a:srgbClr val="1E40AF"/>
+          </a:solidFill>
+          <a:ln w="10160">
+            <a:solidFill>
+              <a:srgbClr val="1E40AF"/>
+            </a:solidFill>
+          </a:ln>
+        </p:spPr>
+        <p:style>
+          <a:lnRef idx="1">
+            <a:schemeClr val="accent1"/>
+          </a:lnRef>
+          <a:fillRef idx="3">
+            <a:schemeClr val="accent1"/>
+          </a:fillRef>
+          <a:effectRef idx="2">
+            <a:schemeClr val="accent1"/>
+          </a:effectRef>
+          <a:fontRef idx="minor">
+            <a:schemeClr val="lt1"/>
+          </a:fontRef>
+        </p:style>
+        <p:txBody>
+          <a:bodyPr rtlCol="0" anchor="ctr"/>
+          <a:lstStyle/>
+          <a:p>
+            <a:pPr algn="ctr"/>
+            <a:r>
+              <a:rPr sz="1150" b="1">
+                <a:solidFill>
+                  <a:srgbClr val="FFFFFF"/>
+                </a:solidFill>
+                <a:latin typeface="Arial"/>
+              </a:rPr>
+              <a:t>.NET</a:t>
+            </a:r>
+            <a:br/>
+            <a:r>
+              <a:t>API</a:t>
+            </a:r>
+          </a:p>
+        </p:txBody>
+      </p:sp>
+      <p:sp>
+        <p:nvSpPr>
+          <p:cNvPr id="37" name="Rounded Rectangle 36"/>
+          <p:cNvSpPr/>
+          <p:nvPr/>
+        </p:nvSpPr>
+        <p:spPr>
+          <a:xfrm>
+            <a:off x="5886000" y="16020000"/>
+            <a:ext cx="1728000" cy="827999"/>
+          </a:xfrm>
+          <a:prstGeom prst="roundRect">
+            <a:avLst/>
+          </a:prstGeom>
+          <a:solidFill>
+            <a:srgbClr val="10B981"/>
+          </a:solidFill>
+          <a:ln w="10160">
+            <a:solidFill>
+              <a:srgbClr val="10B981"/>
+            </a:solidFill>
+          </a:ln>
+        </p:spPr>
+        <p:style>
+          <a:lnRef idx="1">
+            <a:schemeClr val="accent1"/>
+          </a:lnRef>
+          <a:fillRef idx="3">
+            <a:schemeClr val="accent1"/>
+          </a:fillRef>
+          <a:effectRef idx="2">
+            <a:schemeClr val="accent1"/>
+          </a:effectRef>
+          <a:fontRef idx="minor">
+            <a:schemeClr val="lt1"/>
+          </a:fontRef>
+        </p:style>
+        <p:txBody>
+          <a:bodyPr rtlCol="0" anchor="ctr"/>
+          <a:lstStyle/>
+          <a:p>
+            <a:pPr algn="ctr"/>
+            <a:r>
+              <a:rPr sz="1150" b="1">
+                <a:solidFill>
+                  <a:srgbClr val="FFFFFF"/>
+                </a:solidFill>
+                <a:latin typeface="Arial"/>
+              </a:rPr>
+              <a:t>MSSQL</a:t>
+            </a:r>
+            <a:br/>
+            <a:r>
+              <a:t>Veri</a:t>
+            </a:r>
+          </a:p>
+        </p:txBody>
+      </p:sp>
+      <p:sp>
+        <p:nvSpPr>
+          <p:cNvPr id="38" name="Rounded Rectangle 37"/>
+          <p:cNvSpPr/>
+          <p:nvPr/>
+        </p:nvSpPr>
+        <p:spPr>
+          <a:xfrm>
+            <a:off x="7920000" y="16020000"/>
+            <a:ext cx="1872000" cy="827999"/>
+          </a:xfrm>
+          <a:prstGeom prst="roundRect">
+            <a:avLst/>
+          </a:prstGeom>
+          <a:solidFill>
+            <a:srgbClr val="0F172A"/>
+          </a:solidFill>
+          <a:ln w="10160">
+            <a:solidFill>
+              <a:srgbClr val="0F172A"/>
+            </a:solidFill>
+          </a:ln>
+        </p:spPr>
+        <p:style>
+          <a:lnRef idx="1">
+            <a:schemeClr val="accent1"/>
+          </a:lnRef>
+          <a:fillRef idx="3">
+            <a:schemeClr val="accent1"/>
+          </a:fillRef>
+          <a:effectRef idx="2">
+            <a:schemeClr val="accent1"/>
+          </a:effectRef>
+          <a:fontRef idx="minor">
+            <a:schemeClr val="lt1"/>
+          </a:fontRef>
+        </p:style>
+        <p:txBody>
+          <a:bodyPr rtlCol="0" anchor="ctr"/>
+          <a:lstStyle/>
+          <a:p>
+            <a:pPr algn="ctr"/>
+            <a:r>
+              <a:rPr sz="1150" b="1">
+                <a:solidFill>
+                  <a:srgbClr val="FFFFFF"/>
+                </a:solidFill>
+                <a:latin typeface="Arial"/>
+              </a:rPr>
+              <a:t>FastAPI</a:t>
+            </a:r>
+            <a:br/>
+            <a:r>
+              <a:t>Öneri</a:t>
+            </a:r>
+          </a:p>
+        </p:txBody>
+      </p:sp>
+      <p:cxnSp>
+        <p:nvCxnSpPr>
+          <p:cNvPr id="39" name="Connector 38"/>
+          <p:cNvCxnSpPr/>
+          <p:nvPr/>
+        </p:nvCxnSpPr>
+        <p:spPr>
+          <a:xfrm>
+            <a:off x="3546000" y="16434000"/>
+            <a:ext cx="306000" cy="0"/>
+          </a:xfrm>
+          <a:prstGeom prst="line">
+            <a:avLst/>
+          </a:prstGeom>
+          <a:ln w="21590">
+            <a:solidFill>
+              <a:srgbClr val="2563EB"/>
+            </a:solidFill>
+          </a:ln>
+        </p:spPr>
+        <p:style>
+          <a:lnRef idx="2">
+            <a:schemeClr val="accent1"/>
+          </a:lnRef>
+          <a:fillRef idx="0">
+            <a:schemeClr val="accent1"/>
+          </a:fillRef>
+          <a:effectRef idx="1">
+            <a:schemeClr val="accent1"/>
+          </a:effectRef>
+          <a:fontRef idx="minor">
+            <a:schemeClr val="tx1"/>
+          </a:fontRef>
+        </p:style>
+      </p:cxnSp>
+      <p:cxnSp>
+        <p:nvCxnSpPr>
+          <p:cNvPr id="40" name="Connector 39"/>
+          <p:cNvCxnSpPr/>
+          <p:nvPr/>
+        </p:nvCxnSpPr>
+        <p:spPr>
+          <a:xfrm>
+            <a:off x="5580000" y="16434000"/>
+            <a:ext cx="306000" cy="0"/>
+          </a:xfrm>
+          <a:prstGeom prst="line">
+            <a:avLst/>
+          </a:prstGeom>
+          <a:ln w="21590">
+            <a:solidFill>
+              <a:srgbClr val="2563EB"/>
+            </a:solidFill>
+          </a:ln>
+        </p:spPr>
+        <p:style>
+          <a:lnRef idx="2">
+            <a:schemeClr val="accent1"/>
+          </a:lnRef>
+          <a:fillRef idx="0">
+            <a:schemeClr val="accent1"/>
+          </a:fillRef>
+          <a:effectRef idx="1">
+            <a:schemeClr val="accent1"/>
+          </a:effectRef>
+          <a:fontRef idx="minor">
+            <a:schemeClr val="tx1"/>
+          </a:fontRef>
+        </p:style>
+      </p:cxnSp>
+      <p:cxnSp>
+        <p:nvCxnSpPr>
+          <p:cNvPr id="41" name="Connector 40"/>
+          <p:cNvCxnSpPr/>
+          <p:nvPr/>
+        </p:nvCxnSpPr>
+        <p:spPr>
+          <a:xfrm>
+            <a:off x="7614000" y="16434000"/>
+            <a:ext cx="306000" cy="0"/>
+          </a:xfrm>
+          <a:prstGeom prst="line">
+            <a:avLst/>
+          </a:prstGeom>
+          <a:ln w="21590">
+            <a:solidFill>
+              <a:srgbClr val="2563EB"/>
+            </a:solidFill>
+          </a:ln>
+        </p:spPr>
+        <p:style>
+          <a:lnRef idx="2">
+            <a:schemeClr val="accent1"/>
+          </a:lnRef>
+          <a:fillRef idx="0">
+            <a:schemeClr val="accent1"/>
+          </a:fillRef>
+          <a:effectRef idx="1">
+            <a:schemeClr val="accent1"/>
+          </a:effectRef>
+          <a:fontRef idx="minor">
+            <a:schemeClr val="tx1"/>
+          </a:fontRef>
+        </p:style>
+      </p:cxnSp>
+      <p:sp>
+        <p:nvSpPr>
+          <p:cNvPr id="42" name="TextBox 41"/>
+          <p:cNvSpPr txBox="1"/>
+          <p:nvPr/>
+        </p:nvSpPr>
+        <p:spPr>
+          <a:xfrm>
+            <a:off x="1818000" y="16956000"/>
+            <a:ext cx="7992000" cy="216000"/>
+          </a:xfrm>
+          <a:prstGeom prst="rect">
+            <a:avLst/>
+          </a:prstGeom>
+          <a:noFill/>
+        </p:spPr>
+        <p:txBody>
+          <a:bodyPr wrap="square" anchor="t">
+            <a:spAutoFit/>
+          </a:bodyPr>
+          <a:lstStyle/>
+          <a:p>
+            <a:pPr algn="ctr"/>
+            <a:r>
+              <a:rPr sz="1150" b="1">
+                <a:solidFill>
+                  <a:srgbClr val="1E40AF"/>
+                </a:solidFill>
+                <a:latin typeface="Arial"/>
+              </a:rPr>
+              <a:t>Docker Compose ile tek komutla çalışan dağıtık yapı</a:t>
+            </a:r>
+          </a:p>
+        </p:txBody>
+      </p:sp>
+      <p:sp>
+        <p:nvSpPr>
+          <p:cNvPr id="43" name="Rectangle 42"/>
           <p:cNvSpPr/>
           <p:nvPr/>
         </p:nvSpPr>
@@ -4537,7 +5071,7 @@
       </p:sp>
       <p:sp>
         <p:nvSpPr>
-          <p:cNvPr id="33" name="Rectangle 32"/>
+          <p:cNvPr id="44" name="Rectangle 43"/>
           <p:cNvSpPr/>
           <p:nvPr/>
         </p:nvSpPr>
@@ -4582,7 +5116,7 @@
       </p:sp>
       <p:sp>
         <p:nvSpPr>
-          <p:cNvPr id="34" name="Rectangle 33"/>
+          <p:cNvPr id="45" name="Rectangle 44"/>
           <p:cNvSpPr/>
           <p:nvPr/>
         </p:nvSpPr>
@@ -4627,7 +5161,7 @@
       </p:sp>
       <p:sp>
         <p:nvSpPr>
-          <p:cNvPr id="35" name="TextBox 34"/>
+          <p:cNvPr id="46" name="TextBox 45"/>
           <p:cNvSpPr txBox="1"/>
           <p:nvPr/>
         </p:nvSpPr>
@@ -4662,7 +5196,7 @@
       </p:sp>
       <p:sp>
         <p:nvSpPr>
-          <p:cNvPr id="36" name="TextBox 35"/>
+          <p:cNvPr id="47" name="TextBox 46"/>
           <p:cNvSpPr txBox="1"/>
           <p:nvPr/>
         </p:nvSpPr>
@@ -4780,7 +5314,7 @@
       </p:sp>
       <p:sp>
         <p:nvSpPr>
-          <p:cNvPr id="37" name="Rectangle 36"/>
+          <p:cNvPr id="48" name="Rectangle 47"/>
           <p:cNvSpPr/>
           <p:nvPr/>
         </p:nvSpPr>
@@ -4825,7 +5359,7 @@
       </p:sp>
       <p:sp>
         <p:nvSpPr>
-          <p:cNvPr id="38" name="Rectangle 37"/>
+          <p:cNvPr id="49" name="Rectangle 48"/>
           <p:cNvSpPr/>
           <p:nvPr/>
         </p:nvSpPr>
@@ -4870,7 +5404,7 @@
       </p:sp>
       <p:sp>
         <p:nvSpPr>
-          <p:cNvPr id="39" name="Rectangle 38"/>
+          <p:cNvPr id="50" name="Rectangle 49"/>
           <p:cNvSpPr/>
           <p:nvPr/>
         </p:nvSpPr>
@@ -4915,7 +5449,7 @@
       </p:sp>
       <p:sp>
         <p:nvSpPr>
-          <p:cNvPr id="40" name="TextBox 39"/>
+          <p:cNvPr id="51" name="TextBox 50"/>
           <p:cNvSpPr txBox="1"/>
           <p:nvPr/>
         </p:nvSpPr>
@@ -4950,7 +5484,7 @@
       </p:sp>
       <p:sp>
         <p:nvSpPr>
-          <p:cNvPr id="41" name="TextBox 40"/>
+          <p:cNvPr id="52" name="TextBox 51"/>
           <p:cNvSpPr txBox="1"/>
           <p:nvPr/>
         </p:nvSpPr>
@@ -5049,7 +5583,592 @@
       </p:sp>
       <p:sp>
         <p:nvSpPr>
-          <p:cNvPr id="42" name="Rectangle 41"/>
+          <p:cNvPr id="53" name="TextBox 52"/>
+          <p:cNvSpPr txBox="1"/>
+          <p:nvPr/>
+        </p:nvSpPr>
+        <p:spPr>
+          <a:xfrm>
+            <a:off x="11376000" y="7560000"/>
+            <a:ext cx="3240000" cy="180000"/>
+          </a:xfrm>
+          <a:prstGeom prst="rect">
+            <a:avLst/>
+          </a:prstGeom>
+          <a:noFill/>
+        </p:spPr>
+        <p:txBody>
+          <a:bodyPr wrap="square" anchor="t">
+            <a:spAutoFit/>
+          </a:bodyPr>
+          <a:lstStyle/>
+          <a:p>
+            <a:pPr algn="l"/>
+            <a:r>
+              <a:rPr sz="1250" b="1">
+                <a:solidFill>
+                  <a:srgbClr val="1E40AF"/>
+                </a:solidFill>
+                <a:latin typeface="Arial"/>
+              </a:rPr>
+              <a:t>Etkileşim gücü</a:t>
+            </a:r>
+          </a:p>
+        </p:txBody>
+      </p:sp>
+      <p:sp>
+        <p:nvSpPr>
+          <p:cNvPr id="54" name="Rounded Rectangle 53"/>
+          <p:cNvSpPr/>
+          <p:nvPr/>
+        </p:nvSpPr>
+        <p:spPr>
+          <a:xfrm>
+            <a:off x="11376000" y="7793999"/>
+            <a:ext cx="720000" cy="450000"/>
+          </a:xfrm>
+          <a:prstGeom prst="roundRect">
+            <a:avLst/>
+          </a:prstGeom>
+          <a:solidFill>
+            <a:srgbClr val="E5F1FF"/>
+          </a:solidFill>
+          <a:ln w="10160">
+            <a:solidFill>
+              <a:srgbClr val="2563EB"/>
+            </a:solidFill>
+          </a:ln>
+        </p:spPr>
+        <p:style>
+          <a:lnRef idx="1">
+            <a:schemeClr val="accent1"/>
+          </a:lnRef>
+          <a:fillRef idx="3">
+            <a:schemeClr val="accent1"/>
+          </a:fillRef>
+          <a:effectRef idx="2">
+            <a:schemeClr val="accent1"/>
+          </a:effectRef>
+          <a:fontRef idx="minor">
+            <a:schemeClr val="lt1"/>
+          </a:fontRef>
+        </p:style>
+        <p:txBody>
+          <a:bodyPr rtlCol="0" anchor="ctr"/>
+          <a:lstStyle/>
+          <a:p>
+            <a:pPr algn="ctr"/>
+            <a:r>
+              <a:rPr sz="1300" b="1">
+                <a:solidFill>
+                  <a:srgbClr val="1E40AF"/>
+                </a:solidFill>
+                <a:latin typeface="Arial"/>
+              </a:rPr>
+              <a:t>1.0</a:t>
+            </a:r>
+          </a:p>
+        </p:txBody>
+      </p:sp>
+      <p:sp>
+        <p:nvSpPr>
+          <p:cNvPr id="55" name="TextBox 54"/>
+          <p:cNvSpPr txBox="1"/>
+          <p:nvPr/>
+        </p:nvSpPr>
+        <p:spPr>
+          <a:xfrm>
+            <a:off x="11142000" y="8305200"/>
+            <a:ext cx="1188000" cy="162000"/>
+          </a:xfrm>
+          <a:prstGeom prst="rect">
+            <a:avLst/>
+          </a:prstGeom>
+          <a:noFill/>
+        </p:spPr>
+        <p:txBody>
+          <a:bodyPr wrap="square" anchor="t">
+            <a:spAutoFit/>
+          </a:bodyPr>
+          <a:lstStyle/>
+          <a:p>
+            <a:pPr algn="ctr"/>
+            <a:r>
+              <a:rPr sz="980" b="1">
+                <a:solidFill>
+                  <a:srgbClr val="0F172A"/>
+                </a:solidFill>
+                <a:latin typeface="Arial"/>
+              </a:rPr>
+              <a:t>Görüntüleme</a:t>
+            </a:r>
+          </a:p>
+        </p:txBody>
+      </p:sp>
+      <p:sp>
+        <p:nvSpPr>
+          <p:cNvPr id="56" name="Rounded Rectangle 55"/>
+          <p:cNvSpPr/>
+          <p:nvPr/>
+        </p:nvSpPr>
+        <p:spPr>
+          <a:xfrm>
+            <a:off x="13014000" y="7793999"/>
+            <a:ext cx="720000" cy="450000"/>
+          </a:xfrm>
+          <a:prstGeom prst="roundRect">
+            <a:avLst/>
+          </a:prstGeom>
+          <a:solidFill>
+            <a:srgbClr val="DBEAFE"/>
+          </a:solidFill>
+          <a:ln w="10160">
+            <a:solidFill>
+              <a:srgbClr val="2563EB"/>
+            </a:solidFill>
+          </a:ln>
+        </p:spPr>
+        <p:style>
+          <a:lnRef idx="1">
+            <a:schemeClr val="accent1"/>
+          </a:lnRef>
+          <a:fillRef idx="3">
+            <a:schemeClr val="accent1"/>
+          </a:fillRef>
+          <a:effectRef idx="2">
+            <a:schemeClr val="accent1"/>
+          </a:effectRef>
+          <a:fontRef idx="minor">
+            <a:schemeClr val="lt1"/>
+          </a:fontRef>
+        </p:style>
+        <p:txBody>
+          <a:bodyPr rtlCol="0" anchor="ctr"/>
+          <a:lstStyle/>
+          <a:p>
+            <a:pPr algn="ctr"/>
+            <a:r>
+              <a:rPr sz="1300" b="1">
+                <a:solidFill>
+                  <a:srgbClr val="1E40AF"/>
+                </a:solidFill>
+                <a:latin typeface="Arial"/>
+              </a:rPr>
+              <a:t>2.0</a:t>
+            </a:r>
+          </a:p>
+        </p:txBody>
+      </p:sp>
+      <p:sp>
+        <p:nvSpPr>
+          <p:cNvPr id="57" name="TextBox 56"/>
+          <p:cNvSpPr txBox="1"/>
+          <p:nvPr/>
+        </p:nvSpPr>
+        <p:spPr>
+          <a:xfrm>
+            <a:off x="12780000" y="8305200"/>
+            <a:ext cx="1188000" cy="162000"/>
+          </a:xfrm>
+          <a:prstGeom prst="rect">
+            <a:avLst/>
+          </a:prstGeom>
+          <a:noFill/>
+        </p:spPr>
+        <p:txBody>
+          <a:bodyPr wrap="square" anchor="t">
+            <a:spAutoFit/>
+          </a:bodyPr>
+          <a:lstStyle/>
+          <a:p>
+            <a:pPr algn="ctr"/>
+            <a:r>
+              <a:rPr sz="980" b="1">
+                <a:solidFill>
+                  <a:srgbClr val="0F172A"/>
+                </a:solidFill>
+                <a:latin typeface="Arial"/>
+              </a:rPr>
+              <a:t>Mesaj</a:t>
+            </a:r>
+          </a:p>
+        </p:txBody>
+      </p:sp>
+      <p:sp>
+        <p:nvSpPr>
+          <p:cNvPr id="58" name="Rounded Rectangle 57"/>
+          <p:cNvSpPr/>
+          <p:nvPr/>
+        </p:nvSpPr>
+        <p:spPr>
+          <a:xfrm>
+            <a:off x="14651999" y="7793999"/>
+            <a:ext cx="720000" cy="450000"/>
+          </a:xfrm>
+          <a:prstGeom prst="roundRect">
+            <a:avLst/>
+          </a:prstGeom>
+          <a:solidFill>
+            <a:srgbClr val="CCFBF1"/>
+          </a:solidFill>
+          <a:ln w="10160">
+            <a:solidFill>
+              <a:srgbClr val="2563EB"/>
+            </a:solidFill>
+          </a:ln>
+        </p:spPr>
+        <p:style>
+          <a:lnRef idx="1">
+            <a:schemeClr val="accent1"/>
+          </a:lnRef>
+          <a:fillRef idx="3">
+            <a:schemeClr val="accent1"/>
+          </a:fillRef>
+          <a:effectRef idx="2">
+            <a:schemeClr val="accent1"/>
+          </a:effectRef>
+          <a:fontRef idx="minor">
+            <a:schemeClr val="lt1"/>
+          </a:fontRef>
+        </p:style>
+        <p:txBody>
+          <a:bodyPr rtlCol="0" anchor="ctr"/>
+          <a:lstStyle/>
+          <a:p>
+            <a:pPr algn="ctr"/>
+            <a:r>
+              <a:rPr sz="1300" b="1">
+                <a:solidFill>
+                  <a:srgbClr val="0F172A"/>
+                </a:solidFill>
+                <a:latin typeface="Arial"/>
+              </a:rPr>
+              <a:t>3.0</a:t>
+            </a:r>
+          </a:p>
+        </p:txBody>
+      </p:sp>
+      <p:sp>
+        <p:nvSpPr>
+          <p:cNvPr id="59" name="TextBox 58"/>
+          <p:cNvSpPr txBox="1"/>
+          <p:nvPr/>
+        </p:nvSpPr>
+        <p:spPr>
+          <a:xfrm>
+            <a:off x="14417999" y="8305200"/>
+            <a:ext cx="1188000" cy="162000"/>
+          </a:xfrm>
+          <a:prstGeom prst="rect">
+            <a:avLst/>
+          </a:prstGeom>
+          <a:noFill/>
+        </p:spPr>
+        <p:txBody>
+          <a:bodyPr wrap="square" anchor="t">
+            <a:spAutoFit/>
+          </a:bodyPr>
+          <a:lstStyle/>
+          <a:p>
+            <a:pPr algn="ctr"/>
+            <a:r>
+              <a:rPr sz="980" b="1">
+                <a:solidFill>
+                  <a:srgbClr val="0F172A"/>
+                </a:solidFill>
+                <a:latin typeface="Arial"/>
+              </a:rPr>
+              <a:t>Favori</a:t>
+            </a:r>
+          </a:p>
+        </p:txBody>
+      </p:sp>
+      <p:sp>
+        <p:nvSpPr>
+          <p:cNvPr id="60" name="Rounded Rectangle 59"/>
+          <p:cNvSpPr/>
+          <p:nvPr/>
+        </p:nvSpPr>
+        <p:spPr>
+          <a:xfrm>
+            <a:off x="16290000" y="7793999"/>
+            <a:ext cx="720000" cy="450000"/>
+          </a:xfrm>
+          <a:prstGeom prst="roundRect">
+            <a:avLst/>
+          </a:prstGeom>
+          <a:solidFill>
+            <a:srgbClr val="BBF7D0"/>
+          </a:solidFill>
+          <a:ln w="10160">
+            <a:solidFill>
+              <a:srgbClr val="2563EB"/>
+            </a:solidFill>
+          </a:ln>
+        </p:spPr>
+        <p:style>
+          <a:lnRef idx="1">
+            <a:schemeClr val="accent1"/>
+          </a:lnRef>
+          <a:fillRef idx="3">
+            <a:schemeClr val="accent1"/>
+          </a:fillRef>
+          <a:effectRef idx="2">
+            <a:schemeClr val="accent1"/>
+          </a:effectRef>
+          <a:fontRef idx="minor">
+            <a:schemeClr val="lt1"/>
+          </a:fontRef>
+        </p:style>
+        <p:txBody>
+          <a:bodyPr rtlCol="0" anchor="ctr"/>
+          <a:lstStyle/>
+          <a:p>
+            <a:pPr algn="ctr"/>
+            <a:r>
+              <a:rPr sz="1300" b="1">
+                <a:solidFill>
+                  <a:srgbClr val="0F172A"/>
+                </a:solidFill>
+                <a:latin typeface="Arial"/>
+              </a:rPr>
+              <a:t>4.0</a:t>
+            </a:r>
+          </a:p>
+        </p:txBody>
+      </p:sp>
+      <p:sp>
+        <p:nvSpPr>
+          <p:cNvPr id="61" name="TextBox 60"/>
+          <p:cNvSpPr txBox="1"/>
+          <p:nvPr/>
+        </p:nvSpPr>
+        <p:spPr>
+          <a:xfrm>
+            <a:off x="16056000" y="8305200"/>
+            <a:ext cx="1188000" cy="162000"/>
+          </a:xfrm>
+          <a:prstGeom prst="rect">
+            <a:avLst/>
+          </a:prstGeom>
+          <a:noFill/>
+        </p:spPr>
+        <p:txBody>
+          <a:bodyPr wrap="square" anchor="t">
+            <a:spAutoFit/>
+          </a:bodyPr>
+          <a:lstStyle/>
+          <a:p>
+            <a:pPr algn="ctr"/>
+            <a:r>
+              <a:rPr sz="980" b="1">
+                <a:solidFill>
+                  <a:srgbClr val="0F172A"/>
+                </a:solidFill>
+                <a:latin typeface="Arial"/>
+              </a:rPr>
+              <a:t>Anlaşma</a:t>
+            </a:r>
+          </a:p>
+        </p:txBody>
+      </p:sp>
+      <p:sp>
+        <p:nvSpPr>
+          <p:cNvPr id="62" name="Rounded Rectangle 61"/>
+          <p:cNvSpPr/>
+          <p:nvPr/>
+        </p:nvSpPr>
+        <p:spPr>
+          <a:xfrm>
+            <a:off x="17928000" y="7793999"/>
+            <a:ext cx="720000" cy="450000"/>
+          </a:xfrm>
+          <a:prstGeom prst="roundRect">
+            <a:avLst/>
+          </a:prstGeom>
+          <a:solidFill>
+            <a:srgbClr val="10B981"/>
+          </a:solidFill>
+          <a:ln w="10160">
+            <a:solidFill>
+              <a:srgbClr val="2563EB"/>
+            </a:solidFill>
+          </a:ln>
+        </p:spPr>
+        <p:style>
+          <a:lnRef idx="1">
+            <a:schemeClr val="accent1"/>
+          </a:lnRef>
+          <a:fillRef idx="3">
+            <a:schemeClr val="accent1"/>
+          </a:fillRef>
+          <a:effectRef idx="2">
+            <a:schemeClr val="accent1"/>
+          </a:effectRef>
+          <a:fontRef idx="minor">
+            <a:schemeClr val="lt1"/>
+          </a:fontRef>
+        </p:style>
+        <p:txBody>
+          <a:bodyPr rtlCol="0" anchor="ctr"/>
+          <a:lstStyle/>
+          <a:p>
+            <a:pPr algn="ctr"/>
+            <a:r>
+              <a:rPr sz="1300" b="1">
+                <a:solidFill>
+                  <a:srgbClr val="FFFFFF"/>
+                </a:solidFill>
+                <a:latin typeface="Arial"/>
+              </a:rPr>
+              <a:t>5.0</a:t>
+            </a:r>
+          </a:p>
+        </p:txBody>
+      </p:sp>
+      <p:sp>
+        <p:nvSpPr>
+          <p:cNvPr id="63" name="TextBox 62"/>
+          <p:cNvSpPr txBox="1"/>
+          <p:nvPr/>
+        </p:nvSpPr>
+        <p:spPr>
+          <a:xfrm>
+            <a:off x="17694000" y="8305200"/>
+            <a:ext cx="1188000" cy="162000"/>
+          </a:xfrm>
+          <a:prstGeom prst="rect">
+            <a:avLst/>
+          </a:prstGeom>
+          <a:noFill/>
+        </p:spPr>
+        <p:txBody>
+          <a:bodyPr wrap="square" anchor="t">
+            <a:spAutoFit/>
+          </a:bodyPr>
+          <a:lstStyle/>
+          <a:p>
+            <a:pPr algn="ctr"/>
+            <a:r>
+              <a:rPr sz="980" b="1">
+                <a:solidFill>
+                  <a:srgbClr val="0F172A"/>
+                </a:solidFill>
+                <a:latin typeface="Arial"/>
+              </a:rPr>
+              <a:t>Satıldı</a:t>
+            </a:r>
+          </a:p>
+        </p:txBody>
+      </p:sp>
+      <p:cxnSp>
+        <p:nvCxnSpPr>
+          <p:cNvPr id="64" name="Connector 63"/>
+          <p:cNvCxnSpPr/>
+          <p:nvPr/>
+        </p:nvCxnSpPr>
+        <p:spPr>
+          <a:xfrm>
+            <a:off x="11700000" y="8640000"/>
+            <a:ext cx="6588000" cy="0"/>
+          </a:xfrm>
+          <a:prstGeom prst="line">
+            <a:avLst/>
+          </a:prstGeom>
+          <a:ln w="21590">
+            <a:solidFill>
+              <a:srgbClr val="10B981"/>
+            </a:solidFill>
+          </a:ln>
+        </p:spPr>
+        <p:style>
+          <a:lnRef idx="2">
+            <a:schemeClr val="accent1"/>
+          </a:lnRef>
+          <a:fillRef idx="0">
+            <a:schemeClr val="accent1"/>
+          </a:fillRef>
+          <a:effectRef idx="1">
+            <a:schemeClr val="accent1"/>
+          </a:effectRef>
+          <a:fontRef idx="minor">
+            <a:schemeClr val="tx1"/>
+          </a:fontRef>
+        </p:style>
+      </p:cxnSp>
+      <p:sp>
+        <p:nvSpPr>
+          <p:cNvPr id="65" name="TextBox 64"/>
+          <p:cNvSpPr txBox="1"/>
+          <p:nvPr/>
+        </p:nvSpPr>
+        <p:spPr>
+          <a:xfrm>
+            <a:off x="11376000" y="8712000"/>
+            <a:ext cx="1260000" cy="162000"/>
+          </a:xfrm>
+          <a:prstGeom prst="rect">
+            <a:avLst/>
+          </a:prstGeom>
+          <a:noFill/>
+        </p:spPr>
+        <p:txBody>
+          <a:bodyPr wrap="square" anchor="t">
+            <a:spAutoFit/>
+          </a:bodyPr>
+          <a:lstStyle/>
+          <a:p>
+            <a:pPr algn="l"/>
+            <a:r>
+              <a:rPr sz="960" b="0">
+                <a:solidFill>
+                  <a:srgbClr val="0F172A"/>
+                </a:solidFill>
+                <a:latin typeface="Arial"/>
+              </a:rPr>
+              <a:t>ilgi zayıf</a:t>
+            </a:r>
+          </a:p>
+        </p:txBody>
+      </p:sp>
+      <p:sp>
+        <p:nvSpPr>
+          <p:cNvPr id="66" name="TextBox 65"/>
+          <p:cNvSpPr txBox="1"/>
+          <p:nvPr/>
+        </p:nvSpPr>
+        <p:spPr>
+          <a:xfrm>
+            <a:off x="16848000" y="8712000"/>
+            <a:ext cx="2700000" cy="162000"/>
+          </a:xfrm>
+          <a:prstGeom prst="rect">
+            <a:avLst/>
+          </a:prstGeom>
+          <a:noFill/>
+        </p:spPr>
+        <p:txBody>
+          <a:bodyPr wrap="square" anchor="t">
+            <a:spAutoFit/>
+          </a:bodyPr>
+          <a:lstStyle/>
+          <a:p>
+            <a:pPr algn="r"/>
+            <a:r>
+              <a:rPr sz="960" b="0">
+                <a:solidFill>
+                  <a:srgbClr val="0F172A"/>
+                </a:solidFill>
+                <a:latin typeface="Arial"/>
+              </a:rPr>
+              <a:t>satın alma niyeti güçlü</a:t>
+            </a:r>
+          </a:p>
+        </p:txBody>
+      </p:sp>
+      <p:sp>
+        <p:nvSpPr>
+          <p:cNvPr id="67" name="Rectangle 66"/>
           <p:cNvSpPr/>
           <p:nvPr/>
         </p:nvSpPr>
@@ -5094,7 +6213,7 @@
       </p:sp>
       <p:sp>
         <p:nvSpPr>
-          <p:cNvPr id="43" name="Rectangle 42"/>
+          <p:cNvPr id="68" name="Rectangle 67"/>
           <p:cNvSpPr/>
           <p:nvPr/>
         </p:nvSpPr>
@@ -5139,7 +6258,7 @@
       </p:sp>
       <p:sp>
         <p:nvSpPr>
-          <p:cNvPr id="44" name="Rectangle 43"/>
+          <p:cNvPr id="69" name="Rectangle 68"/>
           <p:cNvSpPr/>
           <p:nvPr/>
         </p:nvSpPr>
@@ -5184,7 +6303,7 @@
       </p:sp>
       <p:sp>
         <p:nvSpPr>
-          <p:cNvPr id="45" name="TextBox 44"/>
+          <p:cNvPr id="70" name="TextBox 69"/>
           <p:cNvSpPr txBox="1"/>
           <p:nvPr/>
         </p:nvSpPr>
@@ -5219,7 +6338,7 @@
       </p:sp>
       <p:sp>
         <p:nvSpPr>
-          <p:cNvPr id="46" name="TextBox 45"/>
+          <p:cNvPr id="71" name="TextBox 70"/>
           <p:cNvSpPr txBox="1"/>
           <p:nvPr/>
         </p:nvSpPr>
@@ -5318,7 +6437,7 @@
       </p:sp>
       <p:sp>
         <p:nvSpPr>
-          <p:cNvPr id="47" name="Rectangle 46"/>
+          <p:cNvPr id="72" name="Rectangle 71"/>
           <p:cNvSpPr/>
           <p:nvPr/>
         </p:nvSpPr>
@@ -5363,7 +6482,7 @@
       </p:sp>
       <p:sp>
         <p:nvSpPr>
-          <p:cNvPr id="48" name="Rectangle 47"/>
+          <p:cNvPr id="73" name="Rectangle 72"/>
           <p:cNvSpPr/>
           <p:nvPr/>
         </p:nvSpPr>
@@ -5408,7 +6527,7 @@
       </p:sp>
       <p:sp>
         <p:nvSpPr>
-          <p:cNvPr id="49" name="Rectangle 48"/>
+          <p:cNvPr id="74" name="Rectangle 73"/>
           <p:cNvSpPr/>
           <p:nvPr/>
         </p:nvSpPr>
@@ -5453,7 +6572,7 @@
       </p:sp>
       <p:sp>
         <p:nvSpPr>
-          <p:cNvPr id="50" name="TextBox 49"/>
+          <p:cNvPr id="75" name="TextBox 74"/>
           <p:cNvSpPr txBox="1"/>
           <p:nvPr/>
         </p:nvSpPr>
@@ -5488,7 +6607,7 @@
       </p:sp>
       <p:sp>
         <p:nvSpPr>
-          <p:cNvPr id="51" name="TextBox 50"/>
+          <p:cNvPr id="76" name="TextBox 75"/>
           <p:cNvSpPr txBox="1"/>
           <p:nvPr/>
         </p:nvSpPr>
@@ -5568,7 +6687,7 @@
       </p:sp>
       <p:graphicFrame>
         <p:nvGraphicFramePr>
-          <p:cNvPr id="52" name="Table 51"/>
+          <p:cNvPr id="77" name="Table 76"/>
           <p:cNvGraphicFramePr>
             <a:graphicFrameLocks noGrp="1"/>
           </p:cNvGraphicFramePr>
@@ -6003,7 +7122,7 @@
       </p:graphicFrame>
       <p:sp>
         <p:nvSpPr>
-          <p:cNvPr id="53" name="Rectangle 52"/>
+          <p:cNvPr id="78" name="Rectangle 77"/>
           <p:cNvSpPr/>
           <p:nvPr/>
         </p:nvSpPr>
@@ -6048,7 +7167,7 @@
       </p:sp>
       <p:sp>
         <p:nvSpPr>
-          <p:cNvPr id="54" name="Rectangle 53"/>
+          <p:cNvPr id="79" name="Rectangle 78"/>
           <p:cNvSpPr/>
           <p:nvPr/>
         </p:nvSpPr>
@@ -6093,7 +7212,7 @@
       </p:sp>
       <p:sp>
         <p:nvSpPr>
-          <p:cNvPr id="55" name="Rectangle 54"/>
+          <p:cNvPr id="80" name="Rectangle 79"/>
           <p:cNvSpPr/>
           <p:nvPr/>
         </p:nvSpPr>
@@ -6138,7 +7257,7 @@
       </p:sp>
       <p:sp>
         <p:nvSpPr>
-          <p:cNvPr id="56" name="TextBox 55"/>
+          <p:cNvPr id="81" name="TextBox 80"/>
           <p:cNvSpPr txBox="1"/>
           <p:nvPr/>
         </p:nvSpPr>
@@ -6173,7 +7292,7 @@
       </p:sp>
       <p:sp>
         <p:nvSpPr>
-          <p:cNvPr id="57" name="TextBox 56"/>
+          <p:cNvPr id="82" name="TextBox 81"/>
           <p:cNvSpPr txBox="1"/>
           <p:nvPr/>
         </p:nvSpPr>
@@ -6272,7 +7391,7 @@
       </p:sp>
       <p:sp>
         <p:nvSpPr>
-          <p:cNvPr id="58" name="Oval 57"/>
+          <p:cNvPr id="83" name="Oval 82"/>
           <p:cNvSpPr/>
           <p:nvPr/>
         </p:nvSpPr>
@@ -6317,7 +7436,7 @@
       </p:sp>
       <p:sp>
         <p:nvSpPr>
-          <p:cNvPr id="59" name="TextBox 58"/>
+          <p:cNvPr id="84" name="TextBox 83"/>
           <p:cNvSpPr txBox="1"/>
           <p:nvPr/>
         </p:nvSpPr>
@@ -6352,7 +7471,7 @@
       </p:sp>
       <p:sp>
         <p:nvSpPr>
-          <p:cNvPr id="60" name="TextBox 59"/>
+          <p:cNvPr id="85" name="TextBox 84"/>
           <p:cNvSpPr txBox="1"/>
           <p:nvPr/>
         </p:nvSpPr>
@@ -6387,7 +7506,7 @@
       </p:sp>
       <p:sp>
         <p:nvSpPr>
-          <p:cNvPr id="61" name="TextBox 60"/>
+          <p:cNvPr id="86" name="TextBox 85"/>
           <p:cNvSpPr txBox="1"/>
           <p:nvPr/>
         </p:nvSpPr>

</xml_diff>

<commit_message>
Add richer visuals to thesis poster
</commit_message>
<xml_diff>
--- a/docs/PAU_Market_Tez_Posteri.pptx
+++ b/docs/PAU_Market_Tez_Posteri.pptx
@@ -3614,7 +3614,223 @@
       </p:sp>
       <p:sp>
         <p:nvSpPr>
-          <p:cNvPr id="15" name="Rectangle 14"/>
+          <p:cNvPr id="15" name="Rounded Rectangle 14"/>
+          <p:cNvSpPr/>
+          <p:nvPr/>
+        </p:nvSpPr>
+        <p:spPr>
+          <a:xfrm>
+            <a:off x="3150000" y="3762000"/>
+            <a:ext cx="2754000" cy="306000"/>
+          </a:xfrm>
+          <a:prstGeom prst="roundRect">
+            <a:avLst/>
+          </a:prstGeom>
+          <a:solidFill>
+            <a:srgbClr val="FFFFFF"/>
+          </a:solidFill>
+          <a:ln w="10160">
+            <a:solidFill>
+              <a:srgbClr val="FFFFFF"/>
+            </a:solidFill>
+          </a:ln>
+        </p:spPr>
+        <p:style>
+          <a:lnRef idx="1">
+            <a:schemeClr val="accent1"/>
+          </a:lnRef>
+          <a:fillRef idx="3">
+            <a:schemeClr val="accent1"/>
+          </a:fillRef>
+          <a:effectRef idx="2">
+            <a:schemeClr val="accent1"/>
+          </a:effectRef>
+          <a:fontRef idx="minor">
+            <a:schemeClr val="lt1"/>
+          </a:fontRef>
+        </p:style>
+        <p:txBody>
+          <a:bodyPr rtlCol="0" anchor="ctr"/>
+          <a:lstStyle/>
+          <a:p>
+            <a:pPr algn="ctr"/>
+            <a:r>
+              <a:rPr sz="880" b="1">
+                <a:solidFill>
+                  <a:srgbClr val="10B981"/>
+                </a:solidFill>
+                <a:latin typeface="Arial"/>
+              </a:rPr>
+              <a:t>PAÜ e-posta doğrulama</a:t>
+            </a:r>
+          </a:p>
+        </p:txBody>
+      </p:sp>
+      <p:sp>
+        <p:nvSpPr>
+          <p:cNvPr id="16" name="Rounded Rectangle 15"/>
+          <p:cNvSpPr/>
+          <p:nvPr/>
+        </p:nvSpPr>
+        <p:spPr>
+          <a:xfrm>
+            <a:off x="6173999" y="3762000"/>
+            <a:ext cx="2754000" cy="306000"/>
+          </a:xfrm>
+          <a:prstGeom prst="roundRect">
+            <a:avLst/>
+          </a:prstGeom>
+          <a:solidFill>
+            <a:srgbClr val="FFFFFF"/>
+          </a:solidFill>
+          <a:ln w="10160">
+            <a:solidFill>
+              <a:srgbClr val="FFFFFF"/>
+            </a:solidFill>
+          </a:ln>
+        </p:spPr>
+        <p:style>
+          <a:lnRef idx="1">
+            <a:schemeClr val="accent1"/>
+          </a:lnRef>
+          <a:fillRef idx="3">
+            <a:schemeClr val="accent1"/>
+          </a:fillRef>
+          <a:effectRef idx="2">
+            <a:schemeClr val="accent1"/>
+          </a:effectRef>
+          <a:fontRef idx="minor">
+            <a:schemeClr val="lt1"/>
+          </a:fontRef>
+        </p:style>
+        <p:txBody>
+          <a:bodyPr rtlCol="0" anchor="ctr"/>
+          <a:lstStyle/>
+          <a:p>
+            <a:pPr algn="ctr"/>
+            <a:r>
+              <a:rPr sz="880" b="1">
+                <a:solidFill>
+                  <a:srgbClr val="0F172A"/>
+                </a:solidFill>
+                <a:latin typeface="Arial"/>
+              </a:rPr>
+              <a:t>Güvenli mesajlaşma</a:t>
+            </a:r>
+          </a:p>
+        </p:txBody>
+      </p:sp>
+      <p:sp>
+        <p:nvSpPr>
+          <p:cNvPr id="17" name="Rounded Rectangle 16"/>
+          <p:cNvSpPr/>
+          <p:nvPr/>
+        </p:nvSpPr>
+        <p:spPr>
+          <a:xfrm>
+            <a:off x="9198000" y="3762000"/>
+            <a:ext cx="2754000" cy="306000"/>
+          </a:xfrm>
+          <a:prstGeom prst="roundRect">
+            <a:avLst/>
+          </a:prstGeom>
+          <a:solidFill>
+            <a:srgbClr val="FFFFFF"/>
+          </a:solidFill>
+          <a:ln w="10160">
+            <a:solidFill>
+              <a:srgbClr val="FFFFFF"/>
+            </a:solidFill>
+          </a:ln>
+        </p:spPr>
+        <p:style>
+          <a:lnRef idx="1">
+            <a:schemeClr val="accent1"/>
+          </a:lnRef>
+          <a:fillRef idx="3">
+            <a:schemeClr val="accent1"/>
+          </a:fillRef>
+          <a:effectRef idx="2">
+            <a:schemeClr val="accent1"/>
+          </a:effectRef>
+          <a:fontRef idx="minor">
+            <a:schemeClr val="lt1"/>
+          </a:fontRef>
+        </p:style>
+        <p:txBody>
+          <a:bodyPr rtlCol="0" anchor="ctr"/>
+          <a:lstStyle/>
+          <a:p>
+            <a:pPr algn="ctr"/>
+            <a:r>
+              <a:rPr sz="880" b="1">
+                <a:solidFill>
+                  <a:srgbClr val="1E40AF"/>
+                </a:solidFill>
+                <a:latin typeface="Arial"/>
+              </a:rPr>
+              <a:t>Kampüs içi teslim</a:t>
+            </a:r>
+          </a:p>
+        </p:txBody>
+      </p:sp>
+      <p:sp>
+        <p:nvSpPr>
+          <p:cNvPr id="18" name="Rounded Rectangle 17"/>
+          <p:cNvSpPr/>
+          <p:nvPr/>
+        </p:nvSpPr>
+        <p:spPr>
+          <a:xfrm>
+            <a:off x="12222000" y="3762000"/>
+            <a:ext cx="2754000" cy="306000"/>
+          </a:xfrm>
+          <a:prstGeom prst="roundRect">
+            <a:avLst/>
+          </a:prstGeom>
+          <a:solidFill>
+            <a:srgbClr val="FFFFFF"/>
+          </a:solidFill>
+          <a:ln w="10160">
+            <a:solidFill>
+              <a:srgbClr val="FFFFFF"/>
+            </a:solidFill>
+          </a:ln>
+        </p:spPr>
+        <p:style>
+          <a:lnRef idx="1">
+            <a:schemeClr val="accent1"/>
+          </a:lnRef>
+          <a:fillRef idx="3">
+            <a:schemeClr val="accent1"/>
+          </a:fillRef>
+          <a:effectRef idx="2">
+            <a:schemeClr val="accent1"/>
+          </a:effectRef>
+          <a:fontRef idx="minor">
+            <a:schemeClr val="lt1"/>
+          </a:fontRef>
+        </p:style>
+        <p:txBody>
+          <a:bodyPr rtlCol="0" anchor="ctr"/>
+          <a:lstStyle/>
+          <a:p>
+            <a:pPr algn="ctr"/>
+            <a:r>
+              <a:rPr sz="880" b="1">
+                <a:solidFill>
+                  <a:srgbClr val="10B981"/>
+                </a:solidFill>
+                <a:latin typeface="Arial"/>
+              </a:rPr>
+              <a:t>LightFM öneri sistemi</a:t>
+            </a:r>
+          </a:p>
+        </p:txBody>
+      </p:sp>
+      <p:sp>
+        <p:nvSpPr>
+          <p:cNvPr id="19" name="Rectangle 18"/>
           <p:cNvSpPr/>
           <p:nvPr/>
         </p:nvSpPr>
@@ -3659,7 +3875,7 @@
       </p:sp>
       <p:sp>
         <p:nvSpPr>
-          <p:cNvPr id="16" name="Rectangle 15"/>
+          <p:cNvPr id="20" name="Rectangle 19"/>
           <p:cNvSpPr/>
           <p:nvPr/>
         </p:nvSpPr>
@@ -3704,7 +3920,7 @@
       </p:sp>
       <p:sp>
         <p:nvSpPr>
-          <p:cNvPr id="17" name="Rectangle 16"/>
+          <p:cNvPr id="21" name="Rectangle 20"/>
           <p:cNvSpPr/>
           <p:nvPr/>
         </p:nvSpPr>
@@ -3749,7 +3965,7 @@
       </p:sp>
       <p:sp>
         <p:nvSpPr>
-          <p:cNvPr id="18" name="Rectangle 17"/>
+          <p:cNvPr id="22" name="Rectangle 21"/>
           <p:cNvSpPr/>
           <p:nvPr/>
         </p:nvSpPr>
@@ -3794,7 +4010,7 @@
       </p:sp>
       <p:sp>
         <p:nvSpPr>
-          <p:cNvPr id="19" name="Rectangle 18"/>
+          <p:cNvPr id="23" name="Rectangle 22"/>
           <p:cNvSpPr/>
           <p:nvPr/>
         </p:nvSpPr>
@@ -3839,7 +4055,7 @@
       </p:sp>
       <p:sp>
         <p:nvSpPr>
-          <p:cNvPr id="20" name="TextBox 19"/>
+          <p:cNvPr id="24" name="TextBox 23"/>
           <p:cNvSpPr txBox="1"/>
           <p:nvPr/>
         </p:nvSpPr>
@@ -3874,7 +4090,7 @@
       </p:sp>
       <p:sp>
         <p:nvSpPr>
-          <p:cNvPr id="21" name="TextBox 20"/>
+          <p:cNvPr id="25" name="TextBox 24"/>
           <p:cNvSpPr txBox="1"/>
           <p:nvPr/>
         </p:nvSpPr>
@@ -3954,7 +4170,7 @@
       </p:sp>
       <p:sp>
         <p:nvSpPr>
-          <p:cNvPr id="22" name="Rounded Rectangle 21"/>
+          <p:cNvPr id="26" name="Rounded Rectangle 25"/>
           <p:cNvSpPr/>
           <p:nvPr/>
         </p:nvSpPr>
@@ -4008,7 +4224,7 @@
       </p:sp>
       <p:sp>
         <p:nvSpPr>
-          <p:cNvPr id="23" name="Rounded Rectangle 22"/>
+          <p:cNvPr id="27" name="Rounded Rectangle 26"/>
           <p:cNvSpPr/>
           <p:nvPr/>
         </p:nvSpPr>
@@ -4062,7 +4278,7 @@
       </p:sp>
       <p:sp>
         <p:nvSpPr>
-          <p:cNvPr id="24" name="Rounded Rectangle 23"/>
+          <p:cNvPr id="28" name="Rounded Rectangle 27"/>
           <p:cNvSpPr/>
           <p:nvPr/>
         </p:nvSpPr>
@@ -4116,7 +4332,7 @@
       </p:sp>
       <p:sp>
         <p:nvSpPr>
-          <p:cNvPr id="25" name="Rectangle 24"/>
+          <p:cNvPr id="29" name="Rectangle 28"/>
           <p:cNvSpPr/>
           <p:nvPr/>
         </p:nvSpPr>
@@ -4161,7 +4377,7 @@
       </p:sp>
       <p:sp>
         <p:nvSpPr>
-          <p:cNvPr id="26" name="Rectangle 25"/>
+          <p:cNvPr id="30" name="Rectangle 29"/>
           <p:cNvSpPr/>
           <p:nvPr/>
         </p:nvSpPr>
@@ -4206,7 +4422,7 @@
       </p:sp>
       <p:sp>
         <p:nvSpPr>
-          <p:cNvPr id="27" name="Rectangle 26"/>
+          <p:cNvPr id="31" name="Rectangle 30"/>
           <p:cNvSpPr/>
           <p:nvPr/>
         </p:nvSpPr>
@@ -4251,7 +4467,7 @@
       </p:sp>
       <p:sp>
         <p:nvSpPr>
-          <p:cNvPr id="28" name="TextBox 27"/>
+          <p:cNvPr id="32" name="TextBox 31"/>
           <p:cNvSpPr txBox="1"/>
           <p:nvPr/>
         </p:nvSpPr>
@@ -4286,7 +4502,7 @@
       </p:sp>
       <p:sp>
         <p:nvSpPr>
-          <p:cNvPr id="29" name="TextBox 28"/>
+          <p:cNvPr id="33" name="TextBox 32"/>
           <p:cNvSpPr txBox="1"/>
           <p:nvPr/>
         </p:nvSpPr>
@@ -4366,7 +4582,7 @@
       </p:sp>
       <p:sp>
         <p:nvSpPr>
-          <p:cNvPr id="30" name="Rectangle 29"/>
+          <p:cNvPr id="34" name="Rectangle 33"/>
           <p:cNvSpPr/>
           <p:nvPr/>
         </p:nvSpPr>
@@ -4411,7 +4627,7 @@
       </p:sp>
       <p:sp>
         <p:nvSpPr>
-          <p:cNvPr id="31" name="Rectangle 30"/>
+          <p:cNvPr id="35" name="Rectangle 34"/>
           <p:cNvSpPr/>
           <p:nvPr/>
         </p:nvSpPr>
@@ -4456,7 +4672,7 @@
       </p:sp>
       <p:sp>
         <p:nvSpPr>
-          <p:cNvPr id="32" name="Rectangle 31"/>
+          <p:cNvPr id="36" name="Rectangle 35"/>
           <p:cNvSpPr/>
           <p:nvPr/>
         </p:nvSpPr>
@@ -4501,7 +4717,7 @@
       </p:sp>
       <p:sp>
         <p:nvSpPr>
-          <p:cNvPr id="33" name="TextBox 32"/>
+          <p:cNvPr id="37" name="TextBox 36"/>
           <p:cNvSpPr txBox="1"/>
           <p:nvPr/>
         </p:nvSpPr>
@@ -4536,7 +4752,7 @@
       </p:sp>
       <p:sp>
         <p:nvSpPr>
-          <p:cNvPr id="34" name="TextBox 33"/>
+          <p:cNvPr id="38" name="TextBox 37"/>
           <p:cNvSpPr txBox="1"/>
           <p:nvPr/>
         </p:nvSpPr>
@@ -4654,7 +4870,7 @@
       </p:sp>
       <p:sp>
         <p:nvSpPr>
-          <p:cNvPr id="35" name="Rounded Rectangle 34"/>
+          <p:cNvPr id="39" name="Rounded Rectangle 38"/>
           <p:cNvSpPr/>
           <p:nvPr/>
         </p:nvSpPr>
@@ -4712,7 +4928,7 @@
       </p:sp>
       <p:sp>
         <p:nvSpPr>
-          <p:cNvPr id="36" name="Rounded Rectangle 35"/>
+          <p:cNvPr id="40" name="Rounded Rectangle 39"/>
           <p:cNvSpPr/>
           <p:nvPr/>
         </p:nvSpPr>
@@ -4770,7 +4986,7 @@
       </p:sp>
       <p:sp>
         <p:nvSpPr>
-          <p:cNvPr id="37" name="Rounded Rectangle 36"/>
+          <p:cNvPr id="41" name="Rounded Rectangle 40"/>
           <p:cNvSpPr/>
           <p:nvPr/>
         </p:nvSpPr>
@@ -4828,7 +5044,7 @@
       </p:sp>
       <p:sp>
         <p:nvSpPr>
-          <p:cNvPr id="38" name="Rounded Rectangle 37"/>
+          <p:cNvPr id="42" name="Rounded Rectangle 41"/>
           <p:cNvSpPr/>
           <p:nvPr/>
         </p:nvSpPr>
@@ -4886,7 +5102,7 @@
       </p:sp>
       <p:cxnSp>
         <p:nvCxnSpPr>
-          <p:cNvPr id="39" name="Connector 38"/>
+          <p:cNvPr id="43" name="Connector 42"/>
           <p:cNvCxnSpPr/>
           <p:nvPr/>
         </p:nvCxnSpPr>
@@ -4921,7 +5137,7 @@
       </p:cxnSp>
       <p:cxnSp>
         <p:nvCxnSpPr>
-          <p:cNvPr id="40" name="Connector 39"/>
+          <p:cNvPr id="44" name="Connector 43"/>
           <p:cNvCxnSpPr/>
           <p:nvPr/>
         </p:nvCxnSpPr>
@@ -4956,7 +5172,7 @@
       </p:cxnSp>
       <p:cxnSp>
         <p:nvCxnSpPr>
-          <p:cNvPr id="41" name="Connector 40"/>
+          <p:cNvPr id="45" name="Connector 44"/>
           <p:cNvCxnSpPr/>
           <p:nvPr/>
         </p:nvCxnSpPr>
@@ -4991,7 +5207,7 @@
       </p:cxnSp>
       <p:sp>
         <p:nvSpPr>
-          <p:cNvPr id="42" name="TextBox 41"/>
+          <p:cNvPr id="46" name="TextBox 45"/>
           <p:cNvSpPr txBox="1"/>
           <p:nvPr/>
         </p:nvSpPr>
@@ -5026,14 +5242,14 @@
       </p:sp>
       <p:sp>
         <p:nvSpPr>
-          <p:cNvPr id="43" name="Rectangle 42"/>
+          <p:cNvPr id="47" name="Rectangle 46"/>
           <p:cNvSpPr/>
           <p:nvPr/>
         </p:nvSpPr>
         <p:spPr>
           <a:xfrm>
             <a:off x="1332000" y="17838000"/>
-            <a:ext cx="9072000" cy="4500000"/>
+            <a:ext cx="9072000" cy="7703999"/>
           </a:xfrm>
           <a:prstGeom prst="rect">
             <a:avLst/>
@@ -5071,14 +5287,14 @@
       </p:sp>
       <p:sp>
         <p:nvSpPr>
-          <p:cNvPr id="44" name="Rectangle 43"/>
+          <p:cNvPr id="48" name="Rectangle 47"/>
           <p:cNvSpPr/>
           <p:nvPr/>
         </p:nvSpPr>
         <p:spPr>
           <a:xfrm>
             <a:off x="1332000" y="17838000"/>
-            <a:ext cx="79200" cy="4500000"/>
+            <a:ext cx="79200" cy="7703999"/>
           </a:xfrm>
           <a:prstGeom prst="rect">
             <a:avLst/>
@@ -5116,7 +5332,7 @@
       </p:sp>
       <p:sp>
         <p:nvSpPr>
-          <p:cNvPr id="45" name="Rectangle 44"/>
+          <p:cNvPr id="49" name="Rectangle 48"/>
           <p:cNvSpPr/>
           <p:nvPr/>
         </p:nvSpPr>
@@ -5161,7 +5377,7 @@
       </p:sp>
       <p:sp>
         <p:nvSpPr>
-          <p:cNvPr id="46" name="TextBox 45"/>
+          <p:cNvPr id="50" name="TextBox 49"/>
           <p:cNvSpPr txBox="1"/>
           <p:nvPr/>
         </p:nvSpPr>
@@ -5196,14 +5412,14 @@
       </p:sp>
       <p:sp>
         <p:nvSpPr>
-          <p:cNvPr id="47" name="TextBox 46"/>
+          <p:cNvPr id="51" name="TextBox 50"/>
           <p:cNvSpPr txBox="1"/>
           <p:nvPr/>
         </p:nvSpPr>
         <p:spPr>
           <a:xfrm>
             <a:off x="1450800" y="18360000"/>
-            <a:ext cx="8834400" cy="3906000"/>
+            <a:ext cx="8834400" cy="7110000"/>
           </a:xfrm>
           <a:prstGeom prst="rect">
             <a:avLst/>
@@ -5314,7 +5530,1143 @@
       </p:sp>
       <p:sp>
         <p:nvSpPr>
-          <p:cNvPr id="48" name="Rectangle 47"/>
+          <p:cNvPr id="52" name="Rectangle 51"/>
+          <p:cNvSpPr/>
+          <p:nvPr/>
+        </p:nvSpPr>
+        <p:spPr>
+          <a:xfrm>
+            <a:off x="1745999" y="21618000"/>
+            <a:ext cx="7703999" cy="2951999"/>
+          </a:xfrm>
+          <a:prstGeom prst="rect">
+            <a:avLst/>
+          </a:prstGeom>
+          <a:solidFill>
+            <a:srgbClr val="FFFFFF"/>
+          </a:solidFill>
+          <a:ln w="10160">
+            <a:solidFill>
+              <a:srgbClr val="BFDBFE"/>
+            </a:solidFill>
+          </a:ln>
+        </p:spPr>
+        <p:style>
+          <a:lnRef idx="1">
+            <a:schemeClr val="accent1"/>
+          </a:lnRef>
+          <a:fillRef idx="3">
+            <a:schemeClr val="accent1"/>
+          </a:fillRef>
+          <a:effectRef idx="2">
+            <a:schemeClr val="accent1"/>
+          </a:effectRef>
+          <a:fontRef idx="minor">
+            <a:schemeClr val="lt1"/>
+          </a:fontRef>
+        </p:style>
+        <p:txBody>
+          <a:bodyPr rtlCol="0" anchor="ctr"/>
+          <a:lstStyle/>
+          <a:p>
+            <a:pPr algn="ctr"/>
+          </a:p>
+        </p:txBody>
+      </p:sp>
+      <p:sp>
+        <p:nvSpPr>
+          <p:cNvPr id="53" name="Rectangle 52"/>
+          <p:cNvSpPr/>
+          <p:nvPr/>
+        </p:nvSpPr>
+        <p:spPr>
+          <a:xfrm>
+            <a:off x="1745999" y="21618000"/>
+            <a:ext cx="7703999" cy="486000"/>
+          </a:xfrm>
+          <a:prstGeom prst="rect">
+            <a:avLst/>
+          </a:prstGeom>
+          <a:solidFill>
+            <a:srgbClr val="0F172A"/>
+          </a:solidFill>
+          <a:ln w="3810">
+            <a:solidFill>
+              <a:srgbClr val="0F172A"/>
+            </a:solidFill>
+          </a:ln>
+        </p:spPr>
+        <p:style>
+          <a:lnRef idx="1">
+            <a:schemeClr val="accent1"/>
+          </a:lnRef>
+          <a:fillRef idx="3">
+            <a:schemeClr val="accent1"/>
+          </a:fillRef>
+          <a:effectRef idx="2">
+            <a:schemeClr val="accent1"/>
+          </a:effectRef>
+          <a:fontRef idx="minor">
+            <a:schemeClr val="lt1"/>
+          </a:fontRef>
+        </p:style>
+        <p:txBody>
+          <a:bodyPr rtlCol="0" anchor="ctr"/>
+          <a:lstStyle/>
+          <a:p>
+            <a:pPr algn="ctr"/>
+          </a:p>
+        </p:txBody>
+      </p:sp>
+      <p:sp>
+        <p:nvSpPr>
+          <p:cNvPr id="54" name="TextBox 53"/>
+          <p:cNvSpPr txBox="1"/>
+          <p:nvPr/>
+        </p:nvSpPr>
+        <p:spPr>
+          <a:xfrm>
+            <a:off x="1998000" y="21733200"/>
+            <a:ext cx="3060000" cy="216000"/>
+          </a:xfrm>
+          <a:prstGeom prst="rect">
+            <a:avLst/>
+          </a:prstGeom>
+          <a:noFill/>
+        </p:spPr>
+        <p:txBody>
+          <a:bodyPr wrap="square" anchor="t">
+            <a:spAutoFit/>
+          </a:bodyPr>
+          <a:lstStyle/>
+          <a:p>
+            <a:pPr algn="l"/>
+            <a:r>
+              <a:rPr sz="1200" b="1">
+                <a:solidFill>
+                  <a:srgbClr val="FFFFFF"/>
+                </a:solidFill>
+                <a:latin typeface="Arial"/>
+              </a:rPr>
+              <a:t>PAÜ Market arayüz örneği</a:t>
+            </a:r>
+          </a:p>
+        </p:txBody>
+      </p:sp>
+      <p:sp>
+        <p:nvSpPr>
+          <p:cNvPr id="55" name="Rounded Rectangle 54"/>
+          <p:cNvSpPr/>
+          <p:nvPr/>
+        </p:nvSpPr>
+        <p:spPr>
+          <a:xfrm>
+            <a:off x="5562000" y="21733200"/>
+            <a:ext cx="3348000" cy="259200"/>
+          </a:xfrm>
+          <a:prstGeom prst="roundRect">
+            <a:avLst/>
+          </a:prstGeom>
+          <a:solidFill>
+            <a:srgbClr val="FFFFFF"/>
+          </a:solidFill>
+          <a:ln w="10160">
+            <a:solidFill>
+              <a:srgbClr val="FFFFFF"/>
+            </a:solidFill>
+          </a:ln>
+        </p:spPr>
+        <p:style>
+          <a:lnRef idx="1">
+            <a:schemeClr val="accent1"/>
+          </a:lnRef>
+          <a:fillRef idx="3">
+            <a:schemeClr val="accent1"/>
+          </a:fillRef>
+          <a:effectRef idx="2">
+            <a:schemeClr val="accent1"/>
+          </a:effectRef>
+          <a:fontRef idx="minor">
+            <a:schemeClr val="lt1"/>
+          </a:fontRef>
+        </p:style>
+        <p:txBody>
+          <a:bodyPr rtlCol="0" anchor="ctr"/>
+          <a:lstStyle/>
+          <a:p>
+            <a:pPr algn="ctr"/>
+            <a:r>
+              <a:rPr sz="860" b="1">
+                <a:solidFill>
+                  <a:srgbClr val="0F172A"/>
+                </a:solidFill>
+                <a:latin typeface="Arial"/>
+              </a:rPr>
+              <a:t>Ara: macbook, şarj, ders notu</a:t>
+            </a:r>
+          </a:p>
+        </p:txBody>
+      </p:sp>
+      <p:sp>
+        <p:nvSpPr>
+          <p:cNvPr id="56" name="Rectangle 55"/>
+          <p:cNvSpPr/>
+          <p:nvPr/>
+        </p:nvSpPr>
+        <p:spPr>
+          <a:xfrm>
+            <a:off x="2015999" y="22355999"/>
+            <a:ext cx="2322000" cy="1638000"/>
+          </a:xfrm>
+          <a:prstGeom prst="rect">
+            <a:avLst/>
+          </a:prstGeom>
+          <a:solidFill>
+            <a:srgbClr val="FFFFFF"/>
+          </a:solidFill>
+          <a:ln w="8890">
+            <a:solidFill>
+              <a:srgbClr val="BFDBFE"/>
+            </a:solidFill>
+          </a:ln>
+        </p:spPr>
+        <p:style>
+          <a:lnRef idx="1">
+            <a:schemeClr val="accent1"/>
+          </a:lnRef>
+          <a:fillRef idx="3">
+            <a:schemeClr val="accent1"/>
+          </a:fillRef>
+          <a:effectRef idx="2">
+            <a:schemeClr val="accent1"/>
+          </a:effectRef>
+          <a:fontRef idx="minor">
+            <a:schemeClr val="lt1"/>
+          </a:fontRef>
+        </p:style>
+        <p:txBody>
+          <a:bodyPr rtlCol="0" anchor="ctr"/>
+          <a:lstStyle/>
+          <a:p>
+            <a:pPr algn="ctr"/>
+          </a:p>
+        </p:txBody>
+      </p:sp>
+      <p:sp>
+        <p:nvSpPr>
+          <p:cNvPr id="57" name="Rectangle 56"/>
+          <p:cNvSpPr/>
+          <p:nvPr/>
+        </p:nvSpPr>
+        <p:spPr>
+          <a:xfrm>
+            <a:off x="2106000" y="22445999"/>
+            <a:ext cx="737999" cy="720000"/>
+          </a:xfrm>
+          <a:prstGeom prst="rect">
+            <a:avLst/>
+          </a:prstGeom>
+          <a:solidFill>
+            <a:srgbClr val="2563EB"/>
+          </a:solidFill>
+          <a:ln w="3810">
+            <a:solidFill>
+              <a:srgbClr val="2563EB"/>
+            </a:solidFill>
+          </a:ln>
+        </p:spPr>
+        <p:style>
+          <a:lnRef idx="1">
+            <a:schemeClr val="accent1"/>
+          </a:lnRef>
+          <a:fillRef idx="3">
+            <a:schemeClr val="accent1"/>
+          </a:fillRef>
+          <a:effectRef idx="2">
+            <a:schemeClr val="accent1"/>
+          </a:effectRef>
+          <a:fontRef idx="minor">
+            <a:schemeClr val="lt1"/>
+          </a:fontRef>
+        </p:style>
+        <p:txBody>
+          <a:bodyPr rtlCol="0" anchor="ctr"/>
+          <a:lstStyle/>
+          <a:p>
+            <a:pPr algn="ctr"/>
+          </a:p>
+        </p:txBody>
+      </p:sp>
+      <p:sp>
+        <p:nvSpPr>
+          <p:cNvPr id="58" name="TextBox 57"/>
+          <p:cNvSpPr txBox="1"/>
+          <p:nvPr/>
+        </p:nvSpPr>
+        <p:spPr>
+          <a:xfrm>
+            <a:off x="2260800" y="22546800"/>
+            <a:ext cx="450000" cy="288000"/>
+          </a:xfrm>
+          <a:prstGeom prst="rect">
+            <a:avLst/>
+          </a:prstGeom>
+          <a:noFill/>
+        </p:spPr>
+        <p:txBody>
+          <a:bodyPr wrap="square" anchor="t">
+            <a:spAutoFit/>
+          </a:bodyPr>
+          <a:lstStyle/>
+          <a:p>
+            <a:pPr algn="ctr"/>
+            <a:r>
+              <a:rPr sz="2100" b="1">
+                <a:solidFill>
+                  <a:srgbClr val="FFFFFF"/>
+                </a:solidFill>
+                <a:latin typeface="Arial"/>
+              </a:rPr>
+              <a:t>✓</a:t>
+            </a:r>
+          </a:p>
+        </p:txBody>
+      </p:sp>
+      <p:sp>
+        <p:nvSpPr>
+          <p:cNvPr id="59" name="TextBox 58"/>
+          <p:cNvSpPr txBox="1"/>
+          <p:nvPr/>
+        </p:nvSpPr>
+        <p:spPr>
+          <a:xfrm>
+            <a:off x="2933999" y="22492800"/>
+            <a:ext cx="1206000" cy="270000"/>
+          </a:xfrm>
+          <a:prstGeom prst="rect">
+            <a:avLst/>
+          </a:prstGeom>
+          <a:noFill/>
+        </p:spPr>
+        <p:txBody>
+          <a:bodyPr wrap="square" anchor="t">
+            <a:spAutoFit/>
+          </a:bodyPr>
+          <a:lstStyle/>
+          <a:p>
+            <a:pPr algn="l"/>
+            <a:r>
+              <a:rPr sz="1070" b="1">
+                <a:solidFill>
+                  <a:srgbClr val="0F172A"/>
+                </a:solidFill>
+                <a:latin typeface="Arial"/>
+              </a:rPr>
+              <a:t>MacBook Air</a:t>
+            </a:r>
+          </a:p>
+        </p:txBody>
+      </p:sp>
+      <p:sp>
+        <p:nvSpPr>
+          <p:cNvPr id="60" name="TextBox 59"/>
+          <p:cNvSpPr txBox="1"/>
+          <p:nvPr/>
+        </p:nvSpPr>
+        <p:spPr>
+          <a:xfrm>
+            <a:off x="2933999" y="22805999"/>
+            <a:ext cx="900000" cy="234000"/>
+          </a:xfrm>
+          <a:prstGeom prst="rect">
+            <a:avLst/>
+          </a:prstGeom>
+          <a:noFill/>
+        </p:spPr>
+        <p:txBody>
+          <a:bodyPr wrap="square" anchor="t">
+            <a:spAutoFit/>
+          </a:bodyPr>
+          <a:lstStyle/>
+          <a:p>
+            <a:pPr algn="l"/>
+            <a:r>
+              <a:rPr sz="1350" b="1">
+                <a:solidFill>
+                  <a:srgbClr val="2563EB"/>
+                </a:solidFill>
+                <a:latin typeface="Arial"/>
+              </a:rPr>
+              <a:t>₺18.500</a:t>
+            </a:r>
+          </a:p>
+        </p:txBody>
+      </p:sp>
+      <p:sp>
+        <p:nvSpPr>
+          <p:cNvPr id="61" name="Rounded Rectangle 60"/>
+          <p:cNvSpPr/>
+          <p:nvPr/>
+        </p:nvSpPr>
+        <p:spPr>
+          <a:xfrm>
+            <a:off x="2933999" y="23130000"/>
+            <a:ext cx="1026000" cy="259200"/>
+          </a:xfrm>
+          <a:prstGeom prst="roundRect">
+            <a:avLst/>
+          </a:prstGeom>
+          <a:solidFill>
+            <a:srgbClr val="E5F1FF"/>
+          </a:solidFill>
+          <a:ln w="10160">
+            <a:solidFill>
+              <a:srgbClr val="BFDBFE"/>
+            </a:solidFill>
+          </a:ln>
+        </p:spPr>
+        <p:style>
+          <a:lnRef idx="1">
+            <a:schemeClr val="accent1"/>
+          </a:lnRef>
+          <a:fillRef idx="3">
+            <a:schemeClr val="accent1"/>
+          </a:fillRef>
+          <a:effectRef idx="2">
+            <a:schemeClr val="accent1"/>
+          </a:effectRef>
+          <a:fontRef idx="minor">
+            <a:schemeClr val="lt1"/>
+          </a:fontRef>
+        </p:style>
+        <p:txBody>
+          <a:bodyPr rtlCol="0" anchor="ctr"/>
+          <a:lstStyle/>
+          <a:p>
+            <a:pPr algn="ctr"/>
+            <a:r>
+              <a:rPr sz="760" b="1">
+                <a:solidFill>
+                  <a:srgbClr val="1E40AF"/>
+                </a:solidFill>
+                <a:latin typeface="Arial"/>
+              </a:rPr>
+              <a:t>Elektronik</a:t>
+            </a:r>
+          </a:p>
+        </p:txBody>
+      </p:sp>
+      <p:sp>
+        <p:nvSpPr>
+          <p:cNvPr id="62" name="TextBox 61"/>
+          <p:cNvSpPr txBox="1"/>
+          <p:nvPr/>
+        </p:nvSpPr>
+        <p:spPr>
+          <a:xfrm>
+            <a:off x="2933999" y="23471999"/>
+            <a:ext cx="1044000" cy="162000"/>
+          </a:xfrm>
+          <a:prstGeom prst="rect">
+            <a:avLst/>
+          </a:prstGeom>
+          <a:noFill/>
+        </p:spPr>
+        <p:txBody>
+          <a:bodyPr wrap="square" anchor="t">
+            <a:spAutoFit/>
+          </a:bodyPr>
+          <a:lstStyle/>
+          <a:p>
+            <a:pPr algn="l"/>
+            <a:r>
+              <a:rPr sz="850" b="0">
+                <a:solidFill>
+                  <a:srgbClr val="475569"/>
+                </a:solidFill>
+                <a:latin typeface="Arial"/>
+              </a:rPr>
+              <a:t>PAÜ Kampüsü</a:t>
+            </a:r>
+          </a:p>
+        </p:txBody>
+      </p:sp>
+      <p:sp>
+        <p:nvSpPr>
+          <p:cNvPr id="63" name="TextBox 62"/>
+          <p:cNvSpPr txBox="1"/>
+          <p:nvPr/>
+        </p:nvSpPr>
+        <p:spPr>
+          <a:xfrm>
+            <a:off x="3941999" y="22428000"/>
+            <a:ext cx="234000" cy="198000"/>
+          </a:xfrm>
+          <a:prstGeom prst="rect">
+            <a:avLst/>
+          </a:prstGeom>
+          <a:noFill/>
+        </p:spPr>
+        <p:txBody>
+          <a:bodyPr wrap="square" anchor="t">
+            <a:spAutoFit/>
+          </a:bodyPr>
+          <a:lstStyle/>
+          <a:p>
+            <a:pPr algn="ctr"/>
+            <a:r>
+              <a:rPr sz="1300" b="1">
+                <a:solidFill>
+                  <a:srgbClr val="DC2626"/>
+                </a:solidFill>
+                <a:latin typeface="Arial"/>
+              </a:rPr>
+              <a:t>♥</a:t>
+            </a:r>
+          </a:p>
+        </p:txBody>
+      </p:sp>
+      <p:sp>
+        <p:nvSpPr>
+          <p:cNvPr id="64" name="Rectangle 63"/>
+          <p:cNvSpPr/>
+          <p:nvPr/>
+        </p:nvSpPr>
+        <p:spPr>
+          <a:xfrm>
+            <a:off x="4428000" y="22355999"/>
+            <a:ext cx="2322000" cy="1638000"/>
+          </a:xfrm>
+          <a:prstGeom prst="rect">
+            <a:avLst/>
+          </a:prstGeom>
+          <a:solidFill>
+            <a:srgbClr val="FFFFFF"/>
+          </a:solidFill>
+          <a:ln w="8890">
+            <a:solidFill>
+              <a:srgbClr val="BFDBFE"/>
+            </a:solidFill>
+          </a:ln>
+        </p:spPr>
+        <p:style>
+          <a:lnRef idx="1">
+            <a:schemeClr val="accent1"/>
+          </a:lnRef>
+          <a:fillRef idx="3">
+            <a:schemeClr val="accent1"/>
+          </a:fillRef>
+          <a:effectRef idx="2">
+            <a:schemeClr val="accent1"/>
+          </a:effectRef>
+          <a:fontRef idx="minor">
+            <a:schemeClr val="lt1"/>
+          </a:fontRef>
+        </p:style>
+        <p:txBody>
+          <a:bodyPr rtlCol="0" anchor="ctr"/>
+          <a:lstStyle/>
+          <a:p>
+            <a:pPr algn="ctr"/>
+          </a:p>
+        </p:txBody>
+      </p:sp>
+      <p:sp>
+        <p:nvSpPr>
+          <p:cNvPr id="65" name="Rectangle 64"/>
+          <p:cNvSpPr/>
+          <p:nvPr/>
+        </p:nvSpPr>
+        <p:spPr>
+          <a:xfrm>
+            <a:off x="4518000" y="22445999"/>
+            <a:ext cx="737999" cy="720000"/>
+          </a:xfrm>
+          <a:prstGeom prst="rect">
+            <a:avLst/>
+          </a:prstGeom>
+          <a:solidFill>
+            <a:srgbClr val="10B981"/>
+          </a:solidFill>
+          <a:ln w="3810">
+            <a:solidFill>
+              <a:srgbClr val="10B981"/>
+            </a:solidFill>
+          </a:ln>
+        </p:spPr>
+        <p:style>
+          <a:lnRef idx="1">
+            <a:schemeClr val="accent1"/>
+          </a:lnRef>
+          <a:fillRef idx="3">
+            <a:schemeClr val="accent1"/>
+          </a:fillRef>
+          <a:effectRef idx="2">
+            <a:schemeClr val="accent1"/>
+          </a:effectRef>
+          <a:fontRef idx="minor">
+            <a:schemeClr val="lt1"/>
+          </a:fontRef>
+        </p:style>
+        <p:txBody>
+          <a:bodyPr rtlCol="0" anchor="ctr"/>
+          <a:lstStyle/>
+          <a:p>
+            <a:pPr algn="ctr"/>
+          </a:p>
+        </p:txBody>
+      </p:sp>
+      <p:sp>
+        <p:nvSpPr>
+          <p:cNvPr id="66" name="TextBox 65"/>
+          <p:cNvSpPr txBox="1"/>
+          <p:nvPr/>
+        </p:nvSpPr>
+        <p:spPr>
+          <a:xfrm>
+            <a:off x="4672800" y="22546800"/>
+            <a:ext cx="450000" cy="288000"/>
+          </a:xfrm>
+          <a:prstGeom prst="rect">
+            <a:avLst/>
+          </a:prstGeom>
+          <a:noFill/>
+        </p:spPr>
+        <p:txBody>
+          <a:bodyPr wrap="square" anchor="t">
+            <a:spAutoFit/>
+          </a:bodyPr>
+          <a:lstStyle/>
+          <a:p>
+            <a:pPr algn="ctr"/>
+            <a:r>
+              <a:rPr sz="2100" b="1">
+                <a:solidFill>
+                  <a:srgbClr val="FFFFFF"/>
+                </a:solidFill>
+                <a:latin typeface="Arial"/>
+              </a:rPr>
+              <a:t>✓</a:t>
+            </a:r>
+          </a:p>
+        </p:txBody>
+      </p:sp>
+      <p:sp>
+        <p:nvSpPr>
+          <p:cNvPr id="67" name="TextBox 66"/>
+          <p:cNvSpPr txBox="1"/>
+          <p:nvPr/>
+        </p:nvSpPr>
+        <p:spPr>
+          <a:xfrm>
+            <a:off x="5346000" y="22492800"/>
+            <a:ext cx="1206000" cy="270000"/>
+          </a:xfrm>
+          <a:prstGeom prst="rect">
+            <a:avLst/>
+          </a:prstGeom>
+          <a:noFill/>
+        </p:spPr>
+        <p:txBody>
+          <a:bodyPr wrap="square" anchor="t">
+            <a:spAutoFit/>
+          </a:bodyPr>
+          <a:lstStyle/>
+          <a:p>
+            <a:pPr algn="l"/>
+            <a:r>
+              <a:rPr sz="1070" b="1">
+                <a:solidFill>
+                  <a:srgbClr val="0F172A"/>
+                </a:solidFill>
+                <a:latin typeface="Arial"/>
+              </a:rPr>
+              <a:t>Şarj Aleti</a:t>
+            </a:r>
+          </a:p>
+        </p:txBody>
+      </p:sp>
+      <p:sp>
+        <p:nvSpPr>
+          <p:cNvPr id="68" name="TextBox 67"/>
+          <p:cNvSpPr txBox="1"/>
+          <p:nvPr/>
+        </p:nvSpPr>
+        <p:spPr>
+          <a:xfrm>
+            <a:off x="5346000" y="22805999"/>
+            <a:ext cx="900000" cy="234000"/>
+          </a:xfrm>
+          <a:prstGeom prst="rect">
+            <a:avLst/>
+          </a:prstGeom>
+          <a:noFill/>
+        </p:spPr>
+        <p:txBody>
+          <a:bodyPr wrap="square" anchor="t">
+            <a:spAutoFit/>
+          </a:bodyPr>
+          <a:lstStyle/>
+          <a:p>
+            <a:pPr algn="l"/>
+            <a:r>
+              <a:rPr sz="1350" b="1">
+                <a:solidFill>
+                  <a:srgbClr val="2563EB"/>
+                </a:solidFill>
+                <a:latin typeface="Arial"/>
+              </a:rPr>
+              <a:t>₺250</a:t>
+            </a:r>
+          </a:p>
+        </p:txBody>
+      </p:sp>
+      <p:sp>
+        <p:nvSpPr>
+          <p:cNvPr id="69" name="Rounded Rectangle 68"/>
+          <p:cNvSpPr/>
+          <p:nvPr/>
+        </p:nvSpPr>
+        <p:spPr>
+          <a:xfrm>
+            <a:off x="5346000" y="23130000"/>
+            <a:ext cx="1026000" cy="259200"/>
+          </a:xfrm>
+          <a:prstGeom prst="roundRect">
+            <a:avLst/>
+          </a:prstGeom>
+          <a:solidFill>
+            <a:srgbClr val="E5F1FF"/>
+          </a:solidFill>
+          <a:ln w="10160">
+            <a:solidFill>
+              <a:srgbClr val="BFDBFE"/>
+            </a:solidFill>
+          </a:ln>
+        </p:spPr>
+        <p:style>
+          <a:lnRef idx="1">
+            <a:schemeClr val="accent1"/>
+          </a:lnRef>
+          <a:fillRef idx="3">
+            <a:schemeClr val="accent1"/>
+          </a:fillRef>
+          <a:effectRef idx="2">
+            <a:schemeClr val="accent1"/>
+          </a:effectRef>
+          <a:fontRef idx="minor">
+            <a:schemeClr val="lt1"/>
+          </a:fontRef>
+        </p:style>
+        <p:txBody>
+          <a:bodyPr rtlCol="0" anchor="ctr"/>
+          <a:lstStyle/>
+          <a:p>
+            <a:pPr algn="ctr"/>
+            <a:r>
+              <a:rPr sz="760" b="1">
+                <a:solidFill>
+                  <a:srgbClr val="1E40AF"/>
+                </a:solidFill>
+                <a:latin typeface="Arial"/>
+              </a:rPr>
+              <a:t>Elektronik</a:t>
+            </a:r>
+          </a:p>
+        </p:txBody>
+      </p:sp>
+      <p:sp>
+        <p:nvSpPr>
+          <p:cNvPr id="70" name="TextBox 69"/>
+          <p:cNvSpPr txBox="1"/>
+          <p:nvPr/>
+        </p:nvSpPr>
+        <p:spPr>
+          <a:xfrm>
+            <a:off x="5346000" y="23471999"/>
+            <a:ext cx="1044000" cy="162000"/>
+          </a:xfrm>
+          <a:prstGeom prst="rect">
+            <a:avLst/>
+          </a:prstGeom>
+          <a:noFill/>
+        </p:spPr>
+        <p:txBody>
+          <a:bodyPr wrap="square" anchor="t">
+            <a:spAutoFit/>
+          </a:bodyPr>
+          <a:lstStyle/>
+          <a:p>
+            <a:pPr algn="l"/>
+            <a:r>
+              <a:rPr sz="850" b="0">
+                <a:solidFill>
+                  <a:srgbClr val="475569"/>
+                </a:solidFill>
+                <a:latin typeface="Arial"/>
+              </a:rPr>
+              <a:t>PAÜ Kampüsü</a:t>
+            </a:r>
+          </a:p>
+        </p:txBody>
+      </p:sp>
+      <p:sp>
+        <p:nvSpPr>
+          <p:cNvPr id="71" name="TextBox 70"/>
+          <p:cNvSpPr txBox="1"/>
+          <p:nvPr/>
+        </p:nvSpPr>
+        <p:spPr>
+          <a:xfrm>
+            <a:off x="6353999" y="22428000"/>
+            <a:ext cx="234000" cy="198000"/>
+          </a:xfrm>
+          <a:prstGeom prst="rect">
+            <a:avLst/>
+          </a:prstGeom>
+          <a:noFill/>
+        </p:spPr>
+        <p:txBody>
+          <a:bodyPr wrap="square" anchor="t">
+            <a:spAutoFit/>
+          </a:bodyPr>
+          <a:lstStyle/>
+          <a:p>
+            <a:pPr algn="ctr"/>
+            <a:r>
+              <a:rPr sz="1300" b="1">
+                <a:solidFill>
+                  <a:srgbClr val="DC2626"/>
+                </a:solidFill>
+                <a:latin typeface="Arial"/>
+              </a:rPr>
+              <a:t>♥</a:t>
+            </a:r>
+          </a:p>
+        </p:txBody>
+      </p:sp>
+      <p:sp>
+        <p:nvSpPr>
+          <p:cNvPr id="72" name="Rectangle 71"/>
+          <p:cNvSpPr/>
+          <p:nvPr/>
+        </p:nvSpPr>
+        <p:spPr>
+          <a:xfrm>
+            <a:off x="6840000" y="22355999"/>
+            <a:ext cx="2322000" cy="1638000"/>
+          </a:xfrm>
+          <a:prstGeom prst="rect">
+            <a:avLst/>
+          </a:prstGeom>
+          <a:solidFill>
+            <a:srgbClr val="FFFFFF"/>
+          </a:solidFill>
+          <a:ln w="8890">
+            <a:solidFill>
+              <a:srgbClr val="BFDBFE"/>
+            </a:solidFill>
+          </a:ln>
+        </p:spPr>
+        <p:style>
+          <a:lnRef idx="1">
+            <a:schemeClr val="accent1"/>
+          </a:lnRef>
+          <a:fillRef idx="3">
+            <a:schemeClr val="accent1"/>
+          </a:fillRef>
+          <a:effectRef idx="2">
+            <a:schemeClr val="accent1"/>
+          </a:effectRef>
+          <a:fontRef idx="minor">
+            <a:schemeClr val="lt1"/>
+          </a:fontRef>
+        </p:style>
+        <p:txBody>
+          <a:bodyPr rtlCol="0" anchor="ctr"/>
+          <a:lstStyle/>
+          <a:p>
+            <a:pPr algn="ctr"/>
+          </a:p>
+        </p:txBody>
+      </p:sp>
+      <p:sp>
+        <p:nvSpPr>
+          <p:cNvPr id="73" name="Rectangle 72"/>
+          <p:cNvSpPr/>
+          <p:nvPr/>
+        </p:nvSpPr>
+        <p:spPr>
+          <a:xfrm>
+            <a:off x="6930000" y="22445999"/>
+            <a:ext cx="737999" cy="720000"/>
+          </a:xfrm>
+          <a:prstGeom prst="rect">
+            <a:avLst/>
+          </a:prstGeom>
+          <a:solidFill>
+            <a:srgbClr val="1E40AF"/>
+          </a:solidFill>
+          <a:ln w="3810">
+            <a:solidFill>
+              <a:srgbClr val="1E40AF"/>
+            </a:solidFill>
+          </a:ln>
+        </p:spPr>
+        <p:style>
+          <a:lnRef idx="1">
+            <a:schemeClr val="accent1"/>
+          </a:lnRef>
+          <a:fillRef idx="3">
+            <a:schemeClr val="accent1"/>
+          </a:fillRef>
+          <a:effectRef idx="2">
+            <a:schemeClr val="accent1"/>
+          </a:effectRef>
+          <a:fontRef idx="minor">
+            <a:schemeClr val="lt1"/>
+          </a:fontRef>
+        </p:style>
+        <p:txBody>
+          <a:bodyPr rtlCol="0" anchor="ctr"/>
+          <a:lstStyle/>
+          <a:p>
+            <a:pPr algn="ctr"/>
+          </a:p>
+        </p:txBody>
+      </p:sp>
+      <p:sp>
+        <p:nvSpPr>
+          <p:cNvPr id="74" name="TextBox 73"/>
+          <p:cNvSpPr txBox="1"/>
+          <p:nvPr/>
+        </p:nvSpPr>
+        <p:spPr>
+          <a:xfrm>
+            <a:off x="7084800" y="22546800"/>
+            <a:ext cx="450000" cy="288000"/>
+          </a:xfrm>
+          <a:prstGeom prst="rect">
+            <a:avLst/>
+          </a:prstGeom>
+          <a:noFill/>
+        </p:spPr>
+        <p:txBody>
+          <a:bodyPr wrap="square" anchor="t">
+            <a:spAutoFit/>
+          </a:bodyPr>
+          <a:lstStyle/>
+          <a:p>
+            <a:pPr algn="ctr"/>
+            <a:r>
+              <a:rPr sz="2100" b="1">
+                <a:solidFill>
+                  <a:srgbClr val="FFFFFF"/>
+                </a:solidFill>
+                <a:latin typeface="Arial"/>
+              </a:rPr>
+              <a:t>✓</a:t>
+            </a:r>
+          </a:p>
+        </p:txBody>
+      </p:sp>
+      <p:sp>
+        <p:nvSpPr>
+          <p:cNvPr id="75" name="TextBox 74"/>
+          <p:cNvSpPr txBox="1"/>
+          <p:nvPr/>
+        </p:nvSpPr>
+        <p:spPr>
+          <a:xfrm>
+            <a:off x="7758000" y="22492800"/>
+            <a:ext cx="1206000" cy="270000"/>
+          </a:xfrm>
+          <a:prstGeom prst="rect">
+            <a:avLst/>
+          </a:prstGeom>
+          <a:noFill/>
+        </p:spPr>
+        <p:txBody>
+          <a:bodyPr wrap="square" anchor="t">
+            <a:spAutoFit/>
+          </a:bodyPr>
+          <a:lstStyle/>
+          <a:p>
+            <a:pPr algn="l"/>
+            <a:r>
+              <a:rPr sz="1070" b="1">
+                <a:solidFill>
+                  <a:srgbClr val="0F172A"/>
+                </a:solidFill>
+                <a:latin typeface="Arial"/>
+              </a:rPr>
+              <a:t>Algoritma Notu</a:t>
+            </a:r>
+          </a:p>
+        </p:txBody>
+      </p:sp>
+      <p:sp>
+        <p:nvSpPr>
+          <p:cNvPr id="76" name="TextBox 75"/>
+          <p:cNvSpPr txBox="1"/>
+          <p:nvPr/>
+        </p:nvSpPr>
+        <p:spPr>
+          <a:xfrm>
+            <a:off x="7758000" y="22805999"/>
+            <a:ext cx="900000" cy="234000"/>
+          </a:xfrm>
+          <a:prstGeom prst="rect">
+            <a:avLst/>
+          </a:prstGeom>
+          <a:noFill/>
+        </p:spPr>
+        <p:txBody>
+          <a:bodyPr wrap="square" anchor="t">
+            <a:spAutoFit/>
+          </a:bodyPr>
+          <a:lstStyle/>
+          <a:p>
+            <a:pPr algn="l"/>
+            <a:r>
+              <a:rPr sz="1350" b="1">
+                <a:solidFill>
+                  <a:srgbClr val="2563EB"/>
+                </a:solidFill>
+                <a:latin typeface="Arial"/>
+              </a:rPr>
+              <a:t>₺50</a:t>
+            </a:r>
+          </a:p>
+        </p:txBody>
+      </p:sp>
+      <p:sp>
+        <p:nvSpPr>
+          <p:cNvPr id="77" name="Rounded Rectangle 76"/>
+          <p:cNvSpPr/>
+          <p:nvPr/>
+        </p:nvSpPr>
+        <p:spPr>
+          <a:xfrm>
+            <a:off x="7758000" y="23130000"/>
+            <a:ext cx="1026000" cy="259200"/>
+          </a:xfrm>
+          <a:prstGeom prst="roundRect">
+            <a:avLst/>
+          </a:prstGeom>
+          <a:solidFill>
+            <a:srgbClr val="E5F1FF"/>
+          </a:solidFill>
+          <a:ln w="10160">
+            <a:solidFill>
+              <a:srgbClr val="BFDBFE"/>
+            </a:solidFill>
+          </a:ln>
+        </p:spPr>
+        <p:style>
+          <a:lnRef idx="1">
+            <a:schemeClr val="accent1"/>
+          </a:lnRef>
+          <a:fillRef idx="3">
+            <a:schemeClr val="accent1"/>
+          </a:fillRef>
+          <a:effectRef idx="2">
+            <a:schemeClr val="accent1"/>
+          </a:effectRef>
+          <a:fontRef idx="minor">
+            <a:schemeClr val="lt1"/>
+          </a:fontRef>
+        </p:style>
+        <p:txBody>
+          <a:bodyPr rtlCol="0" anchor="ctr"/>
+          <a:lstStyle/>
+          <a:p>
+            <a:pPr algn="ctr"/>
+            <a:r>
+              <a:rPr sz="760" b="1">
+                <a:solidFill>
+                  <a:srgbClr val="1E40AF"/>
+                </a:solidFill>
+                <a:latin typeface="Arial"/>
+              </a:rPr>
+              <a:t>Not / Özet</a:t>
+            </a:r>
+          </a:p>
+        </p:txBody>
+      </p:sp>
+      <p:sp>
+        <p:nvSpPr>
+          <p:cNvPr id="78" name="TextBox 77"/>
+          <p:cNvSpPr txBox="1"/>
+          <p:nvPr/>
+        </p:nvSpPr>
+        <p:spPr>
+          <a:xfrm>
+            <a:off x="7758000" y="23471999"/>
+            <a:ext cx="1044000" cy="162000"/>
+          </a:xfrm>
+          <a:prstGeom prst="rect">
+            <a:avLst/>
+          </a:prstGeom>
+          <a:noFill/>
+        </p:spPr>
+        <p:txBody>
+          <a:bodyPr wrap="square" anchor="t">
+            <a:spAutoFit/>
+          </a:bodyPr>
+          <a:lstStyle/>
+          <a:p>
+            <a:pPr algn="l"/>
+            <a:r>
+              <a:rPr sz="850" b="0">
+                <a:solidFill>
+                  <a:srgbClr val="475569"/>
+                </a:solidFill>
+                <a:latin typeface="Arial"/>
+              </a:rPr>
+              <a:t>PAÜ Kampüsü</a:t>
+            </a:r>
+          </a:p>
+        </p:txBody>
+      </p:sp>
+      <p:sp>
+        <p:nvSpPr>
+          <p:cNvPr id="79" name="TextBox 78"/>
+          <p:cNvSpPr txBox="1"/>
+          <p:nvPr/>
+        </p:nvSpPr>
+        <p:spPr>
+          <a:xfrm>
+            <a:off x="8766000" y="22428000"/>
+            <a:ext cx="234000" cy="198000"/>
+          </a:xfrm>
+          <a:prstGeom prst="rect">
+            <a:avLst/>
+          </a:prstGeom>
+          <a:noFill/>
+        </p:spPr>
+        <p:txBody>
+          <a:bodyPr wrap="square" anchor="t">
+            <a:spAutoFit/>
+          </a:bodyPr>
+          <a:lstStyle/>
+          <a:p>
+            <a:pPr algn="ctr"/>
+            <a:r>
+              <a:rPr sz="1300" b="1">
+                <a:solidFill>
+                  <a:srgbClr val="DC2626"/>
+                </a:solidFill>
+                <a:latin typeface="Arial"/>
+              </a:rPr>
+              <a:t>♥</a:t>
+            </a:r>
+          </a:p>
+        </p:txBody>
+      </p:sp>
+      <p:sp>
+        <p:nvSpPr>
+          <p:cNvPr id="80" name="Rectangle 79"/>
           <p:cNvSpPr/>
           <p:nvPr/>
         </p:nvSpPr>
@@ -5359,7 +6711,7 @@
       </p:sp>
       <p:sp>
         <p:nvSpPr>
-          <p:cNvPr id="49" name="Rectangle 48"/>
+          <p:cNvPr id="81" name="Rectangle 80"/>
           <p:cNvSpPr/>
           <p:nvPr/>
         </p:nvSpPr>
@@ -5404,7 +6756,7 @@
       </p:sp>
       <p:sp>
         <p:nvSpPr>
-          <p:cNvPr id="50" name="Rectangle 49"/>
+          <p:cNvPr id="82" name="Rectangle 81"/>
           <p:cNvSpPr/>
           <p:nvPr/>
         </p:nvSpPr>
@@ -5449,7 +6801,7 @@
       </p:sp>
       <p:sp>
         <p:nvSpPr>
-          <p:cNvPr id="51" name="TextBox 50"/>
+          <p:cNvPr id="83" name="TextBox 82"/>
           <p:cNvSpPr txBox="1"/>
           <p:nvPr/>
         </p:nvSpPr>
@@ -5484,7 +6836,7 @@
       </p:sp>
       <p:sp>
         <p:nvSpPr>
-          <p:cNvPr id="52" name="TextBox 51"/>
+          <p:cNvPr id="84" name="TextBox 83"/>
           <p:cNvSpPr txBox="1"/>
           <p:nvPr/>
         </p:nvSpPr>
@@ -5583,7 +6935,7 @@
       </p:sp>
       <p:sp>
         <p:nvSpPr>
-          <p:cNvPr id="53" name="TextBox 52"/>
+          <p:cNvPr id="85" name="TextBox 84"/>
           <p:cNvSpPr txBox="1"/>
           <p:nvPr/>
         </p:nvSpPr>
@@ -5618,14 +6970,14 @@
       </p:sp>
       <p:sp>
         <p:nvSpPr>
-          <p:cNvPr id="54" name="Rounded Rectangle 53"/>
+          <p:cNvPr id="86" name="Rounded Rectangle 85"/>
           <p:cNvSpPr/>
           <p:nvPr/>
         </p:nvSpPr>
         <p:spPr>
           <a:xfrm>
             <a:off x="11376000" y="7793999"/>
-            <a:ext cx="720000" cy="450000"/>
+            <a:ext cx="630000" cy="403200"/>
           </a:xfrm>
           <a:prstGeom prst="roundRect">
             <a:avLst/>
@@ -5659,7 +7011,7 @@
           <a:p>
             <a:pPr algn="ctr"/>
             <a:r>
-              <a:rPr sz="1300" b="1">
+              <a:rPr sz="1150" b="1">
                 <a:solidFill>
                   <a:srgbClr val="1E40AF"/>
                 </a:solidFill>
@@ -5672,14 +7024,14 @@
       </p:sp>
       <p:sp>
         <p:nvSpPr>
-          <p:cNvPr id="55" name="TextBox 54"/>
+          <p:cNvPr id="87" name="TextBox 86"/>
           <p:cNvSpPr txBox="1"/>
           <p:nvPr/>
         </p:nvSpPr>
         <p:spPr>
           <a:xfrm>
-            <a:off x="11142000" y="8305200"/>
-            <a:ext cx="1188000" cy="162000"/>
+            <a:off x="11124000" y="8254800"/>
+            <a:ext cx="1134000" cy="162000"/>
           </a:xfrm>
           <a:prstGeom prst="rect">
             <a:avLst/>
@@ -5694,7 +7046,7 @@
           <a:p>
             <a:pPr algn="ctr"/>
             <a:r>
-              <a:rPr sz="980" b="1">
+              <a:rPr sz="860" b="1">
                 <a:solidFill>
                   <a:srgbClr val="0F172A"/>
                 </a:solidFill>
@@ -5707,14 +7059,14 @@
       </p:sp>
       <p:sp>
         <p:nvSpPr>
-          <p:cNvPr id="56" name="Rounded Rectangle 55"/>
+          <p:cNvPr id="88" name="Rounded Rectangle 87"/>
           <p:cNvSpPr/>
           <p:nvPr/>
         </p:nvSpPr>
         <p:spPr>
           <a:xfrm>
-            <a:off x="13014000" y="7793999"/>
-            <a:ext cx="720000" cy="450000"/>
+            <a:off x="12520800" y="7793999"/>
+            <a:ext cx="630000" cy="403200"/>
           </a:xfrm>
           <a:prstGeom prst="roundRect">
             <a:avLst/>
@@ -5748,7 +7100,7 @@
           <a:p>
             <a:pPr algn="ctr"/>
             <a:r>
-              <a:rPr sz="1300" b="1">
+              <a:rPr sz="1150" b="1">
                 <a:solidFill>
                   <a:srgbClr val="1E40AF"/>
                 </a:solidFill>
@@ -5761,14 +7113,14 @@
       </p:sp>
       <p:sp>
         <p:nvSpPr>
-          <p:cNvPr id="57" name="TextBox 56"/>
+          <p:cNvPr id="89" name="TextBox 88"/>
           <p:cNvSpPr txBox="1"/>
           <p:nvPr/>
         </p:nvSpPr>
         <p:spPr>
           <a:xfrm>
-            <a:off x="12780000" y="8305200"/>
-            <a:ext cx="1188000" cy="162000"/>
+            <a:off x="12268800" y="8254800"/>
+            <a:ext cx="1134000" cy="162000"/>
           </a:xfrm>
           <a:prstGeom prst="rect">
             <a:avLst/>
@@ -5783,7 +7135,7 @@
           <a:p>
             <a:pPr algn="ctr"/>
             <a:r>
-              <a:rPr sz="980" b="1">
+              <a:rPr sz="860" b="1">
                 <a:solidFill>
                   <a:srgbClr val="0F172A"/>
                 </a:solidFill>
@@ -5796,14 +7148,14 @@
       </p:sp>
       <p:sp>
         <p:nvSpPr>
-          <p:cNvPr id="58" name="Rounded Rectangle 57"/>
+          <p:cNvPr id="90" name="Rounded Rectangle 89"/>
           <p:cNvSpPr/>
           <p:nvPr/>
         </p:nvSpPr>
         <p:spPr>
           <a:xfrm>
-            <a:off x="14651999" y="7793999"/>
-            <a:ext cx="720000" cy="450000"/>
+            <a:off x="13665600" y="7793999"/>
+            <a:ext cx="630000" cy="403200"/>
           </a:xfrm>
           <a:prstGeom prst="roundRect">
             <a:avLst/>
@@ -5837,7 +7189,7 @@
           <a:p>
             <a:pPr algn="ctr"/>
             <a:r>
-              <a:rPr sz="1300" b="1">
+              <a:rPr sz="1150" b="1">
                 <a:solidFill>
                   <a:srgbClr val="0F172A"/>
                 </a:solidFill>
@@ -5850,14 +7202,14 @@
       </p:sp>
       <p:sp>
         <p:nvSpPr>
-          <p:cNvPr id="59" name="TextBox 58"/>
+          <p:cNvPr id="91" name="TextBox 90"/>
           <p:cNvSpPr txBox="1"/>
           <p:nvPr/>
         </p:nvSpPr>
         <p:spPr>
           <a:xfrm>
-            <a:off x="14417999" y="8305200"/>
-            <a:ext cx="1188000" cy="162000"/>
+            <a:off x="13413600" y="8254800"/>
+            <a:ext cx="1134000" cy="162000"/>
           </a:xfrm>
           <a:prstGeom prst="rect">
             <a:avLst/>
@@ -5872,7 +7224,7 @@
           <a:p>
             <a:pPr algn="ctr"/>
             <a:r>
-              <a:rPr sz="980" b="1">
+              <a:rPr sz="860" b="1">
                 <a:solidFill>
                   <a:srgbClr val="0F172A"/>
                 </a:solidFill>
@@ -5885,14 +7237,14 @@
       </p:sp>
       <p:sp>
         <p:nvSpPr>
-          <p:cNvPr id="60" name="Rounded Rectangle 59"/>
+          <p:cNvPr id="92" name="Rounded Rectangle 91"/>
           <p:cNvSpPr/>
           <p:nvPr/>
         </p:nvSpPr>
         <p:spPr>
           <a:xfrm>
-            <a:off x="16290000" y="7793999"/>
-            <a:ext cx="720000" cy="450000"/>
+            <a:off x="14810400" y="7793999"/>
+            <a:ext cx="630000" cy="403200"/>
           </a:xfrm>
           <a:prstGeom prst="roundRect">
             <a:avLst/>
@@ -5926,7 +7278,7 @@
           <a:p>
             <a:pPr algn="ctr"/>
             <a:r>
-              <a:rPr sz="1300" b="1">
+              <a:rPr sz="1150" b="1">
                 <a:solidFill>
                   <a:srgbClr val="0F172A"/>
                 </a:solidFill>
@@ -5939,14 +7291,14 @@
       </p:sp>
       <p:sp>
         <p:nvSpPr>
-          <p:cNvPr id="61" name="TextBox 60"/>
+          <p:cNvPr id="93" name="TextBox 92"/>
           <p:cNvSpPr txBox="1"/>
           <p:nvPr/>
         </p:nvSpPr>
         <p:spPr>
           <a:xfrm>
-            <a:off x="16056000" y="8305200"/>
-            <a:ext cx="1188000" cy="162000"/>
+            <a:off x="14558400" y="8254800"/>
+            <a:ext cx="1134000" cy="162000"/>
           </a:xfrm>
           <a:prstGeom prst="rect">
             <a:avLst/>
@@ -5961,7 +7313,7 @@
           <a:p>
             <a:pPr algn="ctr"/>
             <a:r>
-              <a:rPr sz="980" b="1">
+              <a:rPr sz="860" b="1">
                 <a:solidFill>
                   <a:srgbClr val="0F172A"/>
                 </a:solidFill>
@@ -5974,14 +7326,14 @@
       </p:sp>
       <p:sp>
         <p:nvSpPr>
-          <p:cNvPr id="62" name="Rounded Rectangle 61"/>
+          <p:cNvPr id="94" name="Rounded Rectangle 93"/>
           <p:cNvSpPr/>
           <p:nvPr/>
         </p:nvSpPr>
         <p:spPr>
           <a:xfrm>
-            <a:off x="17928000" y="7793999"/>
-            <a:ext cx="720000" cy="450000"/>
+            <a:off x="15955200" y="7793999"/>
+            <a:ext cx="630000" cy="403200"/>
           </a:xfrm>
           <a:prstGeom prst="roundRect">
             <a:avLst/>
@@ -6015,7 +7367,7 @@
           <a:p>
             <a:pPr algn="ctr"/>
             <a:r>
-              <a:rPr sz="1300" b="1">
+              <a:rPr sz="1150" b="1">
                 <a:solidFill>
                   <a:srgbClr val="FFFFFF"/>
                 </a:solidFill>
@@ -6028,14 +7380,14 @@
       </p:sp>
       <p:sp>
         <p:nvSpPr>
-          <p:cNvPr id="63" name="TextBox 62"/>
+          <p:cNvPr id="95" name="TextBox 94"/>
           <p:cNvSpPr txBox="1"/>
           <p:nvPr/>
         </p:nvSpPr>
         <p:spPr>
           <a:xfrm>
-            <a:off x="17694000" y="8305200"/>
-            <a:ext cx="1188000" cy="162000"/>
+            <a:off x="15703200" y="8254800"/>
+            <a:ext cx="1134000" cy="162000"/>
           </a:xfrm>
           <a:prstGeom prst="rect">
             <a:avLst/>
@@ -6050,7 +7402,7 @@
           <a:p>
             <a:pPr algn="ctr"/>
             <a:r>
-              <a:rPr sz="980" b="1">
+              <a:rPr sz="860" b="1">
                 <a:solidFill>
                   <a:srgbClr val="0F172A"/>
                 </a:solidFill>
@@ -6063,14 +7415,14 @@
       </p:sp>
       <p:cxnSp>
         <p:nvCxnSpPr>
-          <p:cNvPr id="64" name="Connector 63"/>
+          <p:cNvPr id="96" name="Connector 95"/>
           <p:cNvCxnSpPr/>
           <p:nvPr/>
         </p:nvCxnSpPr>
         <p:spPr>
           <a:xfrm>
-            <a:off x="11700000" y="8640000"/>
-            <a:ext cx="6588000" cy="0"/>
+            <a:off x="11664000" y="8578800"/>
+            <a:ext cx="4751999" cy="0"/>
           </a:xfrm>
           <a:prstGeom prst="line">
             <a:avLst/>
@@ -6098,7 +7450,7 @@
       </p:cxnSp>
       <p:sp>
         <p:nvSpPr>
-          <p:cNvPr id="65" name="TextBox 64"/>
+          <p:cNvPr id="97" name="TextBox 96"/>
           <p:cNvSpPr txBox="1"/>
           <p:nvPr/>
         </p:nvSpPr>
@@ -6133,14 +7485,14 @@
       </p:sp>
       <p:sp>
         <p:nvSpPr>
-          <p:cNvPr id="66" name="TextBox 65"/>
+          <p:cNvPr id="98" name="TextBox 97"/>
           <p:cNvSpPr txBox="1"/>
           <p:nvPr/>
         </p:nvSpPr>
         <p:spPr>
           <a:xfrm>
-            <a:off x="16848000" y="8712000"/>
-            <a:ext cx="2700000" cy="162000"/>
+            <a:off x="14255999" y="8712000"/>
+            <a:ext cx="2448000" cy="162000"/>
           </a:xfrm>
           <a:prstGeom prst="rect">
             <a:avLst/>
@@ -6168,7 +7520,1337 @@
       </p:sp>
       <p:sp>
         <p:nvSpPr>
-          <p:cNvPr id="67" name="Rectangle 66"/>
+          <p:cNvPr id="99" name="Rectangle 98"/>
+          <p:cNvSpPr/>
+          <p:nvPr/>
+        </p:nvSpPr>
+        <p:spPr>
+          <a:xfrm>
+            <a:off x="16775999" y="6173999"/>
+            <a:ext cx="2951999" cy="1980000"/>
+          </a:xfrm>
+          <a:prstGeom prst="rect">
+            <a:avLst/>
+          </a:prstGeom>
+          <a:solidFill>
+            <a:srgbClr val="FFFFFF"/>
+          </a:solidFill>
+          <a:ln w="8890">
+            <a:solidFill>
+              <a:srgbClr val="BFDBFE"/>
+            </a:solidFill>
+          </a:ln>
+        </p:spPr>
+        <p:style>
+          <a:lnRef idx="1">
+            <a:schemeClr val="accent1"/>
+          </a:lnRef>
+          <a:fillRef idx="3">
+            <a:schemeClr val="accent1"/>
+          </a:fillRef>
+          <a:effectRef idx="2">
+            <a:schemeClr val="accent1"/>
+          </a:effectRef>
+          <a:fontRef idx="minor">
+            <a:schemeClr val="lt1"/>
+          </a:fontRef>
+        </p:style>
+        <p:txBody>
+          <a:bodyPr rtlCol="0" anchor="ctr"/>
+          <a:lstStyle/>
+          <a:p>
+            <a:pPr algn="ctr"/>
+          </a:p>
+        </p:txBody>
+      </p:sp>
+      <p:sp>
+        <p:nvSpPr>
+          <p:cNvPr id="100" name="TextBox 99"/>
+          <p:cNvSpPr txBox="1"/>
+          <p:nvPr/>
+        </p:nvSpPr>
+        <p:spPr>
+          <a:xfrm>
+            <a:off x="16883999" y="6263999"/>
+            <a:ext cx="2700000" cy="180000"/>
+          </a:xfrm>
+          <a:prstGeom prst="rect">
+            <a:avLst/>
+          </a:prstGeom>
+          <a:noFill/>
+        </p:spPr>
+        <p:txBody>
+          <a:bodyPr wrap="square" anchor="t">
+            <a:spAutoFit/>
+          </a:bodyPr>
+          <a:lstStyle/>
+          <a:p>
+            <a:pPr algn="ctr"/>
+            <a:r>
+              <a:rPr sz="1070" b="1">
+                <a:solidFill>
+                  <a:srgbClr val="1E40AF"/>
+                </a:solidFill>
+                <a:latin typeface="Arial"/>
+              </a:rPr>
+              <a:t>R[u,i] Etkileşim Matrisi</a:t>
+            </a:r>
+          </a:p>
+        </p:txBody>
+      </p:sp>
+      <p:sp>
+        <p:nvSpPr>
+          <p:cNvPr id="101" name="TextBox 100"/>
+          <p:cNvSpPr txBox="1"/>
+          <p:nvPr/>
+        </p:nvSpPr>
+        <p:spPr>
+          <a:xfrm>
+            <a:off x="17298000" y="6480000"/>
+            <a:ext cx="270000" cy="125999"/>
+          </a:xfrm>
+          <a:prstGeom prst="rect">
+            <a:avLst/>
+          </a:prstGeom>
+          <a:noFill/>
+        </p:spPr>
+        <p:txBody>
+          <a:bodyPr wrap="square" anchor="t">
+            <a:spAutoFit/>
+          </a:bodyPr>
+          <a:lstStyle/>
+          <a:p>
+            <a:pPr algn="ctr"/>
+            <a:r>
+              <a:rPr sz="740" b="1">
+                <a:solidFill>
+                  <a:srgbClr val="0F172A"/>
+                </a:solidFill>
+                <a:latin typeface="Arial"/>
+              </a:rPr>
+              <a:t>İ1</a:t>
+            </a:r>
+          </a:p>
+        </p:txBody>
+      </p:sp>
+      <p:sp>
+        <p:nvSpPr>
+          <p:cNvPr id="102" name="TextBox 101"/>
+          <p:cNvSpPr txBox="1"/>
+          <p:nvPr/>
+        </p:nvSpPr>
+        <p:spPr>
+          <a:xfrm>
+            <a:off x="17665200" y="6480000"/>
+            <a:ext cx="270000" cy="125999"/>
+          </a:xfrm>
+          <a:prstGeom prst="rect">
+            <a:avLst/>
+          </a:prstGeom>
+          <a:noFill/>
+        </p:spPr>
+        <p:txBody>
+          <a:bodyPr wrap="square" anchor="t">
+            <a:spAutoFit/>
+          </a:bodyPr>
+          <a:lstStyle/>
+          <a:p>
+            <a:pPr algn="ctr"/>
+            <a:r>
+              <a:rPr sz="740" b="1">
+                <a:solidFill>
+                  <a:srgbClr val="0F172A"/>
+                </a:solidFill>
+                <a:latin typeface="Arial"/>
+              </a:rPr>
+              <a:t>İ2</a:t>
+            </a:r>
+          </a:p>
+        </p:txBody>
+      </p:sp>
+      <p:sp>
+        <p:nvSpPr>
+          <p:cNvPr id="103" name="TextBox 102"/>
+          <p:cNvSpPr txBox="1"/>
+          <p:nvPr/>
+        </p:nvSpPr>
+        <p:spPr>
+          <a:xfrm>
+            <a:off x="18032400" y="6480000"/>
+            <a:ext cx="270000" cy="125999"/>
+          </a:xfrm>
+          <a:prstGeom prst="rect">
+            <a:avLst/>
+          </a:prstGeom>
+          <a:noFill/>
+        </p:spPr>
+        <p:txBody>
+          <a:bodyPr wrap="square" anchor="t">
+            <a:spAutoFit/>
+          </a:bodyPr>
+          <a:lstStyle/>
+          <a:p>
+            <a:pPr algn="ctr"/>
+            <a:r>
+              <a:rPr sz="740" b="1">
+                <a:solidFill>
+                  <a:srgbClr val="0F172A"/>
+                </a:solidFill>
+                <a:latin typeface="Arial"/>
+              </a:rPr>
+              <a:t>İ3</a:t>
+            </a:r>
+          </a:p>
+        </p:txBody>
+      </p:sp>
+      <p:sp>
+        <p:nvSpPr>
+          <p:cNvPr id="104" name="TextBox 103"/>
+          <p:cNvSpPr txBox="1"/>
+          <p:nvPr/>
+        </p:nvSpPr>
+        <p:spPr>
+          <a:xfrm>
+            <a:off x="18399600" y="6480000"/>
+            <a:ext cx="270000" cy="125999"/>
+          </a:xfrm>
+          <a:prstGeom prst="rect">
+            <a:avLst/>
+          </a:prstGeom>
+          <a:noFill/>
+        </p:spPr>
+        <p:txBody>
+          <a:bodyPr wrap="square" anchor="t">
+            <a:spAutoFit/>
+          </a:bodyPr>
+          <a:lstStyle/>
+          <a:p>
+            <a:pPr algn="ctr"/>
+            <a:r>
+              <a:rPr sz="740" b="1">
+                <a:solidFill>
+                  <a:srgbClr val="0F172A"/>
+                </a:solidFill>
+                <a:latin typeface="Arial"/>
+              </a:rPr>
+              <a:t>İ4</a:t>
+            </a:r>
+          </a:p>
+        </p:txBody>
+      </p:sp>
+      <p:sp>
+        <p:nvSpPr>
+          <p:cNvPr id="105" name="TextBox 104"/>
+          <p:cNvSpPr txBox="1"/>
+          <p:nvPr/>
+        </p:nvSpPr>
+        <p:spPr>
+          <a:xfrm>
+            <a:off x="18766800" y="6480000"/>
+            <a:ext cx="270000" cy="125999"/>
+          </a:xfrm>
+          <a:prstGeom prst="rect">
+            <a:avLst/>
+          </a:prstGeom>
+          <a:noFill/>
+        </p:spPr>
+        <p:txBody>
+          <a:bodyPr wrap="square" anchor="t">
+            <a:spAutoFit/>
+          </a:bodyPr>
+          <a:lstStyle/>
+          <a:p>
+            <a:pPr algn="ctr"/>
+            <a:r>
+              <a:rPr sz="740" b="1">
+                <a:solidFill>
+                  <a:srgbClr val="0F172A"/>
+                </a:solidFill>
+                <a:latin typeface="Arial"/>
+              </a:rPr>
+              <a:t>İ5</a:t>
+            </a:r>
+          </a:p>
+        </p:txBody>
+      </p:sp>
+      <p:sp>
+        <p:nvSpPr>
+          <p:cNvPr id="106" name="TextBox 105"/>
+          <p:cNvSpPr txBox="1"/>
+          <p:nvPr/>
+        </p:nvSpPr>
+        <p:spPr>
+          <a:xfrm>
+            <a:off x="16973999" y="6667200"/>
+            <a:ext cx="198000" cy="125999"/>
+          </a:xfrm>
+          <a:prstGeom prst="rect">
+            <a:avLst/>
+          </a:prstGeom>
+          <a:noFill/>
+        </p:spPr>
+        <p:txBody>
+          <a:bodyPr wrap="square" anchor="t">
+            <a:spAutoFit/>
+          </a:bodyPr>
+          <a:lstStyle/>
+          <a:p>
+            <a:pPr algn="ctr"/>
+            <a:r>
+              <a:rPr sz="740" b="1">
+                <a:solidFill>
+                  <a:srgbClr val="0F172A"/>
+                </a:solidFill>
+                <a:latin typeface="Arial"/>
+              </a:rPr>
+              <a:t>U1</a:t>
+            </a:r>
+          </a:p>
+        </p:txBody>
+      </p:sp>
+      <p:sp>
+        <p:nvSpPr>
+          <p:cNvPr id="107" name="Rectangle 106"/>
+          <p:cNvSpPr/>
+          <p:nvPr/>
+        </p:nvSpPr>
+        <p:spPr>
+          <a:xfrm>
+            <a:off x="17298000" y="6623999"/>
+            <a:ext cx="280800" cy="280800"/>
+          </a:xfrm>
+          <a:prstGeom prst="rect">
+            <a:avLst/>
+          </a:prstGeom>
+          <a:solidFill>
+            <a:srgbClr val="BFDBFE"/>
+          </a:solidFill>
+          <a:ln w="4445">
+            <a:solidFill>
+              <a:srgbClr val="FFFFFF"/>
+            </a:solidFill>
+          </a:ln>
+        </p:spPr>
+        <p:style>
+          <a:lnRef idx="1">
+            <a:schemeClr val="accent1"/>
+          </a:lnRef>
+          <a:fillRef idx="3">
+            <a:schemeClr val="accent1"/>
+          </a:fillRef>
+          <a:effectRef idx="2">
+            <a:schemeClr val="accent1"/>
+          </a:effectRef>
+          <a:fontRef idx="minor">
+            <a:schemeClr val="lt1"/>
+          </a:fontRef>
+        </p:style>
+        <p:txBody>
+          <a:bodyPr rtlCol="0" anchor="ctr"/>
+          <a:lstStyle/>
+          <a:p>
+            <a:pPr algn="ctr"/>
+          </a:p>
+        </p:txBody>
+      </p:sp>
+      <p:sp>
+        <p:nvSpPr>
+          <p:cNvPr id="108" name="Rectangle 107"/>
+          <p:cNvSpPr/>
+          <p:nvPr/>
+        </p:nvSpPr>
+        <p:spPr>
+          <a:xfrm>
+            <a:off x="17665200" y="6623999"/>
+            <a:ext cx="280800" cy="280800"/>
+          </a:xfrm>
+          <a:prstGeom prst="rect">
+            <a:avLst/>
+          </a:prstGeom>
+          <a:solidFill>
+            <a:srgbClr val="E2E8F0"/>
+          </a:solidFill>
+          <a:ln w="4445">
+            <a:solidFill>
+              <a:srgbClr val="FFFFFF"/>
+            </a:solidFill>
+          </a:ln>
+        </p:spPr>
+        <p:style>
+          <a:lnRef idx="1">
+            <a:schemeClr val="accent1"/>
+          </a:lnRef>
+          <a:fillRef idx="3">
+            <a:schemeClr val="accent1"/>
+          </a:fillRef>
+          <a:effectRef idx="2">
+            <a:schemeClr val="accent1"/>
+          </a:effectRef>
+          <a:fontRef idx="minor">
+            <a:schemeClr val="lt1"/>
+          </a:fontRef>
+        </p:style>
+        <p:txBody>
+          <a:bodyPr rtlCol="0" anchor="ctr"/>
+          <a:lstStyle/>
+          <a:p>
+            <a:pPr algn="ctr"/>
+          </a:p>
+        </p:txBody>
+      </p:sp>
+      <p:sp>
+        <p:nvSpPr>
+          <p:cNvPr id="109" name="Rectangle 108"/>
+          <p:cNvSpPr/>
+          <p:nvPr/>
+        </p:nvSpPr>
+        <p:spPr>
+          <a:xfrm>
+            <a:off x="18032400" y="6623999"/>
+            <a:ext cx="280800" cy="280800"/>
+          </a:xfrm>
+          <a:prstGeom prst="rect">
+            <a:avLst/>
+          </a:prstGeom>
+          <a:solidFill>
+            <a:srgbClr val="60A5FA"/>
+          </a:solidFill>
+          <a:ln w="4445">
+            <a:solidFill>
+              <a:srgbClr val="FFFFFF"/>
+            </a:solidFill>
+          </a:ln>
+        </p:spPr>
+        <p:style>
+          <a:lnRef idx="1">
+            <a:schemeClr val="accent1"/>
+          </a:lnRef>
+          <a:fillRef idx="3">
+            <a:schemeClr val="accent1"/>
+          </a:fillRef>
+          <a:effectRef idx="2">
+            <a:schemeClr val="accent1"/>
+          </a:effectRef>
+          <a:fontRef idx="minor">
+            <a:schemeClr val="lt1"/>
+          </a:fontRef>
+        </p:style>
+        <p:txBody>
+          <a:bodyPr rtlCol="0" anchor="ctr"/>
+          <a:lstStyle/>
+          <a:p>
+            <a:pPr algn="ctr"/>
+          </a:p>
+        </p:txBody>
+      </p:sp>
+      <p:sp>
+        <p:nvSpPr>
+          <p:cNvPr id="110" name="Rectangle 109"/>
+          <p:cNvSpPr/>
+          <p:nvPr/>
+        </p:nvSpPr>
+        <p:spPr>
+          <a:xfrm>
+            <a:off x="18399600" y="6623999"/>
+            <a:ext cx="280800" cy="280800"/>
+          </a:xfrm>
+          <a:prstGeom prst="rect">
+            <a:avLst/>
+          </a:prstGeom>
+          <a:solidFill>
+            <a:srgbClr val="E2E8F0"/>
+          </a:solidFill>
+          <a:ln w="4445">
+            <a:solidFill>
+              <a:srgbClr val="FFFFFF"/>
+            </a:solidFill>
+          </a:ln>
+        </p:spPr>
+        <p:style>
+          <a:lnRef idx="1">
+            <a:schemeClr val="accent1"/>
+          </a:lnRef>
+          <a:fillRef idx="3">
+            <a:schemeClr val="accent1"/>
+          </a:fillRef>
+          <a:effectRef idx="2">
+            <a:schemeClr val="accent1"/>
+          </a:effectRef>
+          <a:fontRef idx="minor">
+            <a:schemeClr val="lt1"/>
+          </a:fontRef>
+        </p:style>
+        <p:txBody>
+          <a:bodyPr rtlCol="0" anchor="ctr"/>
+          <a:lstStyle/>
+          <a:p>
+            <a:pPr algn="ctr"/>
+          </a:p>
+        </p:txBody>
+      </p:sp>
+      <p:sp>
+        <p:nvSpPr>
+          <p:cNvPr id="111" name="Rectangle 110"/>
+          <p:cNvSpPr/>
+          <p:nvPr/>
+        </p:nvSpPr>
+        <p:spPr>
+          <a:xfrm>
+            <a:off x="18766800" y="6623999"/>
+            <a:ext cx="280800" cy="280800"/>
+          </a:xfrm>
+          <a:prstGeom prst="rect">
+            <a:avLst/>
+          </a:prstGeom>
+          <a:solidFill>
+            <a:srgbClr val="10B981"/>
+          </a:solidFill>
+          <a:ln w="4445">
+            <a:solidFill>
+              <a:srgbClr val="FFFFFF"/>
+            </a:solidFill>
+          </a:ln>
+        </p:spPr>
+        <p:style>
+          <a:lnRef idx="1">
+            <a:schemeClr val="accent1"/>
+          </a:lnRef>
+          <a:fillRef idx="3">
+            <a:schemeClr val="accent1"/>
+          </a:fillRef>
+          <a:effectRef idx="2">
+            <a:schemeClr val="accent1"/>
+          </a:effectRef>
+          <a:fontRef idx="minor">
+            <a:schemeClr val="lt1"/>
+          </a:fontRef>
+        </p:style>
+        <p:txBody>
+          <a:bodyPr rtlCol="0" anchor="ctr"/>
+          <a:lstStyle/>
+          <a:p>
+            <a:pPr algn="ctr"/>
+          </a:p>
+        </p:txBody>
+      </p:sp>
+      <p:sp>
+        <p:nvSpPr>
+          <p:cNvPr id="112" name="TextBox 111"/>
+          <p:cNvSpPr txBox="1"/>
+          <p:nvPr/>
+        </p:nvSpPr>
+        <p:spPr>
+          <a:xfrm>
+            <a:off x="16973999" y="7009200"/>
+            <a:ext cx="198000" cy="125999"/>
+          </a:xfrm>
+          <a:prstGeom prst="rect">
+            <a:avLst/>
+          </a:prstGeom>
+          <a:noFill/>
+        </p:spPr>
+        <p:txBody>
+          <a:bodyPr wrap="square" anchor="t">
+            <a:spAutoFit/>
+          </a:bodyPr>
+          <a:lstStyle/>
+          <a:p>
+            <a:pPr algn="ctr"/>
+            <a:r>
+              <a:rPr sz="740" b="1">
+                <a:solidFill>
+                  <a:srgbClr val="0F172A"/>
+                </a:solidFill>
+                <a:latin typeface="Arial"/>
+              </a:rPr>
+              <a:t>U2</a:t>
+            </a:r>
+          </a:p>
+        </p:txBody>
+      </p:sp>
+      <p:sp>
+        <p:nvSpPr>
+          <p:cNvPr id="113" name="Rectangle 112"/>
+          <p:cNvSpPr/>
+          <p:nvPr/>
+        </p:nvSpPr>
+        <p:spPr>
+          <a:xfrm>
+            <a:off x="17298000" y="6965999"/>
+            <a:ext cx="280800" cy="280800"/>
+          </a:xfrm>
+          <a:prstGeom prst="rect">
+            <a:avLst/>
+          </a:prstGeom>
+          <a:solidFill>
+            <a:srgbClr val="E2E8F0"/>
+          </a:solidFill>
+          <a:ln w="4445">
+            <a:solidFill>
+              <a:srgbClr val="FFFFFF"/>
+            </a:solidFill>
+          </a:ln>
+        </p:spPr>
+        <p:style>
+          <a:lnRef idx="1">
+            <a:schemeClr val="accent1"/>
+          </a:lnRef>
+          <a:fillRef idx="3">
+            <a:schemeClr val="accent1"/>
+          </a:fillRef>
+          <a:effectRef idx="2">
+            <a:schemeClr val="accent1"/>
+          </a:effectRef>
+          <a:fontRef idx="minor">
+            <a:schemeClr val="lt1"/>
+          </a:fontRef>
+        </p:style>
+        <p:txBody>
+          <a:bodyPr rtlCol="0" anchor="ctr"/>
+          <a:lstStyle/>
+          <a:p>
+            <a:pPr algn="ctr"/>
+          </a:p>
+        </p:txBody>
+      </p:sp>
+      <p:sp>
+        <p:nvSpPr>
+          <p:cNvPr id="114" name="Rectangle 113"/>
+          <p:cNvSpPr/>
+          <p:nvPr/>
+        </p:nvSpPr>
+        <p:spPr>
+          <a:xfrm>
+            <a:off x="17665200" y="6965999"/>
+            <a:ext cx="280800" cy="280800"/>
+          </a:xfrm>
+          <a:prstGeom prst="rect">
+            <a:avLst/>
+          </a:prstGeom>
+          <a:solidFill>
+            <a:srgbClr val="93C5FD"/>
+          </a:solidFill>
+          <a:ln w="4445">
+            <a:solidFill>
+              <a:srgbClr val="FFFFFF"/>
+            </a:solidFill>
+          </a:ln>
+        </p:spPr>
+        <p:style>
+          <a:lnRef idx="1">
+            <a:schemeClr val="accent1"/>
+          </a:lnRef>
+          <a:fillRef idx="3">
+            <a:schemeClr val="accent1"/>
+          </a:fillRef>
+          <a:effectRef idx="2">
+            <a:schemeClr val="accent1"/>
+          </a:effectRef>
+          <a:fontRef idx="minor">
+            <a:schemeClr val="lt1"/>
+          </a:fontRef>
+        </p:style>
+        <p:txBody>
+          <a:bodyPr rtlCol="0" anchor="ctr"/>
+          <a:lstStyle/>
+          <a:p>
+            <a:pPr algn="ctr"/>
+          </a:p>
+        </p:txBody>
+      </p:sp>
+      <p:sp>
+        <p:nvSpPr>
+          <p:cNvPr id="115" name="Rectangle 114"/>
+          <p:cNvSpPr/>
+          <p:nvPr/>
+        </p:nvSpPr>
+        <p:spPr>
+          <a:xfrm>
+            <a:off x="18032400" y="6965999"/>
+            <a:ext cx="280800" cy="280800"/>
+          </a:xfrm>
+          <a:prstGeom prst="rect">
+            <a:avLst/>
+          </a:prstGeom>
+          <a:solidFill>
+            <a:srgbClr val="E2E8F0"/>
+          </a:solidFill>
+          <a:ln w="4445">
+            <a:solidFill>
+              <a:srgbClr val="FFFFFF"/>
+            </a:solidFill>
+          </a:ln>
+        </p:spPr>
+        <p:style>
+          <a:lnRef idx="1">
+            <a:schemeClr val="accent1"/>
+          </a:lnRef>
+          <a:fillRef idx="3">
+            <a:schemeClr val="accent1"/>
+          </a:fillRef>
+          <a:effectRef idx="2">
+            <a:schemeClr val="accent1"/>
+          </a:effectRef>
+          <a:fontRef idx="minor">
+            <a:schemeClr val="lt1"/>
+          </a:fontRef>
+        </p:style>
+        <p:txBody>
+          <a:bodyPr rtlCol="0" anchor="ctr"/>
+          <a:lstStyle/>
+          <a:p>
+            <a:pPr algn="ctr"/>
+          </a:p>
+        </p:txBody>
+      </p:sp>
+      <p:sp>
+        <p:nvSpPr>
+          <p:cNvPr id="116" name="Rectangle 115"/>
+          <p:cNvSpPr/>
+          <p:nvPr/>
+        </p:nvSpPr>
+        <p:spPr>
+          <a:xfrm>
+            <a:off x="18399600" y="6965999"/>
+            <a:ext cx="280800" cy="280800"/>
+          </a:xfrm>
+          <a:prstGeom prst="rect">
+            <a:avLst/>
+          </a:prstGeom>
+          <a:solidFill>
+            <a:srgbClr val="34D399"/>
+          </a:solidFill>
+          <a:ln w="4445">
+            <a:solidFill>
+              <a:srgbClr val="FFFFFF"/>
+            </a:solidFill>
+          </a:ln>
+        </p:spPr>
+        <p:style>
+          <a:lnRef idx="1">
+            <a:schemeClr val="accent1"/>
+          </a:lnRef>
+          <a:fillRef idx="3">
+            <a:schemeClr val="accent1"/>
+          </a:fillRef>
+          <a:effectRef idx="2">
+            <a:schemeClr val="accent1"/>
+          </a:effectRef>
+          <a:fontRef idx="minor">
+            <a:schemeClr val="lt1"/>
+          </a:fontRef>
+        </p:style>
+        <p:txBody>
+          <a:bodyPr rtlCol="0" anchor="ctr"/>
+          <a:lstStyle/>
+          <a:p>
+            <a:pPr algn="ctr"/>
+          </a:p>
+        </p:txBody>
+      </p:sp>
+      <p:sp>
+        <p:nvSpPr>
+          <p:cNvPr id="117" name="Rectangle 116"/>
+          <p:cNvSpPr/>
+          <p:nvPr/>
+        </p:nvSpPr>
+        <p:spPr>
+          <a:xfrm>
+            <a:off x="18766800" y="6965999"/>
+            <a:ext cx="280800" cy="280800"/>
+          </a:xfrm>
+          <a:prstGeom prst="rect">
+            <a:avLst/>
+          </a:prstGeom>
+          <a:solidFill>
+            <a:srgbClr val="E2E8F0"/>
+          </a:solidFill>
+          <a:ln w="4445">
+            <a:solidFill>
+              <a:srgbClr val="FFFFFF"/>
+            </a:solidFill>
+          </a:ln>
+        </p:spPr>
+        <p:style>
+          <a:lnRef idx="1">
+            <a:schemeClr val="accent1"/>
+          </a:lnRef>
+          <a:fillRef idx="3">
+            <a:schemeClr val="accent1"/>
+          </a:fillRef>
+          <a:effectRef idx="2">
+            <a:schemeClr val="accent1"/>
+          </a:effectRef>
+          <a:fontRef idx="minor">
+            <a:schemeClr val="lt1"/>
+          </a:fontRef>
+        </p:style>
+        <p:txBody>
+          <a:bodyPr rtlCol="0" anchor="ctr"/>
+          <a:lstStyle/>
+          <a:p>
+            <a:pPr algn="ctr"/>
+          </a:p>
+        </p:txBody>
+      </p:sp>
+      <p:sp>
+        <p:nvSpPr>
+          <p:cNvPr id="118" name="TextBox 117"/>
+          <p:cNvSpPr txBox="1"/>
+          <p:nvPr/>
+        </p:nvSpPr>
+        <p:spPr>
+          <a:xfrm>
+            <a:off x="16973999" y="7351199"/>
+            <a:ext cx="198000" cy="125999"/>
+          </a:xfrm>
+          <a:prstGeom prst="rect">
+            <a:avLst/>
+          </a:prstGeom>
+          <a:noFill/>
+        </p:spPr>
+        <p:txBody>
+          <a:bodyPr wrap="square" anchor="t">
+            <a:spAutoFit/>
+          </a:bodyPr>
+          <a:lstStyle/>
+          <a:p>
+            <a:pPr algn="ctr"/>
+            <a:r>
+              <a:rPr sz="740" b="1">
+                <a:solidFill>
+                  <a:srgbClr val="0F172A"/>
+                </a:solidFill>
+                <a:latin typeface="Arial"/>
+              </a:rPr>
+              <a:t>U3</a:t>
+            </a:r>
+          </a:p>
+        </p:txBody>
+      </p:sp>
+      <p:sp>
+        <p:nvSpPr>
+          <p:cNvPr id="119" name="Rectangle 118"/>
+          <p:cNvSpPr/>
+          <p:nvPr/>
+        </p:nvSpPr>
+        <p:spPr>
+          <a:xfrm>
+            <a:off x="17298000" y="7307999"/>
+            <a:ext cx="280800" cy="280800"/>
+          </a:xfrm>
+          <a:prstGeom prst="rect">
+            <a:avLst/>
+          </a:prstGeom>
+          <a:solidFill>
+            <a:srgbClr val="60A5FA"/>
+          </a:solidFill>
+          <a:ln w="4445">
+            <a:solidFill>
+              <a:srgbClr val="FFFFFF"/>
+            </a:solidFill>
+          </a:ln>
+        </p:spPr>
+        <p:style>
+          <a:lnRef idx="1">
+            <a:schemeClr val="accent1"/>
+          </a:lnRef>
+          <a:fillRef idx="3">
+            <a:schemeClr val="accent1"/>
+          </a:fillRef>
+          <a:effectRef idx="2">
+            <a:schemeClr val="accent1"/>
+          </a:effectRef>
+          <a:fontRef idx="minor">
+            <a:schemeClr val="lt1"/>
+          </a:fontRef>
+        </p:style>
+        <p:txBody>
+          <a:bodyPr rtlCol="0" anchor="ctr"/>
+          <a:lstStyle/>
+          <a:p>
+            <a:pPr algn="ctr"/>
+          </a:p>
+        </p:txBody>
+      </p:sp>
+      <p:sp>
+        <p:nvSpPr>
+          <p:cNvPr id="120" name="Rectangle 119"/>
+          <p:cNvSpPr/>
+          <p:nvPr/>
+        </p:nvSpPr>
+        <p:spPr>
+          <a:xfrm>
+            <a:off x="17665200" y="7307999"/>
+            <a:ext cx="280800" cy="280800"/>
+          </a:xfrm>
+          <a:prstGeom prst="rect">
+            <a:avLst/>
+          </a:prstGeom>
+          <a:solidFill>
+            <a:srgbClr val="E2E8F0"/>
+          </a:solidFill>
+          <a:ln w="4445">
+            <a:solidFill>
+              <a:srgbClr val="FFFFFF"/>
+            </a:solidFill>
+          </a:ln>
+        </p:spPr>
+        <p:style>
+          <a:lnRef idx="1">
+            <a:schemeClr val="accent1"/>
+          </a:lnRef>
+          <a:fillRef idx="3">
+            <a:schemeClr val="accent1"/>
+          </a:fillRef>
+          <a:effectRef idx="2">
+            <a:schemeClr val="accent1"/>
+          </a:effectRef>
+          <a:fontRef idx="minor">
+            <a:schemeClr val="lt1"/>
+          </a:fontRef>
+        </p:style>
+        <p:txBody>
+          <a:bodyPr rtlCol="0" anchor="ctr"/>
+          <a:lstStyle/>
+          <a:p>
+            <a:pPr algn="ctr"/>
+          </a:p>
+        </p:txBody>
+      </p:sp>
+      <p:sp>
+        <p:nvSpPr>
+          <p:cNvPr id="121" name="Rectangle 120"/>
+          <p:cNvSpPr/>
+          <p:nvPr/>
+        </p:nvSpPr>
+        <p:spPr>
+          <a:xfrm>
+            <a:off x="18032400" y="7307999"/>
+            <a:ext cx="280800" cy="280800"/>
+          </a:xfrm>
+          <a:prstGeom prst="rect">
+            <a:avLst/>
+          </a:prstGeom>
+          <a:solidFill>
+            <a:srgbClr val="BFDBFE"/>
+          </a:solidFill>
+          <a:ln w="4445">
+            <a:solidFill>
+              <a:srgbClr val="FFFFFF"/>
+            </a:solidFill>
+          </a:ln>
+        </p:spPr>
+        <p:style>
+          <a:lnRef idx="1">
+            <a:schemeClr val="accent1"/>
+          </a:lnRef>
+          <a:fillRef idx="3">
+            <a:schemeClr val="accent1"/>
+          </a:fillRef>
+          <a:effectRef idx="2">
+            <a:schemeClr val="accent1"/>
+          </a:effectRef>
+          <a:fontRef idx="minor">
+            <a:schemeClr val="lt1"/>
+          </a:fontRef>
+        </p:style>
+        <p:txBody>
+          <a:bodyPr rtlCol="0" anchor="ctr"/>
+          <a:lstStyle/>
+          <a:p>
+            <a:pPr algn="ctr"/>
+          </a:p>
+        </p:txBody>
+      </p:sp>
+      <p:sp>
+        <p:nvSpPr>
+          <p:cNvPr id="122" name="Rectangle 121"/>
+          <p:cNvSpPr/>
+          <p:nvPr/>
+        </p:nvSpPr>
+        <p:spPr>
+          <a:xfrm>
+            <a:off x="18399600" y="7307999"/>
+            <a:ext cx="280800" cy="280800"/>
+          </a:xfrm>
+          <a:prstGeom prst="rect">
+            <a:avLst/>
+          </a:prstGeom>
+          <a:solidFill>
+            <a:srgbClr val="E2E8F0"/>
+          </a:solidFill>
+          <a:ln w="4445">
+            <a:solidFill>
+              <a:srgbClr val="FFFFFF"/>
+            </a:solidFill>
+          </a:ln>
+        </p:spPr>
+        <p:style>
+          <a:lnRef idx="1">
+            <a:schemeClr val="accent1"/>
+          </a:lnRef>
+          <a:fillRef idx="3">
+            <a:schemeClr val="accent1"/>
+          </a:fillRef>
+          <a:effectRef idx="2">
+            <a:schemeClr val="accent1"/>
+          </a:effectRef>
+          <a:fontRef idx="minor">
+            <a:schemeClr val="lt1"/>
+          </a:fontRef>
+        </p:style>
+        <p:txBody>
+          <a:bodyPr rtlCol="0" anchor="ctr"/>
+          <a:lstStyle/>
+          <a:p>
+            <a:pPr algn="ctr"/>
+          </a:p>
+        </p:txBody>
+      </p:sp>
+      <p:sp>
+        <p:nvSpPr>
+          <p:cNvPr id="123" name="Rectangle 122"/>
+          <p:cNvSpPr/>
+          <p:nvPr/>
+        </p:nvSpPr>
+        <p:spPr>
+          <a:xfrm>
+            <a:off x="18766800" y="7307999"/>
+            <a:ext cx="280800" cy="280800"/>
+          </a:xfrm>
+          <a:prstGeom prst="rect">
+            <a:avLst/>
+          </a:prstGeom>
+          <a:solidFill>
+            <a:srgbClr val="34D399"/>
+          </a:solidFill>
+          <a:ln w="4445">
+            <a:solidFill>
+              <a:srgbClr val="FFFFFF"/>
+            </a:solidFill>
+          </a:ln>
+        </p:spPr>
+        <p:style>
+          <a:lnRef idx="1">
+            <a:schemeClr val="accent1"/>
+          </a:lnRef>
+          <a:fillRef idx="3">
+            <a:schemeClr val="accent1"/>
+          </a:fillRef>
+          <a:effectRef idx="2">
+            <a:schemeClr val="accent1"/>
+          </a:effectRef>
+          <a:fontRef idx="minor">
+            <a:schemeClr val="lt1"/>
+          </a:fontRef>
+        </p:style>
+        <p:txBody>
+          <a:bodyPr rtlCol="0" anchor="ctr"/>
+          <a:lstStyle/>
+          <a:p>
+            <a:pPr algn="ctr"/>
+          </a:p>
+        </p:txBody>
+      </p:sp>
+      <p:sp>
+        <p:nvSpPr>
+          <p:cNvPr id="124" name="TextBox 123"/>
+          <p:cNvSpPr txBox="1"/>
+          <p:nvPr/>
+        </p:nvSpPr>
+        <p:spPr>
+          <a:xfrm>
+            <a:off x="16973999" y="7693200"/>
+            <a:ext cx="198000" cy="125999"/>
+          </a:xfrm>
+          <a:prstGeom prst="rect">
+            <a:avLst/>
+          </a:prstGeom>
+          <a:noFill/>
+        </p:spPr>
+        <p:txBody>
+          <a:bodyPr wrap="square" anchor="t">
+            <a:spAutoFit/>
+          </a:bodyPr>
+          <a:lstStyle/>
+          <a:p>
+            <a:pPr algn="ctr"/>
+            <a:r>
+              <a:rPr sz="740" b="1">
+                <a:solidFill>
+                  <a:srgbClr val="0F172A"/>
+                </a:solidFill>
+                <a:latin typeface="Arial"/>
+              </a:rPr>
+              <a:t>U4</a:t>
+            </a:r>
+          </a:p>
+        </p:txBody>
+      </p:sp>
+      <p:sp>
+        <p:nvSpPr>
+          <p:cNvPr id="125" name="Rectangle 124"/>
+          <p:cNvSpPr/>
+          <p:nvPr/>
+        </p:nvSpPr>
+        <p:spPr>
+          <a:xfrm>
+            <a:off x="17298000" y="7650000"/>
+            <a:ext cx="280800" cy="280800"/>
+          </a:xfrm>
+          <a:prstGeom prst="rect">
+            <a:avLst/>
+          </a:prstGeom>
+          <a:solidFill>
+            <a:srgbClr val="E2E8F0"/>
+          </a:solidFill>
+          <a:ln w="4445">
+            <a:solidFill>
+              <a:srgbClr val="FFFFFF"/>
+            </a:solidFill>
+          </a:ln>
+        </p:spPr>
+        <p:style>
+          <a:lnRef idx="1">
+            <a:schemeClr val="accent1"/>
+          </a:lnRef>
+          <a:fillRef idx="3">
+            <a:schemeClr val="accent1"/>
+          </a:fillRef>
+          <a:effectRef idx="2">
+            <a:schemeClr val="accent1"/>
+          </a:effectRef>
+          <a:fontRef idx="minor">
+            <a:schemeClr val="lt1"/>
+          </a:fontRef>
+        </p:style>
+        <p:txBody>
+          <a:bodyPr rtlCol="0" anchor="ctr"/>
+          <a:lstStyle/>
+          <a:p>
+            <a:pPr algn="ctr"/>
+          </a:p>
+        </p:txBody>
+      </p:sp>
+      <p:sp>
+        <p:nvSpPr>
+          <p:cNvPr id="126" name="Rectangle 125"/>
+          <p:cNvSpPr/>
+          <p:nvPr/>
+        </p:nvSpPr>
+        <p:spPr>
+          <a:xfrm>
+            <a:off x="17665200" y="7650000"/>
+            <a:ext cx="280800" cy="280800"/>
+          </a:xfrm>
+          <a:prstGeom prst="rect">
+            <a:avLst/>
+          </a:prstGeom>
+          <a:solidFill>
+            <a:srgbClr val="10B981"/>
+          </a:solidFill>
+          <a:ln w="4445">
+            <a:solidFill>
+              <a:srgbClr val="FFFFFF"/>
+            </a:solidFill>
+          </a:ln>
+        </p:spPr>
+        <p:style>
+          <a:lnRef idx="1">
+            <a:schemeClr val="accent1"/>
+          </a:lnRef>
+          <a:fillRef idx="3">
+            <a:schemeClr val="accent1"/>
+          </a:fillRef>
+          <a:effectRef idx="2">
+            <a:schemeClr val="accent1"/>
+          </a:effectRef>
+          <a:fontRef idx="minor">
+            <a:schemeClr val="lt1"/>
+          </a:fontRef>
+        </p:style>
+        <p:txBody>
+          <a:bodyPr rtlCol="0" anchor="ctr"/>
+          <a:lstStyle/>
+          <a:p>
+            <a:pPr algn="ctr"/>
+          </a:p>
+        </p:txBody>
+      </p:sp>
+      <p:sp>
+        <p:nvSpPr>
+          <p:cNvPr id="127" name="Rectangle 126"/>
+          <p:cNvSpPr/>
+          <p:nvPr/>
+        </p:nvSpPr>
+        <p:spPr>
+          <a:xfrm>
+            <a:off x="18032400" y="7650000"/>
+            <a:ext cx="280800" cy="280800"/>
+          </a:xfrm>
+          <a:prstGeom prst="rect">
+            <a:avLst/>
+          </a:prstGeom>
+          <a:solidFill>
+            <a:srgbClr val="93C5FD"/>
+          </a:solidFill>
+          <a:ln w="4445">
+            <a:solidFill>
+              <a:srgbClr val="FFFFFF"/>
+            </a:solidFill>
+          </a:ln>
+        </p:spPr>
+        <p:style>
+          <a:lnRef idx="1">
+            <a:schemeClr val="accent1"/>
+          </a:lnRef>
+          <a:fillRef idx="3">
+            <a:schemeClr val="accent1"/>
+          </a:fillRef>
+          <a:effectRef idx="2">
+            <a:schemeClr val="accent1"/>
+          </a:effectRef>
+          <a:fontRef idx="minor">
+            <a:schemeClr val="lt1"/>
+          </a:fontRef>
+        </p:style>
+        <p:txBody>
+          <a:bodyPr rtlCol="0" anchor="ctr"/>
+          <a:lstStyle/>
+          <a:p>
+            <a:pPr algn="ctr"/>
+          </a:p>
+        </p:txBody>
+      </p:sp>
+      <p:sp>
+        <p:nvSpPr>
+          <p:cNvPr id="128" name="Rectangle 127"/>
+          <p:cNvSpPr/>
+          <p:nvPr/>
+        </p:nvSpPr>
+        <p:spPr>
+          <a:xfrm>
+            <a:off x="18399600" y="7650000"/>
+            <a:ext cx="280800" cy="280800"/>
+          </a:xfrm>
+          <a:prstGeom prst="rect">
+            <a:avLst/>
+          </a:prstGeom>
+          <a:solidFill>
+            <a:srgbClr val="E2E8F0"/>
+          </a:solidFill>
+          <a:ln w="4445">
+            <a:solidFill>
+              <a:srgbClr val="FFFFFF"/>
+            </a:solidFill>
+          </a:ln>
+        </p:spPr>
+        <p:style>
+          <a:lnRef idx="1">
+            <a:schemeClr val="accent1"/>
+          </a:lnRef>
+          <a:fillRef idx="3">
+            <a:schemeClr val="accent1"/>
+          </a:fillRef>
+          <a:effectRef idx="2">
+            <a:schemeClr val="accent1"/>
+          </a:effectRef>
+          <a:fontRef idx="minor">
+            <a:schemeClr val="lt1"/>
+          </a:fontRef>
+        </p:style>
+        <p:txBody>
+          <a:bodyPr rtlCol="0" anchor="ctr"/>
+          <a:lstStyle/>
+          <a:p>
+            <a:pPr algn="ctr"/>
+          </a:p>
+        </p:txBody>
+      </p:sp>
+      <p:sp>
+        <p:nvSpPr>
+          <p:cNvPr id="129" name="Rectangle 128"/>
+          <p:cNvSpPr/>
+          <p:nvPr/>
+        </p:nvSpPr>
+        <p:spPr>
+          <a:xfrm>
+            <a:off x="18766800" y="7650000"/>
+            <a:ext cx="280800" cy="280800"/>
+          </a:xfrm>
+          <a:prstGeom prst="rect">
+            <a:avLst/>
+          </a:prstGeom>
+          <a:solidFill>
+            <a:srgbClr val="E2E8F0"/>
+          </a:solidFill>
+          <a:ln w="4445">
+            <a:solidFill>
+              <a:srgbClr val="FFFFFF"/>
+            </a:solidFill>
+          </a:ln>
+        </p:spPr>
+        <p:style>
+          <a:lnRef idx="1">
+            <a:schemeClr val="accent1"/>
+          </a:lnRef>
+          <a:fillRef idx="3">
+            <a:schemeClr val="accent1"/>
+          </a:fillRef>
+          <a:effectRef idx="2">
+            <a:schemeClr val="accent1"/>
+          </a:effectRef>
+          <a:fontRef idx="minor">
+            <a:schemeClr val="lt1"/>
+          </a:fontRef>
+        </p:style>
+        <p:txBody>
+          <a:bodyPr rtlCol="0" anchor="ctr"/>
+          <a:lstStyle/>
+          <a:p>
+            <a:pPr algn="ctr"/>
+          </a:p>
+        </p:txBody>
+      </p:sp>
+      <p:sp>
+        <p:nvSpPr>
+          <p:cNvPr id="130" name="TextBox 129"/>
+          <p:cNvSpPr txBox="1"/>
+          <p:nvPr/>
+        </p:nvSpPr>
+        <p:spPr>
+          <a:xfrm>
+            <a:off x="17009999" y="7920000"/>
+            <a:ext cx="2484000" cy="125999"/>
+          </a:xfrm>
+          <a:prstGeom prst="rect">
+            <a:avLst/>
+          </a:prstGeom>
+          <a:noFill/>
+        </p:spPr>
+        <p:txBody>
+          <a:bodyPr wrap="square" anchor="t">
+            <a:spAutoFit/>
+          </a:bodyPr>
+          <a:lstStyle/>
+          <a:p>
+            <a:pPr algn="ctr"/>
+            <a:r>
+              <a:rPr sz="740" b="1">
+                <a:solidFill>
+                  <a:srgbClr val="475569"/>
+                </a:solidFill>
+                <a:latin typeface="Arial"/>
+              </a:rPr>
+              <a:t>0: yok  •  5: güçlü niyet</a:t>
+            </a:r>
+          </a:p>
+        </p:txBody>
+      </p:sp>
+      <p:sp>
+        <p:nvSpPr>
+          <p:cNvPr id="131" name="Rectangle 130"/>
           <p:cNvSpPr/>
           <p:nvPr/>
         </p:nvSpPr>
@@ -6213,7 +8895,7 @@
       </p:sp>
       <p:sp>
         <p:nvSpPr>
-          <p:cNvPr id="68" name="Rectangle 67"/>
+          <p:cNvPr id="132" name="Rectangle 131"/>
           <p:cNvSpPr/>
           <p:nvPr/>
         </p:nvSpPr>
@@ -6258,7 +8940,7 @@
       </p:sp>
       <p:sp>
         <p:nvSpPr>
-          <p:cNvPr id="69" name="Rectangle 68"/>
+          <p:cNvPr id="133" name="Rectangle 132"/>
           <p:cNvSpPr/>
           <p:nvPr/>
         </p:nvSpPr>
@@ -6303,7 +8985,7 @@
       </p:sp>
       <p:sp>
         <p:nvSpPr>
-          <p:cNvPr id="70" name="TextBox 69"/>
+          <p:cNvPr id="134" name="TextBox 133"/>
           <p:cNvSpPr txBox="1"/>
           <p:nvPr/>
         </p:nvSpPr>
@@ -6338,7 +9020,7 @@
       </p:sp>
       <p:sp>
         <p:nvSpPr>
-          <p:cNvPr id="71" name="TextBox 70"/>
+          <p:cNvPr id="135" name="TextBox 134"/>
           <p:cNvSpPr txBox="1"/>
           <p:nvPr/>
         </p:nvSpPr>
@@ -6437,7 +9119,602 @@
       </p:sp>
       <p:sp>
         <p:nvSpPr>
-          <p:cNvPr id="72" name="Rectangle 71"/>
+          <p:cNvPr id="136" name="Rectangle 135"/>
+          <p:cNvSpPr/>
+          <p:nvPr/>
+        </p:nvSpPr>
+        <p:spPr>
+          <a:xfrm>
+            <a:off x="11519999" y="11970000"/>
+            <a:ext cx="7848000" cy="1872000"/>
+          </a:xfrm>
+          <a:prstGeom prst="rect">
+            <a:avLst/>
+          </a:prstGeom>
+          <a:solidFill>
+            <a:srgbClr val="FFFFFF"/>
+          </a:solidFill>
+          <a:ln w="8890">
+            <a:solidFill>
+              <a:srgbClr val="BFDBFE"/>
+            </a:solidFill>
+          </a:ln>
+        </p:spPr>
+        <p:style>
+          <a:lnRef idx="1">
+            <a:schemeClr val="accent1"/>
+          </a:lnRef>
+          <a:fillRef idx="3">
+            <a:schemeClr val="accent1"/>
+          </a:fillRef>
+          <a:effectRef idx="2">
+            <a:schemeClr val="accent1"/>
+          </a:effectRef>
+          <a:fontRef idx="minor">
+            <a:schemeClr val="lt1"/>
+          </a:fontRef>
+        </p:style>
+        <p:txBody>
+          <a:bodyPr rtlCol="0" anchor="ctr"/>
+          <a:lstStyle/>
+          <a:p>
+            <a:pPr algn="ctr"/>
+          </a:p>
+        </p:txBody>
+      </p:sp>
+      <p:sp>
+        <p:nvSpPr>
+          <p:cNvPr id="137" name="TextBox 136"/>
+          <p:cNvSpPr txBox="1"/>
+          <p:nvPr/>
+        </p:nvSpPr>
+        <p:spPr>
+          <a:xfrm>
+            <a:off x="11735999" y="12096000"/>
+            <a:ext cx="2520000" cy="198000"/>
+          </a:xfrm>
+          <a:prstGeom prst="rect">
+            <a:avLst/>
+          </a:prstGeom>
+          <a:noFill/>
+        </p:spPr>
+        <p:txBody>
+          <a:bodyPr wrap="square" anchor="t">
+            <a:spAutoFit/>
+          </a:bodyPr>
+          <a:lstStyle/>
+          <a:p>
+            <a:pPr algn="l"/>
+            <a:r>
+              <a:rPr sz="1150" b="1">
+                <a:solidFill>
+                  <a:srgbClr val="1E40AF"/>
+                </a:solidFill>
+                <a:latin typeface="Arial"/>
+              </a:rPr>
+              <a:t>Pilot veri hedefi</a:t>
+            </a:r>
+          </a:p>
+        </p:txBody>
+      </p:sp>
+      <p:sp>
+        <p:nvSpPr>
+          <p:cNvPr id="138" name="TextBox 137"/>
+          <p:cNvSpPr txBox="1"/>
+          <p:nvPr/>
+        </p:nvSpPr>
+        <p:spPr>
+          <a:xfrm>
+            <a:off x="11771999" y="12463200"/>
+            <a:ext cx="1080000" cy="125999"/>
+          </a:xfrm>
+          <a:prstGeom prst="rect">
+            <a:avLst/>
+          </a:prstGeom>
+          <a:noFill/>
+        </p:spPr>
+        <p:txBody>
+          <a:bodyPr wrap="square" anchor="t">
+            <a:spAutoFit/>
+          </a:bodyPr>
+          <a:lstStyle/>
+          <a:p>
+            <a:pPr algn="l"/>
+            <a:r>
+              <a:rPr sz="880" b="1">
+                <a:solidFill>
+                  <a:srgbClr val="0F172A"/>
+                </a:solidFill>
+                <a:latin typeface="Arial"/>
+              </a:rPr>
+              <a:t>İlan</a:t>
+            </a:r>
+          </a:p>
+        </p:txBody>
+      </p:sp>
+      <p:sp>
+        <p:nvSpPr>
+          <p:cNvPr id="139" name="Rectangle 138"/>
+          <p:cNvSpPr/>
+          <p:nvPr/>
+        </p:nvSpPr>
+        <p:spPr>
+          <a:xfrm>
+            <a:off x="12960000" y="12420000"/>
+            <a:ext cx="5256000" cy="198000"/>
+          </a:xfrm>
+          <a:prstGeom prst="rect">
+            <a:avLst/>
+          </a:prstGeom>
+          <a:solidFill>
+            <a:srgbClr val="E5F1FF"/>
+          </a:solidFill>
+          <a:ln w="2540">
+            <a:solidFill>
+              <a:srgbClr val="E5F1FF"/>
+            </a:solidFill>
+          </a:ln>
+        </p:spPr>
+        <p:style>
+          <a:lnRef idx="1">
+            <a:schemeClr val="accent1"/>
+          </a:lnRef>
+          <a:fillRef idx="3">
+            <a:schemeClr val="accent1"/>
+          </a:fillRef>
+          <a:effectRef idx="2">
+            <a:schemeClr val="accent1"/>
+          </a:effectRef>
+          <a:fontRef idx="minor">
+            <a:schemeClr val="lt1"/>
+          </a:fontRef>
+        </p:style>
+        <p:txBody>
+          <a:bodyPr rtlCol="0" anchor="ctr"/>
+          <a:lstStyle/>
+          <a:p>
+            <a:pPr algn="ctr"/>
+          </a:p>
+        </p:txBody>
+      </p:sp>
+      <p:sp>
+        <p:nvSpPr>
+          <p:cNvPr id="140" name="Rectangle 139"/>
+          <p:cNvSpPr/>
+          <p:nvPr/>
+        </p:nvSpPr>
+        <p:spPr>
+          <a:xfrm>
+            <a:off x="12960000" y="12420000"/>
+            <a:ext cx="657000" cy="198000"/>
+          </a:xfrm>
+          <a:prstGeom prst="rect">
+            <a:avLst/>
+          </a:prstGeom>
+          <a:solidFill>
+            <a:srgbClr val="2563EB"/>
+          </a:solidFill>
+          <a:ln w="2540">
+            <a:solidFill>
+              <a:srgbClr val="2563EB"/>
+            </a:solidFill>
+          </a:ln>
+        </p:spPr>
+        <p:style>
+          <a:lnRef idx="1">
+            <a:schemeClr val="accent1"/>
+          </a:lnRef>
+          <a:fillRef idx="3">
+            <a:schemeClr val="accent1"/>
+          </a:fillRef>
+          <a:effectRef idx="2">
+            <a:schemeClr val="accent1"/>
+          </a:effectRef>
+          <a:fontRef idx="minor">
+            <a:schemeClr val="lt1"/>
+          </a:fontRef>
+        </p:style>
+        <p:txBody>
+          <a:bodyPr rtlCol="0" anchor="ctr"/>
+          <a:lstStyle/>
+          <a:p>
+            <a:pPr algn="ctr"/>
+          </a:p>
+        </p:txBody>
+      </p:sp>
+      <p:sp>
+        <p:nvSpPr>
+          <p:cNvPr id="141" name="TextBox 140"/>
+          <p:cNvSpPr txBox="1"/>
+          <p:nvPr/>
+        </p:nvSpPr>
+        <p:spPr>
+          <a:xfrm>
+            <a:off x="18360000" y="12412799"/>
+            <a:ext cx="648000" cy="162000"/>
+          </a:xfrm>
+          <a:prstGeom prst="rect">
+            <a:avLst/>
+          </a:prstGeom>
+          <a:noFill/>
+        </p:spPr>
+        <p:txBody>
+          <a:bodyPr wrap="square" anchor="t">
+            <a:spAutoFit/>
+          </a:bodyPr>
+          <a:lstStyle/>
+          <a:p>
+            <a:pPr algn="r"/>
+            <a:r>
+              <a:rPr sz="919" b="1">
+                <a:solidFill>
+                  <a:srgbClr val="2563EB"/>
+                </a:solidFill>
+                <a:latin typeface="Arial"/>
+              </a:rPr>
+              <a:t>50</a:t>
+            </a:r>
+          </a:p>
+        </p:txBody>
+      </p:sp>
+      <p:sp>
+        <p:nvSpPr>
+          <p:cNvPr id="142" name="TextBox 141"/>
+          <p:cNvSpPr txBox="1"/>
+          <p:nvPr/>
+        </p:nvSpPr>
+        <p:spPr>
+          <a:xfrm>
+            <a:off x="11771999" y="12887999"/>
+            <a:ext cx="1080000" cy="125999"/>
+          </a:xfrm>
+          <a:prstGeom prst="rect">
+            <a:avLst/>
+          </a:prstGeom>
+          <a:noFill/>
+        </p:spPr>
+        <p:txBody>
+          <a:bodyPr wrap="square" anchor="t">
+            <a:spAutoFit/>
+          </a:bodyPr>
+          <a:lstStyle/>
+          <a:p>
+            <a:pPr algn="l"/>
+            <a:r>
+              <a:rPr sz="880" b="1">
+                <a:solidFill>
+                  <a:srgbClr val="0F172A"/>
+                </a:solidFill>
+                <a:latin typeface="Arial"/>
+              </a:rPr>
+              <a:t>Öğrenci</a:t>
+            </a:r>
+          </a:p>
+        </p:txBody>
+      </p:sp>
+      <p:sp>
+        <p:nvSpPr>
+          <p:cNvPr id="143" name="Rectangle 142"/>
+          <p:cNvSpPr/>
+          <p:nvPr/>
+        </p:nvSpPr>
+        <p:spPr>
+          <a:xfrm>
+            <a:off x="12960000" y="12844800"/>
+            <a:ext cx="5256000" cy="198000"/>
+          </a:xfrm>
+          <a:prstGeom prst="rect">
+            <a:avLst/>
+          </a:prstGeom>
+          <a:solidFill>
+            <a:srgbClr val="E5F1FF"/>
+          </a:solidFill>
+          <a:ln w="2540">
+            <a:solidFill>
+              <a:srgbClr val="E5F1FF"/>
+            </a:solidFill>
+          </a:ln>
+        </p:spPr>
+        <p:style>
+          <a:lnRef idx="1">
+            <a:schemeClr val="accent1"/>
+          </a:lnRef>
+          <a:fillRef idx="3">
+            <a:schemeClr val="accent1"/>
+          </a:fillRef>
+          <a:effectRef idx="2">
+            <a:schemeClr val="accent1"/>
+          </a:effectRef>
+          <a:fontRef idx="minor">
+            <a:schemeClr val="lt1"/>
+          </a:fontRef>
+        </p:style>
+        <p:txBody>
+          <a:bodyPr rtlCol="0" anchor="ctr"/>
+          <a:lstStyle/>
+          <a:p>
+            <a:pPr algn="ctr"/>
+          </a:p>
+        </p:txBody>
+      </p:sp>
+      <p:sp>
+        <p:nvSpPr>
+          <p:cNvPr id="144" name="Rectangle 143"/>
+          <p:cNvSpPr/>
+          <p:nvPr/>
+        </p:nvSpPr>
+        <p:spPr>
+          <a:xfrm>
+            <a:off x="12960000" y="12844800"/>
+            <a:ext cx="396000" cy="198000"/>
+          </a:xfrm>
+          <a:prstGeom prst="rect">
+            <a:avLst/>
+          </a:prstGeom>
+          <a:solidFill>
+            <a:srgbClr val="10B981"/>
+          </a:solidFill>
+          <a:ln w="2540">
+            <a:solidFill>
+              <a:srgbClr val="10B981"/>
+            </a:solidFill>
+          </a:ln>
+        </p:spPr>
+        <p:style>
+          <a:lnRef idx="1">
+            <a:schemeClr val="accent1"/>
+          </a:lnRef>
+          <a:fillRef idx="3">
+            <a:schemeClr val="accent1"/>
+          </a:fillRef>
+          <a:effectRef idx="2">
+            <a:schemeClr val="accent1"/>
+          </a:effectRef>
+          <a:fontRef idx="minor">
+            <a:schemeClr val="lt1"/>
+          </a:fontRef>
+        </p:style>
+        <p:txBody>
+          <a:bodyPr rtlCol="0" anchor="ctr"/>
+          <a:lstStyle/>
+          <a:p>
+            <a:pPr algn="ctr"/>
+          </a:p>
+        </p:txBody>
+      </p:sp>
+      <p:sp>
+        <p:nvSpPr>
+          <p:cNvPr id="145" name="TextBox 144"/>
+          <p:cNvSpPr txBox="1"/>
+          <p:nvPr/>
+        </p:nvSpPr>
+        <p:spPr>
+          <a:xfrm>
+            <a:off x="18360000" y="12837599"/>
+            <a:ext cx="648000" cy="162000"/>
+          </a:xfrm>
+          <a:prstGeom prst="rect">
+            <a:avLst/>
+          </a:prstGeom>
+          <a:noFill/>
+        </p:spPr>
+        <p:txBody>
+          <a:bodyPr wrap="square" anchor="t">
+            <a:spAutoFit/>
+          </a:bodyPr>
+          <a:lstStyle/>
+          <a:p>
+            <a:pPr algn="r"/>
+            <a:r>
+              <a:rPr sz="919" b="1">
+                <a:solidFill>
+                  <a:srgbClr val="10B981"/>
+                </a:solidFill>
+                <a:latin typeface="Arial"/>
+              </a:rPr>
+              <a:t>20</a:t>
+            </a:r>
+          </a:p>
+        </p:txBody>
+      </p:sp>
+      <p:sp>
+        <p:nvSpPr>
+          <p:cNvPr id="146" name="TextBox 145"/>
+          <p:cNvSpPr txBox="1"/>
+          <p:nvPr/>
+        </p:nvSpPr>
+        <p:spPr>
+          <a:xfrm>
+            <a:off x="11771999" y="13312799"/>
+            <a:ext cx="1080000" cy="125999"/>
+          </a:xfrm>
+          <a:prstGeom prst="rect">
+            <a:avLst/>
+          </a:prstGeom>
+          <a:noFill/>
+        </p:spPr>
+        <p:txBody>
+          <a:bodyPr wrap="square" anchor="t">
+            <a:spAutoFit/>
+          </a:bodyPr>
+          <a:lstStyle/>
+          <a:p>
+            <a:pPr algn="l"/>
+            <a:r>
+              <a:rPr sz="880" b="1">
+                <a:solidFill>
+                  <a:srgbClr val="0F172A"/>
+                </a:solidFill>
+                <a:latin typeface="Arial"/>
+              </a:rPr>
+              <a:t>Etkileşim</a:t>
+            </a:r>
+          </a:p>
+        </p:txBody>
+      </p:sp>
+      <p:sp>
+        <p:nvSpPr>
+          <p:cNvPr id="147" name="Rectangle 146"/>
+          <p:cNvSpPr/>
+          <p:nvPr/>
+        </p:nvSpPr>
+        <p:spPr>
+          <a:xfrm>
+            <a:off x="12960000" y="13269600"/>
+            <a:ext cx="5256000" cy="198000"/>
+          </a:xfrm>
+          <a:prstGeom prst="rect">
+            <a:avLst/>
+          </a:prstGeom>
+          <a:solidFill>
+            <a:srgbClr val="E5F1FF"/>
+          </a:solidFill>
+          <a:ln w="2540">
+            <a:solidFill>
+              <a:srgbClr val="E5F1FF"/>
+            </a:solidFill>
+          </a:ln>
+        </p:spPr>
+        <p:style>
+          <a:lnRef idx="1">
+            <a:schemeClr val="accent1"/>
+          </a:lnRef>
+          <a:fillRef idx="3">
+            <a:schemeClr val="accent1"/>
+          </a:fillRef>
+          <a:effectRef idx="2">
+            <a:schemeClr val="accent1"/>
+          </a:effectRef>
+          <a:fontRef idx="minor">
+            <a:schemeClr val="lt1"/>
+          </a:fontRef>
+        </p:style>
+        <p:txBody>
+          <a:bodyPr rtlCol="0" anchor="ctr"/>
+          <a:lstStyle/>
+          <a:p>
+            <a:pPr algn="ctr"/>
+          </a:p>
+        </p:txBody>
+      </p:sp>
+      <p:sp>
+        <p:nvSpPr>
+          <p:cNvPr id="148" name="Rectangle 147"/>
+          <p:cNvSpPr/>
+          <p:nvPr/>
+        </p:nvSpPr>
+        <p:spPr>
+          <a:xfrm>
+            <a:off x="12960000" y="13269600"/>
+            <a:ext cx="5256000" cy="198000"/>
+          </a:xfrm>
+          <a:prstGeom prst="rect">
+            <a:avLst/>
+          </a:prstGeom>
+          <a:solidFill>
+            <a:srgbClr val="0F172A"/>
+          </a:solidFill>
+          <a:ln w="2540">
+            <a:solidFill>
+              <a:srgbClr val="0F172A"/>
+            </a:solidFill>
+          </a:ln>
+        </p:spPr>
+        <p:style>
+          <a:lnRef idx="1">
+            <a:schemeClr val="accent1"/>
+          </a:lnRef>
+          <a:fillRef idx="3">
+            <a:schemeClr val="accent1"/>
+          </a:fillRef>
+          <a:effectRef idx="2">
+            <a:schemeClr val="accent1"/>
+          </a:effectRef>
+          <a:fontRef idx="minor">
+            <a:schemeClr val="lt1"/>
+          </a:fontRef>
+        </p:style>
+        <p:txBody>
+          <a:bodyPr rtlCol="0" anchor="ctr"/>
+          <a:lstStyle/>
+          <a:p>
+            <a:pPr algn="ctr"/>
+          </a:p>
+        </p:txBody>
+      </p:sp>
+      <p:sp>
+        <p:nvSpPr>
+          <p:cNvPr id="149" name="TextBox 148"/>
+          <p:cNvSpPr txBox="1"/>
+          <p:nvPr/>
+        </p:nvSpPr>
+        <p:spPr>
+          <a:xfrm>
+            <a:off x="18360000" y="13262399"/>
+            <a:ext cx="648000" cy="162000"/>
+          </a:xfrm>
+          <a:prstGeom prst="rect">
+            <a:avLst/>
+          </a:prstGeom>
+          <a:noFill/>
+        </p:spPr>
+        <p:txBody>
+          <a:bodyPr wrap="square" anchor="t">
+            <a:spAutoFit/>
+          </a:bodyPr>
+          <a:lstStyle/>
+          <a:p>
+            <a:pPr algn="r"/>
+            <a:r>
+              <a:rPr sz="919" b="1">
+                <a:solidFill>
+                  <a:srgbClr val="0F172A"/>
+                </a:solidFill>
+                <a:latin typeface="Arial"/>
+              </a:rPr>
+              <a:t>400</a:t>
+            </a:r>
+          </a:p>
+        </p:txBody>
+      </p:sp>
+      <p:sp>
+        <p:nvSpPr>
+          <p:cNvPr id="150" name="TextBox 149"/>
+          <p:cNvSpPr txBox="1"/>
+          <p:nvPr/>
+        </p:nvSpPr>
+        <p:spPr>
+          <a:xfrm>
+            <a:off x="11771999" y="13536000"/>
+            <a:ext cx="7200000" cy="162000"/>
+          </a:xfrm>
+          <a:prstGeom prst="rect">
+            <a:avLst/>
+          </a:prstGeom>
+          <a:noFill/>
+        </p:spPr>
+        <p:txBody>
+          <a:bodyPr wrap="square" anchor="t">
+            <a:spAutoFit/>
+          </a:bodyPr>
+          <a:lstStyle/>
+          <a:p>
+            <a:pPr algn="ctr"/>
+            <a:r>
+              <a:rPr sz="880" b="1">
+                <a:solidFill>
+                  <a:srgbClr val="475569"/>
+                </a:solidFill>
+                <a:latin typeface="Arial"/>
+              </a:rPr>
+              <a:t>Sentetik veri değil, kontrollü gerçek kampüs etkileşimi</a:t>
+            </a:r>
+          </a:p>
+        </p:txBody>
+      </p:sp>
+      <p:sp>
+        <p:nvSpPr>
+          <p:cNvPr id="151" name="Rectangle 150"/>
           <p:cNvSpPr/>
           <p:nvPr/>
         </p:nvSpPr>
@@ -6482,7 +9759,7 @@
       </p:sp>
       <p:sp>
         <p:nvSpPr>
-          <p:cNvPr id="73" name="Rectangle 72"/>
+          <p:cNvPr id="152" name="Rectangle 151"/>
           <p:cNvSpPr/>
           <p:nvPr/>
         </p:nvSpPr>
@@ -6527,7 +9804,7 @@
       </p:sp>
       <p:sp>
         <p:nvSpPr>
-          <p:cNvPr id="74" name="Rectangle 73"/>
+          <p:cNvPr id="153" name="Rectangle 152"/>
           <p:cNvSpPr/>
           <p:nvPr/>
         </p:nvSpPr>
@@ -6572,7 +9849,7 @@
       </p:sp>
       <p:sp>
         <p:nvSpPr>
-          <p:cNvPr id="75" name="TextBox 74"/>
+          <p:cNvPr id="154" name="TextBox 153"/>
           <p:cNvSpPr txBox="1"/>
           <p:nvPr/>
         </p:nvSpPr>
@@ -6607,7 +9884,7 @@
       </p:sp>
       <p:sp>
         <p:nvSpPr>
-          <p:cNvPr id="76" name="TextBox 75"/>
+          <p:cNvPr id="155" name="TextBox 154"/>
           <p:cNvSpPr txBox="1"/>
           <p:nvPr/>
         </p:nvSpPr>
@@ -6687,7 +9964,7 @@
       </p:sp>
       <p:graphicFrame>
         <p:nvGraphicFramePr>
-          <p:cNvPr id="77" name="Table 76"/>
+          <p:cNvPr id="156" name="Table 155"/>
           <p:cNvGraphicFramePr>
             <a:graphicFrameLocks noGrp="1"/>
           </p:cNvGraphicFramePr>
@@ -7122,14 +10399,506 @@
       </p:graphicFrame>
       <p:sp>
         <p:nvSpPr>
-          <p:cNvPr id="78" name="Rectangle 77"/>
+          <p:cNvPr id="157" name="Rectangle 156"/>
           <p:cNvSpPr/>
           <p:nvPr/>
         </p:nvSpPr>
         <p:spPr>
           <a:xfrm>
-            <a:off x="11016000" y="21222000"/>
-            <a:ext cx="9072000" cy="4716000"/>
+            <a:off x="11286000" y="21078000"/>
+            <a:ext cx="2394000" cy="1188000"/>
+          </a:xfrm>
+          <a:prstGeom prst="rect">
+            <a:avLst/>
+          </a:prstGeom>
+          <a:solidFill>
+            <a:srgbClr val="FFFFFF"/>
+          </a:solidFill>
+          <a:ln w="10160">
+            <a:solidFill>
+              <a:srgbClr val="BFDBFE"/>
+            </a:solidFill>
+          </a:ln>
+        </p:spPr>
+        <p:style>
+          <a:lnRef idx="1">
+            <a:schemeClr val="accent1"/>
+          </a:lnRef>
+          <a:fillRef idx="3">
+            <a:schemeClr val="accent1"/>
+          </a:fillRef>
+          <a:effectRef idx="2">
+            <a:schemeClr val="accent1"/>
+          </a:effectRef>
+          <a:fontRef idx="minor">
+            <a:schemeClr val="lt1"/>
+          </a:fontRef>
+        </p:style>
+        <p:txBody>
+          <a:bodyPr rtlCol="0" anchor="ctr"/>
+          <a:lstStyle/>
+          <a:p>
+            <a:pPr algn="ctr"/>
+          </a:p>
+        </p:txBody>
+      </p:sp>
+      <p:sp>
+        <p:nvSpPr>
+          <p:cNvPr id="158" name="Rectangle 157"/>
+          <p:cNvSpPr/>
+          <p:nvPr/>
+        </p:nvSpPr>
+        <p:spPr>
+          <a:xfrm>
+            <a:off x="11286000" y="21078000"/>
+            <a:ext cx="2394000" cy="86400"/>
+          </a:xfrm>
+          <a:prstGeom prst="rect">
+            <a:avLst/>
+          </a:prstGeom>
+          <a:solidFill>
+            <a:srgbClr val="10B981"/>
+          </a:solidFill>
+          <a:ln>
+            <a:solidFill>
+              <a:srgbClr val="10B981"/>
+            </a:solidFill>
+          </a:ln>
+        </p:spPr>
+        <p:style>
+          <a:lnRef idx="1">
+            <a:schemeClr val="accent1"/>
+          </a:lnRef>
+          <a:fillRef idx="3">
+            <a:schemeClr val="accent1"/>
+          </a:fillRef>
+          <a:effectRef idx="2">
+            <a:schemeClr val="accent1"/>
+          </a:effectRef>
+          <a:fontRef idx="minor">
+            <a:schemeClr val="lt1"/>
+          </a:fontRef>
+        </p:style>
+        <p:txBody>
+          <a:bodyPr rtlCol="0" anchor="ctr"/>
+          <a:lstStyle/>
+          <a:p>
+            <a:pPr algn="ctr"/>
+          </a:p>
+        </p:txBody>
+      </p:sp>
+      <p:sp>
+        <p:nvSpPr>
+          <p:cNvPr id="159" name="TextBox 158"/>
+          <p:cNvSpPr txBox="1"/>
+          <p:nvPr/>
+        </p:nvSpPr>
+        <p:spPr>
+          <a:xfrm>
+            <a:off x="11412000" y="21275999"/>
+            <a:ext cx="2142000" cy="180000"/>
+          </a:xfrm>
+          <a:prstGeom prst="rect">
+            <a:avLst/>
+          </a:prstGeom>
+          <a:noFill/>
+        </p:spPr>
+        <p:txBody>
+          <a:bodyPr wrap="square" anchor="t">
+            <a:spAutoFit/>
+          </a:bodyPr>
+          <a:lstStyle/>
+          <a:p>
+            <a:pPr algn="ctr"/>
+            <a:r>
+              <a:rPr sz="1019" b="1">
+                <a:solidFill>
+                  <a:srgbClr val="1E40AF"/>
+                </a:solidFill>
+                <a:latin typeface="Arial"/>
+              </a:rPr>
+              <a:t>Precision@5</a:t>
+            </a:r>
+          </a:p>
+        </p:txBody>
+      </p:sp>
+      <p:sp>
+        <p:nvSpPr>
+          <p:cNvPr id="160" name="TextBox 159"/>
+          <p:cNvSpPr txBox="1"/>
+          <p:nvPr/>
+        </p:nvSpPr>
+        <p:spPr>
+          <a:xfrm>
+            <a:off x="11484000" y="21564000"/>
+            <a:ext cx="1998000" cy="378000"/>
+          </a:xfrm>
+          <a:prstGeom prst="rect">
+            <a:avLst/>
+          </a:prstGeom>
+          <a:noFill/>
+        </p:spPr>
+        <p:txBody>
+          <a:bodyPr wrap="square" anchor="t">
+            <a:spAutoFit/>
+          </a:bodyPr>
+          <a:lstStyle/>
+          <a:p>
+            <a:pPr algn="ctr"/>
+            <a:r>
+              <a:rPr sz="840" b="0">
+                <a:solidFill>
+                  <a:srgbClr val="0F172A"/>
+                </a:solidFill>
+                <a:latin typeface="Arial"/>
+              </a:rPr>
+              <a:t>İlk 5 öneri</a:t>
+            </a:r>
+            <a:br/>
+            <a:r>
+              <a:t>ne kadar isabetli?</a:t>
+            </a:r>
+          </a:p>
+        </p:txBody>
+      </p:sp>
+      <p:sp>
+        <p:nvSpPr>
+          <p:cNvPr id="161" name="Rectangle 160"/>
+          <p:cNvSpPr/>
+          <p:nvPr/>
+        </p:nvSpPr>
+        <p:spPr>
+          <a:xfrm>
+            <a:off x="13931999" y="21078000"/>
+            <a:ext cx="2394000" cy="1188000"/>
+          </a:xfrm>
+          <a:prstGeom prst="rect">
+            <a:avLst/>
+          </a:prstGeom>
+          <a:solidFill>
+            <a:srgbClr val="FFFFFF"/>
+          </a:solidFill>
+          <a:ln w="10160">
+            <a:solidFill>
+              <a:srgbClr val="BFDBFE"/>
+            </a:solidFill>
+          </a:ln>
+        </p:spPr>
+        <p:style>
+          <a:lnRef idx="1">
+            <a:schemeClr val="accent1"/>
+          </a:lnRef>
+          <a:fillRef idx="3">
+            <a:schemeClr val="accent1"/>
+          </a:fillRef>
+          <a:effectRef idx="2">
+            <a:schemeClr val="accent1"/>
+          </a:effectRef>
+          <a:fontRef idx="minor">
+            <a:schemeClr val="lt1"/>
+          </a:fontRef>
+        </p:style>
+        <p:txBody>
+          <a:bodyPr rtlCol="0" anchor="ctr"/>
+          <a:lstStyle/>
+          <a:p>
+            <a:pPr algn="ctr"/>
+          </a:p>
+        </p:txBody>
+      </p:sp>
+      <p:sp>
+        <p:nvSpPr>
+          <p:cNvPr id="162" name="Rectangle 161"/>
+          <p:cNvSpPr/>
+          <p:nvPr/>
+        </p:nvSpPr>
+        <p:spPr>
+          <a:xfrm>
+            <a:off x="13931999" y="21078000"/>
+            <a:ext cx="2394000" cy="86400"/>
+          </a:xfrm>
+          <a:prstGeom prst="rect">
+            <a:avLst/>
+          </a:prstGeom>
+          <a:solidFill>
+            <a:srgbClr val="2563EB"/>
+          </a:solidFill>
+          <a:ln>
+            <a:solidFill>
+              <a:srgbClr val="2563EB"/>
+            </a:solidFill>
+          </a:ln>
+        </p:spPr>
+        <p:style>
+          <a:lnRef idx="1">
+            <a:schemeClr val="accent1"/>
+          </a:lnRef>
+          <a:fillRef idx="3">
+            <a:schemeClr val="accent1"/>
+          </a:fillRef>
+          <a:effectRef idx="2">
+            <a:schemeClr val="accent1"/>
+          </a:effectRef>
+          <a:fontRef idx="minor">
+            <a:schemeClr val="lt1"/>
+          </a:fontRef>
+        </p:style>
+        <p:txBody>
+          <a:bodyPr rtlCol="0" anchor="ctr"/>
+          <a:lstStyle/>
+          <a:p>
+            <a:pPr algn="ctr"/>
+          </a:p>
+        </p:txBody>
+      </p:sp>
+      <p:sp>
+        <p:nvSpPr>
+          <p:cNvPr id="163" name="TextBox 162"/>
+          <p:cNvSpPr txBox="1"/>
+          <p:nvPr/>
+        </p:nvSpPr>
+        <p:spPr>
+          <a:xfrm>
+            <a:off x="14057999" y="21275999"/>
+            <a:ext cx="2142000" cy="180000"/>
+          </a:xfrm>
+          <a:prstGeom prst="rect">
+            <a:avLst/>
+          </a:prstGeom>
+          <a:noFill/>
+        </p:spPr>
+        <p:txBody>
+          <a:bodyPr wrap="square" anchor="t">
+            <a:spAutoFit/>
+          </a:bodyPr>
+          <a:lstStyle/>
+          <a:p>
+            <a:pPr algn="ctr"/>
+            <a:r>
+              <a:rPr sz="1019" b="1">
+                <a:solidFill>
+                  <a:srgbClr val="1E40AF"/>
+                </a:solidFill>
+                <a:latin typeface="Arial"/>
+              </a:rPr>
+              <a:t>Recall@5</a:t>
+            </a:r>
+          </a:p>
+        </p:txBody>
+      </p:sp>
+      <p:sp>
+        <p:nvSpPr>
+          <p:cNvPr id="164" name="TextBox 163"/>
+          <p:cNvSpPr txBox="1"/>
+          <p:nvPr/>
+        </p:nvSpPr>
+        <p:spPr>
+          <a:xfrm>
+            <a:off x="14129999" y="21564000"/>
+            <a:ext cx="1998000" cy="378000"/>
+          </a:xfrm>
+          <a:prstGeom prst="rect">
+            <a:avLst/>
+          </a:prstGeom>
+          <a:noFill/>
+        </p:spPr>
+        <p:txBody>
+          <a:bodyPr wrap="square" anchor="t">
+            <a:spAutoFit/>
+          </a:bodyPr>
+          <a:lstStyle/>
+          <a:p>
+            <a:pPr algn="ctr"/>
+            <a:r>
+              <a:rPr sz="840" b="0">
+                <a:solidFill>
+                  <a:srgbClr val="0F172A"/>
+                </a:solidFill>
+                <a:latin typeface="Arial"/>
+              </a:rPr>
+              <a:t>İlgili ilanların</a:t>
+            </a:r>
+            <a:br/>
+            <a:r>
+              <a:t>ne kadarı yakalandı?</a:t>
+            </a:r>
+          </a:p>
+        </p:txBody>
+      </p:sp>
+      <p:sp>
+        <p:nvSpPr>
+          <p:cNvPr id="165" name="Rectangle 164"/>
+          <p:cNvSpPr/>
+          <p:nvPr/>
+        </p:nvSpPr>
+        <p:spPr>
+          <a:xfrm>
+            <a:off x="16577999" y="21078000"/>
+            <a:ext cx="2394000" cy="1188000"/>
+          </a:xfrm>
+          <a:prstGeom prst="rect">
+            <a:avLst/>
+          </a:prstGeom>
+          <a:solidFill>
+            <a:srgbClr val="FFFFFF"/>
+          </a:solidFill>
+          <a:ln w="10160">
+            <a:solidFill>
+              <a:srgbClr val="BFDBFE"/>
+            </a:solidFill>
+          </a:ln>
+        </p:spPr>
+        <p:style>
+          <a:lnRef idx="1">
+            <a:schemeClr val="accent1"/>
+          </a:lnRef>
+          <a:fillRef idx="3">
+            <a:schemeClr val="accent1"/>
+          </a:fillRef>
+          <a:effectRef idx="2">
+            <a:schemeClr val="accent1"/>
+          </a:effectRef>
+          <a:fontRef idx="minor">
+            <a:schemeClr val="lt1"/>
+          </a:fontRef>
+        </p:style>
+        <p:txBody>
+          <a:bodyPr rtlCol="0" anchor="ctr"/>
+          <a:lstStyle/>
+          <a:p>
+            <a:pPr algn="ctr"/>
+          </a:p>
+        </p:txBody>
+      </p:sp>
+      <p:sp>
+        <p:nvSpPr>
+          <p:cNvPr id="166" name="Rectangle 165"/>
+          <p:cNvSpPr/>
+          <p:nvPr/>
+        </p:nvSpPr>
+        <p:spPr>
+          <a:xfrm>
+            <a:off x="16577999" y="21078000"/>
+            <a:ext cx="2394000" cy="86400"/>
+          </a:xfrm>
+          <a:prstGeom prst="rect">
+            <a:avLst/>
+          </a:prstGeom>
+          <a:solidFill>
+            <a:srgbClr val="2563EB"/>
+          </a:solidFill>
+          <a:ln>
+            <a:solidFill>
+              <a:srgbClr val="2563EB"/>
+            </a:solidFill>
+          </a:ln>
+        </p:spPr>
+        <p:style>
+          <a:lnRef idx="1">
+            <a:schemeClr val="accent1"/>
+          </a:lnRef>
+          <a:fillRef idx="3">
+            <a:schemeClr val="accent1"/>
+          </a:fillRef>
+          <a:effectRef idx="2">
+            <a:schemeClr val="accent1"/>
+          </a:effectRef>
+          <a:fontRef idx="minor">
+            <a:schemeClr val="lt1"/>
+          </a:fontRef>
+        </p:style>
+        <p:txBody>
+          <a:bodyPr rtlCol="0" anchor="ctr"/>
+          <a:lstStyle/>
+          <a:p>
+            <a:pPr algn="ctr"/>
+          </a:p>
+        </p:txBody>
+      </p:sp>
+      <p:sp>
+        <p:nvSpPr>
+          <p:cNvPr id="167" name="TextBox 166"/>
+          <p:cNvSpPr txBox="1"/>
+          <p:nvPr/>
+        </p:nvSpPr>
+        <p:spPr>
+          <a:xfrm>
+            <a:off x="16704000" y="21275999"/>
+            <a:ext cx="2142000" cy="180000"/>
+          </a:xfrm>
+          <a:prstGeom prst="rect">
+            <a:avLst/>
+          </a:prstGeom>
+          <a:noFill/>
+        </p:spPr>
+        <p:txBody>
+          <a:bodyPr wrap="square" anchor="t">
+            <a:spAutoFit/>
+          </a:bodyPr>
+          <a:lstStyle/>
+          <a:p>
+            <a:pPr algn="ctr"/>
+            <a:r>
+              <a:rPr sz="1019" b="1">
+                <a:solidFill>
+                  <a:srgbClr val="1E40AF"/>
+                </a:solidFill>
+                <a:latin typeface="Arial"/>
+              </a:rPr>
+              <a:t>NDCG@5</a:t>
+            </a:r>
+          </a:p>
+        </p:txBody>
+      </p:sp>
+      <p:sp>
+        <p:nvSpPr>
+          <p:cNvPr id="168" name="TextBox 167"/>
+          <p:cNvSpPr txBox="1"/>
+          <p:nvPr/>
+        </p:nvSpPr>
+        <p:spPr>
+          <a:xfrm>
+            <a:off x="16775999" y="21564000"/>
+            <a:ext cx="1998000" cy="378000"/>
+          </a:xfrm>
+          <a:prstGeom prst="rect">
+            <a:avLst/>
+          </a:prstGeom>
+          <a:noFill/>
+        </p:spPr>
+        <p:txBody>
+          <a:bodyPr wrap="square" anchor="t">
+            <a:spAutoFit/>
+          </a:bodyPr>
+          <a:lstStyle/>
+          <a:p>
+            <a:pPr algn="ctr"/>
+            <a:r>
+              <a:rPr sz="840" b="0">
+                <a:solidFill>
+                  <a:srgbClr val="0F172A"/>
+                </a:solidFill>
+                <a:latin typeface="Arial"/>
+              </a:rPr>
+              <a:t>Doğru ilanlar</a:t>
+            </a:r>
+            <a:br/>
+            <a:r>
+              <a:t>üst sırada mı?</a:t>
+            </a:r>
+          </a:p>
+        </p:txBody>
+      </p:sp>
+      <p:sp>
+        <p:nvSpPr>
+          <p:cNvPr id="169" name="Rectangle 168"/>
+          <p:cNvSpPr/>
+          <p:nvPr/>
+        </p:nvSpPr>
+        <p:spPr>
+          <a:xfrm>
+            <a:off x="11016000" y="22698000"/>
+            <a:ext cx="9072000" cy="3240000"/>
           </a:xfrm>
           <a:prstGeom prst="rect">
             <a:avLst/>
@@ -7167,14 +10936,14 @@
       </p:sp>
       <p:sp>
         <p:nvSpPr>
-          <p:cNvPr id="79" name="Rectangle 78"/>
+          <p:cNvPr id="170" name="Rectangle 169"/>
           <p:cNvSpPr/>
           <p:nvPr/>
         </p:nvSpPr>
         <p:spPr>
           <a:xfrm>
-            <a:off x="11016000" y="21222000"/>
-            <a:ext cx="79200" cy="4716000"/>
+            <a:off x="11016000" y="22698000"/>
+            <a:ext cx="79200" cy="3240000"/>
           </a:xfrm>
           <a:prstGeom prst="rect">
             <a:avLst/>
@@ -7212,13 +10981,13 @@
       </p:sp>
       <p:sp>
         <p:nvSpPr>
-          <p:cNvPr id="80" name="Rectangle 79"/>
+          <p:cNvPr id="171" name="Rectangle 170"/>
           <p:cNvSpPr/>
           <p:nvPr/>
         </p:nvSpPr>
         <p:spPr>
           <a:xfrm>
-            <a:off x="11016000" y="21222000"/>
+            <a:off x="11016000" y="22698000"/>
             <a:ext cx="9072000" cy="424800"/>
           </a:xfrm>
           <a:prstGeom prst="rect">
@@ -7257,13 +11026,13 @@
       </p:sp>
       <p:sp>
         <p:nvSpPr>
-          <p:cNvPr id="81" name="TextBox 80"/>
+          <p:cNvPr id="172" name="TextBox 171"/>
           <p:cNvSpPr txBox="1"/>
           <p:nvPr/>
         </p:nvSpPr>
         <p:spPr>
           <a:xfrm>
-            <a:off x="11069999" y="21286800"/>
+            <a:off x="11069999" y="22762800"/>
             <a:ext cx="8964000" cy="251999"/>
           </a:xfrm>
           <a:prstGeom prst="rect">
@@ -7292,14 +11061,14 @@
       </p:sp>
       <p:sp>
         <p:nvSpPr>
-          <p:cNvPr id="82" name="TextBox 81"/>
+          <p:cNvPr id="173" name="TextBox 172"/>
           <p:cNvSpPr txBox="1"/>
           <p:nvPr/>
         </p:nvSpPr>
         <p:spPr>
           <a:xfrm>
-            <a:off x="11134799" y="21744000"/>
-            <a:ext cx="8834400" cy="4121999"/>
+            <a:off x="11134799" y="23220000"/>
+            <a:ext cx="8834400" cy="2646000"/>
           </a:xfrm>
           <a:prstGeom prst="rect">
             <a:avLst/>
@@ -7391,7 +11160,7 @@
       </p:sp>
       <p:sp>
         <p:nvSpPr>
-          <p:cNvPr id="83" name="Oval 82"/>
+          <p:cNvPr id="174" name="Oval 173"/>
           <p:cNvSpPr/>
           <p:nvPr/>
         </p:nvSpPr>
@@ -7436,7 +11205,7 @@
       </p:sp>
       <p:sp>
         <p:nvSpPr>
-          <p:cNvPr id="84" name="TextBox 83"/>
+          <p:cNvPr id="175" name="TextBox 174"/>
           <p:cNvSpPr txBox="1"/>
           <p:nvPr/>
         </p:nvSpPr>
@@ -7471,7 +11240,7 @@
       </p:sp>
       <p:sp>
         <p:nvSpPr>
-          <p:cNvPr id="85" name="TextBox 84"/>
+          <p:cNvPr id="176" name="TextBox 175"/>
           <p:cNvSpPr txBox="1"/>
           <p:nvPr/>
         </p:nvSpPr>
@@ -7506,7 +11275,7 @@
       </p:sp>
       <p:sp>
         <p:nvSpPr>
-          <p:cNvPr id="86" name="TextBox 85"/>
+          <p:cNvPr id="177" name="TextBox 176"/>
           <p:cNvSpPr txBox="1"/>
           <p:nvPr/>
         </p:nvSpPr>

</xml_diff>

<commit_message>
Add trade flow visuals to thesis poster
</commit_message>
<xml_diff>
--- a/docs/PAU_Market_Tez_Posteri.pptx
+++ b/docs/PAU_Market_Tez_Posteri.pptx
@@ -4582,7 +4582,519 @@
       </p:sp>
       <p:sp>
         <p:nvSpPr>
-          <p:cNvPr id="34" name="Rectangle 33"/>
+          <p:cNvPr id="34" name="TextBox 33"/>
+          <p:cNvSpPr txBox="1"/>
+          <p:nvPr/>
+        </p:nvSpPr>
+        <p:spPr>
+          <a:xfrm>
+            <a:off x="1745999" y="10843200"/>
+            <a:ext cx="3600000" cy="172800"/>
+          </a:xfrm>
+          <a:prstGeom prst="rect">
+            <a:avLst/>
+          </a:prstGeom>
+          <a:noFill/>
+        </p:spPr>
+        <p:txBody>
+          <a:bodyPr wrap="square" anchor="t">
+            <a:spAutoFit/>
+          </a:bodyPr>
+          <a:lstStyle/>
+          <a:p>
+            <a:pPr algn="l"/>
+            <a:r>
+              <a:rPr sz="1200" b="1">
+                <a:solidFill>
+                  <a:srgbClr val="1E40AF"/>
+                </a:solidFill>
+                <a:latin typeface="Arial"/>
+              </a:rPr>
+              <a:t>Güvenli alışveriş akışı</a:t>
+            </a:r>
+          </a:p>
+        </p:txBody>
+      </p:sp>
+      <p:sp>
+        <p:nvSpPr>
+          <p:cNvPr id="35" name="Oval 34"/>
+          <p:cNvSpPr/>
+          <p:nvPr/>
+        </p:nvSpPr>
+        <p:spPr>
+          <a:xfrm>
+            <a:off x="1745999" y="11087999"/>
+            <a:ext cx="594000" cy="594000"/>
+          </a:xfrm>
+          <a:prstGeom prst="ellipse">
+            <a:avLst/>
+          </a:prstGeom>
+          <a:solidFill>
+            <a:srgbClr val="10B981"/>
+          </a:solidFill>
+          <a:ln>
+            <a:solidFill>
+              <a:srgbClr val="10B981"/>
+            </a:solidFill>
+          </a:ln>
+        </p:spPr>
+        <p:style>
+          <a:lnRef idx="1">
+            <a:schemeClr val="accent1"/>
+          </a:lnRef>
+          <a:fillRef idx="3">
+            <a:schemeClr val="accent1"/>
+          </a:fillRef>
+          <a:effectRef idx="2">
+            <a:schemeClr val="accent1"/>
+          </a:effectRef>
+          <a:fontRef idx="minor">
+            <a:schemeClr val="lt1"/>
+          </a:fontRef>
+        </p:style>
+        <p:txBody>
+          <a:bodyPr rtlCol="0" anchor="ctr"/>
+          <a:lstStyle/>
+          <a:p>
+            <a:pPr algn="ctr"/>
+            <a:r>
+              <a:rPr sz="1300" b="1">
+                <a:solidFill>
+                  <a:srgbClr val="FFFFFF"/>
+                </a:solidFill>
+                <a:latin typeface="Arial"/>
+              </a:rPr>
+              <a:t>1</a:t>
+            </a:r>
+          </a:p>
+        </p:txBody>
+      </p:sp>
+      <p:sp>
+        <p:nvSpPr>
+          <p:cNvPr id="36" name="TextBox 35"/>
+          <p:cNvSpPr txBox="1"/>
+          <p:nvPr/>
+        </p:nvSpPr>
+        <p:spPr>
+          <a:xfrm>
+            <a:off x="1458000" y="11771999"/>
+            <a:ext cx="1170000" cy="342000"/>
+          </a:xfrm>
+          <a:prstGeom prst="rect">
+            <a:avLst/>
+          </a:prstGeom>
+          <a:noFill/>
+        </p:spPr>
+        <p:txBody>
+          <a:bodyPr wrap="square" anchor="t">
+            <a:spAutoFit/>
+          </a:bodyPr>
+          <a:lstStyle/>
+          <a:p>
+            <a:pPr algn="ctr"/>
+            <a:r>
+              <a:rPr sz="890" b="1">
+                <a:solidFill>
+                  <a:srgbClr val="0F172A"/>
+                </a:solidFill>
+                <a:latin typeface="Arial"/>
+              </a:rPr>
+              <a:t>Okul e-postası</a:t>
+            </a:r>
+            <a:br/>
+            <a:r>
+              <a:t>ile doğrula</a:t>
+            </a:r>
+          </a:p>
+        </p:txBody>
+      </p:sp>
+      <p:cxnSp>
+        <p:nvCxnSpPr>
+          <p:cNvPr id="37" name="Connector 36"/>
+          <p:cNvCxnSpPr/>
+          <p:nvPr/>
+        </p:nvCxnSpPr>
+        <p:spPr>
+          <a:xfrm>
+            <a:off x="2365200" y="11383200"/>
+            <a:ext cx="1162800" cy="0"/>
+          </a:xfrm>
+          <a:prstGeom prst="line">
+            <a:avLst/>
+          </a:prstGeom>
+          <a:ln w="21590">
+            <a:solidFill>
+              <a:srgbClr val="2563EB"/>
+            </a:solidFill>
+          </a:ln>
+        </p:spPr>
+        <p:style>
+          <a:lnRef idx="2">
+            <a:schemeClr val="accent1"/>
+          </a:lnRef>
+          <a:fillRef idx="0">
+            <a:schemeClr val="accent1"/>
+          </a:fillRef>
+          <a:effectRef idx="1">
+            <a:schemeClr val="accent1"/>
+          </a:effectRef>
+          <a:fontRef idx="minor">
+            <a:schemeClr val="tx1"/>
+          </a:fontRef>
+        </p:style>
+      </p:cxnSp>
+      <p:sp>
+        <p:nvSpPr>
+          <p:cNvPr id="38" name="Oval 37"/>
+          <p:cNvSpPr/>
+          <p:nvPr/>
+        </p:nvSpPr>
+        <p:spPr>
+          <a:xfrm>
+            <a:off x="3671999" y="11087999"/>
+            <a:ext cx="594000" cy="594000"/>
+          </a:xfrm>
+          <a:prstGeom prst="ellipse">
+            <a:avLst/>
+          </a:prstGeom>
+          <a:solidFill>
+            <a:srgbClr val="2563EB"/>
+          </a:solidFill>
+          <a:ln>
+            <a:solidFill>
+              <a:srgbClr val="2563EB"/>
+            </a:solidFill>
+          </a:ln>
+        </p:spPr>
+        <p:style>
+          <a:lnRef idx="1">
+            <a:schemeClr val="accent1"/>
+          </a:lnRef>
+          <a:fillRef idx="3">
+            <a:schemeClr val="accent1"/>
+          </a:fillRef>
+          <a:effectRef idx="2">
+            <a:schemeClr val="accent1"/>
+          </a:effectRef>
+          <a:fontRef idx="minor">
+            <a:schemeClr val="lt1"/>
+          </a:fontRef>
+        </p:style>
+        <p:txBody>
+          <a:bodyPr rtlCol="0" anchor="ctr"/>
+          <a:lstStyle/>
+          <a:p>
+            <a:pPr algn="ctr"/>
+            <a:r>
+              <a:rPr sz="1300" b="1">
+                <a:solidFill>
+                  <a:srgbClr val="FFFFFF"/>
+                </a:solidFill>
+                <a:latin typeface="Arial"/>
+              </a:rPr>
+              <a:t>2</a:t>
+            </a:r>
+          </a:p>
+        </p:txBody>
+      </p:sp>
+      <p:sp>
+        <p:nvSpPr>
+          <p:cNvPr id="39" name="TextBox 38"/>
+          <p:cNvSpPr txBox="1"/>
+          <p:nvPr/>
+        </p:nvSpPr>
+        <p:spPr>
+          <a:xfrm>
+            <a:off x="3383999" y="11771999"/>
+            <a:ext cx="1170000" cy="342000"/>
+          </a:xfrm>
+          <a:prstGeom prst="rect">
+            <a:avLst/>
+          </a:prstGeom>
+          <a:noFill/>
+        </p:spPr>
+        <p:txBody>
+          <a:bodyPr wrap="square" anchor="t">
+            <a:spAutoFit/>
+          </a:bodyPr>
+          <a:lstStyle/>
+          <a:p>
+            <a:pPr algn="ctr"/>
+            <a:r>
+              <a:rPr sz="890" b="1">
+                <a:solidFill>
+                  <a:srgbClr val="0F172A"/>
+                </a:solidFill>
+                <a:latin typeface="Arial"/>
+              </a:rPr>
+              <a:t>İlanı keşfet</a:t>
+            </a:r>
+            <a:br/>
+            <a:r>
+              <a:t>ve favorile</a:t>
+            </a:r>
+          </a:p>
+        </p:txBody>
+      </p:sp>
+      <p:cxnSp>
+        <p:nvCxnSpPr>
+          <p:cNvPr id="40" name="Connector 39"/>
+          <p:cNvCxnSpPr/>
+          <p:nvPr/>
+        </p:nvCxnSpPr>
+        <p:spPr>
+          <a:xfrm>
+            <a:off x="4291200" y="11383200"/>
+            <a:ext cx="1162799" cy="0"/>
+          </a:xfrm>
+          <a:prstGeom prst="line">
+            <a:avLst/>
+          </a:prstGeom>
+          <a:ln w="21590">
+            <a:solidFill>
+              <a:srgbClr val="2563EB"/>
+            </a:solidFill>
+          </a:ln>
+        </p:spPr>
+        <p:style>
+          <a:lnRef idx="2">
+            <a:schemeClr val="accent1"/>
+          </a:lnRef>
+          <a:fillRef idx="0">
+            <a:schemeClr val="accent1"/>
+          </a:fillRef>
+          <a:effectRef idx="1">
+            <a:schemeClr val="accent1"/>
+          </a:effectRef>
+          <a:fontRef idx="minor">
+            <a:schemeClr val="tx1"/>
+          </a:fontRef>
+        </p:style>
+      </p:cxnSp>
+      <p:sp>
+        <p:nvSpPr>
+          <p:cNvPr id="41" name="Oval 40"/>
+          <p:cNvSpPr/>
+          <p:nvPr/>
+        </p:nvSpPr>
+        <p:spPr>
+          <a:xfrm>
+            <a:off x="5598000" y="11087999"/>
+            <a:ext cx="594000" cy="594000"/>
+          </a:xfrm>
+          <a:prstGeom prst="ellipse">
+            <a:avLst/>
+          </a:prstGeom>
+          <a:solidFill>
+            <a:srgbClr val="1E40AF"/>
+          </a:solidFill>
+          <a:ln>
+            <a:solidFill>
+              <a:srgbClr val="1E40AF"/>
+            </a:solidFill>
+          </a:ln>
+        </p:spPr>
+        <p:style>
+          <a:lnRef idx="1">
+            <a:schemeClr val="accent1"/>
+          </a:lnRef>
+          <a:fillRef idx="3">
+            <a:schemeClr val="accent1"/>
+          </a:fillRef>
+          <a:effectRef idx="2">
+            <a:schemeClr val="accent1"/>
+          </a:effectRef>
+          <a:fontRef idx="minor">
+            <a:schemeClr val="lt1"/>
+          </a:fontRef>
+        </p:style>
+        <p:txBody>
+          <a:bodyPr rtlCol="0" anchor="ctr"/>
+          <a:lstStyle/>
+          <a:p>
+            <a:pPr algn="ctr"/>
+            <a:r>
+              <a:rPr sz="1300" b="1">
+                <a:solidFill>
+                  <a:srgbClr val="FFFFFF"/>
+                </a:solidFill>
+                <a:latin typeface="Arial"/>
+              </a:rPr>
+              <a:t>3</a:t>
+            </a:r>
+          </a:p>
+        </p:txBody>
+      </p:sp>
+      <p:sp>
+        <p:nvSpPr>
+          <p:cNvPr id="42" name="TextBox 41"/>
+          <p:cNvSpPr txBox="1"/>
+          <p:nvPr/>
+        </p:nvSpPr>
+        <p:spPr>
+          <a:xfrm>
+            <a:off x="5309999" y="11771999"/>
+            <a:ext cx="1170000" cy="342000"/>
+          </a:xfrm>
+          <a:prstGeom prst="rect">
+            <a:avLst/>
+          </a:prstGeom>
+          <a:noFill/>
+        </p:spPr>
+        <p:txBody>
+          <a:bodyPr wrap="square" anchor="t">
+            <a:spAutoFit/>
+          </a:bodyPr>
+          <a:lstStyle/>
+          <a:p>
+            <a:pPr algn="ctr"/>
+            <a:r>
+              <a:rPr sz="890" b="1">
+                <a:solidFill>
+                  <a:srgbClr val="0F172A"/>
+                </a:solidFill>
+                <a:latin typeface="Arial"/>
+              </a:rPr>
+              <a:t>Satıcıyla</a:t>
+            </a:r>
+            <a:br/>
+            <a:r>
+              <a:t>mesajlaş</a:t>
+            </a:r>
+          </a:p>
+        </p:txBody>
+      </p:sp>
+      <p:cxnSp>
+        <p:nvCxnSpPr>
+          <p:cNvPr id="43" name="Connector 42"/>
+          <p:cNvCxnSpPr/>
+          <p:nvPr/>
+        </p:nvCxnSpPr>
+        <p:spPr>
+          <a:xfrm>
+            <a:off x="6217200" y="11383200"/>
+            <a:ext cx="1162800" cy="0"/>
+          </a:xfrm>
+          <a:prstGeom prst="line">
+            <a:avLst/>
+          </a:prstGeom>
+          <a:ln w="21590">
+            <a:solidFill>
+              <a:srgbClr val="2563EB"/>
+            </a:solidFill>
+          </a:ln>
+        </p:spPr>
+        <p:style>
+          <a:lnRef idx="2">
+            <a:schemeClr val="accent1"/>
+          </a:lnRef>
+          <a:fillRef idx="0">
+            <a:schemeClr val="accent1"/>
+          </a:fillRef>
+          <a:effectRef idx="1">
+            <a:schemeClr val="accent1"/>
+          </a:effectRef>
+          <a:fontRef idx="minor">
+            <a:schemeClr val="tx1"/>
+          </a:fontRef>
+        </p:style>
+      </p:cxnSp>
+      <p:sp>
+        <p:nvSpPr>
+          <p:cNvPr id="44" name="Oval 43"/>
+          <p:cNvSpPr/>
+          <p:nvPr/>
+        </p:nvSpPr>
+        <p:spPr>
+          <a:xfrm>
+            <a:off x="7523999" y="11087999"/>
+            <a:ext cx="594000" cy="594000"/>
+          </a:xfrm>
+          <a:prstGeom prst="ellipse">
+            <a:avLst/>
+          </a:prstGeom>
+          <a:solidFill>
+            <a:srgbClr val="0F172A"/>
+          </a:solidFill>
+          <a:ln>
+            <a:solidFill>
+              <a:srgbClr val="0F172A"/>
+            </a:solidFill>
+          </a:ln>
+        </p:spPr>
+        <p:style>
+          <a:lnRef idx="1">
+            <a:schemeClr val="accent1"/>
+          </a:lnRef>
+          <a:fillRef idx="3">
+            <a:schemeClr val="accent1"/>
+          </a:fillRef>
+          <a:effectRef idx="2">
+            <a:schemeClr val="accent1"/>
+          </a:effectRef>
+          <a:fontRef idx="minor">
+            <a:schemeClr val="lt1"/>
+          </a:fontRef>
+        </p:style>
+        <p:txBody>
+          <a:bodyPr rtlCol="0" anchor="ctr"/>
+          <a:lstStyle/>
+          <a:p>
+            <a:pPr algn="ctr"/>
+            <a:r>
+              <a:rPr sz="1300" b="1">
+                <a:solidFill>
+                  <a:srgbClr val="FFFFFF"/>
+                </a:solidFill>
+                <a:latin typeface="Arial"/>
+              </a:rPr>
+              <a:t>4</a:t>
+            </a:r>
+          </a:p>
+        </p:txBody>
+      </p:sp>
+      <p:sp>
+        <p:nvSpPr>
+          <p:cNvPr id="45" name="TextBox 44"/>
+          <p:cNvSpPr txBox="1"/>
+          <p:nvPr/>
+        </p:nvSpPr>
+        <p:spPr>
+          <a:xfrm>
+            <a:off x="7235999" y="11771999"/>
+            <a:ext cx="1170000" cy="342000"/>
+          </a:xfrm>
+          <a:prstGeom prst="rect">
+            <a:avLst/>
+          </a:prstGeom>
+          <a:noFill/>
+        </p:spPr>
+        <p:txBody>
+          <a:bodyPr wrap="square" anchor="t">
+            <a:spAutoFit/>
+          </a:bodyPr>
+          <a:lstStyle/>
+          <a:p>
+            <a:pPr algn="ctr"/>
+            <a:r>
+              <a:rPr sz="890" b="1">
+                <a:solidFill>
+                  <a:srgbClr val="0F172A"/>
+                </a:solidFill>
+                <a:latin typeface="Arial"/>
+              </a:rPr>
+              <a:t>Kampüste</a:t>
+            </a:r>
+            <a:br/>
+            <a:r>
+              <a:t>el değiştir</a:t>
+            </a:r>
+          </a:p>
+        </p:txBody>
+      </p:sp>
+      <p:sp>
+        <p:nvSpPr>
+          <p:cNvPr id="46" name="Rectangle 45"/>
           <p:cNvSpPr/>
           <p:nvPr/>
         </p:nvSpPr>
@@ -4627,7 +5139,7 @@
       </p:sp>
       <p:sp>
         <p:nvSpPr>
-          <p:cNvPr id="35" name="Rectangle 34"/>
+          <p:cNvPr id="47" name="Rectangle 46"/>
           <p:cNvSpPr/>
           <p:nvPr/>
         </p:nvSpPr>
@@ -4672,7 +5184,7 @@
       </p:sp>
       <p:sp>
         <p:nvSpPr>
-          <p:cNvPr id="36" name="Rectangle 35"/>
+          <p:cNvPr id="48" name="Rectangle 47"/>
           <p:cNvSpPr/>
           <p:nvPr/>
         </p:nvSpPr>
@@ -4717,7 +5229,7 @@
       </p:sp>
       <p:sp>
         <p:nvSpPr>
-          <p:cNvPr id="37" name="TextBox 36"/>
+          <p:cNvPr id="49" name="TextBox 48"/>
           <p:cNvSpPr txBox="1"/>
           <p:nvPr/>
         </p:nvSpPr>
@@ -4752,7 +5264,7 @@
       </p:sp>
       <p:sp>
         <p:nvSpPr>
-          <p:cNvPr id="38" name="TextBox 37"/>
+          <p:cNvPr id="50" name="TextBox 49"/>
           <p:cNvSpPr txBox="1"/>
           <p:nvPr/>
         </p:nvSpPr>
@@ -4870,7 +5382,7 @@
       </p:sp>
       <p:sp>
         <p:nvSpPr>
-          <p:cNvPr id="39" name="Rounded Rectangle 38"/>
+          <p:cNvPr id="51" name="Rounded Rectangle 50"/>
           <p:cNvSpPr/>
           <p:nvPr/>
         </p:nvSpPr>
@@ -4928,7 +5440,7 @@
       </p:sp>
       <p:sp>
         <p:nvSpPr>
-          <p:cNvPr id="40" name="Rounded Rectangle 39"/>
+          <p:cNvPr id="52" name="Rounded Rectangle 51"/>
           <p:cNvSpPr/>
           <p:nvPr/>
         </p:nvSpPr>
@@ -4986,7 +5498,7 @@
       </p:sp>
       <p:sp>
         <p:nvSpPr>
-          <p:cNvPr id="41" name="Rounded Rectangle 40"/>
+          <p:cNvPr id="53" name="Rounded Rectangle 52"/>
           <p:cNvSpPr/>
           <p:nvPr/>
         </p:nvSpPr>
@@ -5044,7 +5556,7 @@
       </p:sp>
       <p:sp>
         <p:nvSpPr>
-          <p:cNvPr id="42" name="Rounded Rectangle 41"/>
+          <p:cNvPr id="54" name="Rounded Rectangle 53"/>
           <p:cNvSpPr/>
           <p:nvPr/>
         </p:nvSpPr>
@@ -5102,7 +5614,7 @@
       </p:sp>
       <p:cxnSp>
         <p:nvCxnSpPr>
-          <p:cNvPr id="43" name="Connector 42"/>
+          <p:cNvPr id="55" name="Connector 54"/>
           <p:cNvCxnSpPr/>
           <p:nvPr/>
         </p:nvCxnSpPr>
@@ -5137,7 +5649,7 @@
       </p:cxnSp>
       <p:cxnSp>
         <p:nvCxnSpPr>
-          <p:cNvPr id="44" name="Connector 43"/>
+          <p:cNvPr id="56" name="Connector 55"/>
           <p:cNvCxnSpPr/>
           <p:nvPr/>
         </p:nvCxnSpPr>
@@ -5172,7 +5684,7 @@
       </p:cxnSp>
       <p:cxnSp>
         <p:nvCxnSpPr>
-          <p:cNvPr id="45" name="Connector 44"/>
+          <p:cNvPr id="57" name="Connector 56"/>
           <p:cNvCxnSpPr/>
           <p:nvPr/>
         </p:nvCxnSpPr>
@@ -5207,7 +5719,7 @@
       </p:cxnSp>
       <p:sp>
         <p:nvSpPr>
-          <p:cNvPr id="46" name="TextBox 45"/>
+          <p:cNvPr id="58" name="TextBox 57"/>
           <p:cNvSpPr txBox="1"/>
           <p:nvPr/>
         </p:nvSpPr>
@@ -5242,7 +5754,7 @@
       </p:sp>
       <p:sp>
         <p:nvSpPr>
-          <p:cNvPr id="47" name="Rectangle 46"/>
+          <p:cNvPr id="59" name="Rectangle 58"/>
           <p:cNvSpPr/>
           <p:nvPr/>
         </p:nvSpPr>
@@ -5287,7 +5799,7 @@
       </p:sp>
       <p:sp>
         <p:nvSpPr>
-          <p:cNvPr id="48" name="Rectangle 47"/>
+          <p:cNvPr id="60" name="Rectangle 59"/>
           <p:cNvSpPr/>
           <p:nvPr/>
         </p:nvSpPr>
@@ -5332,7 +5844,7 @@
       </p:sp>
       <p:sp>
         <p:nvSpPr>
-          <p:cNvPr id="49" name="Rectangle 48"/>
+          <p:cNvPr id="61" name="Rectangle 60"/>
           <p:cNvSpPr/>
           <p:nvPr/>
         </p:nvSpPr>
@@ -5377,7 +5889,7 @@
       </p:sp>
       <p:sp>
         <p:nvSpPr>
-          <p:cNvPr id="50" name="TextBox 49"/>
+          <p:cNvPr id="62" name="TextBox 61"/>
           <p:cNvSpPr txBox="1"/>
           <p:nvPr/>
         </p:nvSpPr>
@@ -5412,7 +5924,7 @@
       </p:sp>
       <p:sp>
         <p:nvSpPr>
-          <p:cNvPr id="51" name="TextBox 50"/>
+          <p:cNvPr id="63" name="TextBox 62"/>
           <p:cNvSpPr txBox="1"/>
           <p:nvPr/>
         </p:nvSpPr>
@@ -5530,7 +6042,7 @@
       </p:sp>
       <p:sp>
         <p:nvSpPr>
-          <p:cNvPr id="52" name="Rectangle 51"/>
+          <p:cNvPr id="64" name="Rectangle 63"/>
           <p:cNvSpPr/>
           <p:nvPr/>
         </p:nvSpPr>
@@ -5575,7 +6087,7 @@
       </p:sp>
       <p:sp>
         <p:nvSpPr>
-          <p:cNvPr id="53" name="Rectangle 52"/>
+          <p:cNvPr id="65" name="Rectangle 64"/>
           <p:cNvSpPr/>
           <p:nvPr/>
         </p:nvSpPr>
@@ -5620,7 +6132,7 @@
       </p:sp>
       <p:sp>
         <p:nvSpPr>
-          <p:cNvPr id="54" name="TextBox 53"/>
+          <p:cNvPr id="66" name="TextBox 65"/>
           <p:cNvSpPr txBox="1"/>
           <p:nvPr/>
         </p:nvSpPr>
@@ -5655,7 +6167,7 @@
       </p:sp>
       <p:sp>
         <p:nvSpPr>
-          <p:cNvPr id="55" name="Rounded Rectangle 54"/>
+          <p:cNvPr id="67" name="Rounded Rectangle 66"/>
           <p:cNvSpPr/>
           <p:nvPr/>
         </p:nvSpPr>
@@ -5709,7 +6221,7 @@
       </p:sp>
       <p:sp>
         <p:nvSpPr>
-          <p:cNvPr id="56" name="Rectangle 55"/>
+          <p:cNvPr id="68" name="Rectangle 67"/>
           <p:cNvSpPr/>
           <p:nvPr/>
         </p:nvSpPr>
@@ -5754,7 +6266,7 @@
       </p:sp>
       <p:sp>
         <p:nvSpPr>
-          <p:cNvPr id="57" name="Rectangle 56"/>
+          <p:cNvPr id="69" name="Rectangle 68"/>
           <p:cNvSpPr/>
           <p:nvPr/>
         </p:nvSpPr>
@@ -5799,7 +6311,7 @@
       </p:sp>
       <p:sp>
         <p:nvSpPr>
-          <p:cNvPr id="58" name="TextBox 57"/>
+          <p:cNvPr id="70" name="TextBox 69"/>
           <p:cNvSpPr txBox="1"/>
           <p:nvPr/>
         </p:nvSpPr>
@@ -5834,7 +6346,7 @@
       </p:sp>
       <p:sp>
         <p:nvSpPr>
-          <p:cNvPr id="59" name="TextBox 58"/>
+          <p:cNvPr id="71" name="TextBox 70"/>
           <p:cNvSpPr txBox="1"/>
           <p:nvPr/>
         </p:nvSpPr>
@@ -5869,7 +6381,7 @@
       </p:sp>
       <p:sp>
         <p:nvSpPr>
-          <p:cNvPr id="60" name="TextBox 59"/>
+          <p:cNvPr id="72" name="TextBox 71"/>
           <p:cNvSpPr txBox="1"/>
           <p:nvPr/>
         </p:nvSpPr>
@@ -5904,7 +6416,7 @@
       </p:sp>
       <p:sp>
         <p:nvSpPr>
-          <p:cNvPr id="61" name="Rounded Rectangle 60"/>
+          <p:cNvPr id="73" name="Rounded Rectangle 72"/>
           <p:cNvSpPr/>
           <p:nvPr/>
         </p:nvSpPr>
@@ -5958,7 +6470,7 @@
       </p:sp>
       <p:sp>
         <p:nvSpPr>
-          <p:cNvPr id="62" name="TextBox 61"/>
+          <p:cNvPr id="74" name="TextBox 73"/>
           <p:cNvSpPr txBox="1"/>
           <p:nvPr/>
         </p:nvSpPr>
@@ -5993,7 +6505,7 @@
       </p:sp>
       <p:sp>
         <p:nvSpPr>
-          <p:cNvPr id="63" name="TextBox 62"/>
+          <p:cNvPr id="75" name="TextBox 74"/>
           <p:cNvSpPr txBox="1"/>
           <p:nvPr/>
         </p:nvSpPr>
@@ -6028,7 +6540,7 @@
       </p:sp>
       <p:sp>
         <p:nvSpPr>
-          <p:cNvPr id="64" name="Rectangle 63"/>
+          <p:cNvPr id="76" name="Rectangle 75"/>
           <p:cNvSpPr/>
           <p:nvPr/>
         </p:nvSpPr>
@@ -6073,7 +6585,7 @@
       </p:sp>
       <p:sp>
         <p:nvSpPr>
-          <p:cNvPr id="65" name="Rectangle 64"/>
+          <p:cNvPr id="77" name="Rectangle 76"/>
           <p:cNvSpPr/>
           <p:nvPr/>
         </p:nvSpPr>
@@ -6118,7 +6630,7 @@
       </p:sp>
       <p:sp>
         <p:nvSpPr>
-          <p:cNvPr id="66" name="TextBox 65"/>
+          <p:cNvPr id="78" name="TextBox 77"/>
           <p:cNvSpPr txBox="1"/>
           <p:nvPr/>
         </p:nvSpPr>
@@ -6153,7 +6665,7 @@
       </p:sp>
       <p:sp>
         <p:nvSpPr>
-          <p:cNvPr id="67" name="TextBox 66"/>
+          <p:cNvPr id="79" name="TextBox 78"/>
           <p:cNvSpPr txBox="1"/>
           <p:nvPr/>
         </p:nvSpPr>
@@ -6188,7 +6700,7 @@
       </p:sp>
       <p:sp>
         <p:nvSpPr>
-          <p:cNvPr id="68" name="TextBox 67"/>
+          <p:cNvPr id="80" name="TextBox 79"/>
           <p:cNvSpPr txBox="1"/>
           <p:nvPr/>
         </p:nvSpPr>
@@ -6223,7 +6735,7 @@
       </p:sp>
       <p:sp>
         <p:nvSpPr>
-          <p:cNvPr id="69" name="Rounded Rectangle 68"/>
+          <p:cNvPr id="81" name="Rounded Rectangle 80"/>
           <p:cNvSpPr/>
           <p:nvPr/>
         </p:nvSpPr>
@@ -6277,7 +6789,7 @@
       </p:sp>
       <p:sp>
         <p:nvSpPr>
-          <p:cNvPr id="70" name="TextBox 69"/>
+          <p:cNvPr id="82" name="TextBox 81"/>
           <p:cNvSpPr txBox="1"/>
           <p:nvPr/>
         </p:nvSpPr>
@@ -6312,7 +6824,7 @@
       </p:sp>
       <p:sp>
         <p:nvSpPr>
-          <p:cNvPr id="71" name="TextBox 70"/>
+          <p:cNvPr id="83" name="TextBox 82"/>
           <p:cNvSpPr txBox="1"/>
           <p:nvPr/>
         </p:nvSpPr>
@@ -6347,7 +6859,7 @@
       </p:sp>
       <p:sp>
         <p:nvSpPr>
-          <p:cNvPr id="72" name="Rectangle 71"/>
+          <p:cNvPr id="84" name="Rectangle 83"/>
           <p:cNvSpPr/>
           <p:nvPr/>
         </p:nvSpPr>
@@ -6392,7 +6904,7 @@
       </p:sp>
       <p:sp>
         <p:nvSpPr>
-          <p:cNvPr id="73" name="Rectangle 72"/>
+          <p:cNvPr id="85" name="Rectangle 84"/>
           <p:cNvSpPr/>
           <p:nvPr/>
         </p:nvSpPr>
@@ -6437,7 +6949,7 @@
       </p:sp>
       <p:sp>
         <p:nvSpPr>
-          <p:cNvPr id="74" name="TextBox 73"/>
+          <p:cNvPr id="86" name="TextBox 85"/>
           <p:cNvSpPr txBox="1"/>
           <p:nvPr/>
         </p:nvSpPr>
@@ -6472,7 +6984,7 @@
       </p:sp>
       <p:sp>
         <p:nvSpPr>
-          <p:cNvPr id="75" name="TextBox 74"/>
+          <p:cNvPr id="87" name="TextBox 86"/>
           <p:cNvSpPr txBox="1"/>
           <p:nvPr/>
         </p:nvSpPr>
@@ -6507,7 +7019,7 @@
       </p:sp>
       <p:sp>
         <p:nvSpPr>
-          <p:cNvPr id="76" name="TextBox 75"/>
+          <p:cNvPr id="88" name="TextBox 87"/>
           <p:cNvSpPr txBox="1"/>
           <p:nvPr/>
         </p:nvSpPr>
@@ -6542,7 +7054,7 @@
       </p:sp>
       <p:sp>
         <p:nvSpPr>
-          <p:cNvPr id="77" name="Rounded Rectangle 76"/>
+          <p:cNvPr id="89" name="Rounded Rectangle 88"/>
           <p:cNvSpPr/>
           <p:nvPr/>
         </p:nvSpPr>
@@ -6596,7 +7108,7 @@
       </p:sp>
       <p:sp>
         <p:nvSpPr>
-          <p:cNvPr id="78" name="TextBox 77"/>
+          <p:cNvPr id="90" name="TextBox 89"/>
           <p:cNvSpPr txBox="1"/>
           <p:nvPr/>
         </p:nvSpPr>
@@ -6631,7 +7143,7 @@
       </p:sp>
       <p:sp>
         <p:nvSpPr>
-          <p:cNvPr id="79" name="TextBox 78"/>
+          <p:cNvPr id="91" name="TextBox 90"/>
           <p:cNvSpPr txBox="1"/>
           <p:nvPr/>
         </p:nvSpPr>
@@ -6666,7 +7178,7 @@
       </p:sp>
       <p:sp>
         <p:nvSpPr>
-          <p:cNvPr id="80" name="Rectangle 79"/>
+          <p:cNvPr id="92" name="Rectangle 91"/>
           <p:cNvSpPr/>
           <p:nvPr/>
         </p:nvSpPr>
@@ -6711,7 +7223,7 @@
       </p:sp>
       <p:sp>
         <p:nvSpPr>
-          <p:cNvPr id="81" name="Rectangle 80"/>
+          <p:cNvPr id="93" name="Rectangle 92"/>
           <p:cNvSpPr/>
           <p:nvPr/>
         </p:nvSpPr>
@@ -6756,7 +7268,7 @@
       </p:sp>
       <p:sp>
         <p:nvSpPr>
-          <p:cNvPr id="82" name="Rectangle 81"/>
+          <p:cNvPr id="94" name="Rectangle 93"/>
           <p:cNvSpPr/>
           <p:nvPr/>
         </p:nvSpPr>
@@ -6801,7 +7313,7 @@
       </p:sp>
       <p:sp>
         <p:nvSpPr>
-          <p:cNvPr id="83" name="TextBox 82"/>
+          <p:cNvPr id="95" name="TextBox 94"/>
           <p:cNvSpPr txBox="1"/>
           <p:nvPr/>
         </p:nvSpPr>
@@ -6836,7 +7348,7 @@
       </p:sp>
       <p:sp>
         <p:nvSpPr>
-          <p:cNvPr id="84" name="TextBox 83"/>
+          <p:cNvPr id="96" name="TextBox 95"/>
           <p:cNvSpPr txBox="1"/>
           <p:nvPr/>
         </p:nvSpPr>
@@ -6935,7 +7447,7 @@
       </p:sp>
       <p:sp>
         <p:nvSpPr>
-          <p:cNvPr id="85" name="TextBox 84"/>
+          <p:cNvPr id="97" name="TextBox 96"/>
           <p:cNvSpPr txBox="1"/>
           <p:nvPr/>
         </p:nvSpPr>
@@ -6970,7 +7482,7 @@
       </p:sp>
       <p:sp>
         <p:nvSpPr>
-          <p:cNvPr id="86" name="Rounded Rectangle 85"/>
+          <p:cNvPr id="98" name="Rounded Rectangle 97"/>
           <p:cNvSpPr/>
           <p:nvPr/>
         </p:nvSpPr>
@@ -7024,7 +7536,7 @@
       </p:sp>
       <p:sp>
         <p:nvSpPr>
-          <p:cNvPr id="87" name="TextBox 86"/>
+          <p:cNvPr id="99" name="TextBox 98"/>
           <p:cNvSpPr txBox="1"/>
           <p:nvPr/>
         </p:nvSpPr>
@@ -7059,7 +7571,7 @@
       </p:sp>
       <p:sp>
         <p:nvSpPr>
-          <p:cNvPr id="88" name="Rounded Rectangle 87"/>
+          <p:cNvPr id="100" name="Rounded Rectangle 99"/>
           <p:cNvSpPr/>
           <p:nvPr/>
         </p:nvSpPr>
@@ -7113,7 +7625,7 @@
       </p:sp>
       <p:sp>
         <p:nvSpPr>
-          <p:cNvPr id="89" name="TextBox 88"/>
+          <p:cNvPr id="101" name="TextBox 100"/>
           <p:cNvSpPr txBox="1"/>
           <p:nvPr/>
         </p:nvSpPr>
@@ -7148,7 +7660,7 @@
       </p:sp>
       <p:sp>
         <p:nvSpPr>
-          <p:cNvPr id="90" name="Rounded Rectangle 89"/>
+          <p:cNvPr id="102" name="Rounded Rectangle 101"/>
           <p:cNvSpPr/>
           <p:nvPr/>
         </p:nvSpPr>
@@ -7202,7 +7714,7 @@
       </p:sp>
       <p:sp>
         <p:nvSpPr>
-          <p:cNvPr id="91" name="TextBox 90"/>
+          <p:cNvPr id="103" name="TextBox 102"/>
           <p:cNvSpPr txBox="1"/>
           <p:nvPr/>
         </p:nvSpPr>
@@ -7237,7 +7749,7 @@
       </p:sp>
       <p:sp>
         <p:nvSpPr>
-          <p:cNvPr id="92" name="Rounded Rectangle 91"/>
+          <p:cNvPr id="104" name="Rounded Rectangle 103"/>
           <p:cNvSpPr/>
           <p:nvPr/>
         </p:nvSpPr>
@@ -7291,7 +7803,7 @@
       </p:sp>
       <p:sp>
         <p:nvSpPr>
-          <p:cNvPr id="93" name="TextBox 92"/>
+          <p:cNvPr id="105" name="TextBox 104"/>
           <p:cNvSpPr txBox="1"/>
           <p:nvPr/>
         </p:nvSpPr>
@@ -7326,7 +7838,7 @@
       </p:sp>
       <p:sp>
         <p:nvSpPr>
-          <p:cNvPr id="94" name="Rounded Rectangle 93"/>
+          <p:cNvPr id="106" name="Rounded Rectangle 105"/>
           <p:cNvSpPr/>
           <p:nvPr/>
         </p:nvSpPr>
@@ -7380,7 +7892,7 @@
       </p:sp>
       <p:sp>
         <p:nvSpPr>
-          <p:cNvPr id="95" name="TextBox 94"/>
+          <p:cNvPr id="107" name="TextBox 106"/>
           <p:cNvSpPr txBox="1"/>
           <p:nvPr/>
         </p:nvSpPr>
@@ -7415,7 +7927,7 @@
       </p:sp>
       <p:cxnSp>
         <p:nvCxnSpPr>
-          <p:cNvPr id="96" name="Connector 95"/>
+          <p:cNvPr id="108" name="Connector 107"/>
           <p:cNvCxnSpPr/>
           <p:nvPr/>
         </p:nvCxnSpPr>
@@ -7450,7 +7962,7 @@
       </p:cxnSp>
       <p:sp>
         <p:nvSpPr>
-          <p:cNvPr id="97" name="TextBox 96"/>
+          <p:cNvPr id="109" name="TextBox 108"/>
           <p:cNvSpPr txBox="1"/>
           <p:nvPr/>
         </p:nvSpPr>
@@ -7485,7 +7997,7 @@
       </p:sp>
       <p:sp>
         <p:nvSpPr>
-          <p:cNvPr id="98" name="TextBox 97"/>
+          <p:cNvPr id="110" name="TextBox 109"/>
           <p:cNvSpPr txBox="1"/>
           <p:nvPr/>
         </p:nvSpPr>
@@ -7520,7 +8032,7 @@
       </p:sp>
       <p:sp>
         <p:nvSpPr>
-          <p:cNvPr id="99" name="Rectangle 98"/>
+          <p:cNvPr id="111" name="Rectangle 110"/>
           <p:cNvSpPr/>
           <p:nvPr/>
         </p:nvSpPr>
@@ -7565,7 +8077,7 @@
       </p:sp>
       <p:sp>
         <p:nvSpPr>
-          <p:cNvPr id="100" name="TextBox 99"/>
+          <p:cNvPr id="112" name="TextBox 111"/>
           <p:cNvSpPr txBox="1"/>
           <p:nvPr/>
         </p:nvSpPr>
@@ -7600,7 +8112,7 @@
       </p:sp>
       <p:sp>
         <p:nvSpPr>
-          <p:cNvPr id="101" name="TextBox 100"/>
+          <p:cNvPr id="113" name="TextBox 112"/>
           <p:cNvSpPr txBox="1"/>
           <p:nvPr/>
         </p:nvSpPr>
@@ -7635,7 +8147,7 @@
       </p:sp>
       <p:sp>
         <p:nvSpPr>
-          <p:cNvPr id="102" name="TextBox 101"/>
+          <p:cNvPr id="114" name="TextBox 113"/>
           <p:cNvSpPr txBox="1"/>
           <p:nvPr/>
         </p:nvSpPr>
@@ -7670,7 +8182,7 @@
       </p:sp>
       <p:sp>
         <p:nvSpPr>
-          <p:cNvPr id="103" name="TextBox 102"/>
+          <p:cNvPr id="115" name="TextBox 114"/>
           <p:cNvSpPr txBox="1"/>
           <p:nvPr/>
         </p:nvSpPr>
@@ -7705,7 +8217,7 @@
       </p:sp>
       <p:sp>
         <p:nvSpPr>
-          <p:cNvPr id="104" name="TextBox 103"/>
+          <p:cNvPr id="116" name="TextBox 115"/>
           <p:cNvSpPr txBox="1"/>
           <p:nvPr/>
         </p:nvSpPr>
@@ -7740,7 +8252,7 @@
       </p:sp>
       <p:sp>
         <p:nvSpPr>
-          <p:cNvPr id="105" name="TextBox 104"/>
+          <p:cNvPr id="117" name="TextBox 116"/>
           <p:cNvSpPr txBox="1"/>
           <p:nvPr/>
         </p:nvSpPr>
@@ -7775,7 +8287,7 @@
       </p:sp>
       <p:sp>
         <p:nvSpPr>
-          <p:cNvPr id="106" name="TextBox 105"/>
+          <p:cNvPr id="118" name="TextBox 117"/>
           <p:cNvSpPr txBox="1"/>
           <p:nvPr/>
         </p:nvSpPr>
@@ -7810,7 +8322,7 @@
       </p:sp>
       <p:sp>
         <p:nvSpPr>
-          <p:cNvPr id="107" name="Rectangle 106"/>
+          <p:cNvPr id="119" name="Rectangle 118"/>
           <p:cNvSpPr/>
           <p:nvPr/>
         </p:nvSpPr>
@@ -7855,7 +8367,7 @@
       </p:sp>
       <p:sp>
         <p:nvSpPr>
-          <p:cNvPr id="108" name="Rectangle 107"/>
+          <p:cNvPr id="120" name="Rectangle 119"/>
           <p:cNvSpPr/>
           <p:nvPr/>
         </p:nvSpPr>
@@ -7900,7 +8412,7 @@
       </p:sp>
       <p:sp>
         <p:nvSpPr>
-          <p:cNvPr id="109" name="Rectangle 108"/>
+          <p:cNvPr id="121" name="Rectangle 120"/>
           <p:cNvSpPr/>
           <p:nvPr/>
         </p:nvSpPr>
@@ -7945,7 +8457,7 @@
       </p:sp>
       <p:sp>
         <p:nvSpPr>
-          <p:cNvPr id="110" name="Rectangle 109"/>
+          <p:cNvPr id="122" name="Rectangle 121"/>
           <p:cNvSpPr/>
           <p:nvPr/>
         </p:nvSpPr>
@@ -7990,7 +8502,7 @@
       </p:sp>
       <p:sp>
         <p:nvSpPr>
-          <p:cNvPr id="111" name="Rectangle 110"/>
+          <p:cNvPr id="123" name="Rectangle 122"/>
           <p:cNvSpPr/>
           <p:nvPr/>
         </p:nvSpPr>
@@ -8035,7 +8547,7 @@
       </p:sp>
       <p:sp>
         <p:nvSpPr>
-          <p:cNvPr id="112" name="TextBox 111"/>
+          <p:cNvPr id="124" name="TextBox 123"/>
           <p:cNvSpPr txBox="1"/>
           <p:nvPr/>
         </p:nvSpPr>
@@ -8070,7 +8582,7 @@
       </p:sp>
       <p:sp>
         <p:nvSpPr>
-          <p:cNvPr id="113" name="Rectangle 112"/>
+          <p:cNvPr id="125" name="Rectangle 124"/>
           <p:cNvSpPr/>
           <p:nvPr/>
         </p:nvSpPr>
@@ -8115,7 +8627,7 @@
       </p:sp>
       <p:sp>
         <p:nvSpPr>
-          <p:cNvPr id="114" name="Rectangle 113"/>
+          <p:cNvPr id="126" name="Rectangle 125"/>
           <p:cNvSpPr/>
           <p:nvPr/>
         </p:nvSpPr>
@@ -8160,7 +8672,7 @@
       </p:sp>
       <p:sp>
         <p:nvSpPr>
-          <p:cNvPr id="115" name="Rectangle 114"/>
+          <p:cNvPr id="127" name="Rectangle 126"/>
           <p:cNvSpPr/>
           <p:nvPr/>
         </p:nvSpPr>
@@ -8205,7 +8717,7 @@
       </p:sp>
       <p:sp>
         <p:nvSpPr>
-          <p:cNvPr id="116" name="Rectangle 115"/>
+          <p:cNvPr id="128" name="Rectangle 127"/>
           <p:cNvSpPr/>
           <p:nvPr/>
         </p:nvSpPr>
@@ -8250,7 +8762,7 @@
       </p:sp>
       <p:sp>
         <p:nvSpPr>
-          <p:cNvPr id="117" name="Rectangle 116"/>
+          <p:cNvPr id="129" name="Rectangle 128"/>
           <p:cNvSpPr/>
           <p:nvPr/>
         </p:nvSpPr>
@@ -8295,7 +8807,7 @@
       </p:sp>
       <p:sp>
         <p:nvSpPr>
-          <p:cNvPr id="118" name="TextBox 117"/>
+          <p:cNvPr id="130" name="TextBox 129"/>
           <p:cNvSpPr txBox="1"/>
           <p:nvPr/>
         </p:nvSpPr>
@@ -8330,7 +8842,7 @@
       </p:sp>
       <p:sp>
         <p:nvSpPr>
-          <p:cNvPr id="119" name="Rectangle 118"/>
+          <p:cNvPr id="131" name="Rectangle 130"/>
           <p:cNvSpPr/>
           <p:nvPr/>
         </p:nvSpPr>
@@ -8375,7 +8887,7 @@
       </p:sp>
       <p:sp>
         <p:nvSpPr>
-          <p:cNvPr id="120" name="Rectangle 119"/>
+          <p:cNvPr id="132" name="Rectangle 131"/>
           <p:cNvSpPr/>
           <p:nvPr/>
         </p:nvSpPr>
@@ -8420,7 +8932,7 @@
       </p:sp>
       <p:sp>
         <p:nvSpPr>
-          <p:cNvPr id="121" name="Rectangle 120"/>
+          <p:cNvPr id="133" name="Rectangle 132"/>
           <p:cNvSpPr/>
           <p:nvPr/>
         </p:nvSpPr>
@@ -8465,7 +8977,7 @@
       </p:sp>
       <p:sp>
         <p:nvSpPr>
-          <p:cNvPr id="122" name="Rectangle 121"/>
+          <p:cNvPr id="134" name="Rectangle 133"/>
           <p:cNvSpPr/>
           <p:nvPr/>
         </p:nvSpPr>
@@ -8510,7 +9022,7 @@
       </p:sp>
       <p:sp>
         <p:nvSpPr>
-          <p:cNvPr id="123" name="Rectangle 122"/>
+          <p:cNvPr id="135" name="Rectangle 134"/>
           <p:cNvSpPr/>
           <p:nvPr/>
         </p:nvSpPr>
@@ -8555,7 +9067,7 @@
       </p:sp>
       <p:sp>
         <p:nvSpPr>
-          <p:cNvPr id="124" name="TextBox 123"/>
+          <p:cNvPr id="136" name="TextBox 135"/>
           <p:cNvSpPr txBox="1"/>
           <p:nvPr/>
         </p:nvSpPr>
@@ -8590,7 +9102,7 @@
       </p:sp>
       <p:sp>
         <p:nvSpPr>
-          <p:cNvPr id="125" name="Rectangle 124"/>
+          <p:cNvPr id="137" name="Rectangle 136"/>
           <p:cNvSpPr/>
           <p:nvPr/>
         </p:nvSpPr>
@@ -8635,7 +9147,7 @@
       </p:sp>
       <p:sp>
         <p:nvSpPr>
-          <p:cNvPr id="126" name="Rectangle 125"/>
+          <p:cNvPr id="138" name="Rectangle 137"/>
           <p:cNvSpPr/>
           <p:nvPr/>
         </p:nvSpPr>
@@ -8680,7 +9192,7 @@
       </p:sp>
       <p:sp>
         <p:nvSpPr>
-          <p:cNvPr id="127" name="Rectangle 126"/>
+          <p:cNvPr id="139" name="Rectangle 138"/>
           <p:cNvSpPr/>
           <p:nvPr/>
         </p:nvSpPr>
@@ -8725,7 +9237,7 @@
       </p:sp>
       <p:sp>
         <p:nvSpPr>
-          <p:cNvPr id="128" name="Rectangle 127"/>
+          <p:cNvPr id="140" name="Rectangle 139"/>
           <p:cNvSpPr/>
           <p:nvPr/>
         </p:nvSpPr>
@@ -8770,7 +9282,7 @@
       </p:sp>
       <p:sp>
         <p:nvSpPr>
-          <p:cNvPr id="129" name="Rectangle 128"/>
+          <p:cNvPr id="141" name="Rectangle 140"/>
           <p:cNvSpPr/>
           <p:nvPr/>
         </p:nvSpPr>
@@ -8815,7 +9327,7 @@
       </p:sp>
       <p:sp>
         <p:nvSpPr>
-          <p:cNvPr id="130" name="TextBox 129"/>
+          <p:cNvPr id="142" name="TextBox 141"/>
           <p:cNvSpPr txBox="1"/>
           <p:nvPr/>
         </p:nvSpPr>
@@ -8850,7 +9362,7 @@
       </p:sp>
       <p:sp>
         <p:nvSpPr>
-          <p:cNvPr id="131" name="Rectangle 130"/>
+          <p:cNvPr id="143" name="Rectangle 142"/>
           <p:cNvSpPr/>
           <p:nvPr/>
         </p:nvSpPr>
@@ -8895,7 +9407,7 @@
       </p:sp>
       <p:sp>
         <p:nvSpPr>
-          <p:cNvPr id="132" name="Rectangle 131"/>
+          <p:cNvPr id="144" name="Rectangle 143"/>
           <p:cNvSpPr/>
           <p:nvPr/>
         </p:nvSpPr>
@@ -8940,7 +9452,7 @@
       </p:sp>
       <p:sp>
         <p:nvSpPr>
-          <p:cNvPr id="133" name="Rectangle 132"/>
+          <p:cNvPr id="145" name="Rectangle 144"/>
           <p:cNvSpPr/>
           <p:nvPr/>
         </p:nvSpPr>
@@ -8985,7 +9497,7 @@
       </p:sp>
       <p:sp>
         <p:nvSpPr>
-          <p:cNvPr id="134" name="TextBox 133"/>
+          <p:cNvPr id="146" name="TextBox 145"/>
           <p:cNvSpPr txBox="1"/>
           <p:nvPr/>
         </p:nvSpPr>
@@ -9020,7 +9532,7 @@
       </p:sp>
       <p:sp>
         <p:nvSpPr>
-          <p:cNvPr id="135" name="TextBox 134"/>
+          <p:cNvPr id="147" name="TextBox 146"/>
           <p:cNvSpPr txBox="1"/>
           <p:nvPr/>
         </p:nvSpPr>
@@ -9119,7 +9631,7 @@
       </p:sp>
       <p:sp>
         <p:nvSpPr>
-          <p:cNvPr id="136" name="Rectangle 135"/>
+          <p:cNvPr id="148" name="Rectangle 147"/>
           <p:cNvSpPr/>
           <p:nvPr/>
         </p:nvSpPr>
@@ -9164,7 +9676,7 @@
       </p:sp>
       <p:sp>
         <p:nvSpPr>
-          <p:cNvPr id="137" name="TextBox 136"/>
+          <p:cNvPr id="149" name="TextBox 148"/>
           <p:cNvSpPr txBox="1"/>
           <p:nvPr/>
         </p:nvSpPr>
@@ -9199,7 +9711,7 @@
       </p:sp>
       <p:sp>
         <p:nvSpPr>
-          <p:cNvPr id="138" name="TextBox 137"/>
+          <p:cNvPr id="150" name="TextBox 149"/>
           <p:cNvSpPr txBox="1"/>
           <p:nvPr/>
         </p:nvSpPr>
@@ -9234,7 +9746,7 @@
       </p:sp>
       <p:sp>
         <p:nvSpPr>
-          <p:cNvPr id="139" name="Rectangle 138"/>
+          <p:cNvPr id="151" name="Rectangle 150"/>
           <p:cNvSpPr/>
           <p:nvPr/>
         </p:nvSpPr>
@@ -9279,7 +9791,7 @@
       </p:sp>
       <p:sp>
         <p:nvSpPr>
-          <p:cNvPr id="140" name="Rectangle 139"/>
+          <p:cNvPr id="152" name="Rectangle 151"/>
           <p:cNvSpPr/>
           <p:nvPr/>
         </p:nvSpPr>
@@ -9324,7 +9836,7 @@
       </p:sp>
       <p:sp>
         <p:nvSpPr>
-          <p:cNvPr id="141" name="TextBox 140"/>
+          <p:cNvPr id="153" name="TextBox 152"/>
           <p:cNvSpPr txBox="1"/>
           <p:nvPr/>
         </p:nvSpPr>
@@ -9359,7 +9871,7 @@
       </p:sp>
       <p:sp>
         <p:nvSpPr>
-          <p:cNvPr id="142" name="TextBox 141"/>
+          <p:cNvPr id="154" name="TextBox 153"/>
           <p:cNvSpPr txBox="1"/>
           <p:nvPr/>
         </p:nvSpPr>
@@ -9394,7 +9906,7 @@
       </p:sp>
       <p:sp>
         <p:nvSpPr>
-          <p:cNvPr id="143" name="Rectangle 142"/>
+          <p:cNvPr id="155" name="Rectangle 154"/>
           <p:cNvSpPr/>
           <p:nvPr/>
         </p:nvSpPr>
@@ -9439,7 +9951,7 @@
       </p:sp>
       <p:sp>
         <p:nvSpPr>
-          <p:cNvPr id="144" name="Rectangle 143"/>
+          <p:cNvPr id="156" name="Rectangle 155"/>
           <p:cNvSpPr/>
           <p:nvPr/>
         </p:nvSpPr>
@@ -9484,7 +9996,7 @@
       </p:sp>
       <p:sp>
         <p:nvSpPr>
-          <p:cNvPr id="145" name="TextBox 144"/>
+          <p:cNvPr id="157" name="TextBox 156"/>
           <p:cNvSpPr txBox="1"/>
           <p:nvPr/>
         </p:nvSpPr>
@@ -9519,7 +10031,7 @@
       </p:sp>
       <p:sp>
         <p:nvSpPr>
-          <p:cNvPr id="146" name="TextBox 145"/>
+          <p:cNvPr id="158" name="TextBox 157"/>
           <p:cNvSpPr txBox="1"/>
           <p:nvPr/>
         </p:nvSpPr>
@@ -9554,7 +10066,7 @@
       </p:sp>
       <p:sp>
         <p:nvSpPr>
-          <p:cNvPr id="147" name="Rectangle 146"/>
+          <p:cNvPr id="159" name="Rectangle 158"/>
           <p:cNvSpPr/>
           <p:nvPr/>
         </p:nvSpPr>
@@ -9599,7 +10111,7 @@
       </p:sp>
       <p:sp>
         <p:nvSpPr>
-          <p:cNvPr id="148" name="Rectangle 147"/>
+          <p:cNvPr id="160" name="Rectangle 159"/>
           <p:cNvSpPr/>
           <p:nvPr/>
         </p:nvSpPr>
@@ -9644,7 +10156,7 @@
       </p:sp>
       <p:sp>
         <p:nvSpPr>
-          <p:cNvPr id="149" name="TextBox 148"/>
+          <p:cNvPr id="161" name="TextBox 160"/>
           <p:cNvSpPr txBox="1"/>
           <p:nvPr/>
         </p:nvSpPr>
@@ -9679,7 +10191,7 @@
       </p:sp>
       <p:sp>
         <p:nvSpPr>
-          <p:cNvPr id="150" name="TextBox 149"/>
+          <p:cNvPr id="162" name="TextBox 161"/>
           <p:cNvSpPr txBox="1"/>
           <p:nvPr/>
         </p:nvSpPr>
@@ -9714,7 +10226,7 @@
       </p:sp>
       <p:sp>
         <p:nvSpPr>
-          <p:cNvPr id="151" name="Rectangle 150"/>
+          <p:cNvPr id="163" name="Rectangle 162"/>
           <p:cNvSpPr/>
           <p:nvPr/>
         </p:nvSpPr>
@@ -9759,7 +10271,7 @@
       </p:sp>
       <p:sp>
         <p:nvSpPr>
-          <p:cNvPr id="152" name="Rectangle 151"/>
+          <p:cNvPr id="164" name="Rectangle 163"/>
           <p:cNvSpPr/>
           <p:nvPr/>
         </p:nvSpPr>
@@ -9804,7 +10316,7 @@
       </p:sp>
       <p:sp>
         <p:nvSpPr>
-          <p:cNvPr id="153" name="Rectangle 152"/>
+          <p:cNvPr id="165" name="Rectangle 164"/>
           <p:cNvSpPr/>
           <p:nvPr/>
         </p:nvSpPr>
@@ -9849,7 +10361,7 @@
       </p:sp>
       <p:sp>
         <p:nvSpPr>
-          <p:cNvPr id="154" name="TextBox 153"/>
+          <p:cNvPr id="166" name="TextBox 165"/>
           <p:cNvSpPr txBox="1"/>
           <p:nvPr/>
         </p:nvSpPr>
@@ -9884,7 +10396,7 @@
       </p:sp>
       <p:sp>
         <p:nvSpPr>
-          <p:cNvPr id="155" name="TextBox 154"/>
+          <p:cNvPr id="167" name="TextBox 166"/>
           <p:cNvSpPr txBox="1"/>
           <p:nvPr/>
         </p:nvSpPr>
@@ -9964,7 +10476,7 @@
       </p:sp>
       <p:graphicFrame>
         <p:nvGraphicFramePr>
-          <p:cNvPr id="156" name="Table 155"/>
+          <p:cNvPr id="168" name="Table 167"/>
           <p:cNvGraphicFramePr>
             <a:graphicFrameLocks noGrp="1"/>
           </p:cNvGraphicFramePr>
@@ -10399,7 +10911,7 @@
       </p:graphicFrame>
       <p:sp>
         <p:nvSpPr>
-          <p:cNvPr id="157" name="Rectangle 156"/>
+          <p:cNvPr id="169" name="Rectangle 168"/>
           <p:cNvSpPr/>
           <p:nvPr/>
         </p:nvSpPr>
@@ -10444,7 +10956,7 @@
       </p:sp>
       <p:sp>
         <p:nvSpPr>
-          <p:cNvPr id="158" name="Rectangle 157"/>
+          <p:cNvPr id="170" name="Rectangle 169"/>
           <p:cNvSpPr/>
           <p:nvPr/>
         </p:nvSpPr>
@@ -10489,7 +11001,7 @@
       </p:sp>
       <p:sp>
         <p:nvSpPr>
-          <p:cNvPr id="159" name="TextBox 158"/>
+          <p:cNvPr id="171" name="TextBox 170"/>
           <p:cNvSpPr txBox="1"/>
           <p:nvPr/>
         </p:nvSpPr>
@@ -10524,7 +11036,7 @@
       </p:sp>
       <p:sp>
         <p:nvSpPr>
-          <p:cNvPr id="160" name="TextBox 159"/>
+          <p:cNvPr id="172" name="TextBox 171"/>
           <p:cNvSpPr txBox="1"/>
           <p:nvPr/>
         </p:nvSpPr>
@@ -10563,7 +11075,7 @@
       </p:sp>
       <p:sp>
         <p:nvSpPr>
-          <p:cNvPr id="161" name="Rectangle 160"/>
+          <p:cNvPr id="173" name="Rectangle 172"/>
           <p:cNvSpPr/>
           <p:nvPr/>
         </p:nvSpPr>
@@ -10608,7 +11120,7 @@
       </p:sp>
       <p:sp>
         <p:nvSpPr>
-          <p:cNvPr id="162" name="Rectangle 161"/>
+          <p:cNvPr id="174" name="Rectangle 173"/>
           <p:cNvSpPr/>
           <p:nvPr/>
         </p:nvSpPr>
@@ -10653,7 +11165,7 @@
       </p:sp>
       <p:sp>
         <p:nvSpPr>
-          <p:cNvPr id="163" name="TextBox 162"/>
+          <p:cNvPr id="175" name="TextBox 174"/>
           <p:cNvSpPr txBox="1"/>
           <p:nvPr/>
         </p:nvSpPr>
@@ -10688,7 +11200,7 @@
       </p:sp>
       <p:sp>
         <p:nvSpPr>
-          <p:cNvPr id="164" name="TextBox 163"/>
+          <p:cNvPr id="176" name="TextBox 175"/>
           <p:cNvSpPr txBox="1"/>
           <p:nvPr/>
         </p:nvSpPr>
@@ -10727,7 +11239,7 @@
       </p:sp>
       <p:sp>
         <p:nvSpPr>
-          <p:cNvPr id="165" name="Rectangle 164"/>
+          <p:cNvPr id="177" name="Rectangle 176"/>
           <p:cNvSpPr/>
           <p:nvPr/>
         </p:nvSpPr>
@@ -10772,7 +11284,7 @@
       </p:sp>
       <p:sp>
         <p:nvSpPr>
-          <p:cNvPr id="166" name="Rectangle 165"/>
+          <p:cNvPr id="178" name="Rectangle 177"/>
           <p:cNvSpPr/>
           <p:nvPr/>
         </p:nvSpPr>
@@ -10817,7 +11329,7 @@
       </p:sp>
       <p:sp>
         <p:nvSpPr>
-          <p:cNvPr id="167" name="TextBox 166"/>
+          <p:cNvPr id="179" name="TextBox 178"/>
           <p:cNvSpPr txBox="1"/>
           <p:nvPr/>
         </p:nvSpPr>
@@ -10852,7 +11364,7 @@
       </p:sp>
       <p:sp>
         <p:nvSpPr>
-          <p:cNvPr id="168" name="TextBox 167"/>
+          <p:cNvPr id="180" name="TextBox 179"/>
           <p:cNvSpPr txBox="1"/>
           <p:nvPr/>
         </p:nvSpPr>
@@ -10891,7 +11403,7 @@
       </p:sp>
       <p:sp>
         <p:nvSpPr>
-          <p:cNvPr id="169" name="Rectangle 168"/>
+          <p:cNvPr id="181" name="Rectangle 180"/>
           <p:cNvSpPr/>
           <p:nvPr/>
         </p:nvSpPr>
@@ -10936,7 +11448,7 @@
       </p:sp>
       <p:sp>
         <p:nvSpPr>
-          <p:cNvPr id="170" name="Rectangle 169"/>
+          <p:cNvPr id="182" name="Rectangle 181"/>
           <p:cNvSpPr/>
           <p:nvPr/>
         </p:nvSpPr>
@@ -10981,7 +11493,7 @@
       </p:sp>
       <p:sp>
         <p:nvSpPr>
-          <p:cNvPr id="171" name="Rectangle 170"/>
+          <p:cNvPr id="183" name="Rectangle 182"/>
           <p:cNvSpPr/>
           <p:nvPr/>
         </p:nvSpPr>
@@ -11026,7 +11538,7 @@
       </p:sp>
       <p:sp>
         <p:nvSpPr>
-          <p:cNvPr id="172" name="TextBox 171"/>
+          <p:cNvPr id="184" name="TextBox 183"/>
           <p:cNvSpPr txBox="1"/>
           <p:nvPr/>
         </p:nvSpPr>
@@ -11061,7 +11573,7 @@
       </p:sp>
       <p:sp>
         <p:nvSpPr>
-          <p:cNvPr id="173" name="TextBox 172"/>
+          <p:cNvPr id="185" name="TextBox 184"/>
           <p:cNvSpPr txBox="1"/>
           <p:nvPr/>
         </p:nvSpPr>
@@ -11160,7 +11672,488 @@
       </p:sp>
       <p:sp>
         <p:nvSpPr>
-          <p:cNvPr id="174" name="Oval 173"/>
+          <p:cNvPr id="186" name="Rectangle 185"/>
+          <p:cNvSpPr/>
+          <p:nvPr/>
+        </p:nvSpPr>
+        <p:spPr>
+          <a:xfrm>
+            <a:off x="11214000" y="26118000"/>
+            <a:ext cx="8676000" cy="1098000"/>
+          </a:xfrm>
+          <a:prstGeom prst="rect">
+            <a:avLst/>
+          </a:prstGeom>
+          <a:solidFill>
+            <a:srgbClr val="FFFFFF"/>
+          </a:solidFill>
+          <a:ln w="8890">
+            <a:solidFill>
+              <a:srgbClr val="BFDBFE"/>
+            </a:solidFill>
+          </a:ln>
+        </p:spPr>
+        <p:style>
+          <a:lnRef idx="1">
+            <a:schemeClr val="accent1"/>
+          </a:lnRef>
+          <a:fillRef idx="3">
+            <a:schemeClr val="accent1"/>
+          </a:fillRef>
+          <a:effectRef idx="2">
+            <a:schemeClr val="accent1"/>
+          </a:effectRef>
+          <a:fontRef idx="minor">
+            <a:schemeClr val="lt1"/>
+          </a:fontRef>
+        </p:style>
+        <p:txBody>
+          <a:bodyPr rtlCol="0" anchor="ctr"/>
+          <a:lstStyle/>
+          <a:p>
+            <a:pPr algn="ctr"/>
+          </a:p>
+        </p:txBody>
+      </p:sp>
+      <p:sp>
+        <p:nvSpPr>
+          <p:cNvPr id="187" name="Rectangle 186"/>
+          <p:cNvSpPr/>
+          <p:nvPr/>
+        </p:nvSpPr>
+        <p:spPr>
+          <a:xfrm>
+            <a:off x="11214000" y="26118000"/>
+            <a:ext cx="90000" cy="1098000"/>
+          </a:xfrm>
+          <a:prstGeom prst="rect">
+            <a:avLst/>
+          </a:prstGeom>
+          <a:solidFill>
+            <a:srgbClr val="10B981"/>
+          </a:solidFill>
+          <a:ln>
+            <a:solidFill>
+              <a:srgbClr val="10B981"/>
+            </a:solidFill>
+          </a:ln>
+        </p:spPr>
+        <p:style>
+          <a:lnRef idx="1">
+            <a:schemeClr val="accent1"/>
+          </a:lnRef>
+          <a:fillRef idx="3">
+            <a:schemeClr val="accent1"/>
+          </a:fillRef>
+          <a:effectRef idx="2">
+            <a:schemeClr val="accent1"/>
+          </a:effectRef>
+          <a:fontRef idx="minor">
+            <a:schemeClr val="lt1"/>
+          </a:fontRef>
+        </p:style>
+        <p:txBody>
+          <a:bodyPr rtlCol="0" anchor="ctr"/>
+          <a:lstStyle/>
+          <a:p>
+            <a:pPr algn="ctr"/>
+          </a:p>
+        </p:txBody>
+      </p:sp>
+      <p:sp>
+        <p:nvSpPr>
+          <p:cNvPr id="188" name="TextBox 187"/>
+          <p:cNvSpPr txBox="1"/>
+          <p:nvPr/>
+        </p:nvSpPr>
+        <p:spPr>
+          <a:xfrm>
+            <a:off x="11412000" y="26243999"/>
+            <a:ext cx="1800000" cy="172800"/>
+          </a:xfrm>
+          <a:prstGeom prst="rect">
+            <a:avLst/>
+          </a:prstGeom>
+          <a:noFill/>
+        </p:spPr>
+        <p:txBody>
+          <a:bodyPr wrap="square" anchor="t">
+            <a:spAutoFit/>
+          </a:bodyPr>
+          <a:lstStyle/>
+          <a:p>
+            <a:pPr algn="l"/>
+            <a:r>
+              <a:rPr sz="1080" b="1">
+                <a:solidFill>
+                  <a:srgbClr val="1E40AF"/>
+                </a:solidFill>
+                <a:latin typeface="Arial"/>
+              </a:rPr>
+              <a:t>Cold-start kalkanı</a:t>
+            </a:r>
+          </a:p>
+        </p:txBody>
+      </p:sp>
+      <p:sp>
+        <p:nvSpPr>
+          <p:cNvPr id="189" name="Rounded Rectangle 188"/>
+          <p:cNvSpPr/>
+          <p:nvPr/>
+        </p:nvSpPr>
+        <p:spPr>
+          <a:xfrm>
+            <a:off x="13374000" y="26423999"/>
+            <a:ext cx="1170000" cy="342000"/>
+          </a:xfrm>
+          <a:prstGeom prst="roundRect">
+            <a:avLst/>
+          </a:prstGeom>
+          <a:solidFill>
+            <a:srgbClr val="2563EB"/>
+          </a:solidFill>
+          <a:ln w="10160">
+            <a:solidFill>
+              <a:srgbClr val="2563EB"/>
+            </a:solidFill>
+          </a:ln>
+        </p:spPr>
+        <p:style>
+          <a:lnRef idx="1">
+            <a:schemeClr val="accent1"/>
+          </a:lnRef>
+          <a:fillRef idx="3">
+            <a:schemeClr val="accent1"/>
+          </a:fillRef>
+          <a:effectRef idx="2">
+            <a:schemeClr val="accent1"/>
+          </a:effectRef>
+          <a:fontRef idx="minor">
+            <a:schemeClr val="lt1"/>
+          </a:fontRef>
+        </p:style>
+        <p:txBody>
+          <a:bodyPr rtlCol="0" anchor="ctr"/>
+          <a:lstStyle/>
+          <a:p>
+            <a:pPr algn="ctr"/>
+            <a:r>
+              <a:rPr sz="840" b="1">
+                <a:solidFill>
+                  <a:srgbClr val="FFFFFF"/>
+                </a:solidFill>
+                <a:latin typeface="Arial"/>
+              </a:rPr>
+              <a:t>Onboarding</a:t>
+            </a:r>
+          </a:p>
+        </p:txBody>
+      </p:sp>
+      <p:cxnSp>
+        <p:nvCxnSpPr>
+          <p:cNvPr id="190" name="Connector 189"/>
+          <p:cNvCxnSpPr/>
+          <p:nvPr/>
+        </p:nvCxnSpPr>
+        <p:spPr>
+          <a:xfrm>
+            <a:off x="14561999" y="26593199"/>
+            <a:ext cx="306001" cy="0"/>
+          </a:xfrm>
+          <a:prstGeom prst="line">
+            <a:avLst/>
+          </a:prstGeom>
+          <a:ln w="21590">
+            <a:solidFill>
+              <a:srgbClr val="10B981"/>
+            </a:solidFill>
+          </a:ln>
+        </p:spPr>
+        <p:style>
+          <a:lnRef idx="2">
+            <a:schemeClr val="accent1"/>
+          </a:lnRef>
+          <a:fillRef idx="0">
+            <a:schemeClr val="accent1"/>
+          </a:fillRef>
+          <a:effectRef idx="1">
+            <a:schemeClr val="accent1"/>
+          </a:effectRef>
+          <a:fontRef idx="minor">
+            <a:schemeClr val="tx1"/>
+          </a:fontRef>
+        </p:style>
+      </p:cxnSp>
+      <p:sp>
+        <p:nvSpPr>
+          <p:cNvPr id="191" name="Rounded Rectangle 190"/>
+          <p:cNvSpPr/>
+          <p:nvPr/>
+        </p:nvSpPr>
+        <p:spPr>
+          <a:xfrm>
+            <a:off x="14922000" y="26423999"/>
+            <a:ext cx="1170000" cy="342000"/>
+          </a:xfrm>
+          <a:prstGeom prst="roundRect">
+            <a:avLst/>
+          </a:prstGeom>
+          <a:solidFill>
+            <a:srgbClr val="10B981"/>
+          </a:solidFill>
+          <a:ln w="10160">
+            <a:solidFill>
+              <a:srgbClr val="10B981"/>
+            </a:solidFill>
+          </a:ln>
+        </p:spPr>
+        <p:style>
+          <a:lnRef idx="1">
+            <a:schemeClr val="accent1"/>
+          </a:lnRef>
+          <a:fillRef idx="3">
+            <a:schemeClr val="accent1"/>
+          </a:fillRef>
+          <a:effectRef idx="2">
+            <a:schemeClr val="accent1"/>
+          </a:effectRef>
+          <a:fontRef idx="minor">
+            <a:schemeClr val="lt1"/>
+          </a:fontRef>
+        </p:style>
+        <p:txBody>
+          <a:bodyPr rtlCol="0" anchor="ctr"/>
+          <a:lstStyle/>
+          <a:p>
+            <a:pPr algn="ctr"/>
+            <a:r>
+              <a:rPr sz="840" b="1">
+                <a:solidFill>
+                  <a:srgbClr val="FFFFFF"/>
+                </a:solidFill>
+                <a:latin typeface="Arial"/>
+              </a:rPr>
+              <a:t>Kategori</a:t>
+            </a:r>
+          </a:p>
+        </p:txBody>
+      </p:sp>
+      <p:cxnSp>
+        <p:nvCxnSpPr>
+          <p:cNvPr id="192" name="Connector 191"/>
+          <p:cNvCxnSpPr/>
+          <p:nvPr/>
+        </p:nvCxnSpPr>
+        <p:spPr>
+          <a:xfrm>
+            <a:off x="16110000" y="26593199"/>
+            <a:ext cx="198000" cy="0"/>
+          </a:xfrm>
+          <a:prstGeom prst="line">
+            <a:avLst/>
+          </a:prstGeom>
+          <a:ln w="21590">
+            <a:solidFill>
+              <a:srgbClr val="10B981"/>
+            </a:solidFill>
+          </a:ln>
+        </p:spPr>
+        <p:style>
+          <a:lnRef idx="2">
+            <a:schemeClr val="accent1"/>
+          </a:lnRef>
+          <a:fillRef idx="0">
+            <a:schemeClr val="accent1"/>
+          </a:fillRef>
+          <a:effectRef idx="1">
+            <a:schemeClr val="accent1"/>
+          </a:effectRef>
+          <a:fontRef idx="minor">
+            <a:schemeClr val="tx1"/>
+          </a:fontRef>
+        </p:style>
+      </p:cxnSp>
+      <p:sp>
+        <p:nvSpPr>
+          <p:cNvPr id="193" name="Rounded Rectangle 192"/>
+          <p:cNvSpPr/>
+          <p:nvPr/>
+        </p:nvSpPr>
+        <p:spPr>
+          <a:xfrm>
+            <a:off x="16362000" y="26423999"/>
+            <a:ext cx="1170000" cy="342000"/>
+          </a:xfrm>
+          <a:prstGeom prst="roundRect">
+            <a:avLst/>
+          </a:prstGeom>
+          <a:solidFill>
+            <a:srgbClr val="1E40AF"/>
+          </a:solidFill>
+          <a:ln w="10160">
+            <a:solidFill>
+              <a:srgbClr val="1E40AF"/>
+            </a:solidFill>
+          </a:ln>
+        </p:spPr>
+        <p:style>
+          <a:lnRef idx="1">
+            <a:schemeClr val="accent1"/>
+          </a:lnRef>
+          <a:fillRef idx="3">
+            <a:schemeClr val="accent1"/>
+          </a:fillRef>
+          <a:effectRef idx="2">
+            <a:schemeClr val="accent1"/>
+          </a:effectRef>
+          <a:fontRef idx="minor">
+            <a:schemeClr val="lt1"/>
+          </a:fontRef>
+        </p:style>
+        <p:txBody>
+          <a:bodyPr rtlCol="0" anchor="ctr"/>
+          <a:lstStyle/>
+          <a:p>
+            <a:pPr algn="ctr"/>
+            <a:r>
+              <a:rPr sz="840" b="1">
+                <a:solidFill>
+                  <a:srgbClr val="FFFFFF"/>
+                </a:solidFill>
+                <a:latin typeface="Arial"/>
+              </a:rPr>
+              <a:t>Yeni/Popüler</a:t>
+            </a:r>
+          </a:p>
+        </p:txBody>
+      </p:sp>
+      <p:cxnSp>
+        <p:nvCxnSpPr>
+          <p:cNvPr id="194" name="Connector 193"/>
+          <p:cNvCxnSpPr/>
+          <p:nvPr/>
+        </p:nvCxnSpPr>
+        <p:spPr>
+          <a:xfrm>
+            <a:off x="17550000" y="26593199"/>
+            <a:ext cx="450000" cy="0"/>
+          </a:xfrm>
+          <a:prstGeom prst="line">
+            <a:avLst/>
+          </a:prstGeom>
+          <a:ln w="21590">
+            <a:solidFill>
+              <a:srgbClr val="10B981"/>
+            </a:solidFill>
+          </a:ln>
+        </p:spPr>
+        <p:style>
+          <a:lnRef idx="2">
+            <a:schemeClr val="accent1"/>
+          </a:lnRef>
+          <a:fillRef idx="0">
+            <a:schemeClr val="accent1"/>
+          </a:fillRef>
+          <a:effectRef idx="1">
+            <a:schemeClr val="accent1"/>
+          </a:effectRef>
+          <a:fontRef idx="minor">
+            <a:schemeClr val="tx1"/>
+          </a:fontRef>
+        </p:style>
+      </p:cxnSp>
+      <p:sp>
+        <p:nvSpPr>
+          <p:cNvPr id="195" name="Rounded Rectangle 194"/>
+          <p:cNvSpPr/>
+          <p:nvPr/>
+        </p:nvSpPr>
+        <p:spPr>
+          <a:xfrm>
+            <a:off x="18054000" y="26423999"/>
+            <a:ext cx="1170000" cy="342000"/>
+          </a:xfrm>
+          <a:prstGeom prst="roundRect">
+            <a:avLst/>
+          </a:prstGeom>
+          <a:solidFill>
+            <a:srgbClr val="0F172A"/>
+          </a:solidFill>
+          <a:ln w="10160">
+            <a:solidFill>
+              <a:srgbClr val="0F172A"/>
+            </a:solidFill>
+          </a:ln>
+        </p:spPr>
+        <p:style>
+          <a:lnRef idx="1">
+            <a:schemeClr val="accent1"/>
+          </a:lnRef>
+          <a:fillRef idx="3">
+            <a:schemeClr val="accent1"/>
+          </a:fillRef>
+          <a:effectRef idx="2">
+            <a:schemeClr val="accent1"/>
+          </a:effectRef>
+          <a:fontRef idx="minor">
+            <a:schemeClr val="lt1"/>
+          </a:fontRef>
+        </p:style>
+        <p:txBody>
+          <a:bodyPr rtlCol="0" anchor="ctr"/>
+          <a:lstStyle/>
+          <a:p>
+            <a:pPr algn="ctr"/>
+            <a:r>
+              <a:rPr sz="840" b="1">
+                <a:solidFill>
+                  <a:srgbClr val="FFFFFF"/>
+                </a:solidFill>
+                <a:latin typeface="Arial"/>
+              </a:rPr>
+              <a:t>Dolu vitrin</a:t>
+            </a:r>
+          </a:p>
+        </p:txBody>
+      </p:sp>
+      <p:sp>
+        <p:nvSpPr>
+          <p:cNvPr id="196" name="TextBox 195"/>
+          <p:cNvSpPr txBox="1"/>
+          <p:nvPr/>
+        </p:nvSpPr>
+        <p:spPr>
+          <a:xfrm>
+            <a:off x="11412000" y="26881200"/>
+            <a:ext cx="8172000" cy="172800"/>
+          </a:xfrm>
+          <a:prstGeom prst="rect">
+            <a:avLst/>
+          </a:prstGeom>
+          <a:noFill/>
+        </p:spPr>
+        <p:txBody>
+          <a:bodyPr wrap="square" anchor="t">
+            <a:spAutoFit/>
+          </a:bodyPr>
+          <a:lstStyle/>
+          <a:p>
+            <a:pPr algn="ctr"/>
+            <a:r>
+              <a:rPr sz="850" b="0">
+                <a:solidFill>
+                  <a:srgbClr val="475569"/>
+                </a:solidFill>
+                <a:latin typeface="Arial"/>
+              </a:rPr>
+              <a:t>Model yeni kullanıcıyı tanımadığında sistem boş kalmaz; yerel PAÜ ilanlarıyla öneri üretir.</a:t>
+            </a:r>
+          </a:p>
+        </p:txBody>
+      </p:sp>
+      <p:sp>
+        <p:nvSpPr>
+          <p:cNvPr id="197" name="Oval 196"/>
           <p:cNvSpPr/>
           <p:nvPr/>
         </p:nvSpPr>
@@ -11205,7 +12198,7 @@
       </p:sp>
       <p:sp>
         <p:nvSpPr>
-          <p:cNvPr id="175" name="TextBox 174"/>
+          <p:cNvPr id="198" name="TextBox 197"/>
           <p:cNvSpPr txBox="1"/>
           <p:nvPr/>
         </p:nvSpPr>
@@ -11240,7 +12233,7 @@
       </p:sp>
       <p:sp>
         <p:nvSpPr>
-          <p:cNvPr id="176" name="TextBox 175"/>
+          <p:cNvPr id="199" name="TextBox 198"/>
           <p:cNvSpPr txBox="1"/>
           <p:nvPr/>
         </p:nvSpPr>
@@ -11275,7 +12268,7 @@
       </p:sp>
       <p:sp>
         <p:nvSpPr>
-          <p:cNvPr id="177" name="TextBox 176"/>
+          <p:cNvPr id="200" name="TextBox 199"/>
           <p:cNvSpPr txBox="1"/>
           <p:nvPr/>
         </p:nvSpPr>

</xml_diff>